<commit_message>
Advisor deck v3: every slide self-explanatory + Chinese speaker notes
</commit_message>
<xml_diff>
--- a/paper/IFH_advisor_update_2026-09-03.pptx
+++ b/paper/IFH_advisor_update_2026-09-03.pptx
@@ -634,6 +634,1056 @@
     <c:autoUpdate val="0"/>
   </c:externalData>
 </c:chartSpace>
+</file>
+
+<file path=ppt/notesMasters/notesMaster1.xml><?xml version="1.0" encoding="utf-8"?>
+<p:notesMaster xmlns:a="http://schemas.openxmlformats.org/drawingml/2006/main" xmlns:p="http://schemas.openxmlformats.org/presentationml/2006/main" xmlns:r="http://schemas.openxmlformats.org/officeDocument/2006/relationships">
+  <p:cSld>
+    <p:bg>
+      <p:bgRef idx="1001">
+        <a:schemeClr val="bg1"/>
+      </p:bgRef>
+    </p:bg>
+    <p:spTree>
+      <p:nvGrpSpPr>
+        <p:cNvPr id="1" name=""/>
+        <p:cNvGrpSpPr/>
+        <p:nvPr/>
+      </p:nvGrpSpPr>
+      <p:grpSpPr>
+        <a:xfrm>
+          <a:off x="0" y="0"/>
+          <a:ext cx="0" cy="0"/>
+          <a:chOff x="0" y="0"/>
+          <a:chExt cx="0" cy="0"/>
+        </a:xfrm>
+      </p:grpSpPr>
+      <p:sp>
+        <p:nvSpPr>
+          <p:cNvPr id="2" name="Header Placeholder 1"/>
+          <p:cNvSpPr>
+            <a:spLocks noGrp="1"/>
+          </p:cNvSpPr>
+          <p:nvPr>
+            <p:ph type="hdr" sz="quarter"/>
+          </p:nvPr>
+        </p:nvSpPr>
+        <p:spPr>
+          <a:xfrm>
+            <a:off x="0" y="0"/>
+            <a:ext cx="2971800" cy="457200"/>
+          </a:xfrm>
+          <a:prstGeom prst="rect">
+            <a:avLst/>
+          </a:prstGeom>
+        </p:spPr>
+        <p:txBody>
+          <a:bodyPr vert="horz" lIns="91440" tIns="45720" rIns="91440" bIns="45720" rtlCol="0"/>
+          <a:lstStyle>
+            <a:lvl1pPr algn="l">
+              <a:defRPr sz="1200"/>
+            </a:lvl1pPr>
+          </a:lstStyle>
+          <a:p>
+            <a:endParaRPr lang="en-US"/>
+          </a:p>
+        </p:txBody>
+      </p:sp>
+      <p:sp>
+        <p:nvSpPr>
+          <p:cNvPr id="3" name="Date Placeholder 2"/>
+          <p:cNvSpPr>
+            <a:spLocks noGrp="1"/>
+          </p:cNvSpPr>
+          <p:nvPr>
+            <p:ph type="dt" idx="1"/>
+          </p:nvPr>
+        </p:nvSpPr>
+        <p:spPr>
+          <a:xfrm>
+            <a:off x="3884613" y="0"/>
+            <a:ext cx="2971800" cy="457200"/>
+          </a:xfrm>
+          <a:prstGeom prst="rect">
+            <a:avLst/>
+          </a:prstGeom>
+        </p:spPr>
+        <p:txBody>
+          <a:bodyPr vert="horz" lIns="91440" tIns="45720" rIns="91440" bIns="45720" rtlCol="0"/>
+          <a:lstStyle>
+            <a:lvl1pPr algn="r">
+              <a:defRPr sz="1200"/>
+            </a:lvl1pPr>
+          </a:lstStyle>
+          <a:p>
+            <a:fld id="{0F89C1C7-3DCD-1040-A9CF-14679D8B5DDD}" type="datetimeFigureOut">
+              <a:rPr lang="en-US" smtClean="0"/>
+              <a:t>10/17/16</a:t>
+            </a:fld>
+            <a:endParaRPr lang="en-US"/>
+          </a:p>
+        </p:txBody>
+      </p:sp>
+      <p:sp>
+        <p:nvSpPr>
+          <p:cNvPr id="4" name="Slide Image Placeholder 3"/>
+          <p:cNvSpPr>
+            <a:spLocks noGrp="1" noRot="1" noChangeAspect="1"/>
+          </p:cNvSpPr>
+          <p:nvPr>
+            <p:ph type="sldImg" idx="2"/>
+          </p:nvPr>
+        </p:nvSpPr>
+        <p:spPr>
+          <a:xfrm>
+            <a:off x="1143000" y="685800"/>
+            <a:ext cx="4572000" cy="3429000"/>
+          </a:xfrm>
+          <a:prstGeom prst="rect">
+            <a:avLst/>
+          </a:prstGeom>
+          <a:noFill/>
+          <a:ln w="12700">
+            <a:solidFill>
+              <a:prstClr val="black"/>
+            </a:solidFill>
+          </a:ln>
+        </p:spPr>
+        <p:txBody>
+          <a:bodyPr vert="horz" lIns="91440" tIns="45720" rIns="91440" bIns="45720" rtlCol="0" anchor="ctr"/>
+          <a:lstStyle/>
+          <a:p>
+            <a:endParaRPr lang="en-US"/>
+          </a:p>
+        </p:txBody>
+      </p:sp>
+      <p:sp>
+        <p:nvSpPr>
+          <p:cNvPr id="5" name="Notes Placeholder 4"/>
+          <p:cNvSpPr>
+            <a:spLocks noGrp="1"/>
+          </p:cNvSpPr>
+          <p:nvPr>
+            <p:ph type="body" sz="quarter" idx="3"/>
+          </p:nvPr>
+        </p:nvSpPr>
+        <p:spPr>
+          <a:xfrm>
+            <a:off x="685800" y="4343400"/>
+            <a:ext cx="5486400" cy="4114800"/>
+          </a:xfrm>
+          <a:prstGeom prst="rect">
+            <a:avLst/>
+          </a:prstGeom>
+        </p:spPr>
+        <p:txBody>
+          <a:bodyPr vert="horz" lIns="91440" tIns="45720" rIns="91440" bIns="45720" rtlCol="0"/>
+          <a:lstStyle/>
+          <a:p>
+            <a:pPr lvl="0"/>
+            <a:r>
+              <a:rPr lang="en-US" smtClean="0"/>
+              <a:t>Click to edit Master text styles</a:t>
+            </a:r>
+          </a:p>
+          <a:p>
+            <a:pPr lvl="1"/>
+            <a:r>
+              <a:rPr lang="en-US" smtClean="0"/>
+              <a:t>Second level</a:t>
+            </a:r>
+          </a:p>
+          <a:p>
+            <a:pPr lvl="2"/>
+            <a:r>
+              <a:rPr lang="en-US" smtClean="0"/>
+              <a:t>Third level</a:t>
+            </a:r>
+          </a:p>
+          <a:p>
+            <a:pPr lvl="3"/>
+            <a:r>
+              <a:rPr lang="en-US" smtClean="0"/>
+              <a:t>Fourth level</a:t>
+            </a:r>
+          </a:p>
+          <a:p>
+            <a:pPr lvl="4"/>
+            <a:r>
+              <a:rPr lang="en-US" smtClean="0"/>
+              <a:t>Fifth level</a:t>
+            </a:r>
+            <a:endParaRPr lang="en-US"/>
+          </a:p>
+        </p:txBody>
+      </p:sp>
+      <p:sp>
+        <p:nvSpPr>
+          <p:cNvPr id="6" name="Footer Placeholder 5"/>
+          <p:cNvSpPr>
+            <a:spLocks noGrp="1"/>
+          </p:cNvSpPr>
+          <p:nvPr>
+            <p:ph type="ftr" sz="quarter" idx="4"/>
+          </p:nvPr>
+        </p:nvSpPr>
+        <p:spPr>
+          <a:xfrm>
+            <a:off x="0" y="8685213"/>
+            <a:ext cx="2971800" cy="457200"/>
+          </a:xfrm>
+          <a:prstGeom prst="rect">
+            <a:avLst/>
+          </a:prstGeom>
+        </p:spPr>
+        <p:txBody>
+          <a:bodyPr vert="horz" lIns="91440" tIns="45720" rIns="91440" bIns="45720" rtlCol="0" anchor="b"/>
+          <a:lstStyle>
+            <a:lvl1pPr algn="l">
+              <a:defRPr sz="1200"/>
+            </a:lvl1pPr>
+          </a:lstStyle>
+          <a:p>
+            <a:endParaRPr lang="en-US"/>
+          </a:p>
+        </p:txBody>
+      </p:sp>
+      <p:sp>
+        <p:nvSpPr>
+          <p:cNvPr id="7" name="Slide Number Placeholder 6"/>
+          <p:cNvSpPr>
+            <a:spLocks noGrp="1"/>
+          </p:cNvSpPr>
+          <p:nvPr>
+            <p:ph type="sldNum" sz="quarter" idx="5"/>
+          </p:nvPr>
+        </p:nvSpPr>
+        <p:spPr>
+          <a:xfrm>
+            <a:off x="3884613" y="8685213"/>
+            <a:ext cx="2971800" cy="457200"/>
+          </a:xfrm>
+          <a:prstGeom prst="rect">
+            <a:avLst/>
+          </a:prstGeom>
+        </p:spPr>
+        <p:txBody>
+          <a:bodyPr vert="horz" lIns="91440" tIns="45720" rIns="91440" bIns="45720" rtlCol="0" anchor="b"/>
+          <a:lstStyle>
+            <a:lvl1pPr algn="r">
+              <a:defRPr sz="1200"/>
+            </a:lvl1pPr>
+          </a:lstStyle>
+          <a:p>
+            <a:fld id="{BB5E49A5-4136-284D-997B-48E1D791AD67}" type="slidenum">
+              <a:rPr lang="en-US" smtClean="0"/>
+              <a:t>‹#›</a:t>
+            </a:fld>
+            <a:endParaRPr lang="en-US"/>
+          </a:p>
+        </p:txBody>
+      </p:sp>
+    </p:spTree>
+    <p:extLst>
+      <p:ext uri="{BB962C8B-B14F-4D97-AF65-F5344CB8AC3E}">
+        <p14:creationId xmlns:p14="http://schemas.microsoft.com/office/powerpoint/2010/main" val="2623252185"/>
+      </p:ext>
+    </p:extLst>
+  </p:cSld>
+  <p:clrMap bg1="lt1" tx1="dk1" bg2="lt2" tx2="dk2" accent1="accent1" accent2="accent2" accent3="accent3" accent4="accent4" accent5="accent5" accent6="accent6" hlink="hlink" folHlink="folHlink"/>
+  <p:notesStyle>
+    <a:lvl1pPr marL="0" algn="l" defTabSz="457200" rtl="0" eaLnBrk="1" latinLnBrk="0" hangingPunct="1">
+      <a:defRPr sz="1200" kern="1200">
+        <a:solidFill>
+          <a:schemeClr val="tx1"/>
+        </a:solidFill>
+        <a:latin typeface="+mn-lt"/>
+        <a:ea typeface="+mn-ea"/>
+        <a:cs typeface="+mn-cs"/>
+      </a:defRPr>
+    </a:lvl1pPr>
+    <a:lvl2pPr marL="457200" algn="l" defTabSz="457200" rtl="0" eaLnBrk="1" latinLnBrk="0" hangingPunct="1">
+      <a:defRPr sz="1200" kern="1200">
+        <a:solidFill>
+          <a:schemeClr val="tx1"/>
+        </a:solidFill>
+        <a:latin typeface="+mn-lt"/>
+        <a:ea typeface="+mn-ea"/>
+        <a:cs typeface="+mn-cs"/>
+      </a:defRPr>
+    </a:lvl2pPr>
+    <a:lvl3pPr marL="914400" algn="l" defTabSz="457200" rtl="0" eaLnBrk="1" latinLnBrk="0" hangingPunct="1">
+      <a:defRPr sz="1200" kern="1200">
+        <a:solidFill>
+          <a:schemeClr val="tx1"/>
+        </a:solidFill>
+        <a:latin typeface="+mn-lt"/>
+        <a:ea typeface="+mn-ea"/>
+        <a:cs typeface="+mn-cs"/>
+      </a:defRPr>
+    </a:lvl3pPr>
+    <a:lvl4pPr marL="1371600" algn="l" defTabSz="457200" rtl="0" eaLnBrk="1" latinLnBrk="0" hangingPunct="1">
+      <a:defRPr sz="1200" kern="1200">
+        <a:solidFill>
+          <a:schemeClr val="tx1"/>
+        </a:solidFill>
+        <a:latin typeface="+mn-lt"/>
+        <a:ea typeface="+mn-ea"/>
+        <a:cs typeface="+mn-cs"/>
+      </a:defRPr>
+    </a:lvl4pPr>
+    <a:lvl5pPr marL="1828800" algn="l" defTabSz="457200" rtl="0" eaLnBrk="1" latinLnBrk="0" hangingPunct="1">
+      <a:defRPr sz="1200" kern="1200">
+        <a:solidFill>
+          <a:schemeClr val="tx1"/>
+        </a:solidFill>
+        <a:latin typeface="+mn-lt"/>
+        <a:ea typeface="+mn-ea"/>
+        <a:cs typeface="+mn-cs"/>
+      </a:defRPr>
+    </a:lvl5pPr>
+    <a:lvl6pPr marL="2286000" algn="l" defTabSz="457200" rtl="0" eaLnBrk="1" latinLnBrk="0" hangingPunct="1">
+      <a:defRPr sz="1200" kern="1200">
+        <a:solidFill>
+          <a:schemeClr val="tx1"/>
+        </a:solidFill>
+        <a:latin typeface="+mn-lt"/>
+        <a:ea typeface="+mn-ea"/>
+        <a:cs typeface="+mn-cs"/>
+      </a:defRPr>
+    </a:lvl6pPr>
+    <a:lvl7pPr marL="2743200" algn="l" defTabSz="457200" rtl="0" eaLnBrk="1" latinLnBrk="0" hangingPunct="1">
+      <a:defRPr sz="1200" kern="1200">
+        <a:solidFill>
+          <a:schemeClr val="tx1"/>
+        </a:solidFill>
+        <a:latin typeface="+mn-lt"/>
+        <a:ea typeface="+mn-ea"/>
+        <a:cs typeface="+mn-cs"/>
+      </a:defRPr>
+    </a:lvl7pPr>
+    <a:lvl8pPr marL="3200400" algn="l" defTabSz="457200" rtl="0" eaLnBrk="1" latinLnBrk="0" hangingPunct="1">
+      <a:defRPr sz="1200" kern="1200">
+        <a:solidFill>
+          <a:schemeClr val="tx1"/>
+        </a:solidFill>
+        <a:latin typeface="+mn-lt"/>
+        <a:ea typeface="+mn-ea"/>
+        <a:cs typeface="+mn-cs"/>
+      </a:defRPr>
+    </a:lvl8pPr>
+    <a:lvl9pPr marL="3657600" algn="l" defTabSz="457200" rtl="0" eaLnBrk="1" latinLnBrk="0" hangingPunct="1">
+      <a:defRPr sz="1200" kern="1200">
+        <a:solidFill>
+          <a:schemeClr val="tx1"/>
+        </a:solidFill>
+        <a:latin typeface="+mn-lt"/>
+        <a:ea typeface="+mn-ea"/>
+        <a:cs typeface="+mn-cs"/>
+      </a:defRPr>
+    </a:lvl9pPr>
+  </p:notesStyle>
+</p:notesMaster>
+</file>
+
+<file path=ppt/notesSlides/notesSlide1.xml><?xml version="1.0" encoding="utf-8"?>
+<p:notes xmlns:a="http://schemas.openxmlformats.org/drawingml/2006/main" xmlns:p="http://schemas.openxmlformats.org/presentationml/2006/main" xmlns:r="http://schemas.openxmlformats.org/officeDocument/2006/relationships">
+  <p:cSld>
+    <p:spTree>
+      <p:nvGrpSpPr>
+        <p:cNvPr id="1" name=""/>
+        <p:cNvGrpSpPr/>
+        <p:nvPr/>
+      </p:nvGrpSpPr>
+      <p:grpSpPr>
+        <a:xfrm>
+          <a:off x="0" y="0"/>
+          <a:ext cx="0" cy="0"/>
+          <a:chOff x="0" y="0"/>
+          <a:chExt cx="0" cy="0"/>
+        </a:xfrm>
+      </p:grpSpPr>
+      <p:sp>
+        <p:nvSpPr>
+          <p:cNvPr id="2" name="Slide Image Placeholder 1"/>
+          <p:cNvSpPr>
+            <a:spLocks noGrp="1"/>
+          </p:cNvSpPr>
+          <p:nvPr>
+            <p:ph type="sldImg" idx="2"/>
+          </p:nvPr>
+        </p:nvSpPr>
+        <p:spPr/>
+      </p:sp>
+      <p:sp>
+        <p:nvSpPr>
+          <p:cNvPr id="3" name="Notes Placeholder 2"/>
+          <p:cNvSpPr>
+            <a:spLocks noGrp="1"/>
+          </p:cNvSpPr>
+          <p:nvPr>
+            <p:ph type="body" idx="3" sz="quarter"/>
+          </p:nvPr>
+        </p:nvSpPr>
+        <p:spPr/>
+        <p:txBody>
+          <a:bodyPr/>
+          <a:lstStyle/>
+          <a:p>
+            <a:r>
+              <a:t>开场：我们研究的是——把大模型压缩变小的时候，什么情况下能力会被悄悄毁掉、怎么防住。所有实验已完成并冻结（6个模型，约120组实验）。</a:t>
+            </a:r>
+          </a:p>
+        </p:txBody>
+      </p:sp>
+      <p:sp>
+        <p:nvSpPr>
+          <p:cNvPr id="4" name="Slide Number Placeholder 3"/>
+          <p:cNvSpPr>
+            <a:spLocks noGrp="1"/>
+          </p:cNvSpPr>
+          <p:nvPr>
+            <p:ph type="sldNum" idx="5" sz="quarter"/>
+          </p:nvPr>
+        </p:nvSpPr>
+        <p:spPr/>
+      </p:sp>
+    </p:spTree>
+  </p:cSld>
+  <p:clrMapOvr>
+    <a:masterClrMapping/>
+  </p:clrMapOvr>
+</p:notes>
+</file>
+
+<file path=ppt/notesSlides/notesSlide10.xml><?xml version="1.0" encoding="utf-8"?>
+<p:notes xmlns:a="http://schemas.openxmlformats.org/drawingml/2006/main" xmlns:p="http://schemas.openxmlformats.org/presentationml/2006/main" xmlns:r="http://schemas.openxmlformats.org/officeDocument/2006/relationships">
+  <p:cSld>
+    <p:spTree>
+      <p:nvGrpSpPr>
+        <p:cNvPr id="1" name=""/>
+        <p:cNvGrpSpPr/>
+        <p:nvPr/>
+      </p:nvGrpSpPr>
+      <p:grpSpPr>
+        <a:xfrm>
+          <a:off x="0" y="0"/>
+          <a:ext cx="0" cy="0"/>
+          <a:chOff x="0" y="0"/>
+          <a:chExt cx="0" cy="0"/>
+        </a:xfrm>
+      </p:grpSpPr>
+      <p:sp>
+        <p:nvSpPr>
+          <p:cNvPr id="2" name="Slide Image Placeholder 1"/>
+          <p:cNvSpPr>
+            <a:spLocks noGrp="1"/>
+          </p:cNvSpPr>
+          <p:nvPr>
+            <p:ph type="sldImg" idx="2"/>
+          </p:nvPr>
+        </p:nvSpPr>
+        <p:spPr/>
+      </p:sp>
+      <p:sp>
+        <p:nvSpPr>
+          <p:cNvPr id="3" name="Notes Placeholder 2"/>
+          <p:cNvSpPr>
+            <a:spLocks noGrp="1"/>
+          </p:cNvSpPr>
+          <p:nvPr>
+            <p:ph type="body" idx="3" sz="quarter"/>
+          </p:nvPr>
+        </p:nvSpPr>
+        <p:spPr/>
+        <p:txBody>
+          <a:bodyPr/>
+          <a:lstStyle/>
+          <a:p>
+            <a:r>
+              <a:t>征求意见：①故事是否已经是一个干净的问题+干净的答案；②确认ICLR→ACL路线；③如何对接Mengxia的工作（打招呼还是引用即可）；④集群还可用，要不要补实验。</a:t>
+            </a:r>
+          </a:p>
+        </p:txBody>
+      </p:sp>
+      <p:sp>
+        <p:nvSpPr>
+          <p:cNvPr id="4" name="Slide Number Placeholder 3"/>
+          <p:cNvSpPr>
+            <a:spLocks noGrp="1"/>
+          </p:cNvSpPr>
+          <p:nvPr>
+            <p:ph type="sldNum" idx="5" sz="quarter"/>
+          </p:nvPr>
+        </p:nvSpPr>
+        <p:spPr/>
+      </p:sp>
+    </p:spTree>
+  </p:cSld>
+  <p:clrMapOvr>
+    <a:masterClrMapping/>
+  </p:clrMapOvr>
+</p:notes>
+</file>
+
+<file path=ppt/notesSlides/notesSlide2.xml><?xml version="1.0" encoding="utf-8"?>
+<p:notes xmlns:a="http://schemas.openxmlformats.org/drawingml/2006/main" xmlns:p="http://schemas.openxmlformats.org/presentationml/2006/main" xmlns:r="http://schemas.openxmlformats.org/officeDocument/2006/relationships">
+  <p:cSld>
+    <p:spTree>
+      <p:nvGrpSpPr>
+        <p:cNvPr id="1" name=""/>
+        <p:cNvGrpSpPr/>
+        <p:nvPr/>
+      </p:nvGrpSpPr>
+      <p:grpSpPr>
+        <a:xfrm>
+          <a:off x="0" y="0"/>
+          <a:ext cx="0" cy="0"/>
+          <a:chOff x="0" y="0"/>
+          <a:chExt cx="0" cy="0"/>
+        </a:xfrm>
+      </p:grpSpPr>
+      <p:sp>
+        <p:nvSpPr>
+          <p:cNvPr id="2" name="Slide Image Placeholder 1"/>
+          <p:cNvSpPr>
+            <a:spLocks noGrp="1"/>
+          </p:cNvSpPr>
+          <p:nvPr>
+            <p:ph type="sldImg" idx="2"/>
+          </p:nvPr>
+        </p:nvSpPr>
+        <p:spPr/>
+      </p:sp>
+      <p:sp>
+        <p:nvSpPr>
+          <p:cNvPr id="3" name="Notes Placeholder 2"/>
+          <p:cNvSpPr>
+            <a:spLocks noGrp="1"/>
+          </p:cNvSpPr>
+          <p:nvPr>
+            <p:ph type="body" idx="3" sz="quarter"/>
+          </p:nvPr>
+        </p:nvSpPr>
+        <p:spPr/>
+        <p:txBody>
+          <a:bodyPr/>
+          <a:lstStyle/>
+          <a:p>
+            <a:r>
+              <a:t>先立四个词：①量化=把每个权重从16位存成3位，模型小5倍、便宜5倍；②GPTQ=业界标准压缩算法，特点是“聪明”——每压一个权重就调整其他权重来抵消误差；③RTN=笨办法，直接四舍五入，不纠错；④保护=挑出最重要的0.5%权重不压缩，重要性用TaCQ这篇论文的公式打分：|权重值|×|梯度|×|压缩误差|，直觉是“作用大×模型敏感×压缩伤它重”三者相乘。我们的问题：以往论文都默认“保护重要权重总是有帮助”，没人问过什么时候真有帮助。我们的答案：只有压崩溃的时候有帮助，其他时候完全没用。</a:t>
+            </a:r>
+          </a:p>
+        </p:txBody>
+      </p:sp>
+      <p:sp>
+        <p:nvSpPr>
+          <p:cNvPr id="4" name="Slide Number Placeholder 3"/>
+          <p:cNvSpPr>
+            <a:spLocks noGrp="1"/>
+          </p:cNvSpPr>
+          <p:nvPr>
+            <p:ph type="sldNum" idx="5" sz="quarter"/>
+          </p:nvPr>
+        </p:nvSpPr>
+        <p:spPr/>
+      </p:sp>
+    </p:spTree>
+  </p:cSld>
+  <p:clrMapOvr>
+    <a:masterClrMapping/>
+  </p:clrMapOvr>
+</p:notes>
+</file>
+
+<file path=ppt/notesSlides/notesSlide3.xml><?xml version="1.0" encoding="utf-8"?>
+<p:notes xmlns:a="http://schemas.openxmlformats.org/drawingml/2006/main" xmlns:p="http://schemas.openxmlformats.org/presentationml/2006/main" xmlns:r="http://schemas.openxmlformats.org/officeDocument/2006/relationships">
+  <p:cSld>
+    <p:spTree>
+      <p:nvGrpSpPr>
+        <p:cNvPr id="1" name=""/>
+        <p:cNvGrpSpPr/>
+        <p:nvPr/>
+      </p:nvGrpSpPr>
+      <p:grpSpPr>
+        <a:xfrm>
+          <a:off x="0" y="0"/>
+          <a:ext cx="0" cy="0"/>
+          <a:chOff x="0" y="0"/>
+          <a:chExt cx="0" cy="0"/>
+        </a:xfrm>
+      </p:grpSpPr>
+      <p:sp>
+        <p:nvSpPr>
+          <p:cNvPr id="2" name="Slide Image Placeholder 1"/>
+          <p:cNvSpPr>
+            <a:spLocks noGrp="1"/>
+          </p:cNvSpPr>
+          <p:nvPr>
+            <p:ph type="sldImg" idx="2"/>
+          </p:nvPr>
+        </p:nvSpPr>
+        <p:spPr/>
+      </p:sp>
+      <p:sp>
+        <p:nvSpPr>
+          <p:cNvPr id="3" name="Notes Placeholder 2"/>
+          <p:cNvSpPr>
+            <a:spLocks noGrp="1"/>
+          </p:cNvSpPr>
+          <p:nvPr>
+            <p:ph type="body" idx="3" sz="quarter"/>
+          </p:nvPr>
+        </p:nvSpPr>
+        <p:spPr/>
+        <p:txBody>
+          <a:bodyPr/>
+          <a:lstStyle/>
+          <a:p>
+            <a:r>
+              <a:t>六个模型用完全相同的配方压到3位：四个只轻微掉分（掉0.06-0.09），两个崩溃——Llama-8B从0.77掉到0.15，Qwen-14B从0.82掉到0.41。关键是不可预测：同一家族的Qwen，7B没事、14B崩、32B又没事。每个崩溃都换随机种子重跑验证过，是稳定现象不是偶然。</a:t>
+            </a:r>
+          </a:p>
+        </p:txBody>
+      </p:sp>
+      <p:sp>
+        <p:nvSpPr>
+          <p:cNvPr id="4" name="Slide Number Placeholder 3"/>
+          <p:cNvSpPr>
+            <a:spLocks noGrp="1"/>
+          </p:cNvSpPr>
+          <p:nvPr>
+            <p:ph type="sldNum" idx="5" sz="quarter"/>
+          </p:nvPr>
+        </p:nvSpPr>
+        <p:spPr/>
+      </p:sp>
+    </p:spTree>
+  </p:cSld>
+  <p:clrMapOvr>
+    <a:masterClrMapping/>
+  </p:clrMapOvr>
+</p:notes>
+</file>
+
+<file path=ppt/notesSlides/notesSlide4.xml><?xml version="1.0" encoding="utf-8"?>
+<p:notes xmlns:a="http://schemas.openxmlformats.org/drawingml/2006/main" xmlns:p="http://schemas.openxmlformats.org/presentationml/2006/main" xmlns:r="http://schemas.openxmlformats.org/officeDocument/2006/relationships">
+  <p:cSld>
+    <p:spTree>
+      <p:nvGrpSpPr>
+        <p:cNvPr id="1" name=""/>
+        <p:cNvGrpSpPr/>
+        <p:nvPr/>
+      </p:nvGrpSpPr>
+      <p:grpSpPr>
+        <a:xfrm>
+          <a:off x="0" y="0"/>
+          <a:ext cx="0" cy="0"/>
+          <a:chOff x="0" y="0"/>
+          <a:chExt cx="0" cy="0"/>
+        </a:xfrm>
+      </p:grpSpPr>
+      <p:sp>
+        <p:nvSpPr>
+          <p:cNvPr id="2" name="Slide Image Placeholder 1"/>
+          <p:cNvSpPr>
+            <a:spLocks noGrp="1"/>
+          </p:cNvSpPr>
+          <p:nvPr>
+            <p:ph type="sldImg" idx="2"/>
+          </p:nvPr>
+        </p:nvSpPr>
+        <p:spPr/>
+      </p:sp>
+      <p:sp>
+        <p:nvSpPr>
+          <p:cNvPr id="3" name="Notes Placeholder 2"/>
+          <p:cNvSpPr>
+            <a:spLocks noGrp="1"/>
+          </p:cNvSpPr>
+          <p:nvPr>
+            <p:ph type="body" idx="3" sz="quarter"/>
+          </p:nvPr>
+        </p:nvSpPr>
+        <p:spPr/>
+        <p:txBody>
+          <a:bodyPr/>
+          <a:lstStyle/>
+          <a:p>
+            <a:r>
+              <a:t>崩溃能修：压缩时保住TaCQ分数最高的0.5%权重（约几千万个），Llama从0.15回到0.64，Qwen-14B从0.41回到0.78（原始分的95%）。对照实验：保护同样数量的随机权重几乎没用（0.18/0.48）——必须是“对的”权重。数学能力同样被修复：14B的GSM8K从0.93崩到0.13，保护后回到0.89。</a:t>
+            </a:r>
+          </a:p>
+        </p:txBody>
+      </p:sp>
+      <p:sp>
+        <p:nvSpPr>
+          <p:cNvPr id="4" name="Slide Number Placeholder 3"/>
+          <p:cNvSpPr>
+            <a:spLocks noGrp="1"/>
+          </p:cNvSpPr>
+          <p:nvPr>
+            <p:ph type="sldNum" idx="5" sz="quarter"/>
+          </p:nvPr>
+        </p:nvSpPr>
+        <p:spPr/>
+      </p:sp>
+    </p:spTree>
+  </p:cSld>
+  <p:clrMapOvr>
+    <a:masterClrMapping/>
+  </p:clrMapOvr>
+</p:notes>
+</file>
+
+<file path=ppt/notesSlides/notesSlide5.xml><?xml version="1.0" encoding="utf-8"?>
+<p:notes xmlns:a="http://schemas.openxmlformats.org/drawingml/2006/main" xmlns:p="http://schemas.openxmlformats.org/presentationml/2006/main" xmlns:r="http://schemas.openxmlformats.org/officeDocument/2006/relationships">
+  <p:cSld>
+    <p:spTree>
+      <p:nvGrpSpPr>
+        <p:cNvPr id="1" name=""/>
+        <p:cNvGrpSpPr/>
+        <p:nvPr/>
+      </p:nvGrpSpPr>
+      <p:grpSpPr>
+        <a:xfrm>
+          <a:off x="0" y="0"/>
+          <a:ext cx="0" cy="0"/>
+          <a:chOff x="0" y="0"/>
+          <a:chExt cx="0" cy="0"/>
+        </a:xfrm>
+      </p:grpSpPr>
+      <p:sp>
+        <p:nvSpPr>
+          <p:cNvPr id="2" name="Slide Image Placeholder 1"/>
+          <p:cNvSpPr>
+            <a:spLocks noGrp="1"/>
+          </p:cNvSpPr>
+          <p:nvPr>
+            <p:ph type="sldImg" idx="2"/>
+          </p:nvPr>
+        </p:nvSpPr>
+        <p:spPr/>
+      </p:sp>
+      <p:sp>
+        <p:nvSpPr>
+          <p:cNvPr id="3" name="Notes Placeholder 2"/>
+          <p:cNvSpPr>
+            <a:spLocks noGrp="1"/>
+          </p:cNvSpPr>
+          <p:nvPr>
+            <p:ph type="body" idx="3" sz="quarter"/>
+          </p:nvPr>
+        </p:nvSpPr>
+        <p:spPr/>
+        <p:txBody>
+          <a:bodyPr/>
+          <a:lstStyle/>
+          <a:p>
+            <a:r>
+              <a:t>另一半结论：四个没崩溃的场景，一模一样的保护只带来+0.008到+0.033，统计检验全部与零无差别（对比崩溃时的+0.49/+0.37）。所以保护是急救包，不是万金油——文献只展示了它“有用”的一面，没人报告过它大多数时候没用。</a:t>
+            </a:r>
+          </a:p>
+        </p:txBody>
+      </p:sp>
+      <p:sp>
+        <p:nvSpPr>
+          <p:cNvPr id="4" name="Slide Number Placeholder 3"/>
+          <p:cNvSpPr>
+            <a:spLocks noGrp="1"/>
+          </p:cNvSpPr>
+          <p:nvPr>
+            <p:ph type="sldNum" idx="5" sz="quarter"/>
+          </p:nvPr>
+        </p:nvSpPr>
+        <p:spPr/>
+      </p:sp>
+    </p:spTree>
+  </p:cSld>
+  <p:clrMapOvr>
+    <a:masterClrMapping/>
+  </p:clrMapOvr>
+</p:notes>
+</file>
+
+<file path=ppt/notesSlides/notesSlide6.xml><?xml version="1.0" encoding="utf-8"?>
+<p:notes xmlns:a="http://schemas.openxmlformats.org/drawingml/2006/main" xmlns:p="http://schemas.openxmlformats.org/presentationml/2006/main" xmlns:r="http://schemas.openxmlformats.org/officeDocument/2006/relationships">
+  <p:cSld>
+    <p:spTree>
+      <p:nvGrpSpPr>
+        <p:cNvPr id="1" name=""/>
+        <p:cNvGrpSpPr/>
+        <p:nvPr/>
+      </p:nvGrpSpPr>
+      <p:grpSpPr>
+        <a:xfrm>
+          <a:off x="0" y="0"/>
+          <a:ext cx="0" cy="0"/>
+          <a:chOff x="0" y="0"/>
+          <a:chExt cx="0" cy="0"/>
+        </a:xfrm>
+      </p:grpSpPr>
+      <p:sp>
+        <p:nvSpPr>
+          <p:cNvPr id="2" name="Slide Image Placeholder 1"/>
+          <p:cNvSpPr>
+            <a:spLocks noGrp="1"/>
+          </p:cNvSpPr>
+          <p:nvPr>
+            <p:ph type="sldImg" idx="2"/>
+          </p:nvPr>
+        </p:nvSpPr>
+        <p:spPr/>
+      </p:sp>
+      <p:sp>
+        <p:nvSpPr>
+          <p:cNvPr id="3" name="Notes Placeholder 2"/>
+          <p:cNvSpPr>
+            <a:spLocks noGrp="1"/>
+          </p:cNvSpPr>
+          <p:nvPr>
+            <p:ph type="body" idx="3" sz="quarter"/>
+          </p:nvPr>
+        </p:nvSpPr>
+        <p:spPr/>
+        <p:txBody>
+          <a:bodyPr/>
+          <a:lstStyle/>
+          <a:p>
+            <a:r>
+              <a:t>为什么崩：同一个Llama三种压法对比。笨办法RTN反而0.57（受伤但活着），聪明的GPTQ却0.15（崩了）——聪明反被聪明误。机制：GPTQ的纠错会把误差摊到其他权重上；模型里有约10万个超敏感权重（占0.001%，在原模型里把它们清零模型也会死），纠错一碰它们就把毒扩散到全网络。证据：事后把这10万个修回原值也救不活（0.16）——伤已经在网络其他地方了。所以保护必须在压缩过程中做，等于告诉纠错机制“这批别碰”。</a:t>
+            </a:r>
+          </a:p>
+        </p:txBody>
+      </p:sp>
+      <p:sp>
+        <p:nvSpPr>
+          <p:cNvPr id="4" name="Slide Number Placeholder 3"/>
+          <p:cNvSpPr>
+            <a:spLocks noGrp="1"/>
+          </p:cNvSpPr>
+          <p:nvPr>
+            <p:ph type="sldNum" idx="5" sz="quarter"/>
+          </p:nvPr>
+        </p:nvSpPr>
+        <p:spPr/>
+      </p:sp>
+    </p:spTree>
+  </p:cSld>
+  <p:clrMapOvr>
+    <a:masterClrMapping/>
+  </p:clrMapOvr>
+</p:notes>
+</file>
+
+<file path=ppt/notesSlides/notesSlide7.xml><?xml version="1.0" encoding="utf-8"?>
+<p:notes xmlns:a="http://schemas.openxmlformats.org/drawingml/2006/main" xmlns:p="http://schemas.openxmlformats.org/presentationml/2006/main" xmlns:r="http://schemas.openxmlformats.org/officeDocument/2006/relationships">
+  <p:cSld>
+    <p:spTree>
+      <p:nvGrpSpPr>
+        <p:cNvPr id="1" name=""/>
+        <p:cNvGrpSpPr/>
+        <p:nvPr/>
+      </p:nvGrpSpPr>
+      <p:grpSpPr>
+        <a:xfrm>
+          <a:off x="0" y="0"/>
+          <a:ext cx="0" cy="0"/>
+          <a:chOff x="0" y="0"/>
+          <a:chExt cx="0" cy="0"/>
+        </a:xfrm>
+      </p:grpSpPr>
+      <p:sp>
+        <p:nvSpPr>
+          <p:cNvPr id="2" name="Slide Image Placeholder 1"/>
+          <p:cNvSpPr>
+            <a:spLocks noGrp="1"/>
+          </p:cNvSpPr>
+          <p:nvPr>
+            <p:ph type="sldImg" idx="2"/>
+          </p:nvPr>
+        </p:nvSpPr>
+        <p:spPr/>
+      </p:sp>
+      <p:sp>
+        <p:nvSpPr>
+          <p:cNvPr id="3" name="Notes Placeholder 2"/>
+          <p:cNvSpPr>
+            <a:spLocks noGrp="1"/>
+          </p:cNvSpPr>
+          <p:nvPr>
+            <p:ph type="body" idx="3" sz="quarter"/>
+          </p:nvPr>
+        </p:nvSpPr>
+        <p:spPr/>
+        <p:txBody>
+          <a:bodyPr/>
+          <a:lstStyle/>
+          <a:p>
+            <a:r>
+              <a:t>更吓人的发现：这么严重的损坏，业界两个默认质检居然都看不出来。压缩后的14B有69%的回答变成复读机（画面上是真实输出），原版不到1%。但困惑度只涨35%（和无害情况一样）、MMLU选择题只掉6分（也和无害情况一样）。原因：这两个指标只测“逐词预测”，复读机只在模型连续自由生成时才发作。警示：压缩后必须用生成式任务测试。</a:t>
+            </a:r>
+          </a:p>
+        </p:txBody>
+      </p:sp>
+      <p:sp>
+        <p:nvSpPr>
+          <p:cNvPr id="4" name="Slide Number Placeholder 3"/>
+          <p:cNvSpPr>
+            <a:spLocks noGrp="1"/>
+          </p:cNvSpPr>
+          <p:nvPr>
+            <p:ph type="sldNum" idx="5" sz="quarter"/>
+          </p:nvPr>
+        </p:nvSpPr>
+        <p:spPr/>
+      </p:sp>
+    </p:spTree>
+  </p:cSld>
+  <p:clrMapOvr>
+    <a:masterClrMapping/>
+  </p:clrMapOvr>
+</p:notes>
+</file>
+
+<file path=ppt/notesSlides/notesSlide8.xml><?xml version="1.0" encoding="utf-8"?>
+<p:notes xmlns:a="http://schemas.openxmlformats.org/drawingml/2006/main" xmlns:p="http://schemas.openxmlformats.org/presentationml/2006/main" xmlns:r="http://schemas.openxmlformats.org/officeDocument/2006/relationships">
+  <p:cSld>
+    <p:spTree>
+      <p:nvGrpSpPr>
+        <p:cNvPr id="1" name=""/>
+        <p:cNvGrpSpPr/>
+        <p:nvPr/>
+      </p:nvGrpSpPr>
+      <p:grpSpPr>
+        <a:xfrm>
+          <a:off x="0" y="0"/>
+          <a:ext cx="0" cy="0"/>
+          <a:chOff x="0" y="0"/>
+          <a:chExt cx="0" cy="0"/>
+        </a:xfrm>
+      </p:grpSpPr>
+      <p:sp>
+        <p:nvSpPr>
+          <p:cNvPr id="2" name="Slide Image Placeholder 1"/>
+          <p:cNvSpPr>
+            <a:spLocks noGrp="1"/>
+          </p:cNvSpPr>
+          <p:nvPr>
+            <p:ph type="sldImg" idx="2"/>
+          </p:nvPr>
+        </p:nvSpPr>
+        <p:spPr/>
+      </p:sp>
+      <p:sp>
+        <p:nvSpPr>
+          <p:cNvPr id="3" name="Notes Placeholder 2"/>
+          <p:cNvSpPr>
+            <a:spLocks noGrp="1"/>
+          </p:cNvSpPr>
+          <p:nvPr>
+            <p:ph type="body" idx="3" sz="quarter"/>
+          </p:nvPr>
+        </p:nvSpPr>
+        <p:spPr/>
+        <p:txBody>
+          <a:bodyPr/>
+          <a:lstStyle/>
+          <a:p>
+            <a:r>
+              <a:t>论文四句话：①压缩损伤分两种模式，轻微或崩溃，且无法从原模型预测（六个模型上证伪了所有已发表的预测指标）；②保护是崩溃修复工具而非通用增益，崩溃时它胜过包括最新旋转方法在内的所有替代方案；③元凶是压缩算法的纠错机制而非低精度本身；④评测警告：模型可能通过困惑度和MMLU检查但已丧失80%生成能力。</a:t>
+            </a:r>
+          </a:p>
+        </p:txBody>
+      </p:sp>
+      <p:sp>
+        <p:nvSpPr>
+          <p:cNvPr id="4" name="Slide Number Placeholder 3"/>
+          <p:cNvSpPr>
+            <a:spLocks noGrp="1"/>
+          </p:cNvSpPr>
+          <p:nvPr>
+            <p:ph type="sldNum" idx="5" sz="quarter"/>
+          </p:nvPr>
+        </p:nvSpPr>
+        <p:spPr/>
+      </p:sp>
+    </p:spTree>
+  </p:cSld>
+  <p:clrMapOvr>
+    <a:masterClrMapping/>
+  </p:clrMapOvr>
+</p:notes>
+</file>
+
+<file path=ppt/notesSlides/notesSlide9.xml><?xml version="1.0" encoding="utf-8"?>
+<p:notes xmlns:a="http://schemas.openxmlformats.org/drawingml/2006/main" xmlns:p="http://schemas.openxmlformats.org/presentationml/2006/main" xmlns:r="http://schemas.openxmlformats.org/officeDocument/2006/relationships">
+  <p:cSld>
+    <p:spTree>
+      <p:nvGrpSpPr>
+        <p:cNvPr id="1" name=""/>
+        <p:cNvGrpSpPr/>
+        <p:nvPr/>
+      </p:nvGrpSpPr>
+      <p:grpSpPr>
+        <a:xfrm>
+          <a:off x="0" y="0"/>
+          <a:ext cx="0" cy="0"/>
+          <a:chOff x="0" y="0"/>
+          <a:chExt cx="0" cy="0"/>
+        </a:xfrm>
+      </p:grpSpPr>
+      <p:sp>
+        <p:nvSpPr>
+          <p:cNvPr id="2" name="Slide Image Placeholder 1"/>
+          <p:cNvSpPr>
+            <a:spLocks noGrp="1"/>
+          </p:cNvSpPr>
+          <p:nvPr>
+            <p:ph type="sldImg" idx="2"/>
+          </p:nvPr>
+        </p:nvSpPr>
+        <p:spPr/>
+      </p:sp>
+      <p:sp>
+        <p:nvSpPr>
+          <p:cNvPr id="3" name="Notes Placeholder 2"/>
+          <p:cNvSpPr>
+            <a:spLocks noGrp="1"/>
+          </p:cNvSpPr>
+          <p:nvPr>
+            <p:ph type="body" idx="3" sz="quarter"/>
+          </p:nvPr>
+        </p:nvSpPr>
+        <p:spPr/>
+        <p:txBody>
+          <a:bodyPr/>
+          <a:lstStyle/>
+          <a:p>
+            <a:r>
+              <a:t>两篇最近的论文：TaCQ发明了我们用的重要性分数并展示保护有效——我们回答它没问的“何时、为何”；Super Weights是Mengxia学长的工作，发现每个模型有3-6个“超级权重”删一个就死——我们验证了只保护它们救不了GPTQ崩溃，崩溃涉及的是另外约10万个权重，两个工作互补不冲突。投稿：ICLR 2027（摘要9/18、全文9/25），被拒则带着审稿意见转投ACL 2027。</a:t>
+            </a:r>
+          </a:p>
+        </p:txBody>
+      </p:sp>
+      <p:sp>
+        <p:nvSpPr>
+          <p:cNvPr id="4" name="Slide Number Placeholder 3"/>
+          <p:cNvSpPr>
+            <a:spLocks noGrp="1"/>
+          </p:cNvSpPr>
+          <p:nvPr>
+            <p:ph type="sldNum" idx="5" sz="quarter"/>
+          </p:nvPr>
+        </p:nvSpPr>
+        <p:spPr/>
+      </p:sp>
+    </p:spTree>
+  </p:cSld>
+  <p:clrMapOvr>
+    <a:masterClrMapping/>
+  </p:clrMapOvr>
+</p:notes>
 </file>
 
 <file path=ppt/slideLayouts/slideLayout1.xml><?xml version="1.0" encoding="utf-8"?>
@@ -8556,7 +9606,7 @@
           <a:p>
             <a:pPr algn="l">
               <a:spcAft>
-                <a:spcPts val="700"/>
+                <a:spcPts val="400"/>
               </a:spcAft>
             </a:pPr>
             <a:r>
@@ -8575,8 +9625,27 @@
                 </a:solidFill>
                 <a:latin typeface="Georgia"/>
               </a:rPr>
-              <a:t>= keep a tiny fraction of weights (≤0.5%) uncompressed. We pick them with TaCQ, a published importance score.</a:t>
+              <a:t>= keep a tiny fraction of weights (≤0.5%) uncompressed, chosen by an importance score from the TaCQ paper (UNC, 2025):</a:t>
             </a:r>
+          </a:p>
+          <a:p>
+            <a:pPr algn="ctr">
+              <a:spcAft>
+                <a:spcPts val="300"/>
+              </a:spcAft>
+            </a:pPr>
+            <a:r>
+              <a:rPr sz="1250" b="1" i="0">
+                <a:solidFill>
+                  <a:srgbClr val="0C2340"/>
+                </a:solidFill>
+                <a:latin typeface="Georgia"/>
+              </a:rPr>
+              <a:t>importance = |weight| × |gradient| × |compression error|</a:t>
+            </a:r>
+          </a:p>
+          <a:p>
+            <a:pPr algn="ctr"/>
           </a:p>
         </p:txBody>
       </p:sp>
@@ -8620,17 +9689,17 @@
           <a:p>
             <a:pPr algn="l">
               <a:spcAft>
-                <a:spcPts val="1200"/>
+                <a:spcPts val="1000"/>
               </a:spcAft>
             </a:pPr>
             <a:r>
-              <a:rPr sz="1350" b="0" i="0">
+              <a:rPr sz="1300" b="0" i="0">
                 <a:solidFill>
                   <a:srgbClr val="0C2340"/>
                 </a:solidFill>
                 <a:latin typeface="Georgia"/>
               </a:rPr>
-              <a:t>Everyone assumes: protect the important weights and the model's abilities survive compression.</a:t>
+              <a:t>Prior papers (TaCQ, SpQR, Super Weights …) all report: “protecting important weights makes compressed models better” — implying it always helps, for every model.</a:t>
             </a:r>
           </a:p>
           <a:p>
@@ -8640,13 +9709,13 @@
               </a:spcAft>
             </a:pPr>
             <a:r>
-              <a:rPr sz="1350" b="1" i="0">
+              <a:rPr sz="1300" b="1" i="0">
                 <a:solidFill>
                   <a:srgbClr val="0C2340"/>
                 </a:solidFill>
                 <a:latin typeface="Georgia"/>
               </a:rPr>
-              <a:t>Nobody has tested when that is actually true. We did.</a:t>
+              <a:t>We ask: WHEN does it actually help? Answer: only when compression causes a collapse — otherwise never.</a:t>
             </a:r>
           </a:p>
           <a:p>
@@ -9076,7 +10145,7 @@
                 </a:solidFill>
                 <a:latin typeface="Georgia"/>
               </a:rPr>
-              <a:t>But When Compression Is Mild, Protection Does Nothing</a:t>
+              <a:t>The Other Half: No Collapse → Protection Is Useless</a:t>
             </a:r>
           </a:p>
         </p:txBody>
@@ -9116,8 +10185,8 @@
         </p:nvSpPr>
         <p:spPr>
           <a:xfrm>
-            <a:off x="411480" y="1417320"/>
-            <a:ext cx="8321040" cy="365760"/>
+            <a:off x="411480" y="1371600"/>
+            <a:ext cx="8321040" cy="685800"/>
           </a:xfrm>
           <a:prstGeom prst="rect">
             <a:avLst/>
@@ -9138,7 +10207,7 @@
                 </a:solidFill>
                 <a:latin typeface="Georgia"/>
               </a:rPr>
-              <a:t>Gain from the exact same protection, in the four cases where compression was mild:</a:t>
+              <a:t>Finding 2 showed protection rescues collapsed models. Here is the SAME protection applied to four models/settings that did NOT collapse — score before → after adding protection:</a:t>
             </a:r>
           </a:p>
         </p:txBody>
@@ -9151,8 +10220,8 @@
         </p:nvSpPr>
         <p:spPr>
           <a:xfrm>
-            <a:off x="502920" y="1965960"/>
-            <a:ext cx="1920240" cy="1005840"/>
+            <a:off x="457200" y="2194560"/>
+            <a:ext cx="1965960" cy="1188720"/>
           </a:xfrm>
           <a:prstGeom prst="rect">
             <a:avLst/>
@@ -9167,13 +10236,13 @@
           <a:p>
             <a:pPr algn="ctr"/>
             <a:r>
-              <a:rPr sz="3400" b="1" i="0">
+              <a:rPr sz="3000" b="1" i="0">
                 <a:solidFill>
                   <a:srgbClr val="5A5A5A"/>
                 </a:solidFill>
                 <a:latin typeface="Georgia"/>
               </a:rPr>
-              <a:t>+3.0</a:t>
+              <a:t>+0.030</a:t>
             </a:r>
           </a:p>
           <a:p>
@@ -9183,7 +10252,7 @@
               </a:spcBef>
             </a:pPr>
             <a:r>
-              <a:rPr sz="1100" b="0" i="0">
+              <a:rPr sz="1150" b="1" i="0">
                 <a:solidFill>
                   <a:srgbClr val="0C2340"/>
                 </a:solidFill>
@@ -9192,6 +10261,18 @@
               <a:t>Qwen 7B</a:t>
             </a:r>
           </a:p>
+          <a:p>
+            <a:pPr algn="ctr"/>
+            <a:r>
+              <a:rPr sz="1100" b="0" i="0">
+                <a:solidFill>
+                  <a:srgbClr val="5A5A5A"/>
+                </a:solidFill>
+                <a:latin typeface="Georgia"/>
+              </a:rPr>
+              <a:t>0.672 → 0.702</a:t>
+            </a:r>
+          </a:p>
         </p:txBody>
       </p:sp>
       <p:sp>
@@ -9202,8 +10283,8 @@
         </p:nvSpPr>
         <p:spPr>
           <a:xfrm>
-            <a:off x="2606039" y="1965960"/>
-            <a:ext cx="1920240" cy="1005840"/>
+            <a:off x="2578608" y="2194560"/>
+            <a:ext cx="1965960" cy="1188720"/>
           </a:xfrm>
           <a:prstGeom prst="rect">
             <a:avLst/>
@@ -9218,13 +10299,13 @@
           <a:p>
             <a:pPr algn="ctr"/>
             <a:r>
-              <a:rPr sz="3400" b="1" i="0">
+              <a:rPr sz="3000" b="1" i="0">
                 <a:solidFill>
                   <a:srgbClr val="5A5A5A"/>
                 </a:solidFill>
                 <a:latin typeface="Georgia"/>
               </a:rPr>
-              <a:t>+3.3</a:t>
+              <a:t>+0.033</a:t>
             </a:r>
           </a:p>
           <a:p>
@@ -9234,7 +10315,7 @@
               </a:spcBef>
             </a:pPr>
             <a:r>
-              <a:rPr sz="1100" b="0" i="0">
+              <a:rPr sz="1150" b="1" i="0">
                 <a:solidFill>
                   <a:srgbClr val="0C2340"/>
                 </a:solidFill>
@@ -9243,6 +10324,18 @@
               <a:t>Mistral 7B</a:t>
             </a:r>
           </a:p>
+          <a:p>
+            <a:pPr algn="ctr"/>
+            <a:r>
+              <a:rPr sz="1100" b="0" i="0">
+                <a:solidFill>
+                  <a:srgbClr val="5A5A5A"/>
+                </a:solidFill>
+                <a:latin typeface="Georgia"/>
+              </a:rPr>
+              <a:t>0.468 → 0.500</a:t>
+            </a:r>
+          </a:p>
         </p:txBody>
       </p:sp>
       <p:sp>
@@ -9253,8 +10346,8 @@
         </p:nvSpPr>
         <p:spPr>
           <a:xfrm>
-            <a:off x="4709159" y="1965960"/>
-            <a:ext cx="1920240" cy="1005840"/>
+            <a:off x="4700016" y="2194560"/>
+            <a:ext cx="1965960" cy="1188720"/>
           </a:xfrm>
           <a:prstGeom prst="rect">
             <a:avLst/>
@@ -9269,13 +10362,13 @@
           <a:p>
             <a:pPr algn="ctr"/>
             <a:r>
-              <a:rPr sz="3400" b="1" i="0">
+              <a:rPr sz="3000" b="1" i="0">
                 <a:solidFill>
                   <a:srgbClr val="5A5A5A"/>
                 </a:solidFill>
                 <a:latin typeface="Georgia"/>
               </a:rPr>
-              <a:t>+2.7</a:t>
+              <a:t>+0.027</a:t>
             </a:r>
           </a:p>
           <a:p>
@@ -9285,13 +10378,25 @@
               </a:spcBef>
             </a:pPr>
             <a:r>
+              <a:rPr sz="1150" b="1" i="0">
+                <a:solidFill>
+                  <a:srgbClr val="0C2340"/>
+                </a:solidFill>
+                <a:latin typeface="Georgia"/>
+              </a:rPr>
+              <a:t>Llama 8B, rotated</a:t>
+            </a:r>
+          </a:p>
+          <a:p>
+            <a:pPr algn="ctr"/>
+            <a:r>
               <a:rPr sz="1100" b="0" i="0">
                 <a:solidFill>
-                  <a:srgbClr val="0C2340"/>
+                  <a:srgbClr val="5A5A5A"/>
                 </a:solidFill>
                 <a:latin typeface="Georgia"/>
               </a:rPr>
-              <a:t>Llama 8B (rotated)</a:t>
+              <a:t>0.641 → 0.668</a:t>
             </a:r>
           </a:p>
         </p:txBody>
@@ -9304,8 +10409,8 @@
         </p:nvSpPr>
         <p:spPr>
           <a:xfrm>
-            <a:off x="6812279" y="1965960"/>
-            <a:ext cx="1920240" cy="1005840"/>
+            <a:off x="6821423" y="2194560"/>
+            <a:ext cx="1965960" cy="1188720"/>
           </a:xfrm>
           <a:prstGeom prst="rect">
             <a:avLst/>
@@ -9320,13 +10425,13 @@
           <a:p>
             <a:pPr algn="ctr"/>
             <a:r>
-              <a:rPr sz="3400" b="1" i="0">
+              <a:rPr sz="3000" b="1" i="0">
                 <a:solidFill>
                   <a:srgbClr val="5A5A5A"/>
                 </a:solidFill>
                 <a:latin typeface="Georgia"/>
               </a:rPr>
-              <a:t>+0.8</a:t>
+              <a:t>+0.008</a:t>
             </a:r>
           </a:p>
           <a:p>
@@ -9336,7 +10441,7 @@
               </a:spcBef>
             </a:pPr>
             <a:r>
-              <a:rPr sz="1100" b="0" i="0">
+              <a:rPr sz="1150" b="1" i="0">
                 <a:solidFill>
                   <a:srgbClr val="0C2340"/>
                 </a:solidFill>
@@ -9345,6 +10450,18 @@
               <a:t>Llama 8B @ 4-bit</a:t>
             </a:r>
           </a:p>
+          <a:p>
+            <a:pPr algn="ctr"/>
+            <a:r>
+              <a:rPr sz="1100" b="0" i="0">
+                <a:solidFill>
+                  <a:srgbClr val="5A5A5A"/>
+                </a:solidFill>
+                <a:latin typeface="Georgia"/>
+              </a:rPr>
+              <a:t>0.745 → 0.753</a:t>
+            </a:r>
+          </a:p>
         </p:txBody>
       </p:sp>
       <p:sp>
@@ -9355,8 +10472,8 @@
         </p:nvSpPr>
         <p:spPr>
           <a:xfrm>
-            <a:off x="411480" y="3200400"/>
-            <a:ext cx="8321040" cy="1463040"/>
+            <a:off x="411480" y="3657600"/>
+            <a:ext cx="8321040" cy="1005840"/>
           </a:xfrm>
           <a:prstGeom prst="rect">
             <a:avLst/>
@@ -9371,7 +10488,7 @@
           <a:p>
             <a:pPr algn="l">
               <a:spcAft>
-                <a:spcPts val="800"/>
+                <a:spcPts val="700"/>
               </a:spcAft>
             </a:pPr>
             <a:r>
@@ -9381,7 +10498,7 @@
                 </a:solidFill>
                 <a:latin typeface="Georgia"/>
               </a:rPr>
-              <a:t>All four gains are within statistical noise </a:t>
+              <a:t>All four gains are statistically zero </a:t>
             </a:r>
             <a:r>
               <a:rPr sz="1350" b="0" i="0">
@@ -9390,23 +10507,7 @@
                 </a:solidFill>
                 <a:latin typeface="Georgia"/>
               </a:rPr>
-              <a:t>(every 95% confidence interval crosses zero; random protection even “wins” one case).</a:t>
-            </a:r>
-          </a:p>
-          <a:p>
-            <a:pPr algn="l">
-              <a:spcAft>
-                <a:spcPts val="800"/>
-              </a:spcAft>
-            </a:pPr>
-            <a:r>
-              <a:rPr sz="1350" b="0" i="0">
-                <a:solidFill>
-                  <a:srgbClr val="0C2340"/>
-                </a:solidFill>
-                <a:latin typeface="Georgia"/>
-              </a:rPr>
-              <a:t>Even the attention heads that causally drive instruction-following — which we identified first — don't help when protected. </a:t>
+              <a:t>— compare the rescues in Finding 2: +0.49 and +0.37.</a:t>
             </a:r>
           </a:p>
           <a:p>
@@ -9418,7 +10519,7 @@
                 </a:solidFill>
                 <a:latin typeface="Georgia"/>
               </a:rPr>
-              <a:t>Knowing which parts are important ≠ knowing what to protect. Protection only matters when there is a collapse to prevent.</a:t>
+              <a:t>So protection is an emergency repair, not a general upgrade: it only matters when there is a collapse to prevent.</a:t>
             </a:r>
           </a:p>
         </p:txBody>
@@ -9509,8 +10610,8 @@
         </p:nvSpPr>
         <p:spPr>
           <a:xfrm>
-            <a:off x="411480" y="1417320"/>
-            <a:ext cx="8321040" cy="365760"/>
+            <a:off x="411480" y="1371600"/>
+            <a:ext cx="8321040" cy="548640"/>
           </a:xfrm>
           <a:prstGeom prst="rect">
             <a:avLst/>
@@ -9531,7 +10632,7 @@
                 </a:solidFill>
                 <a:latin typeface="Georgia"/>
               </a:rPr>
-              <a:t>Same Llama-8B model, three ways to compress to 3 bits:</a:t>
+              <a:t>Same Llama-8B model, compressed to 3 bits in three different ways (“protection” = the same top-0.5% weight set as in Finding 2):</a:t>
             </a:r>
           </a:p>
         </p:txBody>
@@ -9594,7 +10695,7 @@
                 </a:solidFill>
                 <a:latin typeface="Georgia"/>
               </a:rPr>
-              <a:t>no error correction</a:t>
+              <a:t>no error correction → damaged, not dead</a:t>
             </a:r>
           </a:p>
         </p:txBody>
@@ -9657,7 +10758,7 @@
                 </a:solidFill>
                 <a:latin typeface="Georgia"/>
               </a:rPr>
-              <a:t>with error correction</a:t>
+              <a:t>error correction on → COLLAPSE</a:t>
             </a:r>
           </a:p>
         </p:txBody>
@@ -9708,7 +10809,7 @@
                 </a:solidFill>
                 <a:latin typeface="Georgia"/>
               </a:rPr>
-              <a:t>smart GPTQ</a:t>
+              <a:t>smart GPTQ + protection</a:t>
             </a:r>
           </a:p>
           <a:p>
@@ -9720,7 +10821,7 @@
                 </a:solidFill>
                 <a:latin typeface="Georgia"/>
               </a:rPr>
-              <a:t>+ protect critical weights</a:t>
+              <a:t>correction told to skip those 0.5%</a:t>
             </a:r>
           </a:p>
         </p:txBody>
@@ -9897,7 +10998,7 @@
                 </a:solidFill>
                 <a:latin typeface="Georgia"/>
               </a:rPr>
-              <a:t>Compressed Qwen-14B, asked a math problem:</a:t>
+              <a:t>The compressed Qwen-14B gets stuck repeating itself. A real answer it gave to a grade-school math problem:</a:t>
             </a:r>
           </a:p>
         </p:txBody>
@@ -9946,8 +11047,8 @@
         </p:nvSpPr>
         <p:spPr>
           <a:xfrm>
-            <a:off x="411480" y="3749039"/>
-            <a:ext cx="4480560" cy="822960"/>
+            <a:off x="411480" y="3703320"/>
+            <a:ext cx="4480560" cy="914400"/>
           </a:xfrm>
           <a:prstGeom prst="rect">
             <a:avLst/>
@@ -9968,7 +11069,7 @@
                 </a:solidFill>
                 <a:latin typeface="Georgia"/>
               </a:rPr>
-              <a:t>69% of its answers get stuck in loops like this (original model: 0.7%).</a:t>
+              <a:t>69 out of every 100 answers end in a loop like this. The uncompressed model: fewer than 1 in 100.</a:t>
             </a:r>
           </a:p>
         </p:txBody>
@@ -10003,7 +11104,7 @@
                 </a:solidFill>
                 <a:latin typeface="Georgia"/>
               </a:rPr>
-              <a:t>YET THE STANDARD CHECKS SAY “FINE”:</a:t>
+              <a:t>YET THE FIELD'S STANDARD CHECKS SAY “FINE”:</a:t>
             </a:r>
           </a:p>
         </p:txBody>
@@ -10016,7 +11117,7 @@
         </p:nvSpPr>
         <p:spPr>
           <a:xfrm>
-            <a:off x="5257800" y="1874519"/>
+            <a:off x="5257800" y="1828800"/>
             <a:ext cx="3520440" cy="1005840"/>
           </a:xfrm>
           <a:prstGeom prst="rect">
@@ -10032,13 +11133,13 @@
           <a:p>
             <a:pPr algn="ctr"/>
             <a:r>
-              <a:rPr sz="2800" b="1" i="0">
+              <a:rPr sz="2400" b="1" i="0">
                 <a:solidFill>
                   <a:srgbClr val="0C2340"/>
                 </a:solidFill>
                 <a:latin typeface="Georgia"/>
               </a:rPr>
-              <a:t>+35%</a:t>
+              <a:t>looks fine</a:t>
             </a:r>
           </a:p>
           <a:p>
@@ -10054,7 +11155,7 @@
                 </a:solidFill>
                 <a:latin typeface="Georgia"/>
               </a:rPr>
-              <a:t>perplexity (the field's default quality metric) — within the normal range for mild compression</a:t>
+              <a:t>on perplexity, the default quality check (+35%, same as the harmless cases)</a:t>
             </a:r>
           </a:p>
         </p:txBody>
@@ -10067,7 +11168,7 @@
         </p:nvSpPr>
         <p:spPr>
           <a:xfrm>
-            <a:off x="5257800" y="2834640"/>
+            <a:off x="5257800" y="2697480"/>
             <a:ext cx="3520440" cy="1005840"/>
           </a:xfrm>
           <a:prstGeom prst="rect">
@@ -10083,13 +11184,13 @@
           <a:p>
             <a:pPr algn="ctr"/>
             <a:r>
-              <a:rPr sz="2800" b="1" i="0">
+              <a:rPr sz="2400" b="1" i="0">
                 <a:solidFill>
                   <a:srgbClr val="0C2340"/>
                 </a:solidFill>
                 <a:latin typeface="Georgia"/>
               </a:rPr>
-              <a:t>−6 pts</a:t>
+              <a:t>looks fine</a:t>
             </a:r>
           </a:p>
           <a:p>
@@ -10105,7 +11206,7 @@
                 </a:solidFill>
                 <a:latin typeface="Georgia"/>
               </a:rPr>
-              <a:t>knowledge quiz (MMLU) — looks like mild damage</a:t>
+              <a:t>on the MMLU knowledge quiz (−6 points, same as the harmless cases)</a:t>
             </a:r>
           </a:p>
         </p:txBody>
@@ -10118,7 +11219,7 @@
         </p:nvSpPr>
         <p:spPr>
           <a:xfrm>
-            <a:off x="5257800" y="3794760"/>
+            <a:off x="5257800" y="3611880"/>
             <a:ext cx="3520440" cy="1005840"/>
           </a:xfrm>
           <a:prstGeom prst="rect">
@@ -10134,13 +11235,13 @@
           <a:p>
             <a:pPr algn="ctr"/>
             <a:r>
-              <a:rPr sz="2800" b="1" i="0">
+              <a:rPr sz="2400" b="1" i="0">
                 <a:solidFill>
                   <a:srgbClr val="9B1B1B"/>
                 </a:solidFill>
                 <a:latin typeface="Georgia"/>
               </a:rPr>
-              <a:t>−80 pts</a:t>
+              <a:t>0.93 → 0.13</a:t>
             </a:r>
           </a:p>
           <a:p>
@@ -10156,7 +11257,7 @@
                 </a:solidFill>
                 <a:latin typeface="Georgia"/>
               </a:rPr>
-              <a:t>actual math ability — the damage the checks miss</a:t>
+              <a:t>actual math score — the collapse both checks failed to notice</a:t>
             </a:r>
           </a:p>
         </p:txBody>
@@ -10418,7 +11519,40 @@
       <p:grpSpPr/>
       <p:sp>
         <p:nvSpPr>
-          <p:cNvPr id="2" name="Subtitle 1"/>
+          <p:cNvPr id="4" name="Title 3"/>
+          <p:cNvSpPr>
+            <a:spLocks noGrp="1"/>
+          </p:cNvSpPr>
+          <p:nvPr>
+            <p:ph type="title"/>
+          </p:nvPr>
+        </p:nvSpPr>
+        <p:spPr>
+          <a:xfrm>
+            <a:off x="411480" y="658368"/>
+            <a:ext cx="8321040" cy="658368"/>
+          </a:xfrm>
+        </p:spPr>
+        <p:txBody>
+          <a:bodyPr wrap="square"/>
+          <a:lstStyle/>
+          <a:p>
+            <a:pPr algn="l"/>
+            <a:r>
+              <a:rPr sz="2600" b="1">
+                <a:solidFill>
+                  <a:srgbClr val="0C2340"/>
+                </a:solidFill>
+                <a:latin typeface="Georgia"/>
+              </a:rPr>
+              <a:t>The Two Closest Papers — and Where This Goes</a:t>
+            </a:r>
+          </a:p>
+        </p:txBody>
+      </p:sp>
+      <p:sp>
+        <p:nvSpPr>
+          <p:cNvPr id="5" name="Subtitle 4"/>
           <p:cNvSpPr>
             <a:spLocks noGrp="1"/>
           </p:cNvSpPr>
@@ -10438,21 +11572,21 @@
                 </a:solidFill>
                 <a:latin typeface="Georgia"/>
               </a:rPr>
-              <a:t>PLAN</a:t>
+              <a:t>RELATED WORK &amp; PLAN</a:t>
             </a:r>
           </a:p>
         </p:txBody>
       </p:sp>
       <p:sp>
         <p:nvSpPr>
-          <p:cNvPr id="3" name="TextBox 2"/>
+          <p:cNvPr id="6" name="TextBox 5"/>
           <p:cNvSpPr txBox="1"/>
           <p:nvPr/>
         </p:nvSpPr>
         <p:spPr>
           <a:xfrm>
-            <a:off x="411480" y="658368"/>
-            <a:ext cx="8321040" cy="640080"/>
+            <a:off x="411480" y="1417320"/>
+            <a:ext cx="4892040" cy="3291840"/>
           </a:xfrm>
           <a:prstGeom prst="rect">
             <a:avLst/>
@@ -10465,29 +11599,77 @@
           </a:bodyPr>
           <a:lstStyle/>
           <a:p>
+            <a:pPr algn="l">
+              <a:spcAft>
+                <a:spcPts val="400"/>
+              </a:spcAft>
+            </a:pPr>
+            <a:r>
+              <a:rPr sz="1300" b="1" i="0">
+                <a:solidFill>
+                  <a:srgbClr val="AE9141"/>
+                </a:solidFill>
+                <a:latin typeface="Georgia"/>
+              </a:rPr>
+              <a:t>TaCQ (UNC Chapel Hill, 2025)</a:t>
+            </a:r>
+          </a:p>
+          <a:p>
+            <a:pPr algn="l">
+              <a:spcAft>
+                <a:spcPts val="1000"/>
+              </a:spcAft>
+            </a:pPr>
+            <a:r>
+              <a:rPr sz="1250" b="0" i="0">
+                <a:solidFill>
+                  <a:srgbClr val="0C2340"/>
+                </a:solidFill>
+                <a:latin typeface="Georgia"/>
+              </a:rPr>
+              <a:t>Invented the importance score we use, and showed protection improves compressed models. We answer the question they never asked: WHEN does it help (only in collapses) and WHY (the error-correction mechanism).</a:t>
+            </a:r>
+          </a:p>
+          <a:p>
+            <a:pPr algn="l">
+              <a:spcAft>
+                <a:spcPts val="400"/>
+              </a:spcAft>
+            </a:pPr>
+            <a:r>
+              <a:rPr sz="1300" b="1" i="0">
+                <a:solidFill>
+                  <a:srgbClr val="AE9141"/>
+                </a:solidFill>
+                <a:latin typeface="Georgia"/>
+              </a:rPr>
+              <a:t>Super Weights (Mengxia Yu, ND + Apple, 2024)</a:t>
+            </a:r>
+          </a:p>
+          <a:p>
             <a:pPr algn="l"/>
             <a:r>
-              <a:rPr sz="2600" b="1" i="0">
+              <a:rPr sz="1250" b="0" i="0">
                 <a:solidFill>
                   <a:srgbClr val="0C2340"/>
                 </a:solidFill>
                 <a:latin typeface="Georgia"/>
               </a:rPr>
-              <a:t>Where This Goes</a:t>
+              <a:t>Found that every LLM has 3–6 individual “super weights” — delete one and the model dies. We tested them: protecting ONLY those few does not prevent the collapse (0.16). The collapse involves a different, ~100,000-weight set. Complementary, not competing.</a:t>
             </a:r>
           </a:p>
         </p:txBody>
       </p:sp>
       <p:sp>
         <p:nvSpPr>
-          <p:cNvPr id="4" name="TextBox 3"/>
+          <p:cNvPr id="7" name="TextBox 6"/>
           <p:cNvSpPr txBox="1"/>
           <p:nvPr/>
         </p:nvSpPr>
         <p:spPr>
           <a:xfrm>
-            <a:off x="777240" y="2148840"/>
-            <a:ext cx="2423160" cy="548640"/>
+            <a:off x="5715000" y="1417320"/>
+            <a:ext cx="3063240" cy="3291840"/>
           </a:xfrm>
           <a:prstGeom prst="rect">
             <a:avLst/>
@@ -10500,44 +11682,9 @@
           </a:bodyPr>
           <a:lstStyle/>
           <a:p>
-            <a:pPr algn="l"/>
-            <a:r>
-              <a:rPr sz="1350" b="1" i="0">
-                <a:solidFill>
-                  <a:srgbClr val="AE9141"/>
-                </a:solidFill>
-                <a:latin typeface="Georgia"/>
-              </a:rPr>
-              <a:t>Target: ICLR 2027</a:t>
-            </a:r>
-          </a:p>
-        </p:txBody>
-      </p:sp>
-      <p:sp>
-        <p:nvSpPr>
-          <p:cNvPr id="5" name="TextBox 4"/>
-          <p:cNvSpPr txBox="1"/>
-          <p:nvPr/>
-        </p:nvSpPr>
-        <p:spPr>
-          <a:xfrm>
-            <a:off x="777240" y="2743200"/>
-            <a:ext cx="2423160" cy="1828800"/>
-          </a:xfrm>
-          <a:prstGeom prst="rect">
-            <a:avLst/>
-          </a:prstGeom>
-          <a:noFill/>
-        </p:spPr>
-        <p:txBody>
-          <a:bodyPr wrap="square" lIns="0" rIns="0" tIns="0" bIns="0">
-            <a:spAutoFit/>
-          </a:bodyPr>
-          <a:lstStyle/>
-          <a:p>
             <a:pPr algn="l">
               <a:spcAft>
-                <a:spcPts val="700"/>
+                <a:spcPts val="400"/>
               </a:spcAft>
             </a:pPr>
             <a:r>
@@ -10547,22 +11694,29 @@
                 </a:solidFill>
                 <a:latin typeface="Georgia"/>
               </a:rPr>
-              <a:t>—  </a:t>
+              <a:t>TARGET</a:t>
             </a:r>
+          </a:p>
+          <a:p>
+            <a:pPr algn="l">
+              <a:spcAft>
+                <a:spcPts val="1000"/>
+              </a:spcAft>
+            </a:pPr>
             <a:r>
-              <a:rPr sz="1100" b="0" i="0">
+              <a:rPr sz="1250" b="0" i="0">
                 <a:solidFill>
                   <a:srgbClr val="0C2340"/>
                 </a:solidFill>
                 <a:latin typeface="Georgia"/>
               </a:rPr>
-              <a:t>Abstract due Sept 18, paper Sept 25</a:t>
+              <a:t>ICLR 2027 — abstract Sept 18, paper Sept 25. Backup: ACL 2027 (Feb), reusing the ICLR reviews.</a:t>
             </a:r>
           </a:p>
           <a:p>
             <a:pPr algn="l">
               <a:spcAft>
-                <a:spcPts val="700"/>
+                <a:spcPts val="400"/>
               </a:spcAft>
             </a:pPr>
             <a:r>
@@ -10572,257 +11726,19 @@
                 </a:solidFill>
                 <a:latin typeface="Georgia"/>
               </a:rPr>
-              <a:t>—  </a:t>
+              <a:t>READINESS</a:t>
             </a:r>
-            <a:r>
-              <a:rPr sz="1100" b="0" i="0">
-                <a:solidFill>
-                  <a:srgbClr val="0C2340"/>
-                </a:solidFill>
-                <a:latin typeface="Georgia"/>
-              </a:rPr>
-              <a:t>Backup: ACL 2027 (Feb) — with ICLR reviews in hand</a:t>
-            </a:r>
-          </a:p>
-        </p:txBody>
-      </p:sp>
-      <p:sp>
-        <p:nvSpPr>
-          <p:cNvPr id="6" name="TextBox 5"/>
-          <p:cNvSpPr txBox="1"/>
-          <p:nvPr/>
-        </p:nvSpPr>
-        <p:spPr>
-          <a:xfrm>
-            <a:off x="3474720" y="2148840"/>
-            <a:ext cx="2423160" cy="548640"/>
-          </a:xfrm>
-          <a:prstGeom prst="rect">
-            <a:avLst/>
-          </a:prstGeom>
-          <a:noFill/>
-        </p:spPr>
-        <p:txBody>
-          <a:bodyPr wrap="square" lIns="0" rIns="0" tIns="0" bIns="0">
-            <a:spAutoFit/>
-          </a:bodyPr>
-          <a:lstStyle/>
+          </a:p>
           <a:p>
             <a:pPr algn="l"/>
             <a:r>
-              <a:rPr sz="1350" b="1" i="0">
-                <a:solidFill>
-                  <a:srgbClr val="AE9141"/>
+              <a:rPr sz="1250" b="0" i="0">
+                <a:solidFill>
+                  <a:srgbClr val="0C2340"/>
                 </a:solidFill>
                 <a:latin typeface="Georgia"/>
               </a:rPr>
-              <a:t>Positioning</a:t>
-            </a:r>
-          </a:p>
-        </p:txBody>
-      </p:sp>
-      <p:sp>
-        <p:nvSpPr>
-          <p:cNvPr id="7" name="TextBox 6"/>
-          <p:cNvSpPr txBox="1"/>
-          <p:nvPr/>
-        </p:nvSpPr>
-        <p:spPr>
-          <a:xfrm>
-            <a:off x="3474720" y="2743200"/>
-            <a:ext cx="2423160" cy="1828800"/>
-          </a:xfrm>
-          <a:prstGeom prst="rect">
-            <a:avLst/>
-          </a:prstGeom>
-          <a:noFill/>
-        </p:spPr>
-        <p:txBody>
-          <a:bodyPr wrap="square" lIns="0" rIns="0" tIns="0" bIns="0">
-            <a:spAutoFit/>
-          </a:bodyPr>
-          <a:lstStyle/>
-          <a:p>
-            <a:pPr algn="l">
-              <a:spcAft>
-                <a:spcPts val="700"/>
-              </a:spcAft>
-            </a:pPr>
-            <a:r>
-              <a:rPr sz="1100" b="1" i="0">
-                <a:solidFill>
-                  <a:srgbClr val="AE9141"/>
-                </a:solidFill>
-                <a:latin typeface="Georgia"/>
-              </a:rPr>
-              <a:t>—  </a:t>
-            </a:r>
-            <a:r>
-              <a:rPr sz="1100" b="0" i="0">
-                <a:solidFill>
-                  <a:srgbClr val="0C2340"/>
-                </a:solidFill>
-                <a:latin typeface="Georgia"/>
-              </a:rPr>
-              <a:t>Analysis paper: “when &amp; why”</a:t>
-            </a:r>
-          </a:p>
-          <a:p>
-            <a:pPr algn="l">
-              <a:spcAft>
-                <a:spcPts val="700"/>
-              </a:spcAft>
-            </a:pPr>
-            <a:r>
-              <a:rPr sz="1100" b="1" i="0">
-                <a:solidFill>
-                  <a:srgbClr val="AE9141"/>
-                </a:solidFill>
-                <a:latin typeface="Georgia"/>
-              </a:rPr>
-              <a:t>—  </a:t>
-            </a:r>
-            <a:r>
-              <a:rPr sz="1100" b="0" i="0">
-                <a:solidFill>
-                  <a:srgbClr val="0C2340"/>
-                </a:solidFill>
-                <a:latin typeface="Georgia"/>
-              </a:rPr>
-              <a:t>TaCQ made the tool; we mapped when it works</a:t>
-            </a:r>
-          </a:p>
-          <a:p>
-            <a:pPr algn="l">
-              <a:spcAft>
-                <a:spcPts val="700"/>
-              </a:spcAft>
-            </a:pPr>
-            <a:r>
-              <a:rPr sz="1100" b="1" i="0">
-                <a:solidFill>
-                  <a:srgbClr val="AE9141"/>
-                </a:solidFill>
-                <a:latin typeface="Georgia"/>
-              </a:rPr>
-              <a:t>—  </a:t>
-            </a:r>
-            <a:r>
-              <a:rPr sz="1100" b="0" i="0">
-                <a:solidFill>
-                  <a:srgbClr val="0C2340"/>
-                </a:solidFill>
-                <a:latin typeface="Georgia"/>
-              </a:rPr>
-              <a:t>Extends ND Super-Weights line (Mengxia)</a:t>
-            </a:r>
-          </a:p>
-        </p:txBody>
-      </p:sp>
-      <p:sp>
-        <p:nvSpPr>
-          <p:cNvPr id="8" name="TextBox 7"/>
-          <p:cNvSpPr txBox="1"/>
-          <p:nvPr/>
-        </p:nvSpPr>
-        <p:spPr>
-          <a:xfrm>
-            <a:off x="6172200" y="2148840"/>
-            <a:ext cx="2423160" cy="548640"/>
-          </a:xfrm>
-          <a:prstGeom prst="rect">
-            <a:avLst/>
-          </a:prstGeom>
-          <a:noFill/>
-        </p:spPr>
-        <p:txBody>
-          <a:bodyPr wrap="square" lIns="0" rIns="0" tIns="0" bIns="0">
-            <a:spAutoFit/>
-          </a:bodyPr>
-          <a:lstStyle/>
-          <a:p>
-            <a:pPr algn="l"/>
-            <a:r>
-              <a:rPr sz="1350" b="1" i="0">
-                <a:solidFill>
-                  <a:srgbClr val="AE9141"/>
-                </a:solidFill>
-                <a:latin typeface="Georgia"/>
-              </a:rPr>
-              <a:t>Ready for reviewers</a:t>
-            </a:r>
-          </a:p>
-        </p:txBody>
-      </p:sp>
-      <p:sp>
-        <p:nvSpPr>
-          <p:cNvPr id="9" name="TextBox 8"/>
-          <p:cNvSpPr txBox="1"/>
-          <p:nvPr/>
-        </p:nvSpPr>
-        <p:spPr>
-          <a:xfrm>
-            <a:off x="6172200" y="2743200"/>
-            <a:ext cx="2423160" cy="1828800"/>
-          </a:xfrm>
-          <a:prstGeom prst="rect">
-            <a:avLst/>
-          </a:prstGeom>
-          <a:noFill/>
-        </p:spPr>
-        <p:txBody>
-          <a:bodyPr wrap="square" lIns="0" rIns="0" tIns="0" bIns="0">
-            <a:spAutoFit/>
-          </a:bodyPr>
-          <a:lstStyle/>
-          <a:p>
-            <a:pPr algn="l">
-              <a:spcAft>
-                <a:spcPts val="700"/>
-              </a:spcAft>
-            </a:pPr>
-            <a:r>
-              <a:rPr sz="1100" b="1" i="0">
-                <a:solidFill>
-                  <a:srgbClr val="AE9141"/>
-                </a:solidFill>
-                <a:latin typeface="Georgia"/>
-              </a:rPr>
-              <a:t>—  </a:t>
-            </a:r>
-            <a:r>
-              <a:rPr sz="1100" b="0" i="0">
-                <a:solidFill>
-                  <a:srgbClr val="0C2340"/>
-                </a:solidFill>
-                <a:latin typeface="Georgia"/>
-              </a:rPr>
-              <a:t>Every claim: controls + replicates + CIs</a:t>
-            </a:r>
-          </a:p>
-          <a:p>
-            <a:pPr algn="l">
-              <a:spcAft>
-                <a:spcPts val="700"/>
-              </a:spcAft>
-            </a:pPr>
-            <a:r>
-              <a:rPr sz="1100" b="1" i="0">
-                <a:solidFill>
-                  <a:srgbClr val="AE9141"/>
-                </a:solidFill>
-                <a:latin typeface="Georgia"/>
-              </a:rPr>
-              <a:t>—  </a:t>
-            </a:r>
-            <a:r>
-              <a:rPr sz="1100" b="0" i="0">
-                <a:solidFill>
-                  <a:srgbClr val="0C2340"/>
-                </a:solidFill>
-                <a:latin typeface="Georgia"/>
-              </a:rPr>
-              <a:t>Backup experiments staged (70B, AWQ)</a:t>
+              <a:t>Every claim has controls, replicates, and confidence intervals; backup experiments (70B model, another compressor) are staged for the rebuttal phase.</a:t>
             </a:r>
           </a:p>
         </p:txBody>
@@ -12339,4 +13255,324 @@
     </a:ext>
   </a:extLst>
 </a:theme>
+</file>
+
+<file path=ppt/theme/theme2.xml><?xml version="1.0" encoding="utf-8"?>
+<a:theme xmlns:a="http://schemas.openxmlformats.org/drawingml/2006/main" name="Office Theme">
+  <a:themeElements>
+    <a:clrScheme name="Office">
+      <a:dk1>
+        <a:sysClr val="windowText" lastClr="000000"/>
+      </a:dk1>
+      <a:lt1>
+        <a:sysClr val="window" lastClr="FFFFFF"/>
+      </a:lt1>
+      <a:dk2>
+        <a:srgbClr val="1F497D"/>
+      </a:dk2>
+      <a:lt2>
+        <a:srgbClr val="EEECE1"/>
+      </a:lt2>
+      <a:accent1>
+        <a:srgbClr val="4F81BD"/>
+      </a:accent1>
+      <a:accent2>
+        <a:srgbClr val="C0504D"/>
+      </a:accent2>
+      <a:accent3>
+        <a:srgbClr val="9BBB59"/>
+      </a:accent3>
+      <a:accent4>
+        <a:srgbClr val="8064A2"/>
+      </a:accent4>
+      <a:accent5>
+        <a:srgbClr val="4BACC6"/>
+      </a:accent5>
+      <a:accent6>
+        <a:srgbClr val="F79646"/>
+      </a:accent6>
+      <a:hlink>
+        <a:srgbClr val="0000FF"/>
+      </a:hlink>
+      <a:folHlink>
+        <a:srgbClr val="800080"/>
+      </a:folHlink>
+    </a:clrScheme>
+    <a:fontScheme name="Office">
+      <a:majorFont>
+        <a:latin typeface="Calibri"/>
+        <a:ea typeface=""/>
+        <a:cs typeface=""/>
+        <a:font script="Jpan" typeface="ＭＳ Ｐゴシック"/>
+        <a:font script="Hang" typeface="맑은 고딕"/>
+        <a:font script="Hans" typeface="宋体"/>
+        <a:font script="Hant" typeface="新細明體"/>
+        <a:font script="Arab" typeface="Times New Roman"/>
+        <a:font script="Hebr" typeface="Times New Roman"/>
+        <a:font script="Thai" typeface="Angsana New"/>
+        <a:font script="Ethi" typeface="Nyala"/>
+        <a:font script="Beng" typeface="Vrinda"/>
+        <a:font script="Gujr" typeface="Shruti"/>
+        <a:font script="Khmr" typeface="MoolBoran"/>
+        <a:font script="Knda" typeface="Tunga"/>
+        <a:font script="Guru" typeface="Raavi"/>
+        <a:font script="Cans" typeface="Euphemia"/>
+        <a:font script="Cher" typeface="Plantagenet Cherokee"/>
+        <a:font script="Yiii" typeface="Microsoft Yi Baiti"/>
+        <a:font script="Tibt" typeface="Microsoft Himalaya"/>
+        <a:font script="Thaa" typeface="MV Boli"/>
+        <a:font script="Deva" typeface="Mangal"/>
+        <a:font script="Telu" typeface="Gautami"/>
+        <a:font script="Taml" typeface="Latha"/>
+        <a:font script="Syrc" typeface="Estrangelo Edessa"/>
+        <a:font script="Orya" typeface="Kalinga"/>
+        <a:font script="Mlym" typeface="Kartika"/>
+        <a:font script="Laoo" typeface="DokChampa"/>
+        <a:font script="Sinh" typeface="Iskoola Pota"/>
+        <a:font script="Mong" typeface="Mongolian Baiti"/>
+        <a:font script="Viet" typeface="Times New Roman"/>
+        <a:font script="Uigh" typeface="Microsoft Uighur"/>
+        <a:font script="Geor" typeface="Sylfaen"/>
+      </a:majorFont>
+      <a:minorFont>
+        <a:latin typeface="Calibri"/>
+        <a:ea typeface=""/>
+        <a:cs typeface=""/>
+        <a:font script="Jpan" typeface="ＭＳ Ｐゴシック"/>
+        <a:font script="Hang" typeface="맑은 고딕"/>
+        <a:font script="Hans" typeface="宋体"/>
+        <a:font script="Hant" typeface="新細明體"/>
+        <a:font script="Arab" typeface="Arial"/>
+        <a:font script="Hebr" typeface="Arial"/>
+        <a:font script="Thai" typeface="Cordia New"/>
+        <a:font script="Ethi" typeface="Nyala"/>
+        <a:font script="Beng" typeface="Vrinda"/>
+        <a:font script="Gujr" typeface="Shruti"/>
+        <a:font script="Khmr" typeface="DaunPenh"/>
+        <a:font script="Knda" typeface="Tunga"/>
+        <a:font script="Guru" typeface="Raavi"/>
+        <a:font script="Cans" typeface="Euphemia"/>
+        <a:font script="Cher" typeface="Plantagenet Cherokee"/>
+        <a:font script="Yiii" typeface="Microsoft Yi Baiti"/>
+        <a:font script="Tibt" typeface="Microsoft Himalaya"/>
+        <a:font script="Thaa" typeface="MV Boli"/>
+        <a:font script="Deva" typeface="Mangal"/>
+        <a:font script="Telu" typeface="Gautami"/>
+        <a:font script="Taml" typeface="Latha"/>
+        <a:font script="Syrc" typeface="Estrangelo Edessa"/>
+        <a:font script="Orya" typeface="Kalinga"/>
+        <a:font script="Mlym" typeface="Kartika"/>
+        <a:font script="Laoo" typeface="DokChampa"/>
+        <a:font script="Sinh" typeface="Iskoola Pota"/>
+        <a:font script="Mong" typeface="Mongolian Baiti"/>
+        <a:font script="Viet" typeface="Arial"/>
+        <a:font script="Uigh" typeface="Microsoft Uighur"/>
+        <a:font script="Geor" typeface="Sylfaen"/>
+      </a:minorFont>
+    </a:fontScheme>
+    <a:fmtScheme name="Office">
+      <a:fillStyleLst>
+        <a:solidFill>
+          <a:schemeClr val="phClr"/>
+        </a:solidFill>
+        <a:gradFill rotWithShape="1">
+          <a:gsLst>
+            <a:gs pos="0">
+              <a:schemeClr val="phClr">
+                <a:tint val="50000"/>
+                <a:satMod val="300000"/>
+              </a:schemeClr>
+            </a:gs>
+            <a:gs pos="35000">
+              <a:schemeClr val="phClr">
+                <a:tint val="37000"/>
+                <a:satMod val="300000"/>
+              </a:schemeClr>
+            </a:gs>
+            <a:gs pos="100000">
+              <a:schemeClr val="phClr">
+                <a:tint val="15000"/>
+                <a:satMod val="350000"/>
+              </a:schemeClr>
+            </a:gs>
+          </a:gsLst>
+          <a:lin ang="16200000" scaled="1"/>
+        </a:gradFill>
+        <a:gradFill rotWithShape="1">
+          <a:gsLst>
+            <a:gs pos="0">
+              <a:schemeClr val="phClr">
+                <a:tint val="100000"/>
+                <a:shade val="100000"/>
+                <a:satMod val="130000"/>
+              </a:schemeClr>
+            </a:gs>
+            <a:gs pos="100000">
+              <a:schemeClr val="phClr">
+                <a:tint val="50000"/>
+                <a:shade val="100000"/>
+                <a:satMod val="350000"/>
+              </a:schemeClr>
+            </a:gs>
+          </a:gsLst>
+          <a:lin ang="16200000" scaled="0"/>
+        </a:gradFill>
+      </a:fillStyleLst>
+      <a:lnStyleLst>
+        <a:ln w="9525" cap="flat" cmpd="sng" algn="ctr">
+          <a:solidFill>
+            <a:schemeClr val="phClr">
+              <a:shade val="95000"/>
+              <a:satMod val="105000"/>
+            </a:schemeClr>
+          </a:solidFill>
+          <a:prstDash val="solid"/>
+        </a:ln>
+        <a:ln w="25400" cap="flat" cmpd="sng" algn="ctr">
+          <a:solidFill>
+            <a:schemeClr val="phClr"/>
+          </a:solidFill>
+          <a:prstDash val="solid"/>
+        </a:ln>
+        <a:ln w="38100" cap="flat" cmpd="sng" algn="ctr">
+          <a:solidFill>
+            <a:schemeClr val="phClr"/>
+          </a:solidFill>
+          <a:prstDash val="solid"/>
+        </a:ln>
+      </a:lnStyleLst>
+      <a:effectStyleLst>
+        <a:effectStyle>
+          <a:effectLst>
+            <a:outerShdw blurRad="40000" dist="20000" dir="5400000" rotWithShape="0">
+              <a:srgbClr val="000000">
+                <a:alpha val="38000"/>
+              </a:srgbClr>
+            </a:outerShdw>
+          </a:effectLst>
+        </a:effectStyle>
+        <a:effectStyle>
+          <a:effectLst>
+            <a:outerShdw blurRad="40000" dist="23000" dir="5400000" rotWithShape="0">
+              <a:srgbClr val="000000">
+                <a:alpha val="35000"/>
+              </a:srgbClr>
+            </a:outerShdw>
+          </a:effectLst>
+        </a:effectStyle>
+        <a:effectStyle>
+          <a:effectLst>
+            <a:outerShdw blurRad="40000" dist="23000" dir="5400000" rotWithShape="0">
+              <a:srgbClr val="000000">
+                <a:alpha val="35000"/>
+              </a:srgbClr>
+            </a:outerShdw>
+          </a:effectLst>
+          <a:scene3d>
+            <a:camera prst="orthographicFront">
+              <a:rot lat="0" lon="0" rev="0"/>
+            </a:camera>
+            <a:lightRig rig="threePt" dir="t">
+              <a:rot lat="0" lon="0" rev="1200000"/>
+            </a:lightRig>
+          </a:scene3d>
+          <a:sp3d>
+            <a:bevelT w="63500" h="25400"/>
+          </a:sp3d>
+        </a:effectStyle>
+      </a:effectStyleLst>
+      <a:bgFillStyleLst>
+        <a:solidFill>
+          <a:schemeClr val="phClr"/>
+        </a:solidFill>
+        <a:gradFill rotWithShape="1">
+          <a:gsLst>
+            <a:gs pos="0">
+              <a:schemeClr val="phClr">
+                <a:tint val="40000"/>
+                <a:satMod val="350000"/>
+              </a:schemeClr>
+            </a:gs>
+            <a:gs pos="40000">
+              <a:schemeClr val="phClr">
+                <a:tint val="45000"/>
+                <a:shade val="99000"/>
+                <a:satMod val="350000"/>
+              </a:schemeClr>
+            </a:gs>
+            <a:gs pos="100000">
+              <a:schemeClr val="phClr">
+                <a:shade val="20000"/>
+                <a:satMod val="255000"/>
+              </a:schemeClr>
+            </a:gs>
+          </a:gsLst>
+          <a:path path="circle">
+            <a:fillToRect l="50000" t="-80000" r="50000" b="180000"/>
+          </a:path>
+        </a:gradFill>
+        <a:gradFill rotWithShape="1">
+          <a:gsLst>
+            <a:gs pos="0">
+              <a:schemeClr val="phClr">
+                <a:tint val="80000"/>
+                <a:satMod val="300000"/>
+              </a:schemeClr>
+            </a:gs>
+            <a:gs pos="100000">
+              <a:schemeClr val="phClr">
+                <a:shade val="30000"/>
+                <a:satMod val="200000"/>
+              </a:schemeClr>
+            </a:gs>
+          </a:gsLst>
+          <a:path path="circle">
+            <a:fillToRect l="50000" t="50000" r="50000" b="50000"/>
+          </a:path>
+        </a:gradFill>
+      </a:bgFillStyleLst>
+    </a:fmtScheme>
+  </a:themeElements>
+  <a:objectDefaults>
+    <a:spDef>
+      <a:spPr/>
+      <a:bodyPr/>
+      <a:lstStyle/>
+      <a:style>
+        <a:lnRef idx="1">
+          <a:schemeClr val="accent1"/>
+        </a:lnRef>
+        <a:fillRef idx="3">
+          <a:schemeClr val="accent1"/>
+        </a:fillRef>
+        <a:effectRef idx="2">
+          <a:schemeClr val="accent1"/>
+        </a:effectRef>
+        <a:fontRef idx="minor">
+          <a:schemeClr val="lt1"/>
+        </a:fontRef>
+      </a:style>
+    </a:spDef>
+    <a:lnDef>
+      <a:spPr/>
+      <a:bodyPr/>
+      <a:lstStyle/>
+      <a:style>
+        <a:lnRef idx="2">
+          <a:schemeClr val="accent1"/>
+        </a:lnRef>
+        <a:fillRef idx="0">
+          <a:schemeClr val="accent1"/>
+        </a:fillRef>
+        <a:effectRef idx="1">
+          <a:schemeClr val="accent1"/>
+        </a:effectRef>
+        <a:fontRef idx="minor">
+          <a:schemeClr val="tx1"/>
+        </a:fontRef>
+      </a:style>
+    </a:lnDef>
+  </a:objectDefaults>
+  <a:extraClrSchemeLst/>
+</a:theme>
 </file>
</xml_diff>

<commit_message>
Deck: label bit-width on every Finding-3 case
</commit_message>
<xml_diff>
--- a/paper/IFH_advisor_update_2026-09-03.pptx
+++ b/paper/IFH_advisor_update_2026-09-03.pptx
@@ -10258,7 +10258,7 @@
                 </a:solidFill>
                 <a:latin typeface="Georgia"/>
               </a:rPr>
-              <a:t>Qwen 7B</a:t>
+              <a:t>Qwen 7B @ 3-bit</a:t>
             </a:r>
           </a:p>
           <a:p>
@@ -10321,7 +10321,7 @@
                 </a:solidFill>
                 <a:latin typeface="Georgia"/>
               </a:rPr>
-              <a:t>Mistral 7B</a:t>
+              <a:t>Mistral 7B @ 3-bit</a:t>
             </a:r>
           </a:p>
           <a:p>
@@ -10384,7 +10384,7 @@
                 </a:solidFill>
                 <a:latin typeface="Georgia"/>
               </a:rPr>
-              <a:t>Llama 8B, rotated</a:t>
+              <a:t>Llama 8B @ 3-bit, rotated</a:t>
             </a:r>
           </a:p>
           <a:p>

</xml_diff>

<commit_message>
W15 census verdicts (mid-tier, no 3rd collapse) + W16 dose-response batch + deck update
</commit_message>
<xml_diff>
--- a/paper/IFH_advisor_update_2026-09-03.pptx
+++ b/paper/IFH_advisor_update_2026-09-03.pptx
@@ -1241,7 +1241,7 @@
           <a:lstStyle/>
           <a:p>
             <a:r>
-              <a:t>六个模型用完全相同的配方压到3位：四个只轻微掉分（掉0.06-0.09），两个崩溃——Llama-8B从0.77掉到0.15，Qwen-14B从0.82掉到0.41。关键是不可预测：同一家族的Qwen，7B没事、14B崩、32B又没事。每个崩溃都换随机种子重跑验证过，是稳定现象不是偶然。</a:t>
+              <a:t>六个主模型用完全相同的配方压到3位：四个只轻微掉分（掉0.06-0.09），两个崩溃——Llama-8B从0.77掉到0.15，Qwen-14B从0.82掉到0.41。关键是不可预测：同一家族的Qwen，7B没事、14B崩、32B又没事。每个崩溃都换随机种子重跑验证过，是稳定现象不是偶然。最新补充：又普查了6个模型（共12个）。新模型都落在中间档（掉0.15-0.25，多是3B小模型——小模型本来就压得更惨，这是已知规律），没有出现第三个崩溃。重点：两个崩溃严重偏离“越小越惨”的趋势线（Llama-3.2-3B才掉0.17，更大的Llama-3.1-8B却掉0.62），而且复读机率有断层（中间档最高22%，崩溃是55-92%）——所以崩溃是一种性质不同的故障，不是普通退化的加重版。如果被问“上一代Llama-3-8B呢”：它只掉0.15——同尺寸同家族，隔一代就翻转。</a:t>
             </a:r>
           </a:p>
         </p:txBody>
@@ -9852,8 +9852,8 @@
         </p:nvSpPr>
         <p:spPr>
           <a:xfrm>
-            <a:off x="6080760" y="1554480"/>
-            <a:ext cx="2697480" cy="3108960"/>
+            <a:off x="6080760" y="1481328"/>
+            <a:ext cx="2697480" cy="3200400"/>
           </a:xfrm>
           <a:prstGeom prst="rect">
             <a:avLst/>
@@ -9868,49 +9868,58 @@
           <a:p>
             <a:pPr algn="l">
               <a:spcAft>
-                <a:spcPts val="1000"/>
+                <a:spcPts val="800"/>
               </a:spcAft>
             </a:pPr>
             <a:r>
-              <a:rPr sz="1300" b="0" i="0">
+              <a:rPr sz="1250" b="1" i="0">
+                <a:solidFill>
+                  <a:srgbClr val="9B1B1B"/>
+                </a:solidFill>
+                <a:latin typeface="Georgia"/>
+              </a:rPr>
+              <a:t>Identical compression recipe. Four barely notice; two — Llama-8B and Qwen-14B — lose most of their ability.</a:t>
+            </a:r>
+          </a:p>
+          <a:p>
+            <a:pPr algn="l">
+              <a:spcAft>
+                <a:spcPts val="800"/>
+              </a:spcAft>
+            </a:pPr>
+            <a:r>
+              <a:rPr sz="1250" b="0" i="0">
                 <a:solidFill>
                   <a:srgbClr val="0C2340"/>
                 </a:solidFill>
                 <a:latin typeface="Georgia"/>
               </a:rPr>
-              <a:t>Six models, identical compression recipe.</a:t>
+              <a:t>Unpredictable: Qwen 7B fine, 14B collapses, 32B fine — same family, same training. (Every collapse re-run twice; it replicates.)</a:t>
             </a:r>
           </a:p>
           <a:p>
             <a:pPr algn="l">
               <a:spcAft>
-                <a:spcPts val="1000"/>
+                <a:spcPts val="800"/>
               </a:spcAft>
             </a:pPr>
             <a:r>
-              <a:rPr sz="1300" b="1" i="0">
-                <a:solidFill>
-                  <a:srgbClr val="9B1B1B"/>
+              <a:rPr sz="1250" b="1" i="0">
+                <a:solidFill>
+                  <a:srgbClr val="0C2340"/>
                 </a:solidFill>
                 <a:latin typeface="Georgia"/>
               </a:rPr>
-              <a:t>Four barely notice. Two — Llama-8B and Qwen-14B — lose most of their ability.</a:t>
-            </a:r>
-          </a:p>
-          <a:p>
-            <a:pPr algn="l">
-              <a:spcAft>
-                <a:spcPts val="1000"/>
-              </a:spcAft>
-            </a:pPr>
-            <a:r>
-              <a:rPr sz="1300" b="0" i="0">
+              <a:t>New 12-model census: </a:t>
+            </a:r>
+            <a:r>
+              <a:rPr sz="1250" b="0" i="0">
                 <a:solidFill>
                   <a:srgbClr val="0C2340"/>
                 </a:solidFill>
                 <a:latin typeface="Georgia"/>
               </a:rPr>
-              <a:t>And it's unpredictable: Qwen 7B is fine, 14B collapses, 32B is fine again — same family, same training.</a:t>
+              <a:t>six more models land in a middle tier (−0.15 to −0.25, mostly small 3B models). Still no third catastrophe — the two collapses sit far off the size trend.</a:t>
             </a:r>
           </a:p>
           <a:p>
@@ -9922,7 +9931,7 @@
                 </a:solidFill>
                 <a:latin typeface="Georgia"/>
               </a:rPr>
-              <a:t>(instruction-following score; every collapse re-run twice — it replicates)</a:t>
+              <a:t>(instruction-following score, 0–1)</a:t>
             </a:r>
           </a:p>
         </p:txBody>

</xml_diff>

<commit_message>
Deck: 0.5% budget provenance on slide 2, IFEval-by-default statement, mid-tier explanation
</commit_message>
<xml_diff>
--- a/paper/IFH_advisor_update_2026-09-03.pptx
+++ b/paper/IFH_advisor_update_2026-09-03.pptx
@@ -1171,7 +1171,7 @@
           <a:lstStyle/>
           <a:p>
             <a:r>
-              <a:t>先立四个词：①量化=把每个权重从16位存成3位，模型小5倍、便宜5倍；②GPTQ=业界标准压缩算法，特点是“聪明”——每压一个权重就调整其他权重来抵消误差；③RTN=笨办法，直接四舍五入，不纠错；④保护=挑出最重要的0.5%权重不压缩，重要性用TaCQ这篇论文的公式打分：|权重值|×|梯度|×|压缩误差|，直觉是“作用大×模型敏感×压缩伤它重”三者相乘。我们的问题：以往论文都默认“保护重要权重总是有帮助”，没人问过什么时候真有帮助。我们的答案：只有压崩溃的时候有帮助，其他时候完全没用。</a:t>
+              <a:t>先立四个词：①量化=把每个权重从16位存成3位，模型小5倍、便宜5倍；②GPTQ=业界标准压缩算法，特点是“聪明”——每压一个权重就调整其他权重来抵消误差；③RTN=笨办法，直接四舍五入，不纠错；④保护=挑出最重要的0.5%权重不压缩，重要性用TaCQ这篇论文的公式打分：|权重值|×|梯度|×|压缩误差|，直觉是“作用大×模型敏感×压缩伤它重”三者相乘。我们的问题：以往论文都默认“保护重要权重总是有帮助”，没人问过什么时候真有帮助。我们的答案：只有压崩溃的时候有帮助，其他时候完全没用。两个备注：①0.5%这个预算是我们定的（为了和“保护32个注意力头”做同预算公平对照，算出来恰好约0.5%；TaCQ自己的配置也在0.5-0.8%一档；我们的扫描证明真正必需的只有0.001-0.01%）；②除标明“数学/知识题/困惑度”的地方外，全片所有数字都是IFEval指令遵循分（0-1）。</a:t>
             </a:r>
           </a:p>
         </p:txBody>
@@ -9515,8 +9515,8 @@
         </p:nvSpPr>
         <p:spPr>
           <a:xfrm>
-            <a:off x="411480" y="1417320"/>
-            <a:ext cx="4297680" cy="3291840"/>
+            <a:off x="411480" y="1325880"/>
+            <a:ext cx="4297680" cy="3520440"/>
           </a:xfrm>
           <a:prstGeom prst="rect">
             <a:avLst/>
@@ -9531,11 +9531,11 @@
           <a:p>
             <a:pPr algn="l">
               <a:spcAft>
-                <a:spcPts val="700"/>
+                <a:spcPts val="600"/>
               </a:spcAft>
             </a:pPr>
             <a:r>
-              <a:rPr sz="1300" b="1" i="0">
+              <a:rPr sz="1200" b="1" i="0">
                 <a:solidFill>
                   <a:srgbClr val="AE9141"/>
                 </a:solidFill>
@@ -9544,23 +9544,23 @@
               <a:t>Quantization </a:t>
             </a:r>
             <a:r>
-              <a:rPr sz="1300" b="0" i="0">
+              <a:rPr sz="1200" b="0" i="0">
                 <a:solidFill>
                   <a:srgbClr val="0C2340"/>
                 </a:solidFill>
                 <a:latin typeface="Georgia"/>
               </a:rPr>
-              <a:t>= compressing a model by storing each weight in 3 bits instead of 16 → ~5× smaller and cheaper to run.</a:t>
+              <a:t>= storing each weight in 3 bits instead of 16 → ~5× smaller and cheaper to run.</a:t>
             </a:r>
           </a:p>
           <a:p>
             <a:pPr algn="l">
               <a:spcAft>
-                <a:spcPts val="700"/>
+                <a:spcPts val="600"/>
               </a:spcAft>
             </a:pPr>
             <a:r>
-              <a:rPr sz="1300" b="1" i="0">
+              <a:rPr sz="1200" b="1" i="0">
                 <a:solidFill>
                   <a:srgbClr val="AE9141"/>
                 </a:solidFill>
@@ -9569,23 +9569,23 @@
               <a:t>GPTQ </a:t>
             </a:r>
             <a:r>
-              <a:rPr sz="1300" b="0" i="0">
+              <a:rPr sz="1200" b="0" i="0">
                 <a:solidFill>
                   <a:srgbClr val="0C2340"/>
                 </a:solidFill>
                 <a:latin typeface="Georgia"/>
               </a:rPr>
-              <a:t>= the standard compression algorithm. It is “smart”: after rounding each weight it adjusts the remaining ones to cancel the error.</a:t>
+              <a:t>= the standard compression algorithm. “Smart”: after rounding each weight it adjusts the remaining ones to cancel the error.</a:t>
             </a:r>
           </a:p>
           <a:p>
             <a:pPr algn="l">
               <a:spcAft>
-                <a:spcPts val="700"/>
+                <a:spcPts val="600"/>
               </a:spcAft>
             </a:pPr>
             <a:r>
-              <a:rPr sz="1300" b="1" i="0">
+              <a:rPr sz="1200" b="1" i="0">
                 <a:solidFill>
                   <a:srgbClr val="AE9141"/>
                 </a:solidFill>
@@ -9594,7 +9594,7 @@
               <a:t>RTN </a:t>
             </a:r>
             <a:r>
-              <a:rPr sz="1300" b="0" i="0">
+              <a:rPr sz="1200" b="0" i="0">
                 <a:solidFill>
                   <a:srgbClr val="0C2340"/>
                 </a:solidFill>
@@ -9606,11 +9606,11 @@
           <a:p>
             <a:pPr algn="l">
               <a:spcAft>
-                <a:spcPts val="400"/>
+                <a:spcPts val="300"/>
               </a:spcAft>
             </a:pPr>
             <a:r>
-              <a:rPr sz="1300" b="1" i="0">
+              <a:rPr sz="1200" b="1" i="0">
                 <a:solidFill>
                   <a:srgbClr val="AE9141"/>
                 </a:solidFill>
@@ -9619,7 +9619,7 @@
               <a:t>Protection </a:t>
             </a:r>
             <a:r>
-              <a:rPr sz="1300" b="0" i="0">
+              <a:rPr sz="1200" b="0" i="0">
                 <a:solidFill>
                   <a:srgbClr val="0C2340"/>
                 </a:solidFill>
@@ -9631,11 +9631,11 @@
           <a:p>
             <a:pPr algn="ctr">
               <a:spcAft>
-                <a:spcPts val="300"/>
+                <a:spcPts val="200"/>
               </a:spcAft>
             </a:pPr>
             <a:r>
-              <a:rPr sz="1250" b="1" i="0">
+              <a:rPr sz="1150" b="1" i="0">
                 <a:solidFill>
                   <a:srgbClr val="0C2340"/>
                 </a:solidFill>
@@ -9645,7 +9645,32 @@
             </a:r>
           </a:p>
           <a:p>
-            <a:pPr algn="ctr"/>
+            <a:pPr algn="ctr">
+              <a:spcAft>
+                <a:spcPts val="500"/>
+              </a:spcAft>
+            </a:pPr>
+            <a:r>
+              <a:rPr sz="1000" b="0" i="1">
+                <a:solidFill>
+                  <a:srgbClr val="5A5A5A"/>
+                </a:solidFill>
+                <a:latin typeface="Georgia"/>
+              </a:rPr>
+              <a:t>(“does a lot × model is sensitive × compression hits it hard”)</a:t>
+            </a:r>
+          </a:p>
+          <a:p>
+            <a:pPr algn="l"/>
+            <a:r>
+              <a:rPr sz="1000" b="0" i="0">
+                <a:solidFill>
+                  <a:srgbClr val="5A5A5A"/>
+                </a:solidFill>
+                <a:latin typeface="Georgia"/>
+              </a:rPr>
+              <a:t>The score is TaCQ's; the 0.5% budget is ours (set to match the cost of protecting 32 attention heads; TaCQ uses a similar 0.5–0.8%). Sweeps show 0.001–0.01% does the real work.</a:t>
+            </a:r>
           </a:p>
         </p:txBody>
       </p:sp>
@@ -9735,7 +9760,11 @@
             </a:r>
           </a:p>
           <a:p>
-            <a:pPr algn="l"/>
+            <a:pPr algn="l">
+              <a:spcAft>
+                <a:spcPts val="600"/>
+              </a:spcAft>
+            </a:pPr>
             <a:r>
               <a:rPr sz="1250" b="0" i="0">
                 <a:solidFill>
@@ -9743,7 +9772,16 @@
                 </a:solidFill>
                 <a:latin typeface="Georgia"/>
               </a:rPr>
-              <a:t>Ability scores from 0 to 1: following instructions (IFEval), math (GSM8K), knowledge quiz (MMLU). Higher = better.</a:t>
+              <a:t>Ability scores from 0 to 1, higher = better. Unless a number is explicitly labeled “math” (GSM8K), “knowledge quiz” (MMLU) or “perplexity”, </a:t>
+            </a:r>
+            <a:r>
+              <a:rPr sz="1250" b="1" i="0">
+                <a:solidFill>
+                  <a:srgbClr val="0C2340"/>
+                </a:solidFill>
+                <a:latin typeface="Georgia"/>
+              </a:rPr>
+              <a:t>every number in this deck is the IFEval instruction-following score.</a:t>
             </a:r>
           </a:p>
         </p:txBody>
@@ -9919,7 +9957,7 @@
                 </a:solidFill>
                 <a:latin typeface="Georgia"/>
               </a:rPr>
-              <a:t>six more models land in a middle tier (−0.15 to −0.25, mostly small 3B models). Still no third catastrophe — the two collapses sit far off the size trend.</a:t>
+              <a:t>six more, mostly SMALL models (3–12B), form a middle tier (−0.15 to −0.25) — expected, since small models have less redundancy to absorb rounding noise. Still no third collapse: their failure looks nothing like the two collapses (see Finding 5).</a:t>
             </a:r>
           </a:p>
           <a:p>
@@ -9931,7 +9969,7 @@
                 </a:solidFill>
                 <a:latin typeface="Georgia"/>
               </a:rPr>
-              <a:t>(instruction-following score, 0–1)</a:t>
+              <a:t>(IFEval instruction-following score, 0–1)</a:t>
             </a:r>
           </a:p>
         </p:txBody>
@@ -10066,7 +10104,7 @@
                 </a:solidFill>
                 <a:latin typeface="Georgia"/>
               </a:rPr>
-              <a:t>Keep the top-scoring ≤0.5% of weights exact — the model comes back (Qwen-14B: to 95% of its original score).</a:t>
+              <a:t>Keep the top-scoring ≤0.5% of weights exact — the model comes back (Qwen-14B: to 95% of its original score). Bars: IFEval score.</a:t>
             </a:r>
           </a:p>
           <a:p>
@@ -10216,7 +10254,7 @@
                 </a:solidFill>
                 <a:latin typeface="Georgia"/>
               </a:rPr>
-              <a:t>Finding 2 showed protection rescues collapsed models. Here is the SAME protection applied to four models/settings that did NOT collapse — score before → after adding protection:</a:t>
+              <a:t>Finding 2 showed protection rescues collapsed models. Here is the SAME protection applied to four models/settings that did NOT collapse — IFEval score before → after adding protection:</a:t>
             </a:r>
           </a:p>
         </p:txBody>
@@ -10641,7 +10679,7 @@
                 </a:solidFill>
                 <a:latin typeface="Georgia"/>
               </a:rPr>
-              <a:t>Same Llama-8B model, compressed to 3 bits in three different ways (“protection” = the same top-0.5% weight set as in Finding 2):</a:t>
+              <a:t>Same Llama-8B model, compressed to 3 bits in three different ways — IFEval scores (“protection” = the same top-0.5% weight set as in Finding 2):</a:t>
             </a:r>
           </a:p>
         </p:txBody>

</xml_diff>

<commit_message>
Deck: add WHEN-window slide (within-model bit ladder, 8/4/3/2-bit + protection)
</commit_message>
<xml_diff>
--- a/paper/IFH_advisor_update_2026-09-03.pptx
+++ b/paper/IFH_advisor_update_2026-09-03.pptx
@@ -15,6 +15,7 @@
     <p:sldId id="274" r:id="rId22"/>
     <p:sldId id="275" r:id="rId23"/>
     <p:sldId id="276" r:id="rId24"/>
+    <p:sldId id="277" r:id="rId25"/>
   </p:sldIdLst>
   <p:sldSz cx="9144000" cy="5148263"/>
   <p:notesSz cx="6858000" cy="9144000"/>
@@ -636,6 +637,464 @@
 </c:chartSpace>
 </file>
 
+<file path=ppt/charts/chart3.xml><?xml version="1.0" encoding="utf-8"?>
+<c:chartSpace xmlns:c="http://schemas.openxmlformats.org/drawingml/2006/chart" xmlns:a="http://schemas.openxmlformats.org/drawingml/2006/main" xmlns:r="http://schemas.openxmlformats.org/officeDocument/2006/relationships">
+  <c:date1904 val="0"/>
+  <c:chart>
+    <c:autoTitleDeleted val="1"/>
+    <c:plotArea>
+      <c:barChart>
+        <c:barDir val="col"/>
+        <c:grouping val="clustered"/>
+        <c:ser>
+          <c:idx val="0"/>
+          <c:order val="0"/>
+          <c:tx>
+            <c:strRef>
+              <c:f>Sheet1!$B$1</c:f>
+              <c:strCache>
+                <c:ptCount val="1"/>
+                <c:pt idx="0">
+                  <c:v>compressed</c:v>
+                </c:pt>
+              </c:strCache>
+            </c:strRef>
+          </c:tx>
+          <c:spPr>
+            <a:solidFill>
+              <a:srgbClr val="AE9141"/>
+            </a:solidFill>
+          </c:spPr>
+          <c:cat>
+            <c:strRef>
+              <c:f>Sheet1!$A$2:$A$3</c:f>
+              <c:strCache>
+                <c:ptCount val="2"/>
+                <c:pt idx="0">
+                  <c:v>4-bit (mild)</c:v>
+                </c:pt>
+                <c:pt idx="1">
+                  <c:v>3-bit (deep)</c:v>
+                </c:pt>
+              </c:strCache>
+            </c:strRef>
+          </c:cat>
+          <c:val>
+            <c:numRef>
+              <c:f>Sheet1!$B$2:$B$3</c:f>
+              <c:numCache>
+                <c:formatCode>General</c:formatCode>
+                <c:ptCount val="2"/>
+                <c:pt idx="0">
+                  <c:v>0.745</c:v>
+                </c:pt>
+                <c:pt idx="1">
+                  <c:v>0.15</c:v>
+                </c:pt>
+              </c:numCache>
+            </c:numRef>
+          </c:val>
+        </c:ser>
+        <c:ser>
+          <c:idx val="1"/>
+          <c:order val="1"/>
+          <c:tx>
+            <c:strRef>
+              <c:f>Sheet1!$C$1</c:f>
+              <c:strCache>
+                <c:ptCount val="1"/>
+                <c:pt idx="0">
+                  <c:v>+ protection</c:v>
+                </c:pt>
+              </c:strCache>
+            </c:strRef>
+          </c:tx>
+          <c:spPr>
+            <a:solidFill>
+              <a:srgbClr val="0A833C"/>
+            </a:solidFill>
+          </c:spPr>
+          <c:cat>
+            <c:strRef>
+              <c:f>Sheet1!$A$2:$A$3</c:f>
+              <c:strCache>
+                <c:ptCount val="2"/>
+                <c:pt idx="0">
+                  <c:v>4-bit (mild)</c:v>
+                </c:pt>
+                <c:pt idx="1">
+                  <c:v>3-bit (deep)</c:v>
+                </c:pt>
+              </c:strCache>
+            </c:strRef>
+          </c:cat>
+          <c:val>
+            <c:numRef>
+              <c:f>Sheet1!$C$2:$C$3</c:f>
+              <c:numCache>
+                <c:formatCode>General</c:formatCode>
+                <c:ptCount val="2"/>
+                <c:pt idx="0">
+                  <c:v>0.753</c:v>
+                </c:pt>
+                <c:pt idx="1">
+                  <c:v>0.643</c:v>
+                </c:pt>
+              </c:numCache>
+            </c:numRef>
+          </c:val>
+        </c:ser>
+        <c:dLbls>
+          <c:numFmt formatCode="0.00" sourceLinked="0"/>
+          <c:txPr>
+            <a:bodyPr/>
+            <a:lstStyle/>
+            <a:p>
+              <a:pPr>
+                <a:defRPr sz="900">
+                  <a:latin typeface="Georgia"/>
+                </a:defRPr>
+              </a:pPr>
+            </a:p>
+          </c:txPr>
+          <c:dLblPos val="outEnd"/>
+          <c:showLegendKey val="0"/>
+          <c:showVal val="1"/>
+          <c:showCatName val="0"/>
+          <c:showSerName val="0"/>
+          <c:showPercent val="0"/>
+          <c:showBubbleSize val="0"/>
+          <c:showLeaderLines val="1"/>
+        </c:dLbls>
+        <c:axId val="-2068027336"/>
+        <c:axId val="-2113994440"/>
+      </c:barChart>
+      <c:catAx>
+        <c:axId val="-2068027336"/>
+        <c:scaling>
+          <c:orientation val="minMax"/>
+        </c:scaling>
+        <c:delete val="0"/>
+        <c:axPos val="b"/>
+        <c:majorTickMark val="out"/>
+        <c:minorTickMark val="none"/>
+        <c:tickLblPos val="nextTo"/>
+        <c:txPr>
+          <a:bodyPr/>
+          <a:lstStyle/>
+          <a:p>
+            <a:pPr>
+              <a:defRPr sz="950">
+                <a:latin typeface="Georgia"/>
+              </a:defRPr>
+            </a:pPr>
+          </a:p>
+        </c:txPr>
+        <c:crossAx val="-2113994440"/>
+        <c:crosses val="autoZero"/>
+        <c:auto val="1"/>
+        <c:lblAlgn val="ctr"/>
+        <c:lblOffset val="100"/>
+        <c:noMultiLvlLbl val="0"/>
+      </c:catAx>
+      <c:valAx>
+        <c:axId val="-2113994440"/>
+        <c:scaling>
+          <c:max val="0.9"/>
+          <c:min val="0.0"/>
+        </c:scaling>
+        <c:delete val="0"/>
+        <c:axPos val="l"/>
+        <c:majorGridlines/>
+        <c:majorTickMark val="out"/>
+        <c:minorTickMark val="none"/>
+        <c:tickLblPos val="nextTo"/>
+        <c:txPr>
+          <a:bodyPr/>
+          <a:lstStyle/>
+          <a:p>
+            <a:pPr>
+              <a:defRPr sz="950">
+                <a:latin typeface="Georgia"/>
+              </a:defRPr>
+            </a:pPr>
+          </a:p>
+        </c:txPr>
+        <c:crossAx val="-2068027336"/>
+        <c:crosses val="autoZero"/>
+      </c:valAx>
+    </c:plotArea>
+    <c:legend>
+      <c:legendPos val="b"/>
+      <c:overlay val="0"/>
+      <c:txPr>
+        <a:bodyPr/>
+        <a:lstStyle/>
+        <a:p>
+          <a:pPr>
+            <a:defRPr sz="1000">
+              <a:latin typeface="Georgia"/>
+            </a:defRPr>
+          </a:pPr>
+        </a:p>
+      </c:txPr>
+    </c:legend>
+    <c:dispBlanksAs val="gap"/>
+  </c:chart>
+  <c:txPr>
+    <a:bodyPr/>
+    <a:lstStyle/>
+    <a:p>
+      <a:pPr>
+        <a:defRPr sz="1800"/>
+      </a:pPr>
+      <a:endParaRPr lang="en-US"/>
+    </a:p>
+  </c:txPr>
+  <c:externalData r:id="rId1">
+    <c:autoUpdate val="0"/>
+  </c:externalData>
+</c:chartSpace>
+</file>
+
+<file path=ppt/charts/chart4.xml><?xml version="1.0" encoding="utf-8"?>
+<c:chartSpace xmlns:c="http://schemas.openxmlformats.org/drawingml/2006/chart" xmlns:a="http://schemas.openxmlformats.org/drawingml/2006/main" xmlns:r="http://schemas.openxmlformats.org/officeDocument/2006/relationships">
+  <c:date1904 val="0"/>
+  <c:chart>
+    <c:autoTitleDeleted val="1"/>
+    <c:plotArea>
+      <c:barChart>
+        <c:barDir val="col"/>
+        <c:grouping val="clustered"/>
+        <c:ser>
+          <c:idx val="0"/>
+          <c:order val="0"/>
+          <c:tx>
+            <c:strRef>
+              <c:f>Sheet1!$B$1</c:f>
+              <c:strCache>
+                <c:ptCount val="1"/>
+                <c:pt idx="0">
+                  <c:v>compressed</c:v>
+                </c:pt>
+              </c:strCache>
+            </c:strRef>
+          </c:tx>
+          <c:spPr>
+            <a:solidFill>
+              <a:srgbClr val="AE9141"/>
+            </a:solidFill>
+          </c:spPr>
+          <c:cat>
+            <c:strRef>
+              <c:f>Sheet1!$A$2:$A$5</c:f>
+              <c:strCache>
+                <c:ptCount val="4"/>
+                <c:pt idx="0">
+                  <c:v>8-bit</c:v>
+                </c:pt>
+                <c:pt idx="1">
+                  <c:v>4-bit</c:v>
+                </c:pt>
+                <c:pt idx="2">
+                  <c:v>3-bit</c:v>
+                </c:pt>
+                <c:pt idx="3">
+                  <c:v>2-bit (extreme)</c:v>
+                </c:pt>
+              </c:strCache>
+            </c:strRef>
+          </c:cat>
+          <c:val>
+            <c:numRef>
+              <c:f>Sheet1!$B$2:$B$5</c:f>
+              <c:numCache>
+                <c:formatCode>General</c:formatCode>
+                <c:ptCount val="4"/>
+                <c:pt idx="0">
+                  <c:v>0.77</c:v>
+                </c:pt>
+                <c:pt idx="1">
+                  <c:v>0.758</c:v>
+                </c:pt>
+                <c:pt idx="2">
+                  <c:v>0.672</c:v>
+                </c:pt>
+                <c:pt idx="3">
+                  <c:v>0.121</c:v>
+                </c:pt>
+              </c:numCache>
+            </c:numRef>
+          </c:val>
+        </c:ser>
+        <c:ser>
+          <c:idx val="1"/>
+          <c:order val="1"/>
+          <c:tx>
+            <c:strRef>
+              <c:f>Sheet1!$C$1</c:f>
+              <c:strCache>
+                <c:ptCount val="1"/>
+                <c:pt idx="0">
+                  <c:v>+ protection</c:v>
+                </c:pt>
+              </c:strCache>
+            </c:strRef>
+          </c:tx>
+          <c:spPr>
+            <a:solidFill>
+              <a:srgbClr val="0A833C"/>
+            </a:solidFill>
+          </c:spPr>
+          <c:cat>
+            <c:strRef>
+              <c:f>Sheet1!$A$2:$A$5</c:f>
+              <c:strCache>
+                <c:ptCount val="4"/>
+                <c:pt idx="0">
+                  <c:v>8-bit</c:v>
+                </c:pt>
+                <c:pt idx="1">
+                  <c:v>4-bit</c:v>
+                </c:pt>
+                <c:pt idx="2">
+                  <c:v>3-bit</c:v>
+                </c:pt>
+                <c:pt idx="3">
+                  <c:v>2-bit (extreme)</c:v>
+                </c:pt>
+              </c:strCache>
+            </c:strRef>
+          </c:cat>
+          <c:val>
+            <c:numRef>
+              <c:f>Sheet1!$C$2:$C$5</c:f>
+              <c:numCache>
+                <c:formatCode>General</c:formatCode>
+                <c:ptCount val="4"/>
+                <c:pt idx="2">
+                  <c:v>0.702</c:v>
+                </c:pt>
+                <c:pt idx="3">
+                  <c:v>0.133</c:v>
+                </c:pt>
+              </c:numCache>
+            </c:numRef>
+          </c:val>
+        </c:ser>
+        <c:dLbls>
+          <c:numFmt formatCode="0.00" sourceLinked="0"/>
+          <c:txPr>
+            <a:bodyPr/>
+            <a:lstStyle/>
+            <a:p>
+              <a:pPr>
+                <a:defRPr sz="900">
+                  <a:latin typeface="Georgia"/>
+                </a:defRPr>
+              </a:pPr>
+            </a:p>
+          </c:txPr>
+          <c:dLblPos val="outEnd"/>
+          <c:showLegendKey val="0"/>
+          <c:showVal val="1"/>
+          <c:showCatName val="0"/>
+          <c:showSerName val="0"/>
+          <c:showPercent val="0"/>
+          <c:showBubbleSize val="0"/>
+          <c:showLeaderLines val="1"/>
+        </c:dLbls>
+        <c:axId val="-2068027336"/>
+        <c:axId val="-2113994440"/>
+      </c:barChart>
+      <c:catAx>
+        <c:axId val="-2068027336"/>
+        <c:scaling>
+          <c:orientation val="minMax"/>
+        </c:scaling>
+        <c:delete val="0"/>
+        <c:axPos val="b"/>
+        <c:majorTickMark val="out"/>
+        <c:minorTickMark val="none"/>
+        <c:tickLblPos val="nextTo"/>
+        <c:txPr>
+          <a:bodyPr/>
+          <a:lstStyle/>
+          <a:p>
+            <a:pPr>
+              <a:defRPr sz="950">
+                <a:latin typeface="Georgia"/>
+              </a:defRPr>
+            </a:pPr>
+          </a:p>
+        </c:txPr>
+        <c:crossAx val="-2113994440"/>
+        <c:crosses val="autoZero"/>
+        <c:auto val="1"/>
+        <c:lblAlgn val="ctr"/>
+        <c:lblOffset val="100"/>
+        <c:noMultiLvlLbl val="0"/>
+      </c:catAx>
+      <c:valAx>
+        <c:axId val="-2113994440"/>
+        <c:scaling>
+          <c:max val="0.9"/>
+          <c:min val="0.0"/>
+        </c:scaling>
+        <c:delete val="0"/>
+        <c:axPos val="l"/>
+        <c:majorGridlines/>
+        <c:majorTickMark val="out"/>
+        <c:minorTickMark val="none"/>
+        <c:tickLblPos val="nextTo"/>
+        <c:txPr>
+          <a:bodyPr/>
+          <a:lstStyle/>
+          <a:p>
+            <a:pPr>
+              <a:defRPr sz="950">
+                <a:latin typeface="Georgia"/>
+              </a:defRPr>
+            </a:pPr>
+          </a:p>
+        </c:txPr>
+        <c:crossAx val="-2068027336"/>
+        <c:crosses val="autoZero"/>
+      </c:valAx>
+    </c:plotArea>
+    <c:legend>
+      <c:legendPos val="b"/>
+      <c:overlay val="0"/>
+      <c:txPr>
+        <a:bodyPr/>
+        <a:lstStyle/>
+        <a:p>
+          <a:pPr>
+            <a:defRPr sz="1000">
+              <a:latin typeface="Georgia"/>
+            </a:defRPr>
+          </a:pPr>
+        </a:p>
+      </c:txPr>
+    </c:legend>
+    <c:dispBlanksAs val="gap"/>
+  </c:chart>
+  <c:txPr>
+    <a:bodyPr/>
+    <a:lstStyle/>
+    <a:p>
+      <a:pPr>
+        <a:defRPr sz="1800"/>
+      </a:pPr>
+      <a:endParaRPr lang="en-US"/>
+    </a:p>
+  </c:txPr>
+  <c:externalData r:id="rId1">
+    <c:autoUpdate val="0"/>
+  </c:externalData>
+</c:chartSpace>
+</file>
+
 <file path=ppt/notesMasters/notesMaster1.xml><?xml version="1.0" encoding="utf-8"?>
 <p:notesMaster xmlns:a="http://schemas.openxmlformats.org/drawingml/2006/main" xmlns:p="http://schemas.openxmlformats.org/presentationml/2006/main" xmlns:r="http://schemas.openxmlformats.org/officeDocument/2006/relationships">
   <p:cSld>
@@ -1101,6 +1560,76 @@
           <a:lstStyle/>
           <a:p>
             <a:r>
+              <a:t>两篇最近的论文：TaCQ发明了我们用的重要性分数并展示保护有效——我们回答它没问的“何时、为何”；Super Weights是Mengxia学长的工作，发现每个模型有3-6个“超级权重”删一个就死——我们验证了只保护它们救不了GPTQ崩溃，崩溃涉及的是另外约10万个权重，两个工作互补不冲突。投稿：ICLR 2027（摘要9/18、全文9/25），被拒则带着审稿意见转投ACL 2027。</a:t>
+            </a:r>
+          </a:p>
+        </p:txBody>
+      </p:sp>
+      <p:sp>
+        <p:nvSpPr>
+          <p:cNvPr id="4" name="Slide Number Placeholder 3"/>
+          <p:cNvSpPr>
+            <a:spLocks noGrp="1"/>
+          </p:cNvSpPr>
+          <p:nvPr>
+            <p:ph type="sldNum" idx="5" sz="quarter"/>
+          </p:nvPr>
+        </p:nvSpPr>
+        <p:spPr/>
+      </p:sp>
+    </p:spTree>
+  </p:cSld>
+  <p:clrMapOvr>
+    <a:masterClrMapping/>
+  </p:clrMapOvr>
+</p:notes>
+</file>
+
+<file path=ppt/notesSlides/notesSlide11.xml><?xml version="1.0" encoding="utf-8"?>
+<p:notes xmlns:a="http://schemas.openxmlformats.org/drawingml/2006/main" xmlns:p="http://schemas.openxmlformats.org/presentationml/2006/main" xmlns:r="http://schemas.openxmlformats.org/officeDocument/2006/relationships">
+  <p:cSld>
+    <p:spTree>
+      <p:nvGrpSpPr>
+        <p:cNvPr id="1" name=""/>
+        <p:cNvGrpSpPr/>
+        <p:nvPr/>
+      </p:nvGrpSpPr>
+      <p:grpSpPr>
+        <a:xfrm>
+          <a:off x="0" y="0"/>
+          <a:ext cx="0" cy="0"/>
+          <a:chOff x="0" y="0"/>
+          <a:chExt cx="0" cy="0"/>
+        </a:xfrm>
+      </p:grpSpPr>
+      <p:sp>
+        <p:nvSpPr>
+          <p:cNvPr id="2" name="Slide Image Placeholder 1"/>
+          <p:cNvSpPr>
+            <a:spLocks noGrp="1"/>
+          </p:cNvSpPr>
+          <p:nvPr>
+            <p:ph type="sldImg" idx="2"/>
+          </p:nvPr>
+        </p:nvSpPr>
+        <p:spPr/>
+      </p:sp>
+      <p:sp>
+        <p:nvSpPr>
+          <p:cNvPr id="3" name="Notes Placeholder 2"/>
+          <p:cNvSpPr>
+            <a:spLocks noGrp="1"/>
+          </p:cNvSpPr>
+          <p:nvPr>
+            <p:ph type="body" idx="3" sz="quarter"/>
+          </p:nvPr>
+        </p:nvSpPr>
+        <p:spPr/>
+        <p:txBody>
+          <a:bodyPr/>
+          <a:lstStyle/>
+          <a:p>
+            <a:r>
               <a:t>征求意见：①故事是否已经是一个干净的问题+干净的答案；②确认ICLR→ACL路线；③如何对接Mengxia的工作（打招呼还是引用即可）；④集群还可用，要不要补实验。</a:t>
             </a:r>
           </a:p>
@@ -1451,7 +1980,7 @@
           <a:lstStyle/>
           <a:p>
             <a:r>
-              <a:t>为什么崩：同一个Llama三种压法对比。笨办法RTN反而0.57（受伤但活着），聪明的GPTQ却0.15（崩了）——聪明反被聪明误。机制：GPTQ的纠错会把误差摊到其他权重上；模型里有约10万个超敏感权重（占0.001%，在原模型里把它们清零模型也会死），纠错一碰它们就把毒扩散到全网络。证据：事后把这10万个修回原值也救不活（0.16）——伤已经在网络其他地方了。所以保护必须在压缩过程中做，等于告诉纠错机制“这批别碰”。</a:t>
+              <a:t>这页直接回答“WHEN是什么意思”：同一个模型内部沿bit阶梯看。Llama-8B：4位时轻伤（保护+0.008，无用），3位时崩溃（保护+0.49，救命）。Qwen-7B：8位无损、4位近无损、3位轻伤（保护+0.03，无用）、2位彻底毁灭（0.12，保护无用——加到10倍预算2%也只有0.13，救不活）。所以“何时”的答案是一个窗口：压得不够深没病可治；压进崩溃区保护决定生死；压到2位病入膏肓。加上第3页的跨模型轴（12模型只有2个崩）和发现4的算法轴（GPTQ崩、RTN不崩、旋转不崩），三个轴合起来的统一判据就是：保护只在“纠错在净行凶”的组合里有用。</a:t>
             </a:r>
           </a:p>
         </p:txBody>
@@ -1521,7 +2050,7 @@
           <a:lstStyle/>
           <a:p>
             <a:r>
-              <a:t>更吓人的发现：这么严重的损坏，业界两个默认质检居然都看不出来。压缩后的14B有69%的回答变成复读机（画面上是真实输出），原版不到1%。但困惑度只涨35%（和无害情况一样）、MMLU选择题只掉6分（也和无害情况一样）。原因：这两个指标只测“逐词预测”，复读机只在模型连续自由生成时才发作。警示：压缩后必须用生成式任务测试。</a:t>
+              <a:t>为什么崩：同一个Llama三种压法对比。笨办法RTN反而0.57（受伤但活着），聪明的GPTQ却0.15（崩了）——聪明反被聪明误。机制：GPTQ的纠错会把误差摊到其他权重上；模型里有约10万个超敏感权重（占0.001%，在原模型里把它们清零模型也会死），纠错一碰它们就把毒扩散到全网络。证据：事后把这10万个修回原值也救不活（0.16）——伤已经在网络其他地方了。所以保护必须在压缩过程中做，等于告诉纠错机制“这批别碰”。</a:t>
             </a:r>
           </a:p>
         </p:txBody>
@@ -1591,7 +2120,7 @@
           <a:lstStyle/>
           <a:p>
             <a:r>
-              <a:t>论文四句话：①压缩损伤分两种模式，轻微或崩溃，且无法从原模型预测（六个模型上证伪了所有已发表的预测指标）；②保护是崩溃修复工具而非通用增益，崩溃时它胜过包括最新旋转方法在内的所有替代方案；③元凶是压缩算法的纠错机制而非低精度本身；④评测警告：模型可能通过困惑度和MMLU检查但已丧失80%生成能力。</a:t>
+              <a:t>更吓人的发现：这么严重的损坏，业界两个默认质检居然都看不出来。压缩后的14B有69%的回答变成复读机（画面上是真实输出），原版不到1%。但困惑度只涨35%（和无害情况一样）、MMLU选择题只掉6分（也和无害情况一样）。原因：这两个指标只测“逐词预测”，复读机只在模型连续自由生成时才发作。警示：压缩后必须用生成式任务测试。</a:t>
             </a:r>
           </a:p>
         </p:txBody>
@@ -1661,7 +2190,7 @@
           <a:lstStyle/>
           <a:p>
             <a:r>
-              <a:t>两篇最近的论文：TaCQ发明了我们用的重要性分数并展示保护有效——我们回答它没问的“何时、为何”；Super Weights是Mengxia学长的工作，发现每个模型有3-6个“超级权重”删一个就死——我们验证了只保护它们救不了GPTQ崩溃，崩溃涉及的是另外约10万个权重，两个工作互补不冲突。投稿：ICLR 2027（摘要9/18、全文9/25），被拒则带着审稿意见转投ACL 2027。</a:t>
+              <a:t>论文四句话：①压缩损伤分两种模式，轻微或崩溃，且无法从原模型预测（六个模型上证伪了所有已发表的预测指标）；②保护是崩溃修复工具而非通用增益，崩溃时它胜过包括最新旋转方法在内的所有替代方案；③元凶是压缩算法的纠错机制而非低精度本身；④评测警告：模型可能通过困惑度和MMLU检查但已丧失80%生成能力。</a:t>
             </a:r>
           </a:p>
         </p:txBody>
@@ -10617,7 +11146,7 @@
                 </a:solidFill>
                 <a:latin typeface="Georgia"/>
               </a:rPr>
-              <a:t>The Culprit: the Compressor's Own Error Correction</a:t>
+              <a:t>Protection Helps Only in a Window</a:t>
             </a:r>
           </a:p>
         </p:txBody>
@@ -10644,7 +11173,7 @@
                 </a:solidFill>
                 <a:latin typeface="Georgia"/>
               </a:rPr>
-              <a:t>FINDING 4</a:t>
+              <a:t>THE ANSWER TO “WHEN” — SAME MODEL, DIFFERENT BITS</a:t>
             </a:r>
           </a:p>
         </p:txBody>
@@ -10658,6 +11187,112 @@
         <p:spPr>
           <a:xfrm>
             <a:off x="411480" y="1371600"/>
+            <a:ext cx="3977639" cy="274320"/>
+          </a:xfrm>
+          <a:prstGeom prst="rect">
+            <a:avLst/>
+          </a:prstGeom>
+          <a:noFill/>
+        </p:spPr>
+        <p:txBody>
+          <a:bodyPr wrap="square" lIns="0" rIns="0" tIns="0" bIns="0">
+            <a:spAutoFit/>
+          </a:bodyPr>
+          <a:lstStyle/>
+          <a:p>
+            <a:pPr algn="ctr"/>
+            <a:r>
+              <a:rPr sz="1200" b="1" i="0">
+                <a:solidFill>
+                  <a:srgbClr val="0C2340"/>
+                </a:solidFill>
+                <a:latin typeface="Georgia"/>
+              </a:rPr>
+              <a:t>Llama-8B  (uncompressed: 0.768)</a:t>
+            </a:r>
+          </a:p>
+        </p:txBody>
+      </p:sp>
+      <p:graphicFrame>
+        <p:nvGraphicFramePr>
+          <p:cNvPr id="7" name="Chart 6"/>
+          <p:cNvGraphicFramePr>
+            <a:graphicFrameLocks noGrp="1"/>
+          </p:cNvGraphicFramePr>
+          <p:nvPr/>
+        </p:nvGraphicFramePr>
+        <p:xfrm>
+          <a:off x="411480" y="1691640"/>
+          <a:ext cx="3977639" cy="2514600"/>
+        </p:xfrm>
+        <a:graphic>
+          <a:graphicData uri="http://schemas.openxmlformats.org/drawingml/2006/chart">
+            <c:chart xmlns:c="http://schemas.openxmlformats.org/drawingml/2006/chart" r:id="rId2"/>
+          </a:graphicData>
+        </a:graphic>
+      </p:graphicFrame>
+      <p:sp>
+        <p:nvSpPr>
+          <p:cNvPr id="8" name="TextBox 7"/>
+          <p:cNvSpPr txBox="1"/>
+          <p:nvPr/>
+        </p:nvSpPr>
+        <p:spPr>
+          <a:xfrm>
+            <a:off x="4709160" y="1371600"/>
+            <a:ext cx="3977639" cy="274320"/>
+          </a:xfrm>
+          <a:prstGeom prst="rect">
+            <a:avLst/>
+          </a:prstGeom>
+          <a:noFill/>
+        </p:spPr>
+        <p:txBody>
+          <a:bodyPr wrap="square" lIns="0" rIns="0" tIns="0" bIns="0">
+            <a:spAutoFit/>
+          </a:bodyPr>
+          <a:lstStyle/>
+          <a:p>
+            <a:pPr algn="ctr"/>
+            <a:r>
+              <a:rPr sz="1200" b="1" i="0">
+                <a:solidFill>
+                  <a:srgbClr val="0C2340"/>
+                </a:solidFill>
+                <a:latin typeface="Georgia"/>
+              </a:rPr>
+              <a:t>Qwen-7B  (uncompressed: 0.765)</a:t>
+            </a:r>
+          </a:p>
+        </p:txBody>
+      </p:sp>
+      <p:graphicFrame>
+        <p:nvGraphicFramePr>
+          <p:cNvPr id="9" name="Chart 8"/>
+          <p:cNvGraphicFramePr>
+            <a:graphicFrameLocks noGrp="1"/>
+          </p:cNvGraphicFramePr>
+          <p:nvPr/>
+        </p:nvGraphicFramePr>
+        <p:xfrm>
+          <a:off x="4709160" y="1691640"/>
+          <a:ext cx="3977639" cy="2514600"/>
+        </p:xfrm>
+        <a:graphic>
+          <a:graphicData uri="http://schemas.openxmlformats.org/drawingml/2006/chart">
+            <c:chart xmlns:c="http://schemas.openxmlformats.org/drawingml/2006/chart" r:id="rId3"/>
+          </a:graphicData>
+        </a:graphic>
+      </p:graphicFrame>
+      <p:sp>
+        <p:nvSpPr>
+          <p:cNvPr id="10" name="TextBox 9"/>
+          <p:cNvSpPr txBox="1"/>
+          <p:nvPr/>
+        </p:nvSpPr>
+        <p:spPr>
+          <a:xfrm>
+            <a:off x="411480" y="4315968"/>
             <a:ext cx="8321040" cy="548640"/>
           </a:xfrm>
           <a:prstGeom prst="rect">
@@ -10673,262 +11308,22 @@
           <a:p>
             <a:pPr algn="l"/>
             <a:r>
-              <a:rPr sz="1350" b="0" i="0">
+              <a:rPr sz="1250" b="1" i="0">
+                <a:solidFill>
+                  <a:srgbClr val="AE9141"/>
+                </a:solidFill>
+                <a:latin typeface="Georgia"/>
+              </a:rPr>
+              <a:t>The window: </a:t>
+            </a:r>
+            <a:r>
+              <a:rPr sz="1250" b="0" i="0">
                 <a:solidFill>
                   <a:srgbClr val="0C2340"/>
                 </a:solidFill>
                 <a:latin typeface="Georgia"/>
               </a:rPr>
-              <a:t>Same Llama-8B model, compressed to 3 bits in three different ways — IFEval scores (“protection” = the same top-0.5% weight set as in Finding 2):</a:t>
-            </a:r>
-          </a:p>
-        </p:txBody>
-      </p:sp>
-      <p:sp>
-        <p:nvSpPr>
-          <p:cNvPr id="7" name="TextBox 6"/>
-          <p:cNvSpPr txBox="1"/>
-          <p:nvPr/>
-        </p:nvSpPr>
-        <p:spPr>
-          <a:xfrm>
-            <a:off x="640080" y="1920240"/>
-            <a:ext cx="2468880" cy="1371600"/>
-          </a:xfrm>
-          <a:prstGeom prst="rect">
-            <a:avLst/>
-          </a:prstGeom>
-          <a:noFill/>
-        </p:spPr>
-        <p:txBody>
-          <a:bodyPr wrap="square" lIns="0" rIns="0" tIns="0" bIns="0">
-            <a:spAutoFit/>
-          </a:bodyPr>
-          <a:lstStyle/>
-          <a:p>
-            <a:pPr algn="ctr"/>
-            <a:r>
-              <a:rPr sz="4000" b="1" i="0">
-                <a:solidFill>
-                  <a:srgbClr val="0C2340"/>
-                </a:solidFill>
-                <a:latin typeface="Georgia"/>
-              </a:rPr>
-              <a:t>0.57</a:t>
-            </a:r>
-          </a:p>
-          <a:p>
-            <a:pPr algn="ctr">
-              <a:spcBef>
-                <a:spcPts val="300"/>
-              </a:spcBef>
-            </a:pPr>
-            <a:r>
-              <a:rPr sz="1200" b="1" i="0">
-                <a:solidFill>
-                  <a:srgbClr val="0C2340"/>
-                </a:solidFill>
-                <a:latin typeface="Georgia"/>
-              </a:rPr>
-              <a:t>naive rounding (RTN)</a:t>
-            </a:r>
-          </a:p>
-          <a:p>
-            <a:pPr algn="ctr"/>
-            <a:r>
-              <a:rPr sz="1200" b="0" i="0">
-                <a:solidFill>
-                  <a:srgbClr val="0C2340"/>
-                </a:solidFill>
-                <a:latin typeface="Georgia"/>
-              </a:rPr>
-              <a:t>no error correction → damaged, not dead</a:t>
-            </a:r>
-          </a:p>
-        </p:txBody>
-      </p:sp>
-      <p:sp>
-        <p:nvSpPr>
-          <p:cNvPr id="8" name="TextBox 7"/>
-          <p:cNvSpPr txBox="1"/>
-          <p:nvPr/>
-        </p:nvSpPr>
-        <p:spPr>
-          <a:xfrm>
-            <a:off x="3429000" y="1920240"/>
-            <a:ext cx="2468880" cy="1371600"/>
-          </a:xfrm>
-          <a:prstGeom prst="rect">
-            <a:avLst/>
-          </a:prstGeom>
-          <a:noFill/>
-        </p:spPr>
-        <p:txBody>
-          <a:bodyPr wrap="square" lIns="0" rIns="0" tIns="0" bIns="0">
-            <a:spAutoFit/>
-          </a:bodyPr>
-          <a:lstStyle/>
-          <a:p>
-            <a:pPr algn="ctr"/>
-            <a:r>
-              <a:rPr sz="4000" b="1" i="0">
-                <a:solidFill>
-                  <a:srgbClr val="9B1B1B"/>
-                </a:solidFill>
-                <a:latin typeface="Georgia"/>
-              </a:rPr>
-              <a:t>0.15</a:t>
-            </a:r>
-          </a:p>
-          <a:p>
-            <a:pPr algn="ctr">
-              <a:spcBef>
-                <a:spcPts val="300"/>
-              </a:spcBef>
-            </a:pPr>
-            <a:r>
-              <a:rPr sz="1200" b="1" i="0">
-                <a:solidFill>
-                  <a:srgbClr val="0C2340"/>
-                </a:solidFill>
-                <a:latin typeface="Georgia"/>
-              </a:rPr>
-              <a:t>smart GPTQ</a:t>
-            </a:r>
-          </a:p>
-          <a:p>
-            <a:pPr algn="ctr"/>
-            <a:r>
-              <a:rPr sz="1200" b="0" i="0">
-                <a:solidFill>
-                  <a:srgbClr val="0C2340"/>
-                </a:solidFill>
-                <a:latin typeface="Georgia"/>
-              </a:rPr>
-              <a:t>error correction on → COLLAPSE</a:t>
-            </a:r>
-          </a:p>
-        </p:txBody>
-      </p:sp>
-      <p:sp>
-        <p:nvSpPr>
-          <p:cNvPr id="9" name="TextBox 8"/>
-          <p:cNvSpPr txBox="1"/>
-          <p:nvPr/>
-        </p:nvSpPr>
-        <p:spPr>
-          <a:xfrm>
-            <a:off x="6217920" y="1920240"/>
-            <a:ext cx="2468880" cy="1371600"/>
-          </a:xfrm>
-          <a:prstGeom prst="rect">
-            <a:avLst/>
-          </a:prstGeom>
-          <a:noFill/>
-        </p:spPr>
-        <p:txBody>
-          <a:bodyPr wrap="square" lIns="0" rIns="0" tIns="0" bIns="0">
-            <a:spAutoFit/>
-          </a:bodyPr>
-          <a:lstStyle/>
-          <a:p>
-            <a:pPr algn="ctr"/>
-            <a:r>
-              <a:rPr sz="4000" b="1" i="0">
-                <a:solidFill>
-                  <a:srgbClr val="0A833C"/>
-                </a:solidFill>
-                <a:latin typeface="Georgia"/>
-              </a:rPr>
-              <a:t>0.64</a:t>
-            </a:r>
-          </a:p>
-          <a:p>
-            <a:pPr algn="ctr">
-              <a:spcBef>
-                <a:spcPts val="300"/>
-              </a:spcBef>
-            </a:pPr>
-            <a:r>
-              <a:rPr sz="1200" b="1" i="0">
-                <a:solidFill>
-                  <a:srgbClr val="0C2340"/>
-                </a:solidFill>
-                <a:latin typeface="Georgia"/>
-              </a:rPr>
-              <a:t>smart GPTQ + protection</a:t>
-            </a:r>
-          </a:p>
-          <a:p>
-            <a:pPr algn="ctr"/>
-            <a:r>
-              <a:rPr sz="1200" b="0" i="0">
-                <a:solidFill>
-                  <a:srgbClr val="0C2340"/>
-                </a:solidFill>
-                <a:latin typeface="Georgia"/>
-              </a:rPr>
-              <a:t>correction told to skip those 0.5%</a:t>
-            </a:r>
-          </a:p>
-        </p:txBody>
-      </p:sp>
-      <p:sp>
-        <p:nvSpPr>
-          <p:cNvPr id="10" name="TextBox 9"/>
-          <p:cNvSpPr txBox="1"/>
-          <p:nvPr/>
-        </p:nvSpPr>
-        <p:spPr>
-          <a:xfrm>
-            <a:off x="411480" y="3520440"/>
-            <a:ext cx="8321040" cy="1188720"/>
-          </a:xfrm>
-          <a:prstGeom prst="rect">
-            <a:avLst/>
-          </a:prstGeom>
-          <a:noFill/>
-        </p:spPr>
-        <p:txBody>
-          <a:bodyPr wrap="square" lIns="0" rIns="0" tIns="0" bIns="0">
-            <a:spAutoFit/>
-          </a:bodyPr>
-          <a:lstStyle/>
-          <a:p>
-            <a:pPr algn="l">
-              <a:spcAft>
-                <a:spcPts val="700"/>
-              </a:spcAft>
-            </a:pPr>
-            <a:r>
-              <a:rPr sz="1350" b="1" i="0">
-                <a:solidFill>
-                  <a:srgbClr val="0C2340"/>
-                </a:solidFill>
-                <a:latin typeface="Georgia"/>
-              </a:rPr>
-              <a:t>The “smart” correction is the problem: </a:t>
-            </a:r>
-            <a:r>
-              <a:rPr sz="1350" b="0" i="0">
-                <a:solidFill>
-                  <a:srgbClr val="0C2340"/>
-                </a:solidFill>
-                <a:latin typeface="Georgia"/>
-              </a:rPr>
-              <a:t>when it touches ~100,000 hyper-sensitive weights (0.001% of the model — zeroing them at full precision also destroys the model), it spreads their error everywhere.</a:t>
-            </a:r>
-          </a:p>
-          <a:p>
-            <a:pPr algn="l"/>
-            <a:r>
-              <a:rPr sz="1350" b="0" i="0">
-                <a:solidFill>
-                  <a:srgbClr val="0C2340"/>
-                </a:solidFill>
-                <a:latin typeface="Georgia"/>
-              </a:rPr>
-              <a:t>Proof: repairing those weights afterwards does NOT help (0.16) — the damage already lives in the rest of the network. Protection must happen during compression.</a:t>
+              <a:t>too mild → nothing to fix (gains ≈0) · collapse → decisive (+0.49) · too extreme (2-bit) → beyond saving (even a 10× budget stays at 0.13).</a:t>
             </a:r>
           </a:p>
         </p:txBody>
@@ -10979,7 +11374,7 @@
                 </a:solidFill>
                 <a:latin typeface="Georgia"/>
               </a:rPr>
-              <a:t>The Damage Can Be Invisible to Standard Checks</a:t>
+              <a:t>The Culprit: the Compressor's Own Error Correction</a:t>
             </a:r>
           </a:p>
         </p:txBody>
@@ -11006,7 +11401,7 @@
                 </a:solidFill>
                 <a:latin typeface="Georgia"/>
               </a:rPr>
-              <a:t>FINDING 5</a:t>
+              <a:t>FINDING 4</a:t>
             </a:r>
           </a:p>
         </p:txBody>
@@ -11019,8 +11414,8 @@
         </p:nvSpPr>
         <p:spPr>
           <a:xfrm>
-            <a:off x="411480" y="1417320"/>
-            <a:ext cx="4480560" cy="914400"/>
+            <a:off x="411480" y="1371600"/>
+            <a:ext cx="8321040" cy="548640"/>
           </a:xfrm>
           <a:prstGeom prst="rect">
             <a:avLst/>
@@ -11033,19 +11428,15 @@
           </a:bodyPr>
           <a:lstStyle/>
           <a:p>
-            <a:pPr algn="l">
-              <a:spcAft>
-                <a:spcPts val="400"/>
-              </a:spcAft>
-            </a:pPr>
-            <a:r>
-              <a:rPr sz="1250" b="0" i="0">
+            <a:pPr algn="l"/>
+            <a:r>
+              <a:rPr sz="1350" b="0" i="0">
                 <a:solidFill>
                   <a:srgbClr val="0C2340"/>
                 </a:solidFill>
                 <a:latin typeface="Georgia"/>
               </a:rPr>
-              <a:t>The compressed Qwen-14B gets stuck repeating itself. A real answer it gave to a grade-school math problem:</a:t>
+              <a:t>Same Llama-8B model, compressed to 3 bits in three different ways — IFEval scores (“protection” = the same top-0.5% weight set as in Finding 2):</a:t>
             </a:r>
           </a:p>
         </p:txBody>
@@ -11058,44 +11449,8 @@
         </p:nvSpPr>
         <p:spPr>
           <a:xfrm>
-            <a:off x="411480" y="1874519"/>
-            <a:ext cx="4480560" cy="1737360"/>
-          </a:xfrm>
-          <a:prstGeom prst="rect">
-            <a:avLst/>
-          </a:prstGeom>
-          <a:solidFill>
-            <a:srgbClr val="EFE9D9"/>
-          </a:solidFill>
-        </p:spPr>
-        <p:txBody>
-          <a:bodyPr wrap="square" lIns="109728" rIns="109728" tIns="109728" bIns="109728">
-            <a:spAutoFit/>
-          </a:bodyPr>
-          <a:lstStyle/>
-          <a:p>
-            <a:r>
-              <a:rPr sz="1200" i="1">
-                <a:solidFill>
-                  <a:srgbClr val="9B1B1B"/>
-                </a:solidFill>
-                <a:latin typeface="Georgia"/>
-              </a:rPr>
-              <a:t>“… each pail contains 5 × 5 = 250 liters of water. Therefore, each pail contains 5 × 5 = 250 liters of water. Therefore, each pail contains 5 × 5 = 250 liters of water. Therefore, each pail …”</a:t>
-            </a:r>
-          </a:p>
-        </p:txBody>
-      </p:sp>
-      <p:sp>
-        <p:nvSpPr>
-          <p:cNvPr id="8" name="TextBox 7"/>
-          <p:cNvSpPr txBox="1"/>
-          <p:nvPr/>
-        </p:nvSpPr>
-        <p:spPr>
-          <a:xfrm>
-            <a:off x="411480" y="3703320"/>
-            <a:ext cx="4480560" cy="914400"/>
+            <a:off x="640080" y="1920240"/>
+            <a:ext cx="2468880" cy="1371600"/>
           </a:xfrm>
           <a:prstGeom prst="rect">
             <a:avLst/>
@@ -11108,29 +11463,57 @@
           </a:bodyPr>
           <a:lstStyle/>
           <a:p>
-            <a:pPr algn="l"/>
-            <a:r>
-              <a:rPr sz="1250" b="1" i="0">
+            <a:pPr algn="ctr"/>
+            <a:r>
+              <a:rPr sz="4000" b="1" i="0">
                 <a:solidFill>
                   <a:srgbClr val="0C2340"/>
                 </a:solidFill>
                 <a:latin typeface="Georgia"/>
               </a:rPr>
-              <a:t>69 out of every 100 answers end in a loop like this. The uncompressed model: fewer than 1 in 100.</a:t>
-            </a:r>
-          </a:p>
-        </p:txBody>
-      </p:sp>
-      <p:sp>
-        <p:nvSpPr>
-          <p:cNvPr id="9" name="TextBox 8"/>
+              <a:t>0.57</a:t>
+            </a:r>
+          </a:p>
+          <a:p>
+            <a:pPr algn="ctr">
+              <a:spcBef>
+                <a:spcPts val="300"/>
+              </a:spcBef>
+            </a:pPr>
+            <a:r>
+              <a:rPr sz="1200" b="1" i="0">
+                <a:solidFill>
+                  <a:srgbClr val="0C2340"/>
+                </a:solidFill>
+                <a:latin typeface="Georgia"/>
+              </a:rPr>
+              <a:t>naive rounding (RTN)</a:t>
+            </a:r>
+          </a:p>
+          <a:p>
+            <a:pPr algn="ctr"/>
+            <a:r>
+              <a:rPr sz="1200" b="0" i="0">
+                <a:solidFill>
+                  <a:srgbClr val="0C2340"/>
+                </a:solidFill>
+                <a:latin typeface="Georgia"/>
+              </a:rPr>
+              <a:t>no error correction → damaged, not dead</a:t>
+            </a:r>
+          </a:p>
+        </p:txBody>
+      </p:sp>
+      <p:sp>
+        <p:nvSpPr>
+          <p:cNvPr id="8" name="TextBox 7"/>
           <p:cNvSpPr txBox="1"/>
           <p:nvPr/>
         </p:nvSpPr>
         <p:spPr>
           <a:xfrm>
-            <a:off x="5257800" y="1417320"/>
-            <a:ext cx="3520440" cy="365760"/>
+            <a:off x="3429000" y="1920240"/>
+            <a:ext cx="2468880" cy="1371600"/>
           </a:xfrm>
           <a:prstGeom prst="rect">
             <a:avLst/>
@@ -11143,29 +11526,57 @@
           </a:bodyPr>
           <a:lstStyle/>
           <a:p>
-            <a:pPr algn="l"/>
-            <a:r>
-              <a:rPr sz="1100" b="1" i="0">
-                <a:solidFill>
-                  <a:srgbClr val="AE9141"/>
+            <a:pPr algn="ctr"/>
+            <a:r>
+              <a:rPr sz="4000" b="1" i="0">
+                <a:solidFill>
+                  <a:srgbClr val="9B1B1B"/>
                 </a:solidFill>
                 <a:latin typeface="Georgia"/>
               </a:rPr>
-              <a:t>YET THE FIELD'S STANDARD CHECKS SAY “FINE”:</a:t>
-            </a:r>
-          </a:p>
-        </p:txBody>
-      </p:sp>
-      <p:sp>
-        <p:nvSpPr>
-          <p:cNvPr id="10" name="TextBox 9"/>
+              <a:t>0.15</a:t>
+            </a:r>
+          </a:p>
+          <a:p>
+            <a:pPr algn="ctr">
+              <a:spcBef>
+                <a:spcPts val="300"/>
+              </a:spcBef>
+            </a:pPr>
+            <a:r>
+              <a:rPr sz="1200" b="1" i="0">
+                <a:solidFill>
+                  <a:srgbClr val="0C2340"/>
+                </a:solidFill>
+                <a:latin typeface="Georgia"/>
+              </a:rPr>
+              <a:t>smart GPTQ</a:t>
+            </a:r>
+          </a:p>
+          <a:p>
+            <a:pPr algn="ctr"/>
+            <a:r>
+              <a:rPr sz="1200" b="0" i="0">
+                <a:solidFill>
+                  <a:srgbClr val="0C2340"/>
+                </a:solidFill>
+                <a:latin typeface="Georgia"/>
+              </a:rPr>
+              <a:t>error correction on → COLLAPSE</a:t>
+            </a:r>
+          </a:p>
+        </p:txBody>
+      </p:sp>
+      <p:sp>
+        <p:nvSpPr>
+          <p:cNvPr id="9" name="TextBox 8"/>
           <p:cNvSpPr txBox="1"/>
           <p:nvPr/>
         </p:nvSpPr>
         <p:spPr>
           <a:xfrm>
-            <a:off x="5257800" y="1828800"/>
-            <a:ext cx="3520440" cy="1005840"/>
+            <a:off x="6217920" y="1920240"/>
+            <a:ext cx="2468880" cy="1371600"/>
           </a:xfrm>
           <a:prstGeom prst="rect">
             <a:avLst/>
@@ -11180,43 +11591,55 @@
           <a:p>
             <a:pPr algn="ctr"/>
             <a:r>
-              <a:rPr sz="2400" b="1" i="0">
+              <a:rPr sz="4000" b="1" i="0">
+                <a:solidFill>
+                  <a:srgbClr val="0A833C"/>
+                </a:solidFill>
+                <a:latin typeface="Georgia"/>
+              </a:rPr>
+              <a:t>0.64</a:t>
+            </a:r>
+          </a:p>
+          <a:p>
+            <a:pPr algn="ctr">
+              <a:spcBef>
+                <a:spcPts val="300"/>
+              </a:spcBef>
+            </a:pPr>
+            <a:r>
+              <a:rPr sz="1200" b="1" i="0">
                 <a:solidFill>
                   <a:srgbClr val="0C2340"/>
                 </a:solidFill>
                 <a:latin typeface="Georgia"/>
               </a:rPr>
-              <a:t>looks fine</a:t>
-            </a:r>
-          </a:p>
-          <a:p>
-            <a:pPr algn="ctr">
-              <a:spcBef>
-                <a:spcPts val="300"/>
-              </a:spcBef>
-            </a:pPr>
-            <a:r>
-              <a:rPr sz="1100" b="0" i="0">
+              <a:t>smart GPTQ + protection</a:t>
+            </a:r>
+          </a:p>
+          <a:p>
+            <a:pPr algn="ctr"/>
+            <a:r>
+              <a:rPr sz="1200" b="0" i="0">
                 <a:solidFill>
                   <a:srgbClr val="0C2340"/>
                 </a:solidFill>
                 <a:latin typeface="Georgia"/>
               </a:rPr>
-              <a:t>on perplexity, the default quality check (+35%, same as the harmless cases)</a:t>
-            </a:r>
-          </a:p>
-        </p:txBody>
-      </p:sp>
-      <p:sp>
-        <p:nvSpPr>
-          <p:cNvPr id="11" name="TextBox 10"/>
+              <a:t>correction told to skip those 0.5%</a:t>
+            </a:r>
+          </a:p>
+        </p:txBody>
+      </p:sp>
+      <p:sp>
+        <p:nvSpPr>
+          <p:cNvPr id="10" name="TextBox 9"/>
           <p:cNvSpPr txBox="1"/>
           <p:nvPr/>
         </p:nvSpPr>
         <p:spPr>
           <a:xfrm>
-            <a:off x="5257800" y="2697480"/>
-            <a:ext cx="3520440" cy="1005840"/>
+            <a:off x="411480" y="3520440"/>
+            <a:ext cx="8321040" cy="1188720"/>
           </a:xfrm>
           <a:prstGeom prst="rect">
             <a:avLst/>
@@ -11229,82 +11652,40 @@
           </a:bodyPr>
           <a:lstStyle/>
           <a:p>
-            <a:pPr algn="ctr"/>
-            <a:r>
-              <a:rPr sz="2400" b="1" i="0">
+            <a:pPr algn="l">
+              <a:spcAft>
+                <a:spcPts val="700"/>
+              </a:spcAft>
+            </a:pPr>
+            <a:r>
+              <a:rPr sz="1350" b="1" i="0">
                 <a:solidFill>
                   <a:srgbClr val="0C2340"/>
                 </a:solidFill>
                 <a:latin typeface="Georgia"/>
               </a:rPr>
-              <a:t>looks fine</a:t>
-            </a:r>
-          </a:p>
-          <a:p>
-            <a:pPr algn="ctr">
-              <a:spcBef>
-                <a:spcPts val="300"/>
-              </a:spcBef>
-            </a:pPr>
-            <a:r>
-              <a:rPr sz="1100" b="0" i="0">
+              <a:t>The “smart” correction is the problem: </a:t>
+            </a:r>
+            <a:r>
+              <a:rPr sz="1350" b="0" i="0">
                 <a:solidFill>
                   <a:srgbClr val="0C2340"/>
                 </a:solidFill>
                 <a:latin typeface="Georgia"/>
               </a:rPr>
-              <a:t>on the MMLU knowledge quiz (−6 points, same as the harmless cases)</a:t>
-            </a:r>
-          </a:p>
-        </p:txBody>
-      </p:sp>
-      <p:sp>
-        <p:nvSpPr>
-          <p:cNvPr id="12" name="TextBox 11"/>
-          <p:cNvSpPr txBox="1"/>
-          <p:nvPr/>
-        </p:nvSpPr>
-        <p:spPr>
-          <a:xfrm>
-            <a:off x="5257800" y="3611880"/>
-            <a:ext cx="3520440" cy="1005840"/>
-          </a:xfrm>
-          <a:prstGeom prst="rect">
-            <a:avLst/>
-          </a:prstGeom>
-          <a:noFill/>
-        </p:spPr>
-        <p:txBody>
-          <a:bodyPr wrap="square" lIns="0" rIns="0" tIns="0" bIns="0">
-            <a:spAutoFit/>
-          </a:bodyPr>
-          <a:lstStyle/>
-          <a:p>
-            <a:pPr algn="ctr"/>
-            <a:r>
-              <a:rPr sz="2400" b="1" i="0">
-                <a:solidFill>
-                  <a:srgbClr val="9B1B1B"/>
+              <a:t>when it touches ~100,000 hyper-sensitive weights (0.001% of the model — zeroing them at full precision also destroys the model), it spreads their error everywhere.</a:t>
+            </a:r>
+          </a:p>
+          <a:p>
+            <a:pPr algn="l"/>
+            <a:r>
+              <a:rPr sz="1350" b="0" i="0">
+                <a:solidFill>
+                  <a:srgbClr val="0C2340"/>
                 </a:solidFill>
                 <a:latin typeface="Georgia"/>
               </a:rPr>
-              <a:t>0.93 → 0.13</a:t>
-            </a:r>
-          </a:p>
-          <a:p>
-            <a:pPr algn="ctr">
-              <a:spcBef>
-                <a:spcPts val="300"/>
-              </a:spcBef>
-            </a:pPr>
-            <a:r>
-              <a:rPr sz="1100" b="0" i="0">
-                <a:solidFill>
-                  <a:srgbClr val="0C2340"/>
-                </a:solidFill>
-                <a:latin typeface="Georgia"/>
-              </a:rPr>
-              <a:t>actual math score — the collapse both checks failed to notice</a:t>
+              <a:t>Proof: repairing those weights afterwards does NOT help (0.16) — the damage already lives in the rest of the network. Protection must happen during compression.</a:t>
             </a:r>
           </a:p>
         </p:txBody>
@@ -11355,7 +11736,7 @@
                 </a:solidFill>
                 <a:latin typeface="Georgia"/>
               </a:rPr>
-              <a:t>What This Paper Says</a:t>
+              <a:t>The Damage Can Be Invisible to Standard Checks</a:t>
             </a:r>
           </a:p>
         </p:txBody>
@@ -11382,7 +11763,7 @@
                 </a:solidFill>
                 <a:latin typeface="Georgia"/>
               </a:rPr>
-              <a:t>SUMMARY</a:t>
+              <a:t>FINDING 5</a:t>
             </a:r>
           </a:p>
         </p:txBody>
@@ -11395,8 +11776,8 @@
         </p:nvSpPr>
         <p:spPr>
           <a:xfrm>
-            <a:off x="411480" y="1463040"/>
-            <a:ext cx="8321040" cy="3200400"/>
+            <a:off x="411480" y="1417320"/>
+            <a:ext cx="4480560" cy="914400"/>
           </a:xfrm>
           <a:prstGeom prst="rect">
             <a:avLst/>
@@ -11411,137 +11792,276 @@
           <a:p>
             <a:pPr algn="l">
               <a:spcAft>
-                <a:spcPts val="1200"/>
+                <a:spcPts val="400"/>
               </a:spcAft>
             </a:pPr>
             <a:r>
-              <a:rPr sz="1350" b="1" i="0">
+              <a:rPr sz="1250" b="0" i="0">
+                <a:solidFill>
+                  <a:srgbClr val="0C2340"/>
+                </a:solidFill>
+                <a:latin typeface="Georgia"/>
+              </a:rPr>
+              <a:t>The compressed Qwen-14B gets stuck repeating itself. A real answer it gave to a grade-school math problem:</a:t>
+            </a:r>
+          </a:p>
+        </p:txBody>
+      </p:sp>
+      <p:sp>
+        <p:nvSpPr>
+          <p:cNvPr id="7" name="TextBox 6"/>
+          <p:cNvSpPr txBox="1"/>
+          <p:nvPr/>
+        </p:nvSpPr>
+        <p:spPr>
+          <a:xfrm>
+            <a:off x="411480" y="1874519"/>
+            <a:ext cx="4480560" cy="1737360"/>
+          </a:xfrm>
+          <a:prstGeom prst="rect">
+            <a:avLst/>
+          </a:prstGeom>
+          <a:solidFill>
+            <a:srgbClr val="EFE9D9"/>
+          </a:solidFill>
+        </p:spPr>
+        <p:txBody>
+          <a:bodyPr wrap="square" lIns="109728" rIns="109728" tIns="109728" bIns="109728">
+            <a:spAutoFit/>
+          </a:bodyPr>
+          <a:lstStyle/>
+          <a:p>
+            <a:r>
+              <a:rPr sz="1200" i="1">
+                <a:solidFill>
+                  <a:srgbClr val="9B1B1B"/>
+                </a:solidFill>
+                <a:latin typeface="Georgia"/>
+              </a:rPr>
+              <a:t>“… each pail contains 5 × 5 = 250 liters of water. Therefore, each pail contains 5 × 5 = 250 liters of water. Therefore, each pail contains 5 × 5 = 250 liters of water. Therefore, each pail …”</a:t>
+            </a:r>
+          </a:p>
+        </p:txBody>
+      </p:sp>
+      <p:sp>
+        <p:nvSpPr>
+          <p:cNvPr id="8" name="TextBox 7"/>
+          <p:cNvSpPr txBox="1"/>
+          <p:nvPr/>
+        </p:nvSpPr>
+        <p:spPr>
+          <a:xfrm>
+            <a:off x="411480" y="3703320"/>
+            <a:ext cx="4480560" cy="914400"/>
+          </a:xfrm>
+          <a:prstGeom prst="rect">
+            <a:avLst/>
+          </a:prstGeom>
+          <a:noFill/>
+        </p:spPr>
+        <p:txBody>
+          <a:bodyPr wrap="square" lIns="0" rIns="0" tIns="0" bIns="0">
+            <a:spAutoFit/>
+          </a:bodyPr>
+          <a:lstStyle/>
+          <a:p>
+            <a:pPr algn="l"/>
+            <a:r>
+              <a:rPr sz="1250" b="1" i="0">
+                <a:solidFill>
+                  <a:srgbClr val="0C2340"/>
+                </a:solidFill>
+                <a:latin typeface="Georgia"/>
+              </a:rPr>
+              <a:t>69 out of every 100 answers end in a loop like this. The uncompressed model: fewer than 1 in 100.</a:t>
+            </a:r>
+          </a:p>
+        </p:txBody>
+      </p:sp>
+      <p:sp>
+        <p:nvSpPr>
+          <p:cNvPr id="9" name="TextBox 8"/>
+          <p:cNvSpPr txBox="1"/>
+          <p:nvPr/>
+        </p:nvSpPr>
+        <p:spPr>
+          <a:xfrm>
+            <a:off x="5257800" y="1417320"/>
+            <a:ext cx="3520440" cy="365760"/>
+          </a:xfrm>
+          <a:prstGeom prst="rect">
+            <a:avLst/>
+          </a:prstGeom>
+          <a:noFill/>
+        </p:spPr>
+        <p:txBody>
+          <a:bodyPr wrap="square" lIns="0" rIns="0" tIns="0" bIns="0">
+            <a:spAutoFit/>
+          </a:bodyPr>
+          <a:lstStyle/>
+          <a:p>
+            <a:pPr algn="l"/>
+            <a:r>
+              <a:rPr sz="1100" b="1" i="0">
                 <a:solidFill>
                   <a:srgbClr val="AE9141"/>
                 </a:solidFill>
                 <a:latin typeface="Georgia"/>
               </a:rPr>
-              <a:t>—  </a:t>
-            </a:r>
-            <a:r>
-              <a:rPr sz="1350" b="1" i="0">
+              <a:t>YET THE FIELD'S STANDARD CHECKS SAY “FINE”:</a:t>
+            </a:r>
+          </a:p>
+        </p:txBody>
+      </p:sp>
+      <p:sp>
+        <p:nvSpPr>
+          <p:cNvPr id="10" name="TextBox 9"/>
+          <p:cNvSpPr txBox="1"/>
+          <p:nvPr/>
+        </p:nvSpPr>
+        <p:spPr>
+          <a:xfrm>
+            <a:off x="5257800" y="1828800"/>
+            <a:ext cx="3520440" cy="1005840"/>
+          </a:xfrm>
+          <a:prstGeom prst="rect">
+            <a:avLst/>
+          </a:prstGeom>
+          <a:noFill/>
+        </p:spPr>
+        <p:txBody>
+          <a:bodyPr wrap="square" lIns="0" rIns="0" tIns="0" bIns="0">
+            <a:spAutoFit/>
+          </a:bodyPr>
+          <a:lstStyle/>
+          <a:p>
+            <a:pPr algn="ctr"/>
+            <a:r>
+              <a:rPr sz="2400" b="1" i="0">
                 <a:solidFill>
                   <a:srgbClr val="0C2340"/>
                 </a:solidFill>
                 <a:latin typeface="Georgia"/>
               </a:rPr>
-              <a:t>1 · Compression damage comes in two modes. </a:t>
-            </a:r>
-            <a:r>
-              <a:rPr sz="1350" b="0" i="0">
+              <a:t>looks fine</a:t>
+            </a:r>
+          </a:p>
+          <a:p>
+            <a:pPr algn="ctr">
+              <a:spcBef>
+                <a:spcPts val="300"/>
+              </a:spcBef>
+            </a:pPr>
+            <a:r>
+              <a:rPr sz="1100" b="0" i="0">
                 <a:solidFill>
                   <a:srgbClr val="0C2340"/>
                 </a:solidFill>
                 <a:latin typeface="Georgia"/>
               </a:rPr>
-              <a:t>Usually mild; occasionally a collapse — and no statistic of the original model predicts which (we falsified every published candidate, on 6 models).</a:t>
-            </a:r>
-          </a:p>
-          <a:p>
-            <a:pPr algn="l">
-              <a:spcAft>
-                <a:spcPts val="1200"/>
-              </a:spcAft>
+              <a:t>on perplexity, the default quality check (+35%, same as the harmless cases)</a:t>
+            </a:r>
+          </a:p>
+        </p:txBody>
+      </p:sp>
+      <p:sp>
+        <p:nvSpPr>
+          <p:cNvPr id="11" name="TextBox 10"/>
+          <p:cNvSpPr txBox="1"/>
+          <p:nvPr/>
+        </p:nvSpPr>
+        <p:spPr>
+          <a:xfrm>
+            <a:off x="5257800" y="2697480"/>
+            <a:ext cx="3520440" cy="1005840"/>
+          </a:xfrm>
+          <a:prstGeom prst="rect">
+            <a:avLst/>
+          </a:prstGeom>
+          <a:noFill/>
+        </p:spPr>
+        <p:txBody>
+          <a:bodyPr wrap="square" lIns="0" rIns="0" tIns="0" bIns="0">
+            <a:spAutoFit/>
+          </a:bodyPr>
+          <a:lstStyle/>
+          <a:p>
+            <a:pPr algn="ctr"/>
+            <a:r>
+              <a:rPr sz="2400" b="1" i="0">
+                <a:solidFill>
+                  <a:srgbClr val="0C2340"/>
+                </a:solidFill>
+                <a:latin typeface="Georgia"/>
+              </a:rPr>
+              <a:t>looks fine</a:t>
+            </a:r>
+          </a:p>
+          <a:p>
+            <a:pPr algn="ctr">
+              <a:spcBef>
+                <a:spcPts val="300"/>
+              </a:spcBef>
             </a:pPr>
             <a:r>
-              <a:rPr sz="1350" b="1" i="0">
-                <a:solidFill>
-                  <a:srgbClr val="AE9141"/>
+              <a:rPr sz="1100" b="0" i="0">
+                <a:solidFill>
+                  <a:srgbClr val="0C2340"/>
                 </a:solidFill>
                 <a:latin typeface="Georgia"/>
               </a:rPr>
-              <a:t>—  </a:t>
-            </a:r>
-            <a:r>
-              <a:rPr sz="1350" b="1" i="0">
+              <a:t>on the MMLU knowledge quiz (−6 points, same as the harmless cases)</a:t>
+            </a:r>
+          </a:p>
+        </p:txBody>
+      </p:sp>
+      <p:sp>
+        <p:nvSpPr>
+          <p:cNvPr id="12" name="TextBox 11"/>
+          <p:cNvSpPr txBox="1"/>
+          <p:nvPr/>
+        </p:nvSpPr>
+        <p:spPr>
+          <a:xfrm>
+            <a:off x="5257800" y="3611880"/>
+            <a:ext cx="3520440" cy="1005840"/>
+          </a:xfrm>
+          <a:prstGeom prst="rect">
+            <a:avLst/>
+          </a:prstGeom>
+          <a:noFill/>
+        </p:spPr>
+        <p:txBody>
+          <a:bodyPr wrap="square" lIns="0" rIns="0" tIns="0" bIns="0">
+            <a:spAutoFit/>
+          </a:bodyPr>
+          <a:lstStyle/>
+          <a:p>
+            <a:pPr algn="ctr"/>
+            <a:r>
+              <a:rPr sz="2400" b="1" i="0">
+                <a:solidFill>
+                  <a:srgbClr val="9B1B1B"/>
+                </a:solidFill>
+                <a:latin typeface="Georgia"/>
+              </a:rPr>
+              <a:t>0.93 → 0.13</a:t>
+            </a:r>
+          </a:p>
+          <a:p>
+            <a:pPr algn="ctr">
+              <a:spcBef>
+                <a:spcPts val="300"/>
+              </a:spcBef>
+            </a:pPr>
+            <a:r>
+              <a:rPr sz="1100" b="0" i="0">
                 <a:solidFill>
                   <a:srgbClr val="0C2340"/>
                 </a:solidFill>
                 <a:latin typeface="Georgia"/>
               </a:rPr>
-              <a:t>2 · Protection is a collapse-repair tool, not a general upgrade. </a:t>
-            </a:r>
-            <a:r>
-              <a:rPr sz="1350" b="0" i="0">
-                <a:solidFill>
-                  <a:srgbClr val="0C2340"/>
-                </a:solidFill>
-                <a:latin typeface="Georgia"/>
-              </a:rPr>
-              <a:t>In a collapse it beats every alternative (including the newest rotation-based methods); otherwise it buys nothing.</a:t>
-            </a:r>
-          </a:p>
-          <a:p>
-            <a:pPr algn="l">
-              <a:spcAft>
-                <a:spcPts val="1200"/>
-              </a:spcAft>
-            </a:pPr>
-            <a:r>
-              <a:rPr sz="1350" b="1" i="0">
-                <a:solidFill>
-                  <a:srgbClr val="AE9141"/>
-                </a:solidFill>
-                <a:latin typeface="Georgia"/>
-              </a:rPr>
-              <a:t>—  </a:t>
-            </a:r>
-            <a:r>
-              <a:rPr sz="1350" b="1" i="0">
-                <a:solidFill>
-                  <a:srgbClr val="0C2340"/>
-                </a:solidFill>
-                <a:latin typeface="Georgia"/>
-              </a:rPr>
-              <a:t>3 · The cause is the compressor, not the low precision. </a:t>
-            </a:r>
-            <a:r>
-              <a:rPr sz="1350" b="0" i="0">
-                <a:solidFill>
-                  <a:srgbClr val="0C2340"/>
-                </a:solidFill>
-                <a:latin typeface="Georgia"/>
-              </a:rPr>
-              <a:t>GPTQ's error correction × ~10⁵ hyper-sensitive weights. Naive rounding never collapses.</a:t>
-            </a:r>
-          </a:p>
-          <a:p>
-            <a:pPr algn="l">
-              <a:spcAft>
-                <a:spcPts val="1200"/>
-              </a:spcAft>
-            </a:pPr>
-            <a:r>
-              <a:rPr sz="1350" b="1" i="0">
-                <a:solidFill>
-                  <a:srgbClr val="AE9141"/>
-                </a:solidFill>
-                <a:latin typeface="Georgia"/>
-              </a:rPr>
-              <a:t>—  </a:t>
-            </a:r>
-            <a:r>
-              <a:rPr sz="1350" b="1" i="0">
-                <a:solidFill>
-                  <a:srgbClr val="0C2340"/>
-                </a:solidFill>
-                <a:latin typeface="Georgia"/>
-              </a:rPr>
-              <a:t>4 · Evaluation warning for the field. </a:t>
-            </a:r>
-            <a:r>
-              <a:rPr sz="1350" b="0" i="0">
-                <a:solidFill>
-                  <a:srgbClr val="0C2340"/>
-                </a:solidFill>
-                <a:latin typeface="Georgia"/>
-              </a:rPr>
-              <a:t>A compressed model can pass perplexity + MMLU while losing 80% of its generative ability. Always test with generation.</a:t>
+              <a:t>actual math score — the collapse both checks failed to notice</a:t>
             </a:r>
           </a:p>
         </p:txBody>
@@ -11592,7 +12112,7 @@
                 </a:solidFill>
                 <a:latin typeface="Georgia"/>
               </a:rPr>
-              <a:t>The Two Closest Papers — and Where This Goes</a:t>
+              <a:t>What This Paper Says</a:t>
             </a:r>
           </a:p>
         </p:txBody>
@@ -11619,7 +12139,7 @@
                 </a:solidFill>
                 <a:latin typeface="Georgia"/>
               </a:rPr>
-              <a:t>RELATED WORK &amp; PLAN</a:t>
+              <a:t>SUMMARY</a:t>
             </a:r>
           </a:p>
         </p:txBody>
@@ -11632,8 +12152,8 @@
         </p:nvSpPr>
         <p:spPr>
           <a:xfrm>
-            <a:off x="411480" y="1417320"/>
-            <a:ext cx="4892040" cy="3291840"/>
+            <a:off x="411480" y="1463040"/>
+            <a:ext cx="8321040" cy="3200400"/>
           </a:xfrm>
           <a:prstGeom prst="rect">
             <a:avLst/>
@@ -11648,144 +12168,137 @@
           <a:p>
             <a:pPr algn="l">
               <a:spcAft>
-                <a:spcPts val="400"/>
+                <a:spcPts val="1200"/>
               </a:spcAft>
             </a:pPr>
             <a:r>
-              <a:rPr sz="1300" b="1" i="0">
+              <a:rPr sz="1350" b="1" i="0">
                 <a:solidFill>
                   <a:srgbClr val="AE9141"/>
                 </a:solidFill>
                 <a:latin typeface="Georgia"/>
               </a:rPr>
-              <a:t>TaCQ (UNC Chapel Hill, 2025)</a:t>
+              <a:t>—  </a:t>
+            </a:r>
+            <a:r>
+              <a:rPr sz="1350" b="1" i="0">
+                <a:solidFill>
+                  <a:srgbClr val="0C2340"/>
+                </a:solidFill>
+                <a:latin typeface="Georgia"/>
+              </a:rPr>
+              <a:t>1 · Compression damage comes in two modes. </a:t>
+            </a:r>
+            <a:r>
+              <a:rPr sz="1350" b="0" i="0">
+                <a:solidFill>
+                  <a:srgbClr val="0C2340"/>
+                </a:solidFill>
+                <a:latin typeface="Georgia"/>
+              </a:rPr>
+              <a:t>Usually mild; occasionally a collapse — and no statistic of the original model predicts which (we falsified every published candidate, on 6 models).</a:t>
             </a:r>
           </a:p>
           <a:p>
             <a:pPr algn="l">
               <a:spcAft>
-                <a:spcPts val="1000"/>
+                <a:spcPts val="1200"/>
               </a:spcAft>
             </a:pPr>
             <a:r>
-              <a:rPr sz="1250" b="0" i="0">
+              <a:rPr sz="1350" b="1" i="0">
+                <a:solidFill>
+                  <a:srgbClr val="AE9141"/>
+                </a:solidFill>
+                <a:latin typeface="Georgia"/>
+              </a:rPr>
+              <a:t>—  </a:t>
+            </a:r>
+            <a:r>
+              <a:rPr sz="1350" b="1" i="0">
                 <a:solidFill>
                   <a:srgbClr val="0C2340"/>
                 </a:solidFill>
                 <a:latin typeface="Georgia"/>
               </a:rPr>
-              <a:t>Invented the importance score we use, and showed protection improves compressed models. We answer the question they never asked: WHEN does it help (only in collapses) and WHY (the error-correction mechanism).</a:t>
+              <a:t>2 · Protection is a collapse-repair tool, not a general upgrade. </a:t>
+            </a:r>
+            <a:r>
+              <a:rPr sz="1350" b="0" i="0">
+                <a:solidFill>
+                  <a:srgbClr val="0C2340"/>
+                </a:solidFill>
+                <a:latin typeface="Georgia"/>
+              </a:rPr>
+              <a:t>In a collapse it beats every alternative (including the newest rotation-based methods); otherwise it buys nothing.</a:t>
             </a:r>
           </a:p>
           <a:p>
             <a:pPr algn="l">
               <a:spcAft>
-                <a:spcPts val="400"/>
+                <a:spcPts val="1200"/>
               </a:spcAft>
             </a:pPr>
             <a:r>
-              <a:rPr sz="1300" b="1" i="0">
+              <a:rPr sz="1350" b="1" i="0">
                 <a:solidFill>
                   <a:srgbClr val="AE9141"/>
                 </a:solidFill>
                 <a:latin typeface="Georgia"/>
               </a:rPr>
-              <a:t>Super Weights (Mengxia Yu, ND + Apple, 2024)</a:t>
-            </a:r>
-          </a:p>
-          <a:p>
-            <a:pPr algn="l"/>
-            <a:r>
-              <a:rPr sz="1250" b="0" i="0">
+              <a:t>—  </a:t>
+            </a:r>
+            <a:r>
+              <a:rPr sz="1350" b="1" i="0">
                 <a:solidFill>
                   <a:srgbClr val="0C2340"/>
                 </a:solidFill>
                 <a:latin typeface="Georgia"/>
               </a:rPr>
-              <a:t>Found that every LLM has 3–6 individual “super weights” — delete one and the model dies. We tested them: protecting ONLY those few does not prevent the collapse (0.16). The collapse involves a different, ~100,000-weight set. Complementary, not competing.</a:t>
-            </a:r>
-          </a:p>
-        </p:txBody>
-      </p:sp>
-      <p:sp>
-        <p:nvSpPr>
-          <p:cNvPr id="7" name="TextBox 6"/>
-          <p:cNvSpPr txBox="1"/>
-          <p:nvPr/>
-        </p:nvSpPr>
-        <p:spPr>
-          <a:xfrm>
-            <a:off x="5715000" y="1417320"/>
-            <a:ext cx="3063240" cy="3291840"/>
-          </a:xfrm>
-          <a:prstGeom prst="rect">
-            <a:avLst/>
-          </a:prstGeom>
-          <a:noFill/>
-        </p:spPr>
-        <p:txBody>
-          <a:bodyPr wrap="square" lIns="0" rIns="0" tIns="0" bIns="0">
-            <a:spAutoFit/>
-          </a:bodyPr>
-          <a:lstStyle/>
+              <a:t>3 · The cause is the compressor, not the low precision. </a:t>
+            </a:r>
+            <a:r>
+              <a:rPr sz="1350" b="0" i="0">
+                <a:solidFill>
+                  <a:srgbClr val="0C2340"/>
+                </a:solidFill>
+                <a:latin typeface="Georgia"/>
+              </a:rPr>
+              <a:t>GPTQ's error correction × ~10⁵ hyper-sensitive weights. Naive rounding never collapses.</a:t>
+            </a:r>
+          </a:p>
           <a:p>
             <a:pPr algn="l">
               <a:spcAft>
-                <a:spcPts val="400"/>
+                <a:spcPts val="1200"/>
               </a:spcAft>
             </a:pPr>
             <a:r>
-              <a:rPr sz="1100" b="1" i="0">
+              <a:rPr sz="1350" b="1" i="0">
                 <a:solidFill>
                   <a:srgbClr val="AE9141"/>
                 </a:solidFill>
                 <a:latin typeface="Georgia"/>
               </a:rPr>
-              <a:t>TARGET</a:t>
-            </a:r>
-          </a:p>
-          <a:p>
-            <a:pPr algn="l">
-              <a:spcAft>
-                <a:spcPts val="1000"/>
-              </a:spcAft>
-            </a:pPr>
-            <a:r>
-              <a:rPr sz="1250" b="0" i="0">
+              <a:t>—  </a:t>
+            </a:r>
+            <a:r>
+              <a:rPr sz="1350" b="1" i="0">
                 <a:solidFill>
                   <a:srgbClr val="0C2340"/>
                 </a:solidFill>
                 <a:latin typeface="Georgia"/>
               </a:rPr>
-              <a:t>ICLR 2027 — abstract Sept 18, paper Sept 25. Backup: ACL 2027 (Feb), reusing the ICLR reviews.</a:t>
-            </a:r>
-          </a:p>
-          <a:p>
-            <a:pPr algn="l">
-              <a:spcAft>
-                <a:spcPts val="400"/>
-              </a:spcAft>
-            </a:pPr>
-            <a:r>
-              <a:rPr sz="1100" b="1" i="0">
-                <a:solidFill>
-                  <a:srgbClr val="AE9141"/>
+              <a:t>4 · Evaluation warning for the field. </a:t>
+            </a:r>
+            <a:r>
+              <a:rPr sz="1350" b="0" i="0">
+                <a:solidFill>
+                  <a:srgbClr val="0C2340"/>
                 </a:solidFill>
                 <a:latin typeface="Georgia"/>
               </a:rPr>
-              <a:t>READINESS</a:t>
-            </a:r>
-          </a:p>
-          <a:p>
-            <a:pPr algn="l"/>
-            <a:r>
-              <a:rPr sz="1250" b="0" i="0">
-                <a:solidFill>
-                  <a:srgbClr val="0C2340"/>
-                </a:solidFill>
-                <a:latin typeface="Georgia"/>
-              </a:rPr>
-              <a:t>Every claim has controls, replicates, and confidence intervals; backup experiments (70B model, another compressor) are staged for the rebuttal phase.</a:t>
+              <a:t>A compressed model can pass perplexity + MMLU while losing 80% of its generative ability. Always test with generation.</a:t>
             </a:r>
           </a:p>
         </p:txBody>
@@ -11810,7 +12323,40 @@
       <p:grpSpPr/>
       <p:sp>
         <p:nvSpPr>
-          <p:cNvPr id="2" name="Subtitle 1"/>
+          <p:cNvPr id="4" name="Title 3"/>
+          <p:cNvSpPr>
+            <a:spLocks noGrp="1"/>
+          </p:cNvSpPr>
+          <p:nvPr>
+            <p:ph type="title"/>
+          </p:nvPr>
+        </p:nvSpPr>
+        <p:spPr>
+          <a:xfrm>
+            <a:off x="411480" y="658368"/>
+            <a:ext cx="8321040" cy="658368"/>
+          </a:xfrm>
+        </p:spPr>
+        <p:txBody>
+          <a:bodyPr wrap="square"/>
+          <a:lstStyle/>
+          <a:p>
+            <a:pPr algn="l"/>
+            <a:r>
+              <a:rPr sz="2600" b="1">
+                <a:solidFill>
+                  <a:srgbClr val="0C2340"/>
+                </a:solidFill>
+                <a:latin typeface="Georgia"/>
+              </a:rPr>
+              <a:t>The Two Closest Papers — and Where This Goes</a:t>
+            </a:r>
+          </a:p>
+        </p:txBody>
+      </p:sp>
+      <p:sp>
+        <p:nvSpPr>
+          <p:cNvPr id="5" name="Subtitle 4"/>
           <p:cNvSpPr>
             <a:spLocks noGrp="1"/>
           </p:cNvSpPr>
@@ -11830,54 +12376,21 @@
                 </a:solidFill>
                 <a:latin typeface="Georgia"/>
               </a:rPr>
-              <a:t>DISCUSSION</a:t>
-            </a:r>
-          </a:p>
-        </p:txBody>
-      </p:sp>
-      <p:sp>
-        <p:nvSpPr>
-          <p:cNvPr id="3" name="Title 2"/>
-          <p:cNvSpPr>
-            <a:spLocks noGrp="1"/>
-          </p:cNvSpPr>
-          <p:nvPr>
-            <p:ph type="title"/>
-          </p:nvPr>
+              <a:t>RELATED WORK &amp; PLAN</a:t>
+            </a:r>
+          </a:p>
+        </p:txBody>
+      </p:sp>
+      <p:sp>
+        <p:nvSpPr>
+          <p:cNvPr id="6" name="TextBox 5"/>
+          <p:cNvSpPr txBox="1"/>
+          <p:nvPr/>
         </p:nvSpPr>
         <p:spPr>
           <a:xfrm>
-            <a:off x="914400" y="1234440"/>
-            <a:ext cx="7315200" cy="731520"/>
-          </a:xfrm>
-        </p:spPr>
-        <p:txBody>
-          <a:bodyPr wrap="square"/>
-          <a:lstStyle/>
-          <a:p>
-            <a:pPr algn="l"/>
-            <a:r>
-              <a:rPr sz="2800" b="1">
-                <a:solidFill>
-                  <a:srgbClr val="FFFFFF"/>
-                </a:solidFill>
-                <a:latin typeface="Georgia"/>
-              </a:rPr>
-              <a:t>What I'd Like Your Input On</a:t>
-            </a:r>
-          </a:p>
-        </p:txBody>
-      </p:sp>
-      <p:sp>
-        <p:nvSpPr>
-          <p:cNvPr id="4" name="TextBox 3"/>
-          <p:cNvSpPr txBox="1"/>
-          <p:nvPr/>
-        </p:nvSpPr>
-        <p:spPr>
-          <a:xfrm>
-            <a:off x="914400" y="2194560"/>
-            <a:ext cx="7315200" cy="2286000"/>
+            <a:off x="411480" y="1417320"/>
+            <a:ext cx="4892040" cy="3291840"/>
           </a:xfrm>
           <a:prstGeom prst="rect">
             <a:avLst/>
@@ -11892,101 +12405,144 @@
           <a:p>
             <a:pPr algn="l">
               <a:spcAft>
-                <a:spcPts val="1200"/>
+                <a:spcPts val="400"/>
               </a:spcAft>
             </a:pPr>
             <a:r>
-              <a:rPr sz="1400" b="1" i="0">
+              <a:rPr sz="1300" b="1" i="0">
                 <a:solidFill>
                   <a:srgbClr val="AE9141"/>
                 </a:solidFill>
                 <a:latin typeface="Georgia"/>
               </a:rPr>
-              <a:t>—  </a:t>
-            </a:r>
-            <a:r>
-              <a:rPr sz="1400" b="0" i="0">
-                <a:solidFill>
-                  <a:srgbClr val="FFFFFF"/>
+              <a:t>TaCQ (UNC Chapel Hill, 2025)</a:t>
+            </a:r>
+          </a:p>
+          <a:p>
+            <a:pPr algn="l">
+              <a:spcAft>
+                <a:spcPts val="1000"/>
+              </a:spcAft>
+            </a:pPr>
+            <a:r>
+              <a:rPr sz="1250" b="0" i="0">
+                <a:solidFill>
+                  <a:srgbClr val="0C2340"/>
                 </a:solidFill>
                 <a:latin typeface="Georgia"/>
               </a:rPr>
-              <a:t>Does the story read as one clean question with one clean answer?</a:t>
+              <a:t>Invented the importance score we use, and showed protection improves compressed models. We answer the question they never asked: WHEN does it help (only in collapses) and WHY (the error-correction mechanism).</a:t>
             </a:r>
           </a:p>
           <a:p>
             <a:pPr algn="l">
               <a:spcAft>
-                <a:spcPts val="1200"/>
+                <a:spcPts val="400"/>
               </a:spcAft>
             </a:pPr>
             <a:r>
-              <a:rPr sz="1400" b="1" i="0">
+              <a:rPr sz="1300" b="1" i="0">
                 <a:solidFill>
                   <a:srgbClr val="AE9141"/>
                 </a:solidFill>
                 <a:latin typeface="Georgia"/>
               </a:rPr>
-              <a:t>—  </a:t>
-            </a:r>
-            <a:r>
-              <a:rPr sz="1400" b="0" i="0">
-                <a:solidFill>
-                  <a:srgbClr val="FFFFFF"/>
+              <a:t>Super Weights (Mengxia Yu, ND + Apple, 2024)</a:t>
+            </a:r>
+          </a:p>
+          <a:p>
+            <a:pPr algn="l"/>
+            <a:r>
+              <a:rPr sz="1250" b="0" i="0">
+                <a:solidFill>
+                  <a:srgbClr val="0C2340"/>
                 </a:solidFill>
                 <a:latin typeface="Georgia"/>
               </a:rPr>
-              <a:t>Venue: OK to commit to ICLR (Sept 25) with ACL as the fallback?</a:t>
-            </a:r>
-          </a:p>
+              <a:t>Found that every LLM has 3–6 individual “super weights” — delete one and the model dies. We tested them: protecting ONLY those few does not prevent the collapse (0.16). The collapse involves a different, ~100,000-weight set. Complementary, not competing.</a:t>
+            </a:r>
+          </a:p>
+        </p:txBody>
+      </p:sp>
+      <p:sp>
+        <p:nvSpPr>
+          <p:cNvPr id="7" name="TextBox 6"/>
+          <p:cNvSpPr txBox="1"/>
+          <p:nvPr/>
+        </p:nvSpPr>
+        <p:spPr>
+          <a:xfrm>
+            <a:off x="5715000" y="1417320"/>
+            <a:ext cx="3063240" cy="3291840"/>
+          </a:xfrm>
+          <a:prstGeom prst="rect">
+            <a:avLst/>
+          </a:prstGeom>
+          <a:noFill/>
+        </p:spPr>
+        <p:txBody>
+          <a:bodyPr wrap="square" lIns="0" rIns="0" tIns="0" bIns="0">
+            <a:spAutoFit/>
+          </a:bodyPr>
+          <a:lstStyle/>
           <a:p>
             <a:pPr algn="l">
               <a:spcAft>
-                <a:spcPts val="1200"/>
+                <a:spcPts val="400"/>
               </a:spcAft>
             </a:pPr>
             <a:r>
-              <a:rPr sz="1400" b="1" i="0">
+              <a:rPr sz="1100" b="1" i="0">
                 <a:solidFill>
                   <a:srgbClr val="AE9141"/>
                 </a:solidFill>
                 <a:latin typeface="Georgia"/>
               </a:rPr>
-              <a:t>—  </a:t>
-            </a:r>
-            <a:r>
-              <a:rPr sz="1400" b="0" i="0">
-                <a:solidFill>
-                  <a:srgbClr val="FFFFFF"/>
+              <a:t>TARGET</a:t>
+            </a:r>
+          </a:p>
+          <a:p>
+            <a:pPr algn="l">
+              <a:spcAft>
+                <a:spcPts val="1000"/>
+              </a:spcAft>
+            </a:pPr>
+            <a:r>
+              <a:rPr sz="1250" b="0" i="0">
+                <a:solidFill>
+                  <a:srgbClr val="0C2340"/>
                 </a:solidFill>
                 <a:latin typeface="Georgia"/>
               </a:rPr>
-              <a:t>How should we engage Mengxia's Super-Weights work — note or citation?</a:t>
+              <a:t>ICLR 2027 — abstract Sept 18, paper Sept 25. Backup: ACL 2027 (Feb), reusing the ICLR reviews.</a:t>
             </a:r>
           </a:p>
           <a:p>
             <a:pPr algn="l">
               <a:spcAft>
-                <a:spcPts val="1200"/>
+                <a:spcPts val="400"/>
               </a:spcAft>
             </a:pPr>
             <a:r>
-              <a:rPr sz="1400" b="1" i="0">
+              <a:rPr sz="1100" b="1" i="0">
                 <a:solidFill>
                   <a:srgbClr val="AE9141"/>
                 </a:solidFill>
                 <a:latin typeface="Georgia"/>
               </a:rPr>
-              <a:t>—  </a:t>
-            </a:r>
-            <a:r>
-              <a:rPr sz="1400" b="0" i="0">
-                <a:solidFill>
-                  <a:srgbClr val="FFFFFF"/>
+              <a:t>READINESS</a:t>
+            </a:r>
+          </a:p>
+          <a:p>
+            <a:pPr algn="l"/>
+            <a:r>
+              <a:rPr sz="1250" b="0" i="0">
+                <a:solidFill>
+                  <a:srgbClr val="0C2340"/>
                 </a:solidFill>
                 <a:latin typeface="Georgia"/>
               </a:rPr>
-              <a:t>Anything worth adding while the cluster is still available?</a:t>
+              <a:t>Every claim has controls, replicates, and confidence intervals; backup experiments (70B model, another compressor) are staged for the rebuttal phase.</a:t>
             </a:r>
           </a:p>
         </p:txBody>
@@ -12122,6 +12678,207 @@
         <p14:creationId xmlns:p14="http://schemas.microsoft.com/office/powerpoint/2010/main" val="3007564937"/>
       </p:ext>
     </p:extLst>
+  </p:cSld>
+  <p:clrMapOvr>
+    <a:masterClrMapping/>
+  </p:clrMapOvr>
+</p:sld>
+</file>
+
+<file path=ppt/slides/slide20.xml><?xml version="1.0" encoding="utf-8"?>
+<p:sld xmlns:a="http://schemas.openxmlformats.org/drawingml/2006/main" xmlns:p="http://schemas.openxmlformats.org/presentationml/2006/main" xmlns:r="http://schemas.openxmlformats.org/officeDocument/2006/relationships">
+  <p:cSld>
+    <p:spTree>
+      <p:nvGrpSpPr>
+        <p:cNvPr id="1" name=""/>
+        <p:cNvGrpSpPr/>
+        <p:nvPr/>
+      </p:nvGrpSpPr>
+      <p:grpSpPr/>
+      <p:sp>
+        <p:nvSpPr>
+          <p:cNvPr id="2" name="Subtitle 1"/>
+          <p:cNvSpPr>
+            <a:spLocks noGrp="1"/>
+          </p:cNvSpPr>
+          <p:nvPr>
+            <p:ph type="subTitle" idx="3"/>
+          </p:nvPr>
+        </p:nvSpPr>
+        <p:spPr/>
+        <p:txBody>
+          <a:bodyPr/>
+          <a:lstStyle/>
+          <a:p>
+            <a:r>
+              <a:rPr sz="1100" b="1">
+                <a:solidFill>
+                  <a:srgbClr val="FFFFFF"/>
+                </a:solidFill>
+                <a:latin typeface="Georgia"/>
+              </a:rPr>
+              <a:t>DISCUSSION</a:t>
+            </a:r>
+          </a:p>
+        </p:txBody>
+      </p:sp>
+      <p:sp>
+        <p:nvSpPr>
+          <p:cNvPr id="3" name="Title 2"/>
+          <p:cNvSpPr>
+            <a:spLocks noGrp="1"/>
+          </p:cNvSpPr>
+          <p:nvPr>
+            <p:ph type="title"/>
+          </p:nvPr>
+        </p:nvSpPr>
+        <p:spPr>
+          <a:xfrm>
+            <a:off x="914400" y="1234440"/>
+            <a:ext cx="7315200" cy="731520"/>
+          </a:xfrm>
+        </p:spPr>
+        <p:txBody>
+          <a:bodyPr wrap="square"/>
+          <a:lstStyle/>
+          <a:p>
+            <a:pPr algn="l"/>
+            <a:r>
+              <a:rPr sz="2800" b="1">
+                <a:solidFill>
+                  <a:srgbClr val="FFFFFF"/>
+                </a:solidFill>
+                <a:latin typeface="Georgia"/>
+              </a:rPr>
+              <a:t>What I'd Like Your Input On</a:t>
+            </a:r>
+          </a:p>
+        </p:txBody>
+      </p:sp>
+      <p:sp>
+        <p:nvSpPr>
+          <p:cNvPr id="4" name="TextBox 3"/>
+          <p:cNvSpPr txBox="1"/>
+          <p:nvPr/>
+        </p:nvSpPr>
+        <p:spPr>
+          <a:xfrm>
+            <a:off x="914400" y="2194560"/>
+            <a:ext cx="7315200" cy="2286000"/>
+          </a:xfrm>
+          <a:prstGeom prst="rect">
+            <a:avLst/>
+          </a:prstGeom>
+          <a:noFill/>
+        </p:spPr>
+        <p:txBody>
+          <a:bodyPr wrap="square" lIns="0" rIns="0" tIns="0" bIns="0">
+            <a:spAutoFit/>
+          </a:bodyPr>
+          <a:lstStyle/>
+          <a:p>
+            <a:pPr algn="l">
+              <a:spcAft>
+                <a:spcPts val="1200"/>
+              </a:spcAft>
+            </a:pPr>
+            <a:r>
+              <a:rPr sz="1400" b="1" i="0">
+                <a:solidFill>
+                  <a:srgbClr val="AE9141"/>
+                </a:solidFill>
+                <a:latin typeface="Georgia"/>
+              </a:rPr>
+              <a:t>—  </a:t>
+            </a:r>
+            <a:r>
+              <a:rPr sz="1400" b="0" i="0">
+                <a:solidFill>
+                  <a:srgbClr val="FFFFFF"/>
+                </a:solidFill>
+                <a:latin typeface="Georgia"/>
+              </a:rPr>
+              <a:t>Does the story read as one clean question with one clean answer?</a:t>
+            </a:r>
+          </a:p>
+          <a:p>
+            <a:pPr algn="l">
+              <a:spcAft>
+                <a:spcPts val="1200"/>
+              </a:spcAft>
+            </a:pPr>
+            <a:r>
+              <a:rPr sz="1400" b="1" i="0">
+                <a:solidFill>
+                  <a:srgbClr val="AE9141"/>
+                </a:solidFill>
+                <a:latin typeface="Georgia"/>
+              </a:rPr>
+              <a:t>—  </a:t>
+            </a:r>
+            <a:r>
+              <a:rPr sz="1400" b="0" i="0">
+                <a:solidFill>
+                  <a:srgbClr val="FFFFFF"/>
+                </a:solidFill>
+                <a:latin typeface="Georgia"/>
+              </a:rPr>
+              <a:t>Venue: OK to commit to ICLR (Sept 25) with ACL as the fallback?</a:t>
+            </a:r>
+          </a:p>
+          <a:p>
+            <a:pPr algn="l">
+              <a:spcAft>
+                <a:spcPts val="1200"/>
+              </a:spcAft>
+            </a:pPr>
+            <a:r>
+              <a:rPr sz="1400" b="1" i="0">
+                <a:solidFill>
+                  <a:srgbClr val="AE9141"/>
+                </a:solidFill>
+                <a:latin typeface="Georgia"/>
+              </a:rPr>
+              <a:t>—  </a:t>
+            </a:r>
+            <a:r>
+              <a:rPr sz="1400" b="0" i="0">
+                <a:solidFill>
+                  <a:srgbClr val="FFFFFF"/>
+                </a:solidFill>
+                <a:latin typeface="Georgia"/>
+              </a:rPr>
+              <a:t>How should we engage Mengxia's Super-Weights work — note or citation?</a:t>
+            </a:r>
+          </a:p>
+          <a:p>
+            <a:pPr algn="l">
+              <a:spcAft>
+                <a:spcPts val="1200"/>
+              </a:spcAft>
+            </a:pPr>
+            <a:r>
+              <a:rPr sz="1400" b="1" i="0">
+                <a:solidFill>
+                  <a:srgbClr val="AE9141"/>
+                </a:solidFill>
+                <a:latin typeface="Georgia"/>
+              </a:rPr>
+              <a:t>—  </a:t>
+            </a:r>
+            <a:r>
+              <a:rPr sz="1400" b="0" i="0">
+                <a:solidFill>
+                  <a:srgbClr val="FFFFFF"/>
+                </a:solidFill>
+                <a:latin typeface="Georgia"/>
+              </a:rPr>
+              <a:t>Anything worth adding while the cluster is still available?</a:t>
+            </a:r>
+          </a:p>
+        </p:txBody>
+      </p:sp>
+    </p:spTree>
   </p:cSld>
   <p:clrMapOvr>
     <a:masterClrMapping/>

</xml_diff>

<commit_message>
Deck v5: census purpose clarified, explicit amounts on every control, master table slide
</commit_message>
<xml_diff>
--- a/paper/IFH_advisor_update_2026-09-03.pptx
+++ b/paper/IFH_advisor_update_2026-09-03.pptx
@@ -25,6 +25,7 @@
     <p:sldId id="284" r:id="rId32"/>
     <p:sldId id="285" r:id="rId33"/>
     <p:sldId id="286" r:id="rId34"/>
+    <p:sldId id="287" r:id="rId35"/>
   </p:sldIdLst>
   <p:sldSz cx="9144000" cy="5148263"/>
   <p:notesSz cx="6858000" cy="9144000"/>
@@ -2888,7 +2889,7 @@
           <a:lstStyle/>
           <a:p>
             <a:r>
-              <a:t>论文四句话（加上WHEN规则是五句）：开头第0条是给实践者的一句话诊断：跑一次RTN对比，看纠错在帮忙还是行凶。其余：①压缩损伤分两种模式，轻微或崩溃，且无法从原模型预测（六个模型上证伪了所有已发表的预测指标）；②保护是崩溃修复工具而非通用增益，崩溃时它胜过包括最新旋转方法在内的所有替代方案；③元凶是压缩算法的纠错机制而非低精度本身；④评测警告：模型可能通过困惑度和MMLU检查但已丧失80%生成能力。</a:t>
+              <a:t>总表：12个模型、四种处理（原始/笨压缩RTN/聪明压缩GPTQ/GPTQ+保护）外加保护增益和层次归类，一页看全。读法：从右往左——tier列先看是哪一档；崩溃两行（红）里GPTQ远差于RTN（纠错行凶）、保护增益巨大；其余各行保护增益全是噪声级。空格“—”表示该臂没跑（跑了也不改变结论，普查臂只需fp16和GPTQ两步）。被问任何具体数字时翻回这页。</a:t>
             </a:r>
           </a:p>
         </p:txBody>
@@ -2958,7 +2959,7 @@
           <a:lstStyle/>
           <a:p>
             <a:r>
-              <a:t>两篇最近的论文：TaCQ发明了我们用的重要性分数并展示保护有效——我们回答它没问的“何时、为何”；Super Weights是Mengxia学长的工作，发现每个模型有3-6个“超级权重”删一个就死——我们验证了只保护它们救不了GPTQ崩溃，崩溃涉及的是另外约10万个权重，两个工作互补不冲突。投稿：ICLR 2027（摘要9/18、全文9/25），被拒则带着审稿意见转投ACL 2027。</a:t>
+              <a:t>论文四句话（加上WHEN规则是五句）：开头第0条是给实践者的一句话诊断：跑一次RTN对比，看纠错在帮忙还是行凶。其余：①压缩损伤分两种模式，轻微或崩溃，且无法从原模型预测（六个模型上证伪了所有已发表的预测指标）；②保护是崩溃修复工具而非通用增益，崩溃时它胜过包括最新旋转方法在内的所有替代方案；③元凶是压缩算法的纠错机制而非低精度本身；④评测警告：模型可能通过困惑度和MMLU检查但已丧失80%生成能力。</a:t>
             </a:r>
           </a:p>
         </p:txBody>
@@ -3054,6 +3055,76 @@
 </file>
 
 <file path=ppt/notesSlides/notesSlide20.xml><?xml version="1.0" encoding="utf-8"?>
+<p:notes xmlns:a="http://schemas.openxmlformats.org/drawingml/2006/main" xmlns:p="http://schemas.openxmlformats.org/presentationml/2006/main" xmlns:r="http://schemas.openxmlformats.org/officeDocument/2006/relationships">
+  <p:cSld>
+    <p:spTree>
+      <p:nvGrpSpPr>
+        <p:cNvPr id="1" name=""/>
+        <p:cNvGrpSpPr/>
+        <p:nvPr/>
+      </p:nvGrpSpPr>
+      <p:grpSpPr>
+        <a:xfrm>
+          <a:off x="0" y="0"/>
+          <a:ext cx="0" cy="0"/>
+          <a:chOff x="0" y="0"/>
+          <a:chExt cx="0" cy="0"/>
+        </a:xfrm>
+      </p:grpSpPr>
+      <p:sp>
+        <p:nvSpPr>
+          <p:cNvPr id="2" name="Slide Image Placeholder 1"/>
+          <p:cNvSpPr>
+            <a:spLocks noGrp="1"/>
+          </p:cNvSpPr>
+          <p:nvPr>
+            <p:ph type="sldImg" idx="2"/>
+          </p:nvPr>
+        </p:nvSpPr>
+        <p:spPr/>
+      </p:sp>
+      <p:sp>
+        <p:nvSpPr>
+          <p:cNvPr id="3" name="Notes Placeholder 2"/>
+          <p:cNvSpPr>
+            <a:spLocks noGrp="1"/>
+          </p:cNvSpPr>
+          <p:nvPr>
+            <p:ph type="body" idx="3" sz="quarter"/>
+          </p:nvPr>
+        </p:nvSpPr>
+        <p:spPr/>
+        <p:txBody>
+          <a:bodyPr/>
+          <a:lstStyle/>
+          <a:p>
+            <a:r>
+              <a:t>两篇最近的论文：TaCQ发明了我们用的重要性分数并展示保护有效——我们回答它没问的“何时、为何”；Super Weights是Mengxia学长的工作，发现每个模型有3-6个“超级权重”删一个就死——我们验证了只保护它们救不了GPTQ崩溃，崩溃涉及的是另外约10万个权重，两个工作互补不冲突。投稿：ICLR 2027（摘要9/18、全文9/25），被拒则带着审稿意见转投ACL 2027。</a:t>
+            </a:r>
+          </a:p>
+        </p:txBody>
+      </p:sp>
+      <p:sp>
+        <p:nvSpPr>
+          <p:cNvPr id="4" name="Slide Number Placeholder 3"/>
+          <p:cNvSpPr>
+            <a:spLocks noGrp="1"/>
+          </p:cNvSpPr>
+          <p:nvPr>
+            <p:ph type="sldNum" idx="5" sz="quarter"/>
+          </p:nvPr>
+        </p:nvSpPr>
+        <p:spPr/>
+      </p:sp>
+    </p:spTree>
+  </p:cSld>
+  <p:clrMapOvr>
+    <a:masterClrMapping/>
+  </p:clrMapOvr>
+</p:notes>
+</file>
+
+<file path=ppt/notesSlides/notesSlide21.xml><?xml version="1.0" encoding="utf-8"?>
 <p:notes xmlns:a="http://schemas.openxmlformats.org/drawingml/2006/main" xmlns:p="http://schemas.openxmlformats.org/presentationml/2006/main" xmlns:r="http://schemas.openxmlformats.org/officeDocument/2006/relationships">
   <p:cSld>
     <p:spTree>
@@ -11947,7 +12018,7 @@
                 </a:solidFill>
                 <a:latin typeface="Georgia"/>
               </a:rPr>
-              <a:t>All 12 Models: How Much Ability Is Lost at 3-bit</a:t>
+              <a:t>How Common Is Collapse? 2 in 12 — and Not the Models You'd Guess</a:t>
             </a:r>
           </a:p>
         </p:txBody>
@@ -12005,8 +12076,8 @@
         </p:nvSpPr>
         <p:spPr>
           <a:xfrm>
-            <a:off x="6400800" y="1554480"/>
-            <a:ext cx="2377440" cy="3108960"/>
+            <a:off x="6400800" y="1481328"/>
+            <a:ext cx="2377440" cy="3200400"/>
           </a:xfrm>
           <a:prstGeom prst="rect">
             <a:avLst/>
@@ -12021,23 +12092,7 @@
           <a:p>
             <a:pPr algn="l">
               <a:spcAft>
-                <a:spcPts val="800"/>
-              </a:spcAft>
-            </a:pPr>
-            <a:r>
-              <a:rPr sz="1200" b="0" i="0">
-                <a:solidFill>
-                  <a:srgbClr val="0C2340"/>
-                </a:solidFill>
-                <a:latin typeface="Georgia"/>
-              </a:rPr>
-              <a:t>Bars = IFEval score LOST after 3-bit compression (taller = worse).</a:t>
-            </a:r>
-          </a:p>
-          <a:p>
-            <a:pPr algn="l">
-              <a:spcAft>
-                <a:spcPts val="800"/>
+                <a:spcPts val="700"/>
               </a:spcAft>
             </a:pPr>
             <a:r>
@@ -12047,7 +12102,7 @@
                 </a:solidFill>
                 <a:latin typeface="Georgia"/>
               </a:rPr>
-              <a:t>Three tiers: </a:t>
+              <a:t>Purpose of this survey: </a:t>
             </a:r>
             <a:r>
               <a:rPr sz="1200" b="0" i="0">
@@ -12056,19 +12111,44 @@
                 </a:solidFill>
                 <a:latin typeface="Georgia"/>
               </a:rPr>
-              <a:t>mild (−0.06..−0.09), a middle tier of mostly small models (−0.15..−0.25), and two collapses (−0.41, −0.62).</a:t>
+              <a:t>is collapse a rare fluke of two models, or common? And does it simply follow model size?</a:t>
+            </a:r>
+          </a:p>
+          <a:p>
+            <a:pPr algn="l">
+              <a:spcAft>
+                <a:spcPts val="700"/>
+              </a:spcAft>
+            </a:pPr>
+            <a:r>
+              <a:rPr sz="1200" b="1" i="0">
+                <a:solidFill>
+                  <a:srgbClr val="9B1B1B"/>
+                </a:solidFill>
+                <a:latin typeface="Georgia"/>
+              </a:rPr>
+              <a:t>Answer: 2 of 12 collapse. </a:t>
+            </a:r>
+            <a:r>
+              <a:rPr sz="1200" b="0" i="0">
+                <a:solidFill>
+                  <a:srgbClr val="0C2340"/>
+                </a:solidFill>
+                <a:latin typeface="Georgia"/>
+              </a:rPr>
+              <a:t>Small models lose more (gold, middle tier) — that part is expected. But the two collapses (red) are 8B and 14B, NOT the smallest models: collapse does not follow size.</a:t>
             </a:r>
           </a:p>
           <a:p>
             <a:pPr algn="l"/>
             <a:r>
-              <a:rPr sz="1200" b="1" i="0">
-                <a:solidFill>
-                  <a:srgbClr val="AE9141"/>
+              <a:rPr sz="1050" b="0" i="1">
+                <a:solidFill>
+                  <a:srgbClr val="5A5A5A"/>
                 </a:solidFill>
                 <a:latin typeface="Georgia"/>
               </a:rPr>
-              <a:t>The middle tier is ordinary damage amplified by small size; the collapses are a different disease — proven two slides ahead.</a:t>
+              <a:t>Bars = IFEval score lost at 3-bit (taller = worse).</a:t>
             </a:r>
           </a:p>
         </p:txBody>
@@ -12228,7 +12308,7 @@
                 </a:solidFill>
                 <a:latin typeface="Georgia"/>
               </a:rPr>
-              <a:t>protecting the same number of random weights does almost nothing (0.18 / 0.48).</a:t>
+              <a:t>protecting the same amount (0.5%) of random weights does almost nothing (0.18 / 0.48).</a:t>
             </a:r>
           </a:p>
           <a:p>
@@ -12360,7 +12440,7 @@
                           </a:solidFill>
                           <a:latin typeface="Georgia"/>
                         </a:rPr>
-                        <a:t>What we protect (same size unless noted)</a:t>
+                        <a:t>What we protect</a:t>
                       </a:r>
                     </a:p>
                   </a:txBody>
@@ -12502,7 +12582,7 @@
                           </a:solidFill>
                           <a:latin typeface="Georgia"/>
                         </a:rPr>
-                        <a:t>top-0.5% by the TaCQ importance score</a:t>
+                        <a:t>top 0.5% by the TaCQ importance score</a:t>
                       </a:r>
                     </a:p>
                   </a:txBody>
@@ -12573,7 +12653,7 @@
                           </a:solidFill>
                           <a:latin typeface="Georgia"/>
                         </a:rPr>
-                        <a:t>random weights</a:t>
+                        <a:t>random weights, same amount (0.5%)</a:t>
                       </a:r>
                     </a:p>
                   </a:txBody>
@@ -12644,7 +12724,7 @@
                           </a:solidFill>
                           <a:latin typeface="Georgia"/>
                         </a:rPr>
-                        <a:t>the instruction-following attention heads</a:t>
+                        <a:t>32 instruction-following heads (≈ same 0.5%)</a:t>
                       </a:r>
                     </a:p>
                   </a:txBody>
@@ -12715,7 +12795,7 @@
                           </a:solidFill>
                           <a:latin typeface="Georgia"/>
                         </a:rPr>
-                        <a:t>the 3–6 “super weights”</a:t>
+                        <a:t>the 3–6 “super weights” (just those few)</a:t>
                       </a:r>
                     </a:p>
                   </a:txBody>
@@ -12786,7 +12866,7 @@
                           </a:solidFill>
                           <a:latin typeface="Georgia"/>
                         </a:rPr>
-                        <a:t>whole channels (hardware-friendly layout)</a:t>
+                        <a:t>whole channels, same amount (0.5%)</a:t>
                       </a:r>
                     </a:p>
                   </a:txBody>
@@ -12857,7 +12937,7 @@
                           </a:solidFill>
                           <a:latin typeface="Georgia"/>
                         </a:rPr>
-                        <a:t>importance scored on generic web text</a:t>
+                        <a:t>only 100k weights (0.001%), scored on generic text</a:t>
                       </a:r>
                     </a:p>
                   </a:txBody>
@@ -12964,7 +13044,7 @@
                 </a:solidFill>
                 <a:latin typeface="Georgia"/>
               </a:rPr>
-              <a:t>Bonuses: scoring on generic web text works just as well (the critical set is task-independent); the channel layout works on Llama but not 14B (structure is model-specific).</a:t>
+              <a:t>Bonuses (last two rows): a 50× smaller set scored on generic web text rescues almost as well (task-independent, tiny); whole-channel protection works on Llama but fails on 14B (structure is model-specific).</a:t>
             </a:r>
           </a:p>
         </p:txBody>
@@ -19581,7 +19661,7 @@
                 </a:solidFill>
                 <a:latin typeface="Georgia"/>
               </a:rPr>
-              <a:t>What This Paper Says</a:t>
+              <a:t>The Master Table (IFEval, all @ 3-bit)</a:t>
             </a:r>
           </a:p>
         </p:txBody>
@@ -19608,21 +19688,2171 @@
                 </a:solidFill>
                 <a:latin typeface="Georgia"/>
               </a:rPr>
-              <a:t>SUMMARY</a:t>
+              <a:t>EVERYTHING ON ONE SLIDE</a:t>
             </a:r>
           </a:p>
         </p:txBody>
       </p:sp>
-      <p:sp>
-        <p:nvSpPr>
-          <p:cNvPr id="6" name="TextBox 5"/>
+      <p:graphicFrame>
+        <p:nvGraphicFramePr>
+          <p:cNvPr id="6" name="Table 5"/>
+          <p:cNvGraphicFramePr>
+            <a:graphicFrameLocks noGrp="1"/>
+          </p:cNvGraphicFramePr>
+          <p:nvPr/>
+        </p:nvGraphicFramePr>
+        <p:xfrm>
+          <a:off x="411480" y="1371600"/>
+          <a:ext cx="8366760" cy="3200400"/>
+        </p:xfrm>
+        <a:graphic>
+          <a:graphicData uri="http://schemas.openxmlformats.org/drawingml/2006/table">
+            <a:tbl>
+              <a:tblPr firstRow="0" bandRow="0">
+                <a:tableStyleId>{5940675A-B579-460E-94D1-54222C63F5DA}</a:tableStyleId>
+              </a:tblPr>
+              <a:tblGrid>
+                <a:gridCol w="1600200"/>
+                <a:gridCol w="868680"/>
+                <a:gridCol w="960120"/>
+                <a:gridCol w="868680"/>
+                <a:gridCol w="1325880"/>
+                <a:gridCol w="1600200"/>
+                <a:gridCol w="1143000"/>
+              </a:tblGrid>
+              <a:tr h="292608">
+                <a:tc>
+                  <a:txBody>
+                    <a:bodyPr wrap="square"/>
+                    <a:lstStyle/>
+                    <a:p>
+                      <a:pPr algn="l"/>
+                      <a:r>
+                        <a:rPr sz="950" b="1">
+                          <a:solidFill>
+                            <a:srgbClr val="FFFFFF"/>
+                          </a:solidFill>
+                          <a:latin typeface="Georgia"/>
+                        </a:rPr>
+                        <a:t>Model</a:t>
+                      </a:r>
+                    </a:p>
+                  </a:txBody>
+                  <a:tcPr anchor="ctr" marL="54864" marR="54864" marT="18288" marB="18288">
+                    <a:solidFill>
+                      <a:srgbClr val="0C2340"/>
+                    </a:solidFill>
+                  </a:tcPr>
+                </a:tc>
+                <a:tc>
+                  <a:txBody>
+                    <a:bodyPr wrap="square"/>
+                    <a:lstStyle/>
+                    <a:p>
+                      <a:pPr algn="ctr"/>
+                      <a:r>
+                        <a:rPr sz="950" b="1">
+                          <a:solidFill>
+                            <a:srgbClr val="FFFFFF"/>
+                          </a:solidFill>
+                          <a:latin typeface="Georgia"/>
+                        </a:rPr>
+                        <a:t>original</a:t>
+                      </a:r>
+                    </a:p>
+                  </a:txBody>
+                  <a:tcPr anchor="ctr" marL="54864" marR="54864" marT="18288" marB="18288">
+                    <a:solidFill>
+                      <a:srgbClr val="0C2340"/>
+                    </a:solidFill>
+                  </a:tcPr>
+                </a:tc>
+                <a:tc>
+                  <a:txBody>
+                    <a:bodyPr wrap="square"/>
+                    <a:lstStyle/>
+                    <a:p>
+                      <a:pPr algn="ctr"/>
+                      <a:r>
+                        <a:rPr sz="950" b="1">
+                          <a:solidFill>
+                            <a:srgbClr val="FFFFFF"/>
+                          </a:solidFill>
+                          <a:latin typeface="Georgia"/>
+                        </a:rPr>
+                        <a:t>naive RTN</a:t>
+                      </a:r>
+                    </a:p>
+                  </a:txBody>
+                  <a:tcPr anchor="ctr" marL="54864" marR="54864" marT="18288" marB="18288">
+                    <a:solidFill>
+                      <a:srgbClr val="0C2340"/>
+                    </a:solidFill>
+                  </a:tcPr>
+                </a:tc>
+                <a:tc>
+                  <a:txBody>
+                    <a:bodyPr wrap="square"/>
+                    <a:lstStyle/>
+                    <a:p>
+                      <a:pPr algn="ctr"/>
+                      <a:r>
+                        <a:rPr sz="950" b="1">
+                          <a:solidFill>
+                            <a:srgbClr val="FFFFFF"/>
+                          </a:solidFill>
+                          <a:latin typeface="Georgia"/>
+                        </a:rPr>
+                        <a:t>GPTQ</a:t>
+                      </a:r>
+                    </a:p>
+                  </a:txBody>
+                  <a:tcPr anchor="ctr" marL="54864" marR="54864" marT="18288" marB="18288">
+                    <a:solidFill>
+                      <a:srgbClr val="0C2340"/>
+                    </a:solidFill>
+                  </a:tcPr>
+                </a:tc>
+                <a:tc>
+                  <a:txBody>
+                    <a:bodyPr wrap="square"/>
+                    <a:lstStyle/>
+                    <a:p>
+                      <a:pPr algn="ctr"/>
+                      <a:r>
+                        <a:rPr sz="950" b="1">
+                          <a:solidFill>
+                            <a:srgbClr val="FFFFFF"/>
+                          </a:solidFill>
+                          <a:latin typeface="Georgia"/>
+                        </a:rPr>
+                        <a:t>GPTQ + protect</a:t>
+                      </a:r>
+                    </a:p>
+                  </a:txBody>
+                  <a:tcPr anchor="ctr" marL="54864" marR="54864" marT="18288" marB="18288">
+                    <a:solidFill>
+                      <a:srgbClr val="0C2340"/>
+                    </a:solidFill>
+                  </a:tcPr>
+                </a:tc>
+                <a:tc>
+                  <a:txBody>
+                    <a:bodyPr wrap="square"/>
+                    <a:lstStyle/>
+                    <a:p>
+                      <a:pPr algn="ctr"/>
+                      <a:r>
+                        <a:rPr sz="950" b="1">
+                          <a:solidFill>
+                            <a:srgbClr val="FFFFFF"/>
+                          </a:solidFill>
+                          <a:latin typeface="Georgia"/>
+                        </a:rPr>
+                        <a:t>protection gain</a:t>
+                      </a:r>
+                    </a:p>
+                  </a:txBody>
+                  <a:tcPr anchor="ctr" marL="54864" marR="54864" marT="18288" marB="18288">
+                    <a:solidFill>
+                      <a:srgbClr val="0C2340"/>
+                    </a:solidFill>
+                  </a:tcPr>
+                </a:tc>
+                <a:tc>
+                  <a:txBody>
+                    <a:bodyPr wrap="square"/>
+                    <a:lstStyle/>
+                    <a:p>
+                      <a:pPr algn="ctr"/>
+                      <a:r>
+                        <a:rPr sz="950" b="1">
+                          <a:solidFill>
+                            <a:srgbClr val="FFFFFF"/>
+                          </a:solidFill>
+                          <a:latin typeface="Georgia"/>
+                        </a:rPr>
+                        <a:t>tier</a:t>
+                      </a:r>
+                    </a:p>
+                  </a:txBody>
+                  <a:tcPr anchor="ctr" marL="54864" marR="54864" marT="18288" marB="18288">
+                    <a:solidFill>
+                      <a:srgbClr val="0C2340"/>
+                    </a:solidFill>
+                  </a:tcPr>
+                </a:tc>
+              </a:tr>
+              <a:tr h="242316">
+                <a:tc>
+                  <a:txBody>
+                    <a:bodyPr wrap="square"/>
+                    <a:lstStyle/>
+                    <a:p>
+                      <a:pPr algn="l"/>
+                      <a:r>
+                        <a:rPr sz="950" b="0">
+                          <a:solidFill>
+                            <a:srgbClr val="0C2340"/>
+                          </a:solidFill>
+                          <a:latin typeface="Georgia"/>
+                        </a:rPr>
+                        <a:t>Qwen2.5-7B</a:t>
+                      </a:r>
+                    </a:p>
+                  </a:txBody>
+                  <a:tcPr anchor="ctr" marL="54864" marR="54864" marT="18288" marB="18288">
+                    <a:solidFill>
+                      <a:srgbClr val="FFFFFF"/>
+                    </a:solidFill>
+                  </a:tcPr>
+                </a:tc>
+                <a:tc>
+                  <a:txBody>
+                    <a:bodyPr wrap="square"/>
+                    <a:lstStyle/>
+                    <a:p>
+                      <a:pPr algn="ctr"/>
+                      <a:r>
+                        <a:rPr sz="950" b="0">
+                          <a:solidFill>
+                            <a:srgbClr val="0C2340"/>
+                          </a:solidFill>
+                          <a:latin typeface="Georgia"/>
+                        </a:rPr>
+                        <a:t>0.765</a:t>
+                      </a:r>
+                    </a:p>
+                  </a:txBody>
+                  <a:tcPr anchor="ctr" marL="54864" marR="54864" marT="18288" marB="18288">
+                    <a:solidFill>
+                      <a:srgbClr val="FFFFFF"/>
+                    </a:solidFill>
+                  </a:tcPr>
+                </a:tc>
+                <a:tc>
+                  <a:txBody>
+                    <a:bodyPr wrap="square"/>
+                    <a:lstStyle/>
+                    <a:p>
+                      <a:pPr algn="ctr"/>
+                      <a:r>
+                        <a:rPr sz="950" b="0">
+                          <a:solidFill>
+                            <a:srgbClr val="0C2340"/>
+                          </a:solidFill>
+                          <a:latin typeface="Georgia"/>
+                        </a:rPr>
+                        <a:t>0.500</a:t>
+                      </a:r>
+                    </a:p>
+                  </a:txBody>
+                  <a:tcPr anchor="ctr" marL="54864" marR="54864" marT="18288" marB="18288">
+                    <a:solidFill>
+                      <a:srgbClr val="FFFFFF"/>
+                    </a:solidFill>
+                  </a:tcPr>
+                </a:tc>
+                <a:tc>
+                  <a:txBody>
+                    <a:bodyPr wrap="square"/>
+                    <a:lstStyle/>
+                    <a:p>
+                      <a:pPr algn="ctr"/>
+                      <a:r>
+                        <a:rPr sz="950" b="0">
+                          <a:solidFill>
+                            <a:srgbClr val="0C2340"/>
+                          </a:solidFill>
+                          <a:latin typeface="Georgia"/>
+                        </a:rPr>
+                        <a:t>0.672</a:t>
+                      </a:r>
+                    </a:p>
+                  </a:txBody>
+                  <a:tcPr anchor="ctr" marL="54864" marR="54864" marT="18288" marB="18288">
+                    <a:solidFill>
+                      <a:srgbClr val="FFFFFF"/>
+                    </a:solidFill>
+                  </a:tcPr>
+                </a:tc>
+                <a:tc>
+                  <a:txBody>
+                    <a:bodyPr wrap="square"/>
+                    <a:lstStyle/>
+                    <a:p>
+                      <a:pPr algn="ctr"/>
+                      <a:r>
+                        <a:rPr sz="950" b="0">
+                          <a:solidFill>
+                            <a:srgbClr val="0C2340"/>
+                          </a:solidFill>
+                          <a:latin typeface="Georgia"/>
+                        </a:rPr>
+                        <a:t>0.702</a:t>
+                      </a:r>
+                    </a:p>
+                  </a:txBody>
+                  <a:tcPr anchor="ctr" marL="54864" marR="54864" marT="18288" marB="18288">
+                    <a:solidFill>
+                      <a:srgbClr val="FFFFFF"/>
+                    </a:solidFill>
+                  </a:tcPr>
+                </a:tc>
+                <a:tc>
+                  <a:txBody>
+                    <a:bodyPr wrap="square"/>
+                    <a:lstStyle/>
+                    <a:p>
+                      <a:pPr algn="ctr"/>
+                      <a:r>
+                        <a:rPr sz="950" b="0">
+                          <a:solidFill>
+                            <a:srgbClr val="0C2340"/>
+                          </a:solidFill>
+                          <a:latin typeface="Georgia"/>
+                        </a:rPr>
+                        <a:t>+0.030 (noise)</a:t>
+                      </a:r>
+                    </a:p>
+                  </a:txBody>
+                  <a:tcPr anchor="ctr" marL="54864" marR="54864" marT="18288" marB="18288">
+                    <a:solidFill>
+                      <a:srgbClr val="FFFFFF"/>
+                    </a:solidFill>
+                  </a:tcPr>
+                </a:tc>
+                <a:tc>
+                  <a:txBody>
+                    <a:bodyPr wrap="square"/>
+                    <a:lstStyle/>
+                    <a:p>
+                      <a:pPr algn="ctr"/>
+                      <a:r>
+                        <a:rPr sz="950" b="0">
+                          <a:solidFill>
+                            <a:srgbClr val="0C2340"/>
+                          </a:solidFill>
+                          <a:latin typeface="Georgia"/>
+                        </a:rPr>
+                        <a:t>mild</a:t>
+                      </a:r>
+                    </a:p>
+                  </a:txBody>
+                  <a:tcPr anchor="ctr" marL="54864" marR="54864" marT="18288" marB="18288">
+                    <a:solidFill>
+                      <a:srgbClr val="FFFFFF"/>
+                    </a:solidFill>
+                  </a:tcPr>
+                </a:tc>
+              </a:tr>
+              <a:tr h="242316">
+                <a:tc>
+                  <a:txBody>
+                    <a:bodyPr wrap="square"/>
+                    <a:lstStyle/>
+                    <a:p>
+                      <a:pPr algn="l"/>
+                      <a:r>
+                        <a:rPr sz="950" b="0">
+                          <a:solidFill>
+                            <a:srgbClr val="0C2340"/>
+                          </a:solidFill>
+                          <a:latin typeface="Georgia"/>
+                        </a:rPr>
+                        <a:t>Mistral-7B</a:t>
+                      </a:r>
+                    </a:p>
+                  </a:txBody>
+                  <a:tcPr anchor="ctr" marL="54864" marR="54864" marT="18288" marB="18288">
+                    <a:solidFill>
+                      <a:srgbClr val="EFE9D9"/>
+                    </a:solidFill>
+                  </a:tcPr>
+                </a:tc>
+                <a:tc>
+                  <a:txBody>
+                    <a:bodyPr wrap="square"/>
+                    <a:lstStyle/>
+                    <a:p>
+                      <a:pPr algn="ctr"/>
+                      <a:r>
+                        <a:rPr sz="950" b="0">
+                          <a:solidFill>
+                            <a:srgbClr val="0C2340"/>
+                          </a:solidFill>
+                          <a:latin typeface="Georgia"/>
+                        </a:rPr>
+                        <a:t>0.552</a:t>
+                      </a:r>
+                    </a:p>
+                  </a:txBody>
+                  <a:tcPr anchor="ctr" marL="54864" marR="54864" marT="18288" marB="18288">
+                    <a:solidFill>
+                      <a:srgbClr val="EFE9D9"/>
+                    </a:solidFill>
+                  </a:tcPr>
+                </a:tc>
+                <a:tc>
+                  <a:txBody>
+                    <a:bodyPr wrap="square"/>
+                    <a:lstStyle/>
+                    <a:p>
+                      <a:pPr algn="ctr"/>
+                      <a:r>
+                        <a:rPr sz="950" b="0">
+                          <a:solidFill>
+                            <a:srgbClr val="0C2340"/>
+                          </a:solidFill>
+                          <a:latin typeface="Georgia"/>
+                        </a:rPr>
+                        <a:t>0.420</a:t>
+                      </a:r>
+                    </a:p>
+                  </a:txBody>
+                  <a:tcPr anchor="ctr" marL="54864" marR="54864" marT="18288" marB="18288">
+                    <a:solidFill>
+                      <a:srgbClr val="EFE9D9"/>
+                    </a:solidFill>
+                  </a:tcPr>
+                </a:tc>
+                <a:tc>
+                  <a:txBody>
+                    <a:bodyPr wrap="square"/>
+                    <a:lstStyle/>
+                    <a:p>
+                      <a:pPr algn="ctr"/>
+                      <a:r>
+                        <a:rPr sz="950" b="0">
+                          <a:solidFill>
+                            <a:srgbClr val="0C2340"/>
+                          </a:solidFill>
+                          <a:latin typeface="Georgia"/>
+                        </a:rPr>
+                        <a:t>0.468</a:t>
+                      </a:r>
+                    </a:p>
+                  </a:txBody>
+                  <a:tcPr anchor="ctr" marL="54864" marR="54864" marT="18288" marB="18288">
+                    <a:solidFill>
+                      <a:srgbClr val="EFE9D9"/>
+                    </a:solidFill>
+                  </a:tcPr>
+                </a:tc>
+                <a:tc>
+                  <a:txBody>
+                    <a:bodyPr wrap="square"/>
+                    <a:lstStyle/>
+                    <a:p>
+                      <a:pPr algn="ctr"/>
+                      <a:r>
+                        <a:rPr sz="950" b="0">
+                          <a:solidFill>
+                            <a:srgbClr val="0C2340"/>
+                          </a:solidFill>
+                          <a:latin typeface="Georgia"/>
+                        </a:rPr>
+                        <a:t>0.500</a:t>
+                      </a:r>
+                    </a:p>
+                  </a:txBody>
+                  <a:tcPr anchor="ctr" marL="54864" marR="54864" marT="18288" marB="18288">
+                    <a:solidFill>
+                      <a:srgbClr val="EFE9D9"/>
+                    </a:solidFill>
+                  </a:tcPr>
+                </a:tc>
+                <a:tc>
+                  <a:txBody>
+                    <a:bodyPr wrap="square"/>
+                    <a:lstStyle/>
+                    <a:p>
+                      <a:pPr algn="ctr"/>
+                      <a:r>
+                        <a:rPr sz="950" b="0">
+                          <a:solidFill>
+                            <a:srgbClr val="0C2340"/>
+                          </a:solidFill>
+                          <a:latin typeface="Georgia"/>
+                        </a:rPr>
+                        <a:t>+0.033 (noise)</a:t>
+                      </a:r>
+                    </a:p>
+                  </a:txBody>
+                  <a:tcPr anchor="ctr" marL="54864" marR="54864" marT="18288" marB="18288">
+                    <a:solidFill>
+                      <a:srgbClr val="EFE9D9"/>
+                    </a:solidFill>
+                  </a:tcPr>
+                </a:tc>
+                <a:tc>
+                  <a:txBody>
+                    <a:bodyPr wrap="square"/>
+                    <a:lstStyle/>
+                    <a:p>
+                      <a:pPr algn="ctr"/>
+                      <a:r>
+                        <a:rPr sz="950" b="0">
+                          <a:solidFill>
+                            <a:srgbClr val="0C2340"/>
+                          </a:solidFill>
+                          <a:latin typeface="Georgia"/>
+                        </a:rPr>
+                        <a:t>mild</a:t>
+                      </a:r>
+                    </a:p>
+                  </a:txBody>
+                  <a:tcPr anchor="ctr" marL="54864" marR="54864" marT="18288" marB="18288">
+                    <a:solidFill>
+                      <a:srgbClr val="EFE9D9"/>
+                    </a:solidFill>
+                  </a:tcPr>
+                </a:tc>
+              </a:tr>
+              <a:tr h="242316">
+                <a:tc>
+                  <a:txBody>
+                    <a:bodyPr wrap="square"/>
+                    <a:lstStyle/>
+                    <a:p>
+                      <a:pPr algn="l"/>
+                      <a:r>
+                        <a:rPr sz="950" b="0">
+                          <a:solidFill>
+                            <a:srgbClr val="0C2340"/>
+                          </a:solidFill>
+                          <a:latin typeface="Georgia"/>
+                        </a:rPr>
+                        <a:t>Mistral-24B</a:t>
+                      </a:r>
+                    </a:p>
+                  </a:txBody>
+                  <a:tcPr anchor="ctr" marL="54864" marR="54864" marT="18288" marB="18288">
+                    <a:solidFill>
+                      <a:srgbClr val="FFFFFF"/>
+                    </a:solidFill>
+                  </a:tcPr>
+                </a:tc>
+                <a:tc>
+                  <a:txBody>
+                    <a:bodyPr wrap="square"/>
+                    <a:lstStyle/>
+                    <a:p>
+                      <a:pPr algn="ctr"/>
+                      <a:r>
+                        <a:rPr sz="950" b="0">
+                          <a:solidFill>
+                            <a:srgbClr val="0C2340"/>
+                          </a:solidFill>
+                          <a:latin typeface="Georgia"/>
+                        </a:rPr>
+                        <a:t>0.757</a:t>
+                      </a:r>
+                    </a:p>
+                  </a:txBody>
+                  <a:tcPr anchor="ctr" marL="54864" marR="54864" marT="18288" marB="18288">
+                    <a:solidFill>
+                      <a:srgbClr val="FFFFFF"/>
+                    </a:solidFill>
+                  </a:tcPr>
+                </a:tc>
+                <a:tc>
+                  <a:txBody>
+                    <a:bodyPr wrap="square"/>
+                    <a:lstStyle/>
+                    <a:p>
+                      <a:pPr algn="ctr"/>
+                      <a:r>
+                        <a:rPr sz="950" b="0">
+                          <a:solidFill>
+                            <a:srgbClr val="0C2340"/>
+                          </a:solidFill>
+                          <a:latin typeface="Georgia"/>
+                        </a:rPr>
+                        <a:t>—</a:t>
+                      </a:r>
+                    </a:p>
+                  </a:txBody>
+                  <a:tcPr anchor="ctr" marL="54864" marR="54864" marT="18288" marB="18288">
+                    <a:solidFill>
+                      <a:srgbClr val="FFFFFF"/>
+                    </a:solidFill>
+                  </a:tcPr>
+                </a:tc>
+                <a:tc>
+                  <a:txBody>
+                    <a:bodyPr wrap="square"/>
+                    <a:lstStyle/>
+                    <a:p>
+                      <a:pPr algn="ctr"/>
+                      <a:r>
+                        <a:rPr sz="950" b="0">
+                          <a:solidFill>
+                            <a:srgbClr val="0C2340"/>
+                          </a:solidFill>
+                          <a:latin typeface="Georgia"/>
+                        </a:rPr>
+                        <a:t>0.698</a:t>
+                      </a:r>
+                    </a:p>
+                  </a:txBody>
+                  <a:tcPr anchor="ctr" marL="54864" marR="54864" marT="18288" marB="18288">
+                    <a:solidFill>
+                      <a:srgbClr val="FFFFFF"/>
+                    </a:solidFill>
+                  </a:tcPr>
+                </a:tc>
+                <a:tc>
+                  <a:txBody>
+                    <a:bodyPr wrap="square"/>
+                    <a:lstStyle/>
+                    <a:p>
+                      <a:pPr algn="ctr"/>
+                      <a:r>
+                        <a:rPr sz="950" b="0">
+                          <a:solidFill>
+                            <a:srgbClr val="0C2340"/>
+                          </a:solidFill>
+                          <a:latin typeface="Georgia"/>
+                        </a:rPr>
+                        <a:t>—</a:t>
+                      </a:r>
+                    </a:p>
+                  </a:txBody>
+                  <a:tcPr anchor="ctr" marL="54864" marR="54864" marT="18288" marB="18288">
+                    <a:solidFill>
+                      <a:srgbClr val="FFFFFF"/>
+                    </a:solidFill>
+                  </a:tcPr>
+                </a:tc>
+                <a:tc>
+                  <a:txBody>
+                    <a:bodyPr wrap="square"/>
+                    <a:lstStyle/>
+                    <a:p>
+                      <a:pPr algn="ctr"/>
+                      <a:r>
+                        <a:rPr sz="950" b="0">
+                          <a:solidFill>
+                            <a:srgbClr val="0C2340"/>
+                          </a:solidFill>
+                          <a:latin typeface="Georgia"/>
+                        </a:rPr>
+                        <a:t>—</a:t>
+                      </a:r>
+                    </a:p>
+                  </a:txBody>
+                  <a:tcPr anchor="ctr" marL="54864" marR="54864" marT="18288" marB="18288">
+                    <a:solidFill>
+                      <a:srgbClr val="FFFFFF"/>
+                    </a:solidFill>
+                  </a:tcPr>
+                </a:tc>
+                <a:tc>
+                  <a:txBody>
+                    <a:bodyPr wrap="square"/>
+                    <a:lstStyle/>
+                    <a:p>
+                      <a:pPr algn="ctr"/>
+                      <a:r>
+                        <a:rPr sz="950" b="0">
+                          <a:solidFill>
+                            <a:srgbClr val="0C2340"/>
+                          </a:solidFill>
+                          <a:latin typeface="Georgia"/>
+                        </a:rPr>
+                        <a:t>mild</a:t>
+                      </a:r>
+                    </a:p>
+                  </a:txBody>
+                  <a:tcPr anchor="ctr" marL="54864" marR="54864" marT="18288" marB="18288">
+                    <a:solidFill>
+                      <a:srgbClr val="FFFFFF"/>
+                    </a:solidFill>
+                  </a:tcPr>
+                </a:tc>
+              </a:tr>
+              <a:tr h="242316">
+                <a:tc>
+                  <a:txBody>
+                    <a:bodyPr wrap="square"/>
+                    <a:lstStyle/>
+                    <a:p>
+                      <a:pPr algn="l"/>
+                      <a:r>
+                        <a:rPr sz="950" b="0">
+                          <a:solidFill>
+                            <a:srgbClr val="0C2340"/>
+                          </a:solidFill>
+                          <a:latin typeface="Georgia"/>
+                        </a:rPr>
+                        <a:t>Qwen2.5-32B</a:t>
+                      </a:r>
+                    </a:p>
+                  </a:txBody>
+                  <a:tcPr anchor="ctr" marL="54864" marR="54864" marT="18288" marB="18288">
+                    <a:solidFill>
+                      <a:srgbClr val="EFE9D9"/>
+                    </a:solidFill>
+                  </a:tcPr>
+                </a:tc>
+                <a:tc>
+                  <a:txBody>
+                    <a:bodyPr wrap="square"/>
+                    <a:lstStyle/>
+                    <a:p>
+                      <a:pPr algn="ctr"/>
+                      <a:r>
+                        <a:rPr sz="950" b="0">
+                          <a:solidFill>
+                            <a:srgbClr val="0C2340"/>
+                          </a:solidFill>
+                          <a:latin typeface="Georgia"/>
+                        </a:rPr>
+                        <a:t>0.838</a:t>
+                      </a:r>
+                    </a:p>
+                  </a:txBody>
+                  <a:tcPr anchor="ctr" marL="54864" marR="54864" marT="18288" marB="18288">
+                    <a:solidFill>
+                      <a:srgbClr val="EFE9D9"/>
+                    </a:solidFill>
+                  </a:tcPr>
+                </a:tc>
+                <a:tc>
+                  <a:txBody>
+                    <a:bodyPr wrap="square"/>
+                    <a:lstStyle/>
+                    <a:p>
+                      <a:pPr algn="ctr"/>
+                      <a:r>
+                        <a:rPr sz="950" b="0">
+                          <a:solidFill>
+                            <a:srgbClr val="0C2340"/>
+                          </a:solidFill>
+                          <a:latin typeface="Georgia"/>
+                        </a:rPr>
+                        <a:t>—</a:t>
+                      </a:r>
+                    </a:p>
+                  </a:txBody>
+                  <a:tcPr anchor="ctr" marL="54864" marR="54864" marT="18288" marB="18288">
+                    <a:solidFill>
+                      <a:srgbClr val="EFE9D9"/>
+                    </a:solidFill>
+                  </a:tcPr>
+                </a:tc>
+                <a:tc>
+                  <a:txBody>
+                    <a:bodyPr wrap="square"/>
+                    <a:lstStyle/>
+                    <a:p>
+                      <a:pPr algn="ctr"/>
+                      <a:r>
+                        <a:rPr sz="950" b="0">
+                          <a:solidFill>
+                            <a:srgbClr val="0C2340"/>
+                          </a:solidFill>
+                          <a:latin typeface="Georgia"/>
+                        </a:rPr>
+                        <a:t>0.762</a:t>
+                      </a:r>
+                    </a:p>
+                  </a:txBody>
+                  <a:tcPr anchor="ctr" marL="54864" marR="54864" marT="18288" marB="18288">
+                    <a:solidFill>
+                      <a:srgbClr val="EFE9D9"/>
+                    </a:solidFill>
+                  </a:tcPr>
+                </a:tc>
+                <a:tc>
+                  <a:txBody>
+                    <a:bodyPr wrap="square"/>
+                    <a:lstStyle/>
+                    <a:p>
+                      <a:pPr algn="ctr"/>
+                      <a:r>
+                        <a:rPr sz="950" b="0">
+                          <a:solidFill>
+                            <a:srgbClr val="0C2340"/>
+                          </a:solidFill>
+                          <a:latin typeface="Georgia"/>
+                        </a:rPr>
+                        <a:t>—</a:t>
+                      </a:r>
+                    </a:p>
+                  </a:txBody>
+                  <a:tcPr anchor="ctr" marL="54864" marR="54864" marT="18288" marB="18288">
+                    <a:solidFill>
+                      <a:srgbClr val="EFE9D9"/>
+                    </a:solidFill>
+                  </a:tcPr>
+                </a:tc>
+                <a:tc>
+                  <a:txBody>
+                    <a:bodyPr wrap="square"/>
+                    <a:lstStyle/>
+                    <a:p>
+                      <a:pPr algn="ctr"/>
+                      <a:r>
+                        <a:rPr sz="950" b="0">
+                          <a:solidFill>
+                            <a:srgbClr val="0C2340"/>
+                          </a:solidFill>
+                          <a:latin typeface="Georgia"/>
+                        </a:rPr>
+                        <a:t>—</a:t>
+                      </a:r>
+                    </a:p>
+                  </a:txBody>
+                  <a:tcPr anchor="ctr" marL="54864" marR="54864" marT="18288" marB="18288">
+                    <a:solidFill>
+                      <a:srgbClr val="EFE9D9"/>
+                    </a:solidFill>
+                  </a:tcPr>
+                </a:tc>
+                <a:tc>
+                  <a:txBody>
+                    <a:bodyPr wrap="square"/>
+                    <a:lstStyle/>
+                    <a:p>
+                      <a:pPr algn="ctr"/>
+                      <a:r>
+                        <a:rPr sz="950" b="0">
+                          <a:solidFill>
+                            <a:srgbClr val="0C2340"/>
+                          </a:solidFill>
+                          <a:latin typeface="Georgia"/>
+                        </a:rPr>
+                        <a:t>mild</a:t>
+                      </a:r>
+                    </a:p>
+                  </a:txBody>
+                  <a:tcPr anchor="ctr" marL="54864" marR="54864" marT="18288" marB="18288">
+                    <a:solidFill>
+                      <a:srgbClr val="EFE9D9"/>
+                    </a:solidFill>
+                  </a:tcPr>
+                </a:tc>
+              </a:tr>
+              <a:tr h="242316">
+                <a:tc>
+                  <a:txBody>
+                    <a:bodyPr wrap="square"/>
+                    <a:lstStyle/>
+                    <a:p>
+                      <a:pPr algn="l"/>
+                      <a:r>
+                        <a:rPr sz="950" b="0">
+                          <a:solidFill>
+                            <a:srgbClr val="0C2340"/>
+                          </a:solidFill>
+                          <a:latin typeface="Georgia"/>
+                        </a:rPr>
+                        <a:t>OLMo-2-7B</a:t>
+                      </a:r>
+                    </a:p>
+                  </a:txBody>
+                  <a:tcPr anchor="ctr" marL="54864" marR="54864" marT="18288" marB="18288">
+                    <a:solidFill>
+                      <a:srgbClr val="FFFFFF"/>
+                    </a:solidFill>
+                  </a:tcPr>
+                </a:tc>
+                <a:tc>
+                  <a:txBody>
+                    <a:bodyPr wrap="square"/>
+                    <a:lstStyle/>
+                    <a:p>
+                      <a:pPr algn="ctr"/>
+                      <a:r>
+                        <a:rPr sz="950" b="0">
+                          <a:solidFill>
+                            <a:srgbClr val="0C2340"/>
+                          </a:solidFill>
+                          <a:latin typeface="Georgia"/>
+                        </a:rPr>
+                        <a:t>0.750</a:t>
+                      </a:r>
+                    </a:p>
+                  </a:txBody>
+                  <a:tcPr anchor="ctr" marL="54864" marR="54864" marT="18288" marB="18288">
+                    <a:solidFill>
+                      <a:srgbClr val="FFFFFF"/>
+                    </a:solidFill>
+                  </a:tcPr>
+                </a:tc>
+                <a:tc>
+                  <a:txBody>
+                    <a:bodyPr wrap="square"/>
+                    <a:lstStyle/>
+                    <a:p>
+                      <a:pPr algn="ctr"/>
+                      <a:r>
+                        <a:rPr sz="950" b="0">
+                          <a:solidFill>
+                            <a:srgbClr val="0C2340"/>
+                          </a:solidFill>
+                          <a:latin typeface="Georgia"/>
+                        </a:rPr>
+                        <a:t>—</a:t>
+                      </a:r>
+                    </a:p>
+                  </a:txBody>
+                  <a:tcPr anchor="ctr" marL="54864" marR="54864" marT="18288" marB="18288">
+                    <a:solidFill>
+                      <a:srgbClr val="FFFFFF"/>
+                    </a:solidFill>
+                  </a:tcPr>
+                </a:tc>
+                <a:tc>
+                  <a:txBody>
+                    <a:bodyPr wrap="square"/>
+                    <a:lstStyle/>
+                    <a:p>
+                      <a:pPr algn="ctr"/>
+                      <a:r>
+                        <a:rPr sz="950" b="0">
+                          <a:solidFill>
+                            <a:srgbClr val="0C2340"/>
+                          </a:solidFill>
+                          <a:latin typeface="Georgia"/>
+                        </a:rPr>
+                        <a:t>0.688</a:t>
+                      </a:r>
+                    </a:p>
+                  </a:txBody>
+                  <a:tcPr anchor="ctr" marL="54864" marR="54864" marT="18288" marB="18288">
+                    <a:solidFill>
+                      <a:srgbClr val="FFFFFF"/>
+                    </a:solidFill>
+                  </a:tcPr>
+                </a:tc>
+                <a:tc>
+                  <a:txBody>
+                    <a:bodyPr wrap="square"/>
+                    <a:lstStyle/>
+                    <a:p>
+                      <a:pPr algn="ctr"/>
+                      <a:r>
+                        <a:rPr sz="950" b="0">
+                          <a:solidFill>
+                            <a:srgbClr val="0C2340"/>
+                          </a:solidFill>
+                          <a:latin typeface="Georgia"/>
+                        </a:rPr>
+                        <a:t>—</a:t>
+                      </a:r>
+                    </a:p>
+                  </a:txBody>
+                  <a:tcPr anchor="ctr" marL="54864" marR="54864" marT="18288" marB="18288">
+                    <a:solidFill>
+                      <a:srgbClr val="FFFFFF"/>
+                    </a:solidFill>
+                  </a:tcPr>
+                </a:tc>
+                <a:tc>
+                  <a:txBody>
+                    <a:bodyPr wrap="square"/>
+                    <a:lstStyle/>
+                    <a:p>
+                      <a:pPr algn="ctr"/>
+                      <a:r>
+                        <a:rPr sz="950" b="0">
+                          <a:solidFill>
+                            <a:srgbClr val="0C2340"/>
+                          </a:solidFill>
+                          <a:latin typeface="Georgia"/>
+                        </a:rPr>
+                        <a:t>—</a:t>
+                      </a:r>
+                    </a:p>
+                  </a:txBody>
+                  <a:tcPr anchor="ctr" marL="54864" marR="54864" marT="18288" marB="18288">
+                    <a:solidFill>
+                      <a:srgbClr val="FFFFFF"/>
+                    </a:solidFill>
+                  </a:tcPr>
+                </a:tc>
+                <a:tc>
+                  <a:txBody>
+                    <a:bodyPr wrap="square"/>
+                    <a:lstStyle/>
+                    <a:p>
+                      <a:pPr algn="ctr"/>
+                      <a:r>
+                        <a:rPr sz="950" b="0">
+                          <a:solidFill>
+                            <a:srgbClr val="0C2340"/>
+                          </a:solidFill>
+                          <a:latin typeface="Georgia"/>
+                        </a:rPr>
+                        <a:t>mild</a:t>
+                      </a:r>
+                    </a:p>
+                  </a:txBody>
+                  <a:tcPr anchor="ctr" marL="54864" marR="54864" marT="18288" marB="18288">
+                    <a:solidFill>
+                      <a:srgbClr val="FFFFFF"/>
+                    </a:solidFill>
+                  </a:tcPr>
+                </a:tc>
+              </a:tr>
+              <a:tr h="242316">
+                <a:tc>
+                  <a:txBody>
+                    <a:bodyPr wrap="square"/>
+                    <a:lstStyle/>
+                    <a:p>
+                      <a:pPr algn="l"/>
+                      <a:r>
+                        <a:rPr sz="950" b="0">
+                          <a:solidFill>
+                            <a:srgbClr val="0C2340"/>
+                          </a:solidFill>
+                          <a:latin typeface="Georgia"/>
+                        </a:rPr>
+                        <a:t>Llama-3-8B (older gen)</a:t>
+                      </a:r>
+                    </a:p>
+                  </a:txBody>
+                  <a:tcPr anchor="ctr" marL="54864" marR="54864" marT="18288" marB="18288">
+                    <a:solidFill>
+                      <a:srgbClr val="EFE9D9"/>
+                    </a:solidFill>
+                  </a:tcPr>
+                </a:tc>
+                <a:tc>
+                  <a:txBody>
+                    <a:bodyPr wrap="square"/>
+                    <a:lstStyle/>
+                    <a:p>
+                      <a:pPr algn="ctr"/>
+                      <a:r>
+                        <a:rPr sz="950" b="0">
+                          <a:solidFill>
+                            <a:srgbClr val="0C2340"/>
+                          </a:solidFill>
+                          <a:latin typeface="Georgia"/>
+                        </a:rPr>
+                        <a:t>0.758</a:t>
+                      </a:r>
+                    </a:p>
+                  </a:txBody>
+                  <a:tcPr anchor="ctr" marL="54864" marR="54864" marT="18288" marB="18288">
+                    <a:solidFill>
+                      <a:srgbClr val="EFE9D9"/>
+                    </a:solidFill>
+                  </a:tcPr>
+                </a:tc>
+                <a:tc>
+                  <a:txBody>
+                    <a:bodyPr wrap="square"/>
+                    <a:lstStyle/>
+                    <a:p>
+                      <a:pPr algn="ctr"/>
+                      <a:r>
+                        <a:rPr sz="950" b="0">
+                          <a:solidFill>
+                            <a:srgbClr val="0C2340"/>
+                          </a:solidFill>
+                          <a:latin typeface="Georgia"/>
+                        </a:rPr>
+                        <a:t>—</a:t>
+                      </a:r>
+                    </a:p>
+                  </a:txBody>
+                  <a:tcPr anchor="ctr" marL="54864" marR="54864" marT="18288" marB="18288">
+                    <a:solidFill>
+                      <a:srgbClr val="EFE9D9"/>
+                    </a:solidFill>
+                  </a:tcPr>
+                </a:tc>
+                <a:tc>
+                  <a:txBody>
+                    <a:bodyPr wrap="square"/>
+                    <a:lstStyle/>
+                    <a:p>
+                      <a:pPr algn="ctr"/>
+                      <a:r>
+                        <a:rPr sz="950" b="0">
+                          <a:solidFill>
+                            <a:srgbClr val="0C2340"/>
+                          </a:solidFill>
+                          <a:latin typeface="Georgia"/>
+                        </a:rPr>
+                        <a:t>0.611</a:t>
+                      </a:r>
+                    </a:p>
+                  </a:txBody>
+                  <a:tcPr anchor="ctr" marL="54864" marR="54864" marT="18288" marB="18288">
+                    <a:solidFill>
+                      <a:srgbClr val="EFE9D9"/>
+                    </a:solidFill>
+                  </a:tcPr>
+                </a:tc>
+                <a:tc>
+                  <a:txBody>
+                    <a:bodyPr wrap="square"/>
+                    <a:lstStyle/>
+                    <a:p>
+                      <a:pPr algn="ctr"/>
+                      <a:r>
+                        <a:rPr sz="950" b="0">
+                          <a:solidFill>
+                            <a:srgbClr val="0C2340"/>
+                          </a:solidFill>
+                          <a:latin typeface="Georgia"/>
+                        </a:rPr>
+                        <a:t>—</a:t>
+                      </a:r>
+                    </a:p>
+                  </a:txBody>
+                  <a:tcPr anchor="ctr" marL="54864" marR="54864" marT="18288" marB="18288">
+                    <a:solidFill>
+                      <a:srgbClr val="EFE9D9"/>
+                    </a:solidFill>
+                  </a:tcPr>
+                </a:tc>
+                <a:tc>
+                  <a:txBody>
+                    <a:bodyPr wrap="square"/>
+                    <a:lstStyle/>
+                    <a:p>
+                      <a:pPr algn="ctr"/>
+                      <a:r>
+                        <a:rPr sz="950" b="0">
+                          <a:solidFill>
+                            <a:srgbClr val="0C2340"/>
+                          </a:solidFill>
+                          <a:latin typeface="Georgia"/>
+                        </a:rPr>
+                        <a:t>—</a:t>
+                      </a:r>
+                    </a:p>
+                  </a:txBody>
+                  <a:tcPr anchor="ctr" marL="54864" marR="54864" marT="18288" marB="18288">
+                    <a:solidFill>
+                      <a:srgbClr val="EFE9D9"/>
+                    </a:solidFill>
+                  </a:tcPr>
+                </a:tc>
+                <a:tc>
+                  <a:txBody>
+                    <a:bodyPr wrap="square"/>
+                    <a:lstStyle/>
+                    <a:p>
+                      <a:pPr algn="ctr"/>
+                      <a:r>
+                        <a:rPr sz="950" b="0">
+                          <a:solidFill>
+                            <a:srgbClr val="0C2340"/>
+                          </a:solidFill>
+                          <a:latin typeface="Georgia"/>
+                        </a:rPr>
+                        <a:t>middle</a:t>
+                      </a:r>
+                    </a:p>
+                  </a:txBody>
+                  <a:tcPr anchor="ctr" marL="54864" marR="54864" marT="18288" marB="18288">
+                    <a:solidFill>
+                      <a:srgbClr val="EFE9D9"/>
+                    </a:solidFill>
+                  </a:tcPr>
+                </a:tc>
+              </a:tr>
+              <a:tr h="242316">
+                <a:tc>
+                  <a:txBody>
+                    <a:bodyPr wrap="square"/>
+                    <a:lstStyle/>
+                    <a:p>
+                      <a:pPr algn="l"/>
+                      <a:r>
+                        <a:rPr sz="950" b="0">
+                          <a:solidFill>
+                            <a:srgbClr val="0C2340"/>
+                          </a:solidFill>
+                          <a:latin typeface="Georgia"/>
+                        </a:rPr>
+                        <a:t>Yi-1.5-9B</a:t>
+                      </a:r>
+                    </a:p>
+                  </a:txBody>
+                  <a:tcPr anchor="ctr" marL="54864" marR="54864" marT="18288" marB="18288">
+                    <a:solidFill>
+                      <a:srgbClr val="FFFFFF"/>
+                    </a:solidFill>
+                  </a:tcPr>
+                </a:tc>
+                <a:tc>
+                  <a:txBody>
+                    <a:bodyPr wrap="square"/>
+                    <a:lstStyle/>
+                    <a:p>
+                      <a:pPr algn="ctr"/>
+                      <a:r>
+                        <a:rPr sz="950" b="0">
+                          <a:solidFill>
+                            <a:srgbClr val="0C2340"/>
+                          </a:solidFill>
+                          <a:latin typeface="Georgia"/>
+                        </a:rPr>
+                        <a:t>0.594</a:t>
+                      </a:r>
+                    </a:p>
+                  </a:txBody>
+                  <a:tcPr anchor="ctr" marL="54864" marR="54864" marT="18288" marB="18288">
+                    <a:solidFill>
+                      <a:srgbClr val="FFFFFF"/>
+                    </a:solidFill>
+                  </a:tcPr>
+                </a:tc>
+                <a:tc>
+                  <a:txBody>
+                    <a:bodyPr wrap="square"/>
+                    <a:lstStyle/>
+                    <a:p>
+                      <a:pPr algn="ctr"/>
+                      <a:r>
+                        <a:rPr sz="950" b="0">
+                          <a:solidFill>
+                            <a:srgbClr val="0C2340"/>
+                          </a:solidFill>
+                          <a:latin typeface="Georgia"/>
+                        </a:rPr>
+                        <a:t>0.320</a:t>
+                      </a:r>
+                    </a:p>
+                  </a:txBody>
+                  <a:tcPr anchor="ctr" marL="54864" marR="54864" marT="18288" marB="18288">
+                    <a:solidFill>
+                      <a:srgbClr val="FFFFFF"/>
+                    </a:solidFill>
+                  </a:tcPr>
+                </a:tc>
+                <a:tc>
+                  <a:txBody>
+                    <a:bodyPr wrap="square"/>
+                    <a:lstStyle/>
+                    <a:p>
+                      <a:pPr algn="ctr"/>
+                      <a:r>
+                        <a:rPr sz="950" b="0">
+                          <a:solidFill>
+                            <a:srgbClr val="0C2340"/>
+                          </a:solidFill>
+                          <a:latin typeface="Georgia"/>
+                        </a:rPr>
+                        <a:t>0.443</a:t>
+                      </a:r>
+                    </a:p>
+                  </a:txBody>
+                  <a:tcPr anchor="ctr" marL="54864" marR="54864" marT="18288" marB="18288">
+                    <a:solidFill>
+                      <a:srgbClr val="FFFFFF"/>
+                    </a:solidFill>
+                  </a:tcPr>
+                </a:tc>
+                <a:tc>
+                  <a:txBody>
+                    <a:bodyPr wrap="square"/>
+                    <a:lstStyle/>
+                    <a:p>
+                      <a:pPr algn="ctr"/>
+                      <a:r>
+                        <a:rPr sz="950" b="0">
+                          <a:solidFill>
+                            <a:srgbClr val="0C2340"/>
+                          </a:solidFill>
+                          <a:latin typeface="Georgia"/>
+                        </a:rPr>
+                        <a:t>0.462</a:t>
+                      </a:r>
+                    </a:p>
+                  </a:txBody>
+                  <a:tcPr anchor="ctr" marL="54864" marR="54864" marT="18288" marB="18288">
+                    <a:solidFill>
+                      <a:srgbClr val="FFFFFF"/>
+                    </a:solidFill>
+                  </a:tcPr>
+                </a:tc>
+                <a:tc>
+                  <a:txBody>
+                    <a:bodyPr wrap="square"/>
+                    <a:lstStyle/>
+                    <a:p>
+                      <a:pPr algn="ctr"/>
+                      <a:r>
+                        <a:rPr sz="950" b="0">
+                          <a:solidFill>
+                            <a:srgbClr val="0C2340"/>
+                          </a:solidFill>
+                          <a:latin typeface="Georgia"/>
+                        </a:rPr>
+                        <a:t>+0.020 (noise)</a:t>
+                      </a:r>
+                    </a:p>
+                  </a:txBody>
+                  <a:tcPr anchor="ctr" marL="54864" marR="54864" marT="18288" marB="18288">
+                    <a:solidFill>
+                      <a:srgbClr val="FFFFFF"/>
+                    </a:solidFill>
+                  </a:tcPr>
+                </a:tc>
+                <a:tc>
+                  <a:txBody>
+                    <a:bodyPr wrap="square"/>
+                    <a:lstStyle/>
+                    <a:p>
+                      <a:pPr algn="ctr"/>
+                      <a:r>
+                        <a:rPr sz="950" b="0">
+                          <a:solidFill>
+                            <a:srgbClr val="0C2340"/>
+                          </a:solidFill>
+                          <a:latin typeface="Georgia"/>
+                        </a:rPr>
+                        <a:t>middle</a:t>
+                      </a:r>
+                    </a:p>
+                  </a:txBody>
+                  <a:tcPr anchor="ctr" marL="54864" marR="54864" marT="18288" marB="18288">
+                    <a:solidFill>
+                      <a:srgbClr val="FFFFFF"/>
+                    </a:solidFill>
+                  </a:tcPr>
+                </a:tc>
+              </a:tr>
+              <a:tr h="242316">
+                <a:tc>
+                  <a:txBody>
+                    <a:bodyPr wrap="square"/>
+                    <a:lstStyle/>
+                    <a:p>
+                      <a:pPr algn="l"/>
+                      <a:r>
+                        <a:rPr sz="950" b="0">
+                          <a:solidFill>
+                            <a:srgbClr val="0C2340"/>
+                          </a:solidFill>
+                          <a:latin typeface="Georgia"/>
+                        </a:rPr>
+                        <a:t>Llama-3.2-3B</a:t>
+                      </a:r>
+                    </a:p>
+                  </a:txBody>
+                  <a:tcPr anchor="ctr" marL="54864" marR="54864" marT="18288" marB="18288">
+                    <a:solidFill>
+                      <a:srgbClr val="EFE9D9"/>
+                    </a:solidFill>
+                  </a:tcPr>
+                </a:tc>
+                <a:tc>
+                  <a:txBody>
+                    <a:bodyPr wrap="square"/>
+                    <a:lstStyle/>
+                    <a:p>
+                      <a:pPr algn="ctr"/>
+                      <a:r>
+                        <a:rPr sz="950" b="0">
+                          <a:solidFill>
+                            <a:srgbClr val="0C2340"/>
+                          </a:solidFill>
+                          <a:latin typeface="Georgia"/>
+                        </a:rPr>
+                        <a:t>0.750</a:t>
+                      </a:r>
+                    </a:p>
+                  </a:txBody>
+                  <a:tcPr anchor="ctr" marL="54864" marR="54864" marT="18288" marB="18288">
+                    <a:solidFill>
+                      <a:srgbClr val="EFE9D9"/>
+                    </a:solidFill>
+                  </a:tcPr>
+                </a:tc>
+                <a:tc>
+                  <a:txBody>
+                    <a:bodyPr wrap="square"/>
+                    <a:lstStyle/>
+                    <a:p>
+                      <a:pPr algn="ctr"/>
+                      <a:r>
+                        <a:rPr sz="950" b="0">
+                          <a:solidFill>
+                            <a:srgbClr val="0C2340"/>
+                          </a:solidFill>
+                          <a:latin typeface="Georgia"/>
+                        </a:rPr>
+                        <a:t>—</a:t>
+                      </a:r>
+                    </a:p>
+                  </a:txBody>
+                  <a:tcPr anchor="ctr" marL="54864" marR="54864" marT="18288" marB="18288">
+                    <a:solidFill>
+                      <a:srgbClr val="EFE9D9"/>
+                    </a:solidFill>
+                  </a:tcPr>
+                </a:tc>
+                <a:tc>
+                  <a:txBody>
+                    <a:bodyPr wrap="square"/>
+                    <a:lstStyle/>
+                    <a:p>
+                      <a:pPr algn="ctr"/>
+                      <a:r>
+                        <a:rPr sz="950" b="0">
+                          <a:solidFill>
+                            <a:srgbClr val="0C2340"/>
+                          </a:solidFill>
+                          <a:latin typeface="Georgia"/>
+                        </a:rPr>
+                        <a:t>0.577</a:t>
+                      </a:r>
+                    </a:p>
+                  </a:txBody>
+                  <a:tcPr anchor="ctr" marL="54864" marR="54864" marT="18288" marB="18288">
+                    <a:solidFill>
+                      <a:srgbClr val="EFE9D9"/>
+                    </a:solidFill>
+                  </a:tcPr>
+                </a:tc>
+                <a:tc>
+                  <a:txBody>
+                    <a:bodyPr wrap="square"/>
+                    <a:lstStyle/>
+                    <a:p>
+                      <a:pPr algn="ctr"/>
+                      <a:r>
+                        <a:rPr sz="950" b="0">
+                          <a:solidFill>
+                            <a:srgbClr val="0C2340"/>
+                          </a:solidFill>
+                          <a:latin typeface="Georgia"/>
+                        </a:rPr>
+                        <a:t>—</a:t>
+                      </a:r>
+                    </a:p>
+                  </a:txBody>
+                  <a:tcPr anchor="ctr" marL="54864" marR="54864" marT="18288" marB="18288">
+                    <a:solidFill>
+                      <a:srgbClr val="EFE9D9"/>
+                    </a:solidFill>
+                  </a:tcPr>
+                </a:tc>
+                <a:tc>
+                  <a:txBody>
+                    <a:bodyPr wrap="square"/>
+                    <a:lstStyle/>
+                    <a:p>
+                      <a:pPr algn="ctr"/>
+                      <a:r>
+                        <a:rPr sz="950" b="0">
+                          <a:solidFill>
+                            <a:srgbClr val="0C2340"/>
+                          </a:solidFill>
+                          <a:latin typeface="Georgia"/>
+                        </a:rPr>
+                        <a:t>—</a:t>
+                      </a:r>
+                    </a:p>
+                  </a:txBody>
+                  <a:tcPr anchor="ctr" marL="54864" marR="54864" marT="18288" marB="18288">
+                    <a:solidFill>
+                      <a:srgbClr val="EFE9D9"/>
+                    </a:solidFill>
+                  </a:tcPr>
+                </a:tc>
+                <a:tc>
+                  <a:txBody>
+                    <a:bodyPr wrap="square"/>
+                    <a:lstStyle/>
+                    <a:p>
+                      <a:pPr algn="ctr"/>
+                      <a:r>
+                        <a:rPr sz="950" b="0">
+                          <a:solidFill>
+                            <a:srgbClr val="0C2340"/>
+                          </a:solidFill>
+                          <a:latin typeface="Georgia"/>
+                        </a:rPr>
+                        <a:t>middle</a:t>
+                      </a:r>
+                    </a:p>
+                  </a:txBody>
+                  <a:tcPr anchor="ctr" marL="54864" marR="54864" marT="18288" marB="18288">
+                    <a:solidFill>
+                      <a:srgbClr val="EFE9D9"/>
+                    </a:solidFill>
+                  </a:tcPr>
+                </a:tc>
+              </a:tr>
+              <a:tr h="242316">
+                <a:tc>
+                  <a:txBody>
+                    <a:bodyPr wrap="square"/>
+                    <a:lstStyle/>
+                    <a:p>
+                      <a:pPr algn="l"/>
+                      <a:r>
+                        <a:rPr sz="950" b="0">
+                          <a:solidFill>
+                            <a:srgbClr val="0C2340"/>
+                          </a:solidFill>
+                          <a:latin typeface="Georgia"/>
+                        </a:rPr>
+                        <a:t>Mistral-Nemo-12B</a:t>
+                      </a:r>
+                    </a:p>
+                  </a:txBody>
+                  <a:tcPr anchor="ctr" marL="54864" marR="54864" marT="18288" marB="18288">
+                    <a:solidFill>
+                      <a:srgbClr val="FFFFFF"/>
+                    </a:solidFill>
+                  </a:tcPr>
+                </a:tc>
+                <a:tc>
+                  <a:txBody>
+                    <a:bodyPr wrap="square"/>
+                    <a:lstStyle/>
+                    <a:p>
+                      <a:pPr algn="ctr"/>
+                      <a:r>
+                        <a:rPr sz="950" b="0">
+                          <a:solidFill>
+                            <a:srgbClr val="0C2340"/>
+                          </a:solidFill>
+                          <a:latin typeface="Georgia"/>
+                        </a:rPr>
+                        <a:t>0.651</a:t>
+                      </a:r>
+                    </a:p>
+                  </a:txBody>
+                  <a:tcPr anchor="ctr" marL="54864" marR="54864" marT="18288" marB="18288">
+                    <a:solidFill>
+                      <a:srgbClr val="FFFFFF"/>
+                    </a:solidFill>
+                  </a:tcPr>
+                </a:tc>
+                <a:tc>
+                  <a:txBody>
+                    <a:bodyPr wrap="square"/>
+                    <a:lstStyle/>
+                    <a:p>
+                      <a:pPr algn="ctr"/>
+                      <a:r>
+                        <a:rPr sz="950" b="0">
+                          <a:solidFill>
+                            <a:srgbClr val="0C2340"/>
+                          </a:solidFill>
+                          <a:latin typeface="Georgia"/>
+                        </a:rPr>
+                        <a:t>—</a:t>
+                      </a:r>
+                    </a:p>
+                  </a:txBody>
+                  <a:tcPr anchor="ctr" marL="54864" marR="54864" marT="18288" marB="18288">
+                    <a:solidFill>
+                      <a:srgbClr val="FFFFFF"/>
+                    </a:solidFill>
+                  </a:tcPr>
+                </a:tc>
+                <a:tc>
+                  <a:txBody>
+                    <a:bodyPr wrap="square"/>
+                    <a:lstStyle/>
+                    <a:p>
+                      <a:pPr algn="ctr"/>
+                      <a:r>
+                        <a:rPr sz="950" b="0">
+                          <a:solidFill>
+                            <a:srgbClr val="0C2340"/>
+                          </a:solidFill>
+                          <a:latin typeface="Georgia"/>
+                        </a:rPr>
+                        <a:t>0.476</a:t>
+                      </a:r>
+                    </a:p>
+                  </a:txBody>
+                  <a:tcPr anchor="ctr" marL="54864" marR="54864" marT="18288" marB="18288">
+                    <a:solidFill>
+                      <a:srgbClr val="FFFFFF"/>
+                    </a:solidFill>
+                  </a:tcPr>
+                </a:tc>
+                <a:tc>
+                  <a:txBody>
+                    <a:bodyPr wrap="square"/>
+                    <a:lstStyle/>
+                    <a:p>
+                      <a:pPr algn="ctr"/>
+                      <a:r>
+                        <a:rPr sz="950" b="0">
+                          <a:solidFill>
+                            <a:srgbClr val="0C2340"/>
+                          </a:solidFill>
+                          <a:latin typeface="Georgia"/>
+                        </a:rPr>
+                        <a:t>—</a:t>
+                      </a:r>
+                    </a:p>
+                  </a:txBody>
+                  <a:tcPr anchor="ctr" marL="54864" marR="54864" marT="18288" marB="18288">
+                    <a:solidFill>
+                      <a:srgbClr val="FFFFFF"/>
+                    </a:solidFill>
+                  </a:tcPr>
+                </a:tc>
+                <a:tc>
+                  <a:txBody>
+                    <a:bodyPr wrap="square"/>
+                    <a:lstStyle/>
+                    <a:p>
+                      <a:pPr algn="ctr"/>
+                      <a:r>
+                        <a:rPr sz="950" b="0">
+                          <a:solidFill>
+                            <a:srgbClr val="0C2340"/>
+                          </a:solidFill>
+                          <a:latin typeface="Georgia"/>
+                        </a:rPr>
+                        <a:t>—</a:t>
+                      </a:r>
+                    </a:p>
+                  </a:txBody>
+                  <a:tcPr anchor="ctr" marL="54864" marR="54864" marT="18288" marB="18288">
+                    <a:solidFill>
+                      <a:srgbClr val="FFFFFF"/>
+                    </a:solidFill>
+                  </a:tcPr>
+                </a:tc>
+                <a:tc>
+                  <a:txBody>
+                    <a:bodyPr wrap="square"/>
+                    <a:lstStyle/>
+                    <a:p>
+                      <a:pPr algn="ctr"/>
+                      <a:r>
+                        <a:rPr sz="950" b="0">
+                          <a:solidFill>
+                            <a:srgbClr val="0C2340"/>
+                          </a:solidFill>
+                          <a:latin typeface="Georgia"/>
+                        </a:rPr>
+                        <a:t>middle</a:t>
+                      </a:r>
+                    </a:p>
+                  </a:txBody>
+                  <a:tcPr anchor="ctr" marL="54864" marR="54864" marT="18288" marB="18288">
+                    <a:solidFill>
+                      <a:srgbClr val="FFFFFF"/>
+                    </a:solidFill>
+                  </a:tcPr>
+                </a:tc>
+              </a:tr>
+              <a:tr h="242316">
+                <a:tc>
+                  <a:txBody>
+                    <a:bodyPr wrap="square"/>
+                    <a:lstStyle/>
+                    <a:p>
+                      <a:pPr algn="l"/>
+                      <a:r>
+                        <a:rPr sz="950" b="0">
+                          <a:solidFill>
+                            <a:srgbClr val="0C2340"/>
+                          </a:solidFill>
+                          <a:latin typeface="Georgia"/>
+                        </a:rPr>
+                        <a:t>Qwen2.5-3B</a:t>
+                      </a:r>
+                    </a:p>
+                  </a:txBody>
+                  <a:tcPr anchor="ctr" marL="54864" marR="54864" marT="18288" marB="18288">
+                    <a:solidFill>
+                      <a:srgbClr val="EFE9D9"/>
+                    </a:solidFill>
+                  </a:tcPr>
+                </a:tc>
+                <a:tc>
+                  <a:txBody>
+                    <a:bodyPr wrap="square"/>
+                    <a:lstStyle/>
+                    <a:p>
+                      <a:pPr algn="ctr"/>
+                      <a:r>
+                        <a:rPr sz="950" b="0">
+                          <a:solidFill>
+                            <a:srgbClr val="0C2340"/>
+                          </a:solidFill>
+                          <a:latin typeface="Georgia"/>
+                        </a:rPr>
+                        <a:t>0.658</a:t>
+                      </a:r>
+                    </a:p>
+                  </a:txBody>
+                  <a:tcPr anchor="ctr" marL="54864" marR="54864" marT="18288" marB="18288">
+                    <a:solidFill>
+                      <a:srgbClr val="EFE9D9"/>
+                    </a:solidFill>
+                  </a:tcPr>
+                </a:tc>
+                <a:tc>
+                  <a:txBody>
+                    <a:bodyPr wrap="square"/>
+                    <a:lstStyle/>
+                    <a:p>
+                      <a:pPr algn="ctr"/>
+                      <a:r>
+                        <a:rPr sz="950" b="0">
+                          <a:solidFill>
+                            <a:srgbClr val="0C2340"/>
+                          </a:solidFill>
+                          <a:latin typeface="Georgia"/>
+                        </a:rPr>
+                        <a:t>0.130</a:t>
+                      </a:r>
+                    </a:p>
+                  </a:txBody>
+                  <a:tcPr anchor="ctr" marL="54864" marR="54864" marT="18288" marB="18288">
+                    <a:solidFill>
+                      <a:srgbClr val="EFE9D9"/>
+                    </a:solidFill>
+                  </a:tcPr>
+                </a:tc>
+                <a:tc>
+                  <a:txBody>
+                    <a:bodyPr wrap="square"/>
+                    <a:lstStyle/>
+                    <a:p>
+                      <a:pPr algn="ctr"/>
+                      <a:r>
+                        <a:rPr sz="950" b="0">
+                          <a:solidFill>
+                            <a:srgbClr val="0C2340"/>
+                          </a:solidFill>
+                          <a:latin typeface="Georgia"/>
+                        </a:rPr>
+                        <a:t>0.411</a:t>
+                      </a:r>
+                    </a:p>
+                  </a:txBody>
+                  <a:tcPr anchor="ctr" marL="54864" marR="54864" marT="18288" marB="18288">
+                    <a:solidFill>
+                      <a:srgbClr val="EFE9D9"/>
+                    </a:solidFill>
+                  </a:tcPr>
+                </a:tc>
+                <a:tc>
+                  <a:txBody>
+                    <a:bodyPr wrap="square"/>
+                    <a:lstStyle/>
+                    <a:p>
+                      <a:pPr algn="ctr"/>
+                      <a:r>
+                        <a:rPr sz="950" b="0">
+                          <a:solidFill>
+                            <a:srgbClr val="0C2340"/>
+                          </a:solidFill>
+                          <a:latin typeface="Georgia"/>
+                        </a:rPr>
+                        <a:t>0.484</a:t>
+                      </a:r>
+                    </a:p>
+                  </a:txBody>
+                  <a:tcPr anchor="ctr" marL="54864" marR="54864" marT="18288" marB="18288">
+                    <a:solidFill>
+                      <a:srgbClr val="EFE9D9"/>
+                    </a:solidFill>
+                  </a:tcPr>
+                </a:tc>
+                <a:tc>
+                  <a:txBody>
+                    <a:bodyPr wrap="square"/>
+                    <a:lstStyle/>
+                    <a:p>
+                      <a:pPr algn="ctr"/>
+                      <a:r>
+                        <a:rPr sz="950" b="0">
+                          <a:solidFill>
+                            <a:srgbClr val="0C2340"/>
+                          </a:solidFill>
+                          <a:latin typeface="Georgia"/>
+                        </a:rPr>
+                        <a:t>+0.074 (small)</a:t>
+                      </a:r>
+                    </a:p>
+                  </a:txBody>
+                  <a:tcPr anchor="ctr" marL="54864" marR="54864" marT="18288" marB="18288">
+                    <a:solidFill>
+                      <a:srgbClr val="EFE9D9"/>
+                    </a:solidFill>
+                  </a:tcPr>
+                </a:tc>
+                <a:tc>
+                  <a:txBody>
+                    <a:bodyPr wrap="square"/>
+                    <a:lstStyle/>
+                    <a:p>
+                      <a:pPr algn="ctr"/>
+                      <a:r>
+                        <a:rPr sz="950" b="0">
+                          <a:solidFill>
+                            <a:srgbClr val="0C2340"/>
+                          </a:solidFill>
+                          <a:latin typeface="Georgia"/>
+                        </a:rPr>
+                        <a:t>middle</a:t>
+                      </a:r>
+                    </a:p>
+                  </a:txBody>
+                  <a:tcPr anchor="ctr" marL="54864" marR="54864" marT="18288" marB="18288">
+                    <a:solidFill>
+                      <a:srgbClr val="EFE9D9"/>
+                    </a:solidFill>
+                  </a:tcPr>
+                </a:tc>
+              </a:tr>
+              <a:tr h="242316">
+                <a:tc>
+                  <a:txBody>
+                    <a:bodyPr wrap="square"/>
+                    <a:lstStyle/>
+                    <a:p>
+                      <a:pPr algn="l"/>
+                      <a:r>
+                        <a:rPr sz="950" b="0">
+                          <a:solidFill>
+                            <a:srgbClr val="0C2340"/>
+                          </a:solidFill>
+                          <a:latin typeface="Georgia"/>
+                        </a:rPr>
+                        <a:t>Qwen2.5-14B</a:t>
+                      </a:r>
+                    </a:p>
+                  </a:txBody>
+                  <a:tcPr anchor="ctr" marL="54864" marR="54864" marT="18288" marB="18288">
+                    <a:solidFill>
+                      <a:srgbClr val="FFFFFF"/>
+                    </a:solidFill>
+                  </a:tcPr>
+                </a:tc>
+                <a:tc>
+                  <a:txBody>
+                    <a:bodyPr wrap="square"/>
+                    <a:lstStyle/>
+                    <a:p>
+                      <a:pPr algn="ctr"/>
+                      <a:r>
+                        <a:rPr sz="950" b="0">
+                          <a:solidFill>
+                            <a:srgbClr val="0C2340"/>
+                          </a:solidFill>
+                          <a:latin typeface="Georgia"/>
+                        </a:rPr>
+                        <a:t>0.820</a:t>
+                      </a:r>
+                    </a:p>
+                  </a:txBody>
+                  <a:tcPr anchor="ctr" marL="54864" marR="54864" marT="18288" marB="18288">
+                    <a:solidFill>
+                      <a:srgbClr val="FFFFFF"/>
+                    </a:solidFill>
+                  </a:tcPr>
+                </a:tc>
+                <a:tc>
+                  <a:txBody>
+                    <a:bodyPr wrap="square"/>
+                    <a:lstStyle/>
+                    <a:p>
+                      <a:pPr algn="ctr"/>
+                      <a:r>
+                        <a:rPr sz="950" b="0">
+                          <a:solidFill>
+                            <a:srgbClr val="0C2340"/>
+                          </a:solidFill>
+                          <a:latin typeface="Georgia"/>
+                        </a:rPr>
+                        <a:t>0.697</a:t>
+                      </a:r>
+                    </a:p>
+                  </a:txBody>
+                  <a:tcPr anchor="ctr" marL="54864" marR="54864" marT="18288" marB="18288">
+                    <a:solidFill>
+                      <a:srgbClr val="FFFFFF"/>
+                    </a:solidFill>
+                  </a:tcPr>
+                </a:tc>
+                <a:tc>
+                  <a:txBody>
+                    <a:bodyPr wrap="square"/>
+                    <a:lstStyle/>
+                    <a:p>
+                      <a:pPr algn="ctr"/>
+                      <a:r>
+                        <a:rPr sz="950" b="1">
+                          <a:solidFill>
+                            <a:srgbClr val="9B1B1B"/>
+                          </a:solidFill>
+                          <a:latin typeface="Georgia"/>
+                        </a:rPr>
+                        <a:t>0.412</a:t>
+                      </a:r>
+                    </a:p>
+                  </a:txBody>
+                  <a:tcPr anchor="ctr" marL="54864" marR="54864" marT="18288" marB="18288">
+                    <a:solidFill>
+                      <a:srgbClr val="FFFFFF"/>
+                    </a:solidFill>
+                  </a:tcPr>
+                </a:tc>
+                <a:tc>
+                  <a:txBody>
+                    <a:bodyPr wrap="square"/>
+                    <a:lstStyle/>
+                    <a:p>
+                      <a:pPr algn="ctr"/>
+                      <a:r>
+                        <a:rPr sz="950" b="1">
+                          <a:solidFill>
+                            <a:srgbClr val="0A833C"/>
+                          </a:solidFill>
+                          <a:latin typeface="Georgia"/>
+                        </a:rPr>
+                        <a:t>0.782</a:t>
+                      </a:r>
+                    </a:p>
+                  </a:txBody>
+                  <a:tcPr anchor="ctr" marL="54864" marR="54864" marT="18288" marB="18288">
+                    <a:solidFill>
+                      <a:srgbClr val="FFFFFF"/>
+                    </a:solidFill>
+                  </a:tcPr>
+                </a:tc>
+                <a:tc>
+                  <a:txBody>
+                    <a:bodyPr wrap="square"/>
+                    <a:lstStyle/>
+                    <a:p>
+                      <a:pPr algn="ctr"/>
+                      <a:r>
+                        <a:rPr sz="950" b="1">
+                          <a:solidFill>
+                            <a:srgbClr val="0A833C"/>
+                          </a:solidFill>
+                          <a:latin typeface="Georgia"/>
+                        </a:rPr>
+                        <a:t>+0.370 (rescue)</a:t>
+                      </a:r>
+                    </a:p>
+                  </a:txBody>
+                  <a:tcPr anchor="ctr" marL="54864" marR="54864" marT="18288" marB="18288">
+                    <a:solidFill>
+                      <a:srgbClr val="FFFFFF"/>
+                    </a:solidFill>
+                  </a:tcPr>
+                </a:tc>
+                <a:tc>
+                  <a:txBody>
+                    <a:bodyPr wrap="square"/>
+                    <a:lstStyle/>
+                    <a:p>
+                      <a:pPr algn="ctr"/>
+                      <a:r>
+                        <a:rPr sz="950" b="1">
+                          <a:solidFill>
+                            <a:srgbClr val="9B1B1B"/>
+                          </a:solidFill>
+                          <a:latin typeface="Georgia"/>
+                        </a:rPr>
+                        <a:t>COLLAPSE</a:t>
+                      </a:r>
+                    </a:p>
+                  </a:txBody>
+                  <a:tcPr anchor="ctr" marL="54864" marR="54864" marT="18288" marB="18288">
+                    <a:solidFill>
+                      <a:srgbClr val="FFFFFF"/>
+                    </a:solidFill>
+                  </a:tcPr>
+                </a:tc>
+              </a:tr>
+              <a:tr h="242316">
+                <a:tc>
+                  <a:txBody>
+                    <a:bodyPr wrap="square"/>
+                    <a:lstStyle/>
+                    <a:p>
+                      <a:pPr algn="l"/>
+                      <a:r>
+                        <a:rPr sz="950" b="0">
+                          <a:solidFill>
+                            <a:srgbClr val="0C2340"/>
+                          </a:solidFill>
+                          <a:latin typeface="Georgia"/>
+                        </a:rPr>
+                        <a:t>Llama-3.1-8B</a:t>
+                      </a:r>
+                    </a:p>
+                  </a:txBody>
+                  <a:tcPr anchor="ctr" marL="54864" marR="54864" marT="18288" marB="18288">
+                    <a:solidFill>
+                      <a:srgbClr val="EFE9D9"/>
+                    </a:solidFill>
+                  </a:tcPr>
+                </a:tc>
+                <a:tc>
+                  <a:txBody>
+                    <a:bodyPr wrap="square"/>
+                    <a:lstStyle/>
+                    <a:p>
+                      <a:pPr algn="ctr"/>
+                      <a:r>
+                        <a:rPr sz="950" b="0">
+                          <a:solidFill>
+                            <a:srgbClr val="0C2340"/>
+                          </a:solidFill>
+                          <a:latin typeface="Georgia"/>
+                        </a:rPr>
+                        <a:t>0.768</a:t>
+                      </a:r>
+                    </a:p>
+                  </a:txBody>
+                  <a:tcPr anchor="ctr" marL="54864" marR="54864" marT="18288" marB="18288">
+                    <a:solidFill>
+                      <a:srgbClr val="EFE9D9"/>
+                    </a:solidFill>
+                  </a:tcPr>
+                </a:tc>
+                <a:tc>
+                  <a:txBody>
+                    <a:bodyPr wrap="square"/>
+                    <a:lstStyle/>
+                    <a:p>
+                      <a:pPr algn="ctr"/>
+                      <a:r>
+                        <a:rPr sz="950" b="0">
+                          <a:solidFill>
+                            <a:srgbClr val="0C2340"/>
+                          </a:solidFill>
+                          <a:latin typeface="Georgia"/>
+                        </a:rPr>
+                        <a:t>0.565</a:t>
+                      </a:r>
+                    </a:p>
+                  </a:txBody>
+                  <a:tcPr anchor="ctr" marL="54864" marR="54864" marT="18288" marB="18288">
+                    <a:solidFill>
+                      <a:srgbClr val="EFE9D9"/>
+                    </a:solidFill>
+                  </a:tcPr>
+                </a:tc>
+                <a:tc>
+                  <a:txBody>
+                    <a:bodyPr wrap="square"/>
+                    <a:lstStyle/>
+                    <a:p>
+                      <a:pPr algn="ctr"/>
+                      <a:r>
+                        <a:rPr sz="950" b="1">
+                          <a:solidFill>
+                            <a:srgbClr val="9B1B1B"/>
+                          </a:solidFill>
+                          <a:latin typeface="Georgia"/>
+                        </a:rPr>
+                        <a:t>0.150</a:t>
+                      </a:r>
+                    </a:p>
+                  </a:txBody>
+                  <a:tcPr anchor="ctr" marL="54864" marR="54864" marT="18288" marB="18288">
+                    <a:solidFill>
+                      <a:srgbClr val="EFE9D9"/>
+                    </a:solidFill>
+                  </a:tcPr>
+                </a:tc>
+                <a:tc>
+                  <a:txBody>
+                    <a:bodyPr wrap="square"/>
+                    <a:lstStyle/>
+                    <a:p>
+                      <a:pPr algn="ctr"/>
+                      <a:r>
+                        <a:rPr sz="950" b="1">
+                          <a:solidFill>
+                            <a:srgbClr val="0A833C"/>
+                          </a:solidFill>
+                          <a:latin typeface="Georgia"/>
+                        </a:rPr>
+                        <a:t>0.643</a:t>
+                      </a:r>
+                    </a:p>
+                  </a:txBody>
+                  <a:tcPr anchor="ctr" marL="54864" marR="54864" marT="18288" marB="18288">
+                    <a:solidFill>
+                      <a:srgbClr val="EFE9D9"/>
+                    </a:solidFill>
+                  </a:tcPr>
+                </a:tc>
+                <a:tc>
+                  <a:txBody>
+                    <a:bodyPr wrap="square"/>
+                    <a:lstStyle/>
+                    <a:p>
+                      <a:pPr algn="ctr"/>
+                      <a:r>
+                        <a:rPr sz="950" b="1">
+                          <a:solidFill>
+                            <a:srgbClr val="0A833C"/>
+                          </a:solidFill>
+                          <a:latin typeface="Georgia"/>
+                        </a:rPr>
+                        <a:t>+0.493 (rescue)</a:t>
+                      </a:r>
+                    </a:p>
+                  </a:txBody>
+                  <a:tcPr anchor="ctr" marL="54864" marR="54864" marT="18288" marB="18288">
+                    <a:solidFill>
+                      <a:srgbClr val="EFE9D9"/>
+                    </a:solidFill>
+                  </a:tcPr>
+                </a:tc>
+                <a:tc>
+                  <a:txBody>
+                    <a:bodyPr wrap="square"/>
+                    <a:lstStyle/>
+                    <a:p>
+                      <a:pPr algn="ctr"/>
+                      <a:r>
+                        <a:rPr sz="950" b="1">
+                          <a:solidFill>
+                            <a:srgbClr val="9B1B1B"/>
+                          </a:solidFill>
+                          <a:latin typeface="Georgia"/>
+                        </a:rPr>
+                        <a:t>COLLAPSE</a:t>
+                      </a:r>
+                    </a:p>
+                  </a:txBody>
+                  <a:tcPr anchor="ctr" marL="54864" marR="54864" marT="18288" marB="18288">
+                    <a:solidFill>
+                      <a:srgbClr val="EFE9D9"/>
+                    </a:solidFill>
+                  </a:tcPr>
+                </a:tc>
+              </a:tr>
+            </a:tbl>
+          </a:graphicData>
+        </a:graphic>
+      </p:graphicFrame>
+      <p:sp>
+        <p:nvSpPr>
+          <p:cNvPr id="7" name="TextBox 6"/>
           <p:cNvSpPr txBox="1"/>
           <p:nvPr/>
         </p:nvSpPr>
         <p:spPr>
           <a:xfrm>
-            <a:off x="411480" y="1417320"/>
-            <a:ext cx="8321040" cy="3291840"/>
+            <a:off x="411480" y="4389120"/>
+            <a:ext cx="8321040" cy="365760"/>
           </a:xfrm>
           <a:prstGeom prst="rect">
             <a:avLst/>
@@ -19635,173 +21865,15 @@
           </a:bodyPr>
           <a:lstStyle/>
           <a:p>
-            <a:pPr algn="l">
-              <a:spcAft>
-                <a:spcPts val="900"/>
-              </a:spcAft>
-            </a:pPr>
+            <a:pPr algn="l"/>
             <a:r>
-              <a:rPr sz="1200" b="1" i="0">
-                <a:solidFill>
-                  <a:srgbClr val="AE9141"/>
+              <a:rPr sz="1000" b="0" i="1">
+                <a:solidFill>
+                  <a:srgbClr val="5A5A5A"/>
                 </a:solidFill>
                 <a:latin typeface="Georgia"/>
               </a:rPr>
-              <a:t>—  </a:t>
-            </a:r>
-            <a:r>
-              <a:rPr sz="1200" b="1" i="0">
-                <a:solidFill>
-                  <a:srgbClr val="0C2340"/>
-                </a:solidFill>
-                <a:latin typeface="Georgia"/>
-              </a:rPr>
-              <a:t>0 · The WHEN rule. </a:t>
-            </a:r>
-            <a:r>
-              <a:rPr sz="1200" b="0" i="0">
-                <a:solidFill>
-                  <a:srgbClr val="0C2340"/>
-                </a:solidFill>
-                <a:latin typeface="Georgia"/>
-              </a:rPr>
-              <a:t>Protection helps only inside a window — and the practical diagnostic is one comparison: if GPTQ's error correction is doing net harm (vs. naive rounding), protect; otherwise don't bother.</a:t>
-            </a:r>
-          </a:p>
-          <a:p>
-            <a:pPr algn="l">
-              <a:spcAft>
-                <a:spcPts val="900"/>
-              </a:spcAft>
-            </a:pPr>
-            <a:r>
-              <a:rPr sz="1200" b="1" i="0">
-                <a:solidFill>
-                  <a:srgbClr val="AE9141"/>
-                </a:solidFill>
-                <a:latin typeface="Georgia"/>
-              </a:rPr>
-              <a:t>—  </a:t>
-            </a:r>
-            <a:r>
-              <a:rPr sz="1200" b="1" i="0">
-                <a:solidFill>
-                  <a:srgbClr val="0C2340"/>
-                </a:solidFill>
-                <a:latin typeface="Georgia"/>
-              </a:rPr>
-              <a:t>1 · Compression damage comes in two modes. </a:t>
-            </a:r>
-            <a:r>
-              <a:rPr sz="1200" b="0" i="0">
-                <a:solidFill>
-                  <a:srgbClr val="0C2340"/>
-                </a:solidFill>
-                <a:latin typeface="Georgia"/>
-              </a:rPr>
-              <a:t>Usually mild; occasionally a collapse — and no statistic of the original model predicts which (we falsified every published candidate, on 6 models).</a:t>
-            </a:r>
-          </a:p>
-          <a:p>
-            <a:pPr algn="l">
-              <a:spcAft>
-                <a:spcPts val="900"/>
-              </a:spcAft>
-            </a:pPr>
-            <a:r>
-              <a:rPr sz="1200" b="1" i="0">
-                <a:solidFill>
-                  <a:srgbClr val="AE9141"/>
-                </a:solidFill>
-                <a:latin typeface="Georgia"/>
-              </a:rPr>
-              <a:t>—  </a:t>
-            </a:r>
-            <a:r>
-              <a:rPr sz="1200" b="1" i="0">
-                <a:solidFill>
-                  <a:srgbClr val="0C2340"/>
-                </a:solidFill>
-                <a:latin typeface="Georgia"/>
-              </a:rPr>
-              <a:t>2 · Protection is a collapse-repair tool, not a general upgrade. </a:t>
-            </a:r>
-            <a:r>
-              <a:rPr sz="1200" b="0" i="0">
-                <a:solidFill>
-                  <a:srgbClr val="0C2340"/>
-                </a:solidFill>
-                <a:latin typeface="Georgia"/>
-              </a:rPr>
-              <a:t>In a collapse it beats every alternative (including the newest rotation-based methods); otherwise it buys nothing.</a:t>
-            </a:r>
-          </a:p>
-          <a:p>
-            <a:pPr algn="l">
-              <a:spcAft>
-                <a:spcPts val="900"/>
-              </a:spcAft>
-            </a:pPr>
-            <a:r>
-              <a:rPr sz="1200" b="1" i="0">
-                <a:solidFill>
-                  <a:srgbClr val="AE9141"/>
-                </a:solidFill>
-                <a:latin typeface="Georgia"/>
-              </a:rPr>
-              <a:t>—  </a:t>
-            </a:r>
-            <a:r>
-              <a:rPr sz="1200" b="1" i="0">
-                <a:solidFill>
-                  <a:srgbClr val="0C2340"/>
-                </a:solidFill>
-                <a:latin typeface="Georgia"/>
-              </a:rPr>
-              <a:t>3 · The cause is the compressor, not the low precision. </a:t>
-            </a:r>
-            <a:r>
-              <a:rPr sz="1200" b="0" i="0">
-                <a:solidFill>
-                  <a:srgbClr val="0C2340"/>
-                </a:solidFill>
-                <a:latin typeface="Georgia"/>
-              </a:rPr>
-              <a:t>GPTQ's error correction × ~10⁵ hyper-sensitive weights. Naive rounding never collapses.</a:t>
-            </a:r>
-          </a:p>
-          <a:p>
-            <a:pPr algn="l">
-              <a:spcAft>
-                <a:spcPts val="900"/>
-              </a:spcAft>
-            </a:pPr>
-            <a:r>
-              <a:rPr sz="1200" b="1" i="0">
-                <a:solidFill>
-                  <a:srgbClr val="AE9141"/>
-                </a:solidFill>
-                <a:latin typeface="Georgia"/>
-              </a:rPr>
-              <a:t>—  </a:t>
-            </a:r>
-            <a:r>
-              <a:rPr sz="1200" b="1" i="0">
-                <a:solidFill>
-                  <a:srgbClr val="0C2340"/>
-                </a:solidFill>
-                <a:latin typeface="Georgia"/>
-              </a:rPr>
-              <a:t>4 · Evaluation warning for the field. </a:t>
-            </a:r>
-            <a:r>
-              <a:rPr sz="1200" b="0" i="0">
-                <a:solidFill>
-                  <a:srgbClr val="0C2340"/>
-                </a:solidFill>
-                <a:latin typeface="Georgia"/>
-              </a:rPr>
-              <a:t>A compressed model can pass perplexity + MMLU while losing 80% of its generative ability. Always test with generation.</a:t>
+              <a:t>Protection = top-0.5% by TaCQ score, kept uncompressed. 8/4/2-bit ladders: “window” slide; math &amp; multi-turn: previous slide.</a:t>
             </a:r>
           </a:p>
         </p:txBody>
@@ -19852,7 +21924,7 @@
                 </a:solidFill>
                 <a:latin typeface="Georgia"/>
               </a:rPr>
-              <a:t>The Two Closest Papers — and Where This Goes</a:t>
+              <a:t>What This Paper Says</a:t>
             </a:r>
           </a:p>
         </p:txBody>
@@ -19879,7 +21951,7 @@
                 </a:solidFill>
                 <a:latin typeface="Georgia"/>
               </a:rPr>
-              <a:t>RELATED WORK &amp; PLAN</a:t>
+              <a:t>SUMMARY</a:t>
             </a:r>
           </a:p>
         </p:txBody>
@@ -19893,7 +21965,7 @@
         <p:spPr>
           <a:xfrm>
             <a:off x="411480" y="1417320"/>
-            <a:ext cx="4892040" cy="3291840"/>
+            <a:ext cx="8321040" cy="3291840"/>
           </a:xfrm>
           <a:prstGeom prst="rect">
             <a:avLst/>
@@ -19908,144 +21980,171 @@
           <a:p>
             <a:pPr algn="l">
               <a:spcAft>
-                <a:spcPts val="400"/>
+                <a:spcPts val="900"/>
               </a:spcAft>
             </a:pPr>
             <a:r>
-              <a:rPr sz="1300" b="1" i="0">
+              <a:rPr sz="1200" b="1" i="0">
                 <a:solidFill>
                   <a:srgbClr val="AE9141"/>
                 </a:solidFill>
                 <a:latin typeface="Georgia"/>
               </a:rPr>
-              <a:t>TaCQ (UNC Chapel Hill, 2025)</a:t>
+              <a:t>—  </a:t>
             </a:r>
+            <a:r>
+              <a:rPr sz="1200" b="1" i="0">
+                <a:solidFill>
+                  <a:srgbClr val="0C2340"/>
+                </a:solidFill>
+                <a:latin typeface="Georgia"/>
+              </a:rPr>
+              <a:t>0 · The WHEN rule. </a:t>
+            </a:r>
+            <a:r>
+              <a:rPr sz="1200" b="0" i="0">
+                <a:solidFill>
+                  <a:srgbClr val="0C2340"/>
+                </a:solidFill>
+                <a:latin typeface="Georgia"/>
+              </a:rPr>
+              <a:t>Protection helps only inside a window — and the practical diagnostic is one comparison: if GPTQ's error correction is doing net harm (vs. naive rounding), protect; otherwise don't bother.</a:t>
+            </a:r>
           </a:p>
           <a:p>
             <a:pPr algn="l">
               <a:spcAft>
-                <a:spcPts val="1000"/>
+                <a:spcPts val="900"/>
               </a:spcAft>
             </a:pPr>
             <a:r>
-              <a:rPr sz="1250" b="0" i="0">
+              <a:rPr sz="1200" b="1" i="0">
+                <a:solidFill>
+                  <a:srgbClr val="AE9141"/>
+                </a:solidFill>
+                <a:latin typeface="Georgia"/>
+              </a:rPr>
+              <a:t>—  </a:t>
+            </a:r>
+            <a:r>
+              <a:rPr sz="1200" b="1" i="0">
                 <a:solidFill>
                   <a:srgbClr val="0C2340"/>
                 </a:solidFill>
                 <a:latin typeface="Georgia"/>
               </a:rPr>
-              <a:t>Invented the importance score we use, and showed protection improves compressed models. We answer the question they never asked: WHEN does it help (only in collapses) and WHY (the error-correction mechanism).</a:t>
+              <a:t>1 · Compression damage comes in two modes. </a:t>
             </a:r>
+            <a:r>
+              <a:rPr sz="1200" b="0" i="0">
+                <a:solidFill>
+                  <a:srgbClr val="0C2340"/>
+                </a:solidFill>
+                <a:latin typeface="Georgia"/>
+              </a:rPr>
+              <a:t>Usually mild; occasionally a collapse — and no statistic of the original model predicts which (we falsified every published candidate, on 6 models).</a:t>
+            </a:r>
           </a:p>
           <a:p>
             <a:pPr algn="l">
               <a:spcAft>
-                <a:spcPts val="400"/>
+                <a:spcPts val="900"/>
               </a:spcAft>
             </a:pPr>
             <a:r>
-              <a:rPr sz="1300" b="1" i="0">
+              <a:rPr sz="1200" b="1" i="0">
                 <a:solidFill>
                   <a:srgbClr val="AE9141"/>
                 </a:solidFill>
                 <a:latin typeface="Georgia"/>
               </a:rPr>
-              <a:t>Super Weights (Mengxia Yu, ND + Apple, 2024)</a:t>
+              <a:t>—  </a:t>
             </a:r>
-          </a:p>
-          <a:p>
-            <a:pPr algn="l"/>
             <a:r>
-              <a:rPr sz="1250" b="0" i="0">
+              <a:rPr sz="1200" b="1" i="0">
                 <a:solidFill>
                   <a:srgbClr val="0C2340"/>
                 </a:solidFill>
                 <a:latin typeface="Georgia"/>
               </a:rPr>
-              <a:t>Found that every LLM has 3–6 individual “super weights” — delete one and the model dies. We tested them: protecting ONLY those few does not prevent the collapse (0.16). The collapse involves a different, ~100,000-weight set. Complementary, not competing.</a:t>
+              <a:t>2 · Protection is a collapse-repair tool, not a general upgrade. </a:t>
             </a:r>
-          </a:p>
-        </p:txBody>
-      </p:sp>
-      <p:sp>
-        <p:nvSpPr>
-          <p:cNvPr id="7" name="TextBox 6"/>
-          <p:cNvSpPr txBox="1"/>
-          <p:nvPr/>
-        </p:nvSpPr>
-        <p:spPr>
-          <a:xfrm>
-            <a:off x="5715000" y="1417320"/>
-            <a:ext cx="3063240" cy="3291840"/>
-          </a:xfrm>
-          <a:prstGeom prst="rect">
-            <a:avLst/>
-          </a:prstGeom>
-          <a:noFill/>
-        </p:spPr>
-        <p:txBody>
-          <a:bodyPr wrap="square" lIns="0" rIns="0" tIns="0" bIns="0">
-            <a:spAutoFit/>
-          </a:bodyPr>
-          <a:lstStyle/>
+            <a:r>
+              <a:rPr sz="1200" b="0" i="0">
+                <a:solidFill>
+                  <a:srgbClr val="0C2340"/>
+                </a:solidFill>
+                <a:latin typeface="Georgia"/>
+              </a:rPr>
+              <a:t>In a collapse it beats every alternative (including the newest rotation-based methods); otherwise it buys nothing.</a:t>
+            </a:r>
+          </a:p>
           <a:p>
             <a:pPr algn="l">
               <a:spcAft>
-                <a:spcPts val="400"/>
+                <a:spcPts val="900"/>
               </a:spcAft>
             </a:pPr>
             <a:r>
-              <a:rPr sz="1100" b="1" i="0">
+              <a:rPr sz="1200" b="1" i="0">
                 <a:solidFill>
                   <a:srgbClr val="AE9141"/>
                 </a:solidFill>
                 <a:latin typeface="Georgia"/>
               </a:rPr>
-              <a:t>TARGET</a:t>
+              <a:t>—  </a:t>
             </a:r>
+            <a:r>
+              <a:rPr sz="1200" b="1" i="0">
+                <a:solidFill>
+                  <a:srgbClr val="0C2340"/>
+                </a:solidFill>
+                <a:latin typeface="Georgia"/>
+              </a:rPr>
+              <a:t>3 · The cause is the compressor, not the low precision. </a:t>
+            </a:r>
+            <a:r>
+              <a:rPr sz="1200" b="0" i="0">
+                <a:solidFill>
+                  <a:srgbClr val="0C2340"/>
+                </a:solidFill>
+                <a:latin typeface="Georgia"/>
+              </a:rPr>
+              <a:t>GPTQ's error correction × ~10⁵ hyper-sensitive weights. Naive rounding never collapses.</a:t>
+            </a:r>
           </a:p>
           <a:p>
             <a:pPr algn="l">
               <a:spcAft>
-                <a:spcPts val="1000"/>
+                <a:spcPts val="900"/>
               </a:spcAft>
             </a:pPr>
             <a:r>
-              <a:rPr sz="1250" b="0" i="0">
+              <a:rPr sz="1200" b="1" i="0">
+                <a:solidFill>
+                  <a:srgbClr val="AE9141"/>
+                </a:solidFill>
+                <a:latin typeface="Georgia"/>
+              </a:rPr>
+              <a:t>—  </a:t>
+            </a:r>
+            <a:r>
+              <a:rPr sz="1200" b="1" i="0">
                 <a:solidFill>
                   <a:srgbClr val="0C2340"/>
                 </a:solidFill>
                 <a:latin typeface="Georgia"/>
               </a:rPr>
-              <a:t>ICLR 2027 — abstract Sept 18, paper Sept 25. Backup: ACL 2027 (Feb), reusing the ICLR reviews.</a:t>
+              <a:t>4 · Evaluation warning for the field. </a:t>
             </a:r>
-          </a:p>
-          <a:p>
-            <a:pPr algn="l">
-              <a:spcAft>
-                <a:spcPts val="400"/>
-              </a:spcAft>
-            </a:pPr>
             <a:r>
-              <a:rPr sz="1100" b="1" i="0">
-                <a:solidFill>
-                  <a:srgbClr val="AE9141"/>
+              <a:rPr sz="1200" b="0" i="0">
+                <a:solidFill>
+                  <a:srgbClr val="0C2340"/>
                 </a:solidFill>
                 <a:latin typeface="Georgia"/>
               </a:rPr>
-              <a:t>READINESS</a:t>
-            </a:r>
-          </a:p>
-          <a:p>
-            <a:pPr algn="l"/>
-            <a:r>
-              <a:rPr sz="1250" b="0" i="0">
-                <a:solidFill>
-                  <a:srgbClr val="0C2340"/>
-                </a:solidFill>
-                <a:latin typeface="Georgia"/>
-              </a:rPr>
-              <a:t>Every claim has controls, replicates, and confidence intervals; backup experiments (70B model, another compressor) are staged for the rebuttal phase.</a:t>
+              <a:t>A compressed model can pass perplexity + MMLU while losing 80% of its generative ability. Always test with generation.</a:t>
             </a:r>
           </a:p>
         </p:txBody>
@@ -20070,7 +22169,40 @@
       <p:grpSpPr/>
       <p:sp>
         <p:nvSpPr>
-          <p:cNvPr id="2" name="Subtitle 1"/>
+          <p:cNvPr id="4" name="Title 3"/>
+          <p:cNvSpPr>
+            <a:spLocks noGrp="1"/>
+          </p:cNvSpPr>
+          <p:nvPr>
+            <p:ph type="title"/>
+          </p:nvPr>
+        </p:nvSpPr>
+        <p:spPr>
+          <a:xfrm>
+            <a:off x="411480" y="658368"/>
+            <a:ext cx="8321040" cy="658368"/>
+          </a:xfrm>
+        </p:spPr>
+        <p:txBody>
+          <a:bodyPr wrap="square"/>
+          <a:lstStyle/>
+          <a:p>
+            <a:pPr algn="l"/>
+            <a:r>
+              <a:rPr sz="2600" b="1">
+                <a:solidFill>
+                  <a:srgbClr val="0C2340"/>
+                </a:solidFill>
+                <a:latin typeface="Georgia"/>
+              </a:rPr>
+              <a:t>The Two Closest Papers — and Where This Goes</a:t>
+            </a:r>
+          </a:p>
+        </p:txBody>
+      </p:sp>
+      <p:sp>
+        <p:nvSpPr>
+          <p:cNvPr id="5" name="Subtitle 4"/>
           <p:cNvSpPr>
             <a:spLocks noGrp="1"/>
           </p:cNvSpPr>
@@ -20090,54 +22222,21 @@
                 </a:solidFill>
                 <a:latin typeface="Georgia"/>
               </a:rPr>
-              <a:t>DISCUSSION</a:t>
+              <a:t>RELATED WORK &amp; PLAN</a:t>
             </a:r>
           </a:p>
         </p:txBody>
       </p:sp>
       <p:sp>
         <p:nvSpPr>
-          <p:cNvPr id="3" name="Title 2"/>
-          <p:cNvSpPr>
-            <a:spLocks noGrp="1"/>
-          </p:cNvSpPr>
-          <p:nvPr>
-            <p:ph type="title"/>
-          </p:nvPr>
+          <p:cNvPr id="6" name="TextBox 5"/>
+          <p:cNvSpPr txBox="1"/>
+          <p:nvPr/>
         </p:nvSpPr>
         <p:spPr>
           <a:xfrm>
-            <a:off x="914400" y="1234440"/>
-            <a:ext cx="7315200" cy="731520"/>
-          </a:xfrm>
-        </p:spPr>
-        <p:txBody>
-          <a:bodyPr wrap="square"/>
-          <a:lstStyle/>
-          <a:p>
-            <a:pPr algn="l"/>
-            <a:r>
-              <a:rPr sz="2800" b="1">
-                <a:solidFill>
-                  <a:srgbClr val="FFFFFF"/>
-                </a:solidFill>
-                <a:latin typeface="Georgia"/>
-              </a:rPr>
-              <a:t>What I'd Like Your Input On</a:t>
-            </a:r>
-          </a:p>
-        </p:txBody>
-      </p:sp>
-      <p:sp>
-        <p:nvSpPr>
-          <p:cNvPr id="4" name="TextBox 3"/>
-          <p:cNvSpPr txBox="1"/>
-          <p:nvPr/>
-        </p:nvSpPr>
-        <p:spPr>
-          <a:xfrm>
-            <a:off x="914400" y="2194560"/>
-            <a:ext cx="7315200" cy="2286000"/>
+            <a:off x="411480" y="1417320"/>
+            <a:ext cx="4892040" cy="3291840"/>
           </a:xfrm>
           <a:prstGeom prst="rect">
             <a:avLst/>
@@ -20152,101 +22251,144 @@
           <a:p>
             <a:pPr algn="l">
               <a:spcAft>
-                <a:spcPts val="1200"/>
+                <a:spcPts val="400"/>
               </a:spcAft>
             </a:pPr>
             <a:r>
-              <a:rPr sz="1400" b="1" i="0">
+              <a:rPr sz="1300" b="1" i="0">
                 <a:solidFill>
                   <a:srgbClr val="AE9141"/>
                 </a:solidFill>
                 <a:latin typeface="Georgia"/>
               </a:rPr>
-              <a:t>—  </a:t>
+              <a:t>TaCQ (UNC Chapel Hill, 2025)</a:t>
             </a:r>
-            <a:r>
-              <a:rPr sz="1400" b="0" i="0">
-                <a:solidFill>
-                  <a:srgbClr val="FFFFFF"/>
-                </a:solidFill>
-                <a:latin typeface="Georgia"/>
-              </a:rPr>
-              <a:t>Does the story read as one clean question with one clean answer?</a:t>
-            </a:r>
           </a:p>
           <a:p>
             <a:pPr algn="l">
               <a:spcAft>
-                <a:spcPts val="1200"/>
+                <a:spcPts val="1000"/>
               </a:spcAft>
             </a:pPr>
             <a:r>
-              <a:rPr sz="1400" b="1" i="0">
-                <a:solidFill>
-                  <a:srgbClr val="AE9141"/>
+              <a:rPr sz="1250" b="0" i="0">
+                <a:solidFill>
+                  <a:srgbClr val="0C2340"/>
                 </a:solidFill>
                 <a:latin typeface="Georgia"/>
               </a:rPr>
-              <a:t>—  </a:t>
+              <a:t>Invented the importance score we use, and showed protection improves compressed models. We answer the question they never asked: WHEN does it help (only in collapses) and WHY (the error-correction mechanism).</a:t>
             </a:r>
-            <a:r>
-              <a:rPr sz="1400" b="0" i="0">
-                <a:solidFill>
-                  <a:srgbClr val="FFFFFF"/>
-                </a:solidFill>
-                <a:latin typeface="Georgia"/>
-              </a:rPr>
-              <a:t>Venue: OK to commit to ICLR (Sept 25) with ACL as the fallback?</a:t>
-            </a:r>
           </a:p>
           <a:p>
             <a:pPr algn="l">
               <a:spcAft>
-                <a:spcPts val="1200"/>
+                <a:spcPts val="400"/>
               </a:spcAft>
             </a:pPr>
             <a:r>
-              <a:rPr sz="1400" b="1" i="0">
+              <a:rPr sz="1300" b="1" i="0">
                 <a:solidFill>
                   <a:srgbClr val="AE9141"/>
                 </a:solidFill>
                 <a:latin typeface="Georgia"/>
               </a:rPr>
-              <a:t>—  </a:t>
+              <a:t>Super Weights (Mengxia Yu, ND + Apple, 2024)</a:t>
             </a:r>
+          </a:p>
+          <a:p>
+            <a:pPr algn="l"/>
             <a:r>
-              <a:rPr sz="1400" b="0" i="0">
-                <a:solidFill>
-                  <a:srgbClr val="FFFFFF"/>
+              <a:rPr sz="1250" b="0" i="0">
+                <a:solidFill>
+                  <a:srgbClr val="0C2340"/>
                 </a:solidFill>
                 <a:latin typeface="Georgia"/>
               </a:rPr>
-              <a:t>How should we engage Mengxia's Super-Weights work — note or citation?</a:t>
+              <a:t>Found that every LLM has 3–6 individual “super weights” — delete one and the model dies. We tested them: protecting ONLY those few does not prevent the collapse (0.16). The collapse involves a different, ~100,000-weight set. Complementary, not competing.</a:t>
             </a:r>
           </a:p>
+        </p:txBody>
+      </p:sp>
+      <p:sp>
+        <p:nvSpPr>
+          <p:cNvPr id="7" name="TextBox 6"/>
+          <p:cNvSpPr txBox="1"/>
+          <p:nvPr/>
+        </p:nvSpPr>
+        <p:spPr>
+          <a:xfrm>
+            <a:off x="5715000" y="1417320"/>
+            <a:ext cx="3063240" cy="3291840"/>
+          </a:xfrm>
+          <a:prstGeom prst="rect">
+            <a:avLst/>
+          </a:prstGeom>
+          <a:noFill/>
+        </p:spPr>
+        <p:txBody>
+          <a:bodyPr wrap="square" lIns="0" rIns="0" tIns="0" bIns="0">
+            <a:spAutoFit/>
+          </a:bodyPr>
+          <a:lstStyle/>
           <a:p>
             <a:pPr algn="l">
               <a:spcAft>
-                <a:spcPts val="1200"/>
+                <a:spcPts val="400"/>
               </a:spcAft>
             </a:pPr>
             <a:r>
-              <a:rPr sz="1400" b="1" i="0">
+              <a:rPr sz="1100" b="1" i="0">
                 <a:solidFill>
                   <a:srgbClr val="AE9141"/>
                 </a:solidFill>
                 <a:latin typeface="Georgia"/>
               </a:rPr>
-              <a:t>—  </a:t>
+              <a:t>TARGET</a:t>
             </a:r>
+          </a:p>
+          <a:p>
+            <a:pPr algn="l">
+              <a:spcAft>
+                <a:spcPts val="1000"/>
+              </a:spcAft>
+            </a:pPr>
             <a:r>
-              <a:rPr sz="1400" b="0" i="0">
-                <a:solidFill>
-                  <a:srgbClr val="FFFFFF"/>
+              <a:rPr sz="1250" b="0" i="0">
+                <a:solidFill>
+                  <a:srgbClr val="0C2340"/>
                 </a:solidFill>
                 <a:latin typeface="Georgia"/>
               </a:rPr>
-              <a:t>Anything worth adding while the cluster is still available?</a:t>
+              <a:t>ICLR 2027 — abstract Sept 18, paper Sept 25. Backup: ACL 2027 (Feb), reusing the ICLR reviews.</a:t>
+            </a:r>
+          </a:p>
+          <a:p>
+            <a:pPr algn="l">
+              <a:spcAft>
+                <a:spcPts val="400"/>
+              </a:spcAft>
+            </a:pPr>
+            <a:r>
+              <a:rPr sz="1100" b="1" i="0">
+                <a:solidFill>
+                  <a:srgbClr val="AE9141"/>
+                </a:solidFill>
+                <a:latin typeface="Georgia"/>
+              </a:rPr>
+              <a:t>READINESS</a:t>
+            </a:r>
+          </a:p>
+          <a:p>
+            <a:pPr algn="l"/>
+            <a:r>
+              <a:rPr sz="1250" b="0" i="0">
+                <a:solidFill>
+                  <a:srgbClr val="0C2340"/>
+                </a:solidFill>
+                <a:latin typeface="Georgia"/>
+              </a:rPr>
+              <a:t>Every claim has controls, replicates, and confidence intervals; backup experiments (70B model, another compressor) are staged for the rebuttal phase.</a:t>
             </a:r>
           </a:p>
         </p:txBody>
@@ -20382,6 +22524,207 @@
         <p14:creationId xmlns:p14="http://schemas.microsoft.com/office/powerpoint/2010/main" val="540773422"/>
       </p:ext>
     </p:extLst>
+  </p:cSld>
+  <p:clrMapOvr>
+    <a:masterClrMapping/>
+  </p:clrMapOvr>
+</p:sld>
+</file>
+
+<file path=ppt/slides/slide30.xml><?xml version="1.0" encoding="utf-8"?>
+<p:sld xmlns:a="http://schemas.openxmlformats.org/drawingml/2006/main" xmlns:p="http://schemas.openxmlformats.org/presentationml/2006/main" xmlns:r="http://schemas.openxmlformats.org/officeDocument/2006/relationships">
+  <p:cSld>
+    <p:spTree>
+      <p:nvGrpSpPr>
+        <p:cNvPr id="1" name=""/>
+        <p:cNvGrpSpPr/>
+        <p:nvPr/>
+      </p:nvGrpSpPr>
+      <p:grpSpPr/>
+      <p:sp>
+        <p:nvSpPr>
+          <p:cNvPr id="2" name="Subtitle 1"/>
+          <p:cNvSpPr>
+            <a:spLocks noGrp="1"/>
+          </p:cNvSpPr>
+          <p:nvPr>
+            <p:ph type="subTitle" idx="3"/>
+          </p:nvPr>
+        </p:nvSpPr>
+        <p:spPr/>
+        <p:txBody>
+          <a:bodyPr/>
+          <a:lstStyle/>
+          <a:p>
+            <a:r>
+              <a:rPr sz="1100" b="1">
+                <a:solidFill>
+                  <a:srgbClr val="FFFFFF"/>
+                </a:solidFill>
+                <a:latin typeface="Georgia"/>
+              </a:rPr>
+              <a:t>DISCUSSION</a:t>
+            </a:r>
+          </a:p>
+        </p:txBody>
+      </p:sp>
+      <p:sp>
+        <p:nvSpPr>
+          <p:cNvPr id="3" name="Title 2"/>
+          <p:cNvSpPr>
+            <a:spLocks noGrp="1"/>
+          </p:cNvSpPr>
+          <p:nvPr>
+            <p:ph type="title"/>
+          </p:nvPr>
+        </p:nvSpPr>
+        <p:spPr>
+          <a:xfrm>
+            <a:off x="914400" y="1234440"/>
+            <a:ext cx="7315200" cy="731520"/>
+          </a:xfrm>
+        </p:spPr>
+        <p:txBody>
+          <a:bodyPr wrap="square"/>
+          <a:lstStyle/>
+          <a:p>
+            <a:pPr algn="l"/>
+            <a:r>
+              <a:rPr sz="2800" b="1">
+                <a:solidFill>
+                  <a:srgbClr val="FFFFFF"/>
+                </a:solidFill>
+                <a:latin typeface="Georgia"/>
+              </a:rPr>
+              <a:t>What I'd Like Your Input On</a:t>
+            </a:r>
+          </a:p>
+        </p:txBody>
+      </p:sp>
+      <p:sp>
+        <p:nvSpPr>
+          <p:cNvPr id="4" name="TextBox 3"/>
+          <p:cNvSpPr txBox="1"/>
+          <p:nvPr/>
+        </p:nvSpPr>
+        <p:spPr>
+          <a:xfrm>
+            <a:off x="914400" y="2194560"/>
+            <a:ext cx="7315200" cy="2286000"/>
+          </a:xfrm>
+          <a:prstGeom prst="rect">
+            <a:avLst/>
+          </a:prstGeom>
+          <a:noFill/>
+        </p:spPr>
+        <p:txBody>
+          <a:bodyPr wrap="square" lIns="0" rIns="0" tIns="0" bIns="0">
+            <a:spAutoFit/>
+          </a:bodyPr>
+          <a:lstStyle/>
+          <a:p>
+            <a:pPr algn="l">
+              <a:spcAft>
+                <a:spcPts val="1200"/>
+              </a:spcAft>
+            </a:pPr>
+            <a:r>
+              <a:rPr sz="1400" b="1" i="0">
+                <a:solidFill>
+                  <a:srgbClr val="AE9141"/>
+                </a:solidFill>
+                <a:latin typeface="Georgia"/>
+              </a:rPr>
+              <a:t>—  </a:t>
+            </a:r>
+            <a:r>
+              <a:rPr sz="1400" b="0" i="0">
+                <a:solidFill>
+                  <a:srgbClr val="FFFFFF"/>
+                </a:solidFill>
+                <a:latin typeface="Georgia"/>
+              </a:rPr>
+              <a:t>Does the story read as one clean question with one clean answer?</a:t>
+            </a:r>
+          </a:p>
+          <a:p>
+            <a:pPr algn="l">
+              <a:spcAft>
+                <a:spcPts val="1200"/>
+              </a:spcAft>
+            </a:pPr>
+            <a:r>
+              <a:rPr sz="1400" b="1" i="0">
+                <a:solidFill>
+                  <a:srgbClr val="AE9141"/>
+                </a:solidFill>
+                <a:latin typeface="Georgia"/>
+              </a:rPr>
+              <a:t>—  </a:t>
+            </a:r>
+            <a:r>
+              <a:rPr sz="1400" b="0" i="0">
+                <a:solidFill>
+                  <a:srgbClr val="FFFFFF"/>
+                </a:solidFill>
+                <a:latin typeface="Georgia"/>
+              </a:rPr>
+              <a:t>Venue: OK to commit to ICLR (Sept 25) with ACL as the fallback?</a:t>
+            </a:r>
+          </a:p>
+          <a:p>
+            <a:pPr algn="l">
+              <a:spcAft>
+                <a:spcPts val="1200"/>
+              </a:spcAft>
+            </a:pPr>
+            <a:r>
+              <a:rPr sz="1400" b="1" i="0">
+                <a:solidFill>
+                  <a:srgbClr val="AE9141"/>
+                </a:solidFill>
+                <a:latin typeface="Georgia"/>
+              </a:rPr>
+              <a:t>—  </a:t>
+            </a:r>
+            <a:r>
+              <a:rPr sz="1400" b="0" i="0">
+                <a:solidFill>
+                  <a:srgbClr val="FFFFFF"/>
+                </a:solidFill>
+                <a:latin typeface="Georgia"/>
+              </a:rPr>
+              <a:t>How should we engage Mengxia's Super-Weights work — note or citation?</a:t>
+            </a:r>
+          </a:p>
+          <a:p>
+            <a:pPr algn="l">
+              <a:spcAft>
+                <a:spcPts val="1200"/>
+              </a:spcAft>
+            </a:pPr>
+            <a:r>
+              <a:rPr sz="1400" b="1" i="0">
+                <a:solidFill>
+                  <a:srgbClr val="AE9141"/>
+                </a:solidFill>
+                <a:latin typeface="Georgia"/>
+              </a:rPr>
+              <a:t>—  </a:t>
+            </a:r>
+            <a:r>
+              <a:rPr sz="1400" b="0" i="0">
+                <a:solidFill>
+                  <a:srgbClr val="FFFFFF"/>
+                </a:solidFill>
+                <a:latin typeface="Georgia"/>
+              </a:rPr>
+              <a:t>Anything worth adding while the cluster is still available?</a:t>
+            </a:r>
+          </a:p>
+        </p:txBody>
+      </p:sp>
+    </p:spTree>
   </p:cSld>
   <p:clrMapOvr>
     <a:masterClrMapping/>

</xml_diff>

<commit_message>
Deck v6: TaCQ and Super Weights detail backup slides
</commit_message>
<xml_diff>
--- a/paper/IFH_advisor_update_2026-09-03.pptx
+++ b/paper/IFH_advisor_update_2026-09-03.pptx
@@ -26,6 +26,8 @@
     <p:sldId id="285" r:id="rId33"/>
     <p:sldId id="286" r:id="rId34"/>
     <p:sldId id="287" r:id="rId35"/>
+    <p:sldId id="288" r:id="rId36"/>
+    <p:sldId id="289" r:id="rId37"/>
   </p:sldIdLst>
   <p:sldSz cx="9144000" cy="5148263"/>
   <p:notesSz cx="6858000" cy="9144000"/>
@@ -3169,6 +3171,146 @@
           <a:lstStyle/>
           <a:p>
             <a:r>
+              <a:t>TaCQ备查页。要点：①他们的主模型是上一代Llama-3-8B——在我们普查里只是中间档，不是崩溃的3.1代，所以他们没见过崩溃很正常；②他们没有任何“失效场景”的实验，连同预算随机保护这个最基本的对照都没做——这正是我们论文的空间；③唯一待和解的是2-bit：他们混合精度实存成功、我们同预算fake-quant终末，投稿前精读其协议。</a:t>
+            </a:r>
+          </a:p>
+        </p:txBody>
+      </p:sp>
+      <p:sp>
+        <p:nvSpPr>
+          <p:cNvPr id="4" name="Slide Number Placeholder 3"/>
+          <p:cNvSpPr>
+            <a:spLocks noGrp="1"/>
+          </p:cNvSpPr>
+          <p:nvPr>
+            <p:ph type="sldNum" idx="5" sz="quarter"/>
+          </p:nvPr>
+        </p:nvSpPr>
+        <p:spPr/>
+      </p:sp>
+    </p:spTree>
+  </p:cSld>
+  <p:clrMapOvr>
+    <a:masterClrMapping/>
+  </p:clrMapOvr>
+</p:notes>
+</file>
+
+<file path=ppt/notesSlides/notesSlide22.xml><?xml version="1.0" encoding="utf-8"?>
+<p:notes xmlns:a="http://schemas.openxmlformats.org/drawingml/2006/main" xmlns:p="http://schemas.openxmlformats.org/presentationml/2006/main" xmlns:r="http://schemas.openxmlformats.org/officeDocument/2006/relationships">
+  <p:cSld>
+    <p:spTree>
+      <p:nvGrpSpPr>
+        <p:cNvPr id="1" name=""/>
+        <p:cNvGrpSpPr/>
+        <p:nvPr/>
+      </p:nvGrpSpPr>
+      <p:grpSpPr>
+        <a:xfrm>
+          <a:off x="0" y="0"/>
+          <a:ext cx="0" cy="0"/>
+          <a:chOff x="0" y="0"/>
+          <a:chExt cx="0" cy="0"/>
+        </a:xfrm>
+      </p:grpSpPr>
+      <p:sp>
+        <p:nvSpPr>
+          <p:cNvPr id="2" name="Slide Image Placeholder 1"/>
+          <p:cNvSpPr>
+            <a:spLocks noGrp="1"/>
+          </p:cNvSpPr>
+          <p:nvPr>
+            <p:ph type="sldImg" idx="2"/>
+          </p:nvPr>
+        </p:nvSpPr>
+        <p:spPr/>
+      </p:sp>
+      <p:sp>
+        <p:nvSpPr>
+          <p:cNvPr id="3" name="Notes Placeholder 2"/>
+          <p:cNvSpPr>
+            <a:spLocks noGrp="1"/>
+          </p:cNvSpPr>
+          <p:nvPr>
+            <p:ph type="body" idx="3" sz="quarter"/>
+          </p:nvPr>
+        </p:nvSpPr>
+        <p:spPr/>
+        <p:txBody>
+          <a:bodyPr/>
+          <a:lstStyle/>
+          <a:p>
+            <a:r>
+              <a:t>Super Weights备查页。要点：①他们全部实验在RTN世界，GPTQ从未出现——而我们的数据显示RTN从不崩溃，所以他们的药对他们的病完全对症；②GPTQ崩溃是另一种病：只保护超级权重救不了（0.163），需要的是10万量级的另一批权重；③他们的激活尖峰信号在我们六模型上反向预测。定位：互补不竞争——两种病、两副药，我们是说明何时用哪副的处方笺。这页也是讨论如何对接Mengxia时的材料。</a:t>
+            </a:r>
+          </a:p>
+        </p:txBody>
+      </p:sp>
+      <p:sp>
+        <p:nvSpPr>
+          <p:cNvPr id="4" name="Slide Number Placeholder 3"/>
+          <p:cNvSpPr>
+            <a:spLocks noGrp="1"/>
+          </p:cNvSpPr>
+          <p:nvPr>
+            <p:ph type="sldNum" idx="5" sz="quarter"/>
+          </p:nvPr>
+        </p:nvSpPr>
+        <p:spPr/>
+      </p:sp>
+    </p:spTree>
+  </p:cSld>
+  <p:clrMapOvr>
+    <a:masterClrMapping/>
+  </p:clrMapOvr>
+</p:notes>
+</file>
+
+<file path=ppt/notesSlides/notesSlide23.xml><?xml version="1.0" encoding="utf-8"?>
+<p:notes xmlns:a="http://schemas.openxmlformats.org/drawingml/2006/main" xmlns:p="http://schemas.openxmlformats.org/presentationml/2006/main" xmlns:r="http://schemas.openxmlformats.org/officeDocument/2006/relationships">
+  <p:cSld>
+    <p:spTree>
+      <p:nvGrpSpPr>
+        <p:cNvPr id="1" name=""/>
+        <p:cNvGrpSpPr/>
+        <p:nvPr/>
+      </p:nvGrpSpPr>
+      <p:grpSpPr>
+        <a:xfrm>
+          <a:off x="0" y="0"/>
+          <a:ext cx="0" cy="0"/>
+          <a:chOff x="0" y="0"/>
+          <a:chExt cx="0" cy="0"/>
+        </a:xfrm>
+      </p:grpSpPr>
+      <p:sp>
+        <p:nvSpPr>
+          <p:cNvPr id="2" name="Slide Image Placeholder 1"/>
+          <p:cNvSpPr>
+            <a:spLocks noGrp="1"/>
+          </p:cNvSpPr>
+          <p:nvPr>
+            <p:ph type="sldImg" idx="2"/>
+          </p:nvPr>
+        </p:nvSpPr>
+        <p:spPr/>
+      </p:sp>
+      <p:sp>
+        <p:nvSpPr>
+          <p:cNvPr id="3" name="Notes Placeholder 2"/>
+          <p:cNvSpPr>
+            <a:spLocks noGrp="1"/>
+          </p:cNvSpPr>
+          <p:nvPr>
+            <p:ph type="body" idx="3" sz="quarter"/>
+          </p:nvPr>
+        </p:nvSpPr>
+        <p:spPr/>
+        <p:txBody>
+          <a:bodyPr/>
+          <a:lstStyle/>
+          <a:p>
+            <a:r>
               <a:t>征求意见：①故事是否已经是一个干净的问题+干净的答案；②确认ICLR→ACL路线；③如何对接Mengxia的工作（打招呼还是引用即可）；④集群还可用，要不要补实验。</a:t>
             </a:r>
           </a:p>
@@ -22532,6 +22674,666 @@
 </file>
 
 <file path=ppt/slides/slide30.xml><?xml version="1.0" encoding="utf-8"?>
+<p:sld xmlns:a="http://schemas.openxmlformats.org/drawingml/2006/main" xmlns:p="http://schemas.openxmlformats.org/presentationml/2006/main" xmlns:r="http://schemas.openxmlformats.org/officeDocument/2006/relationships">
+  <p:cSld>
+    <p:spTree>
+      <p:nvGrpSpPr>
+        <p:cNvPr id="1" name=""/>
+        <p:cNvGrpSpPr/>
+        <p:nvPr/>
+      </p:nvGrpSpPr>
+      <p:grpSpPr/>
+      <p:sp>
+        <p:nvSpPr>
+          <p:cNvPr id="4" name="Title 3"/>
+          <p:cNvSpPr>
+            <a:spLocks noGrp="1"/>
+          </p:cNvSpPr>
+          <p:nvPr>
+            <p:ph type="title"/>
+          </p:nvPr>
+        </p:nvSpPr>
+        <p:spPr>
+          <a:xfrm>
+            <a:off x="411480" y="658368"/>
+            <a:ext cx="8321040" cy="658368"/>
+          </a:xfrm>
+        </p:spPr>
+        <p:txBody>
+          <a:bodyPr wrap="square"/>
+          <a:lstStyle/>
+          <a:p>
+            <a:pPr algn="l"/>
+            <a:r>
+              <a:rPr sz="2600" b="1">
+                <a:solidFill>
+                  <a:srgbClr val="0C2340"/>
+                </a:solidFill>
+                <a:latin typeface="Georgia"/>
+              </a:rPr>
+              <a:t>TaCQ (UNC Chapel Hill, 2025)</a:t>
+            </a:r>
+          </a:p>
+        </p:txBody>
+      </p:sp>
+      <p:sp>
+        <p:nvSpPr>
+          <p:cNvPr id="5" name="Subtitle 4"/>
+          <p:cNvSpPr>
+            <a:spLocks noGrp="1"/>
+          </p:cNvSpPr>
+          <p:nvPr>
+            <p:ph type="subTitle" idx="3"/>
+          </p:nvPr>
+        </p:nvSpPr>
+        <p:spPr/>
+        <p:txBody>
+          <a:bodyPr/>
+          <a:lstStyle/>
+          <a:p>
+            <a:r>
+              <a:rPr sz="1100" b="1">
+                <a:solidFill>
+                  <a:srgbClr val="FFFFFF"/>
+                </a:solidFill>
+                <a:latin typeface="Georgia"/>
+              </a:rPr>
+              <a:t>BACKUP - TACQ IN DETAIL</a:t>
+            </a:r>
+          </a:p>
+        </p:txBody>
+      </p:sp>
+      <p:sp>
+        <p:nvSpPr>
+          <p:cNvPr id="6" name="TextBox 5"/>
+          <p:cNvSpPr txBox="1"/>
+          <p:nvPr/>
+        </p:nvSpPr>
+        <p:spPr>
+          <a:xfrm>
+            <a:off x="411480" y="1371600"/>
+            <a:ext cx="4206240" cy="3383280"/>
+          </a:xfrm>
+          <a:prstGeom prst="rect">
+            <a:avLst/>
+          </a:prstGeom>
+          <a:noFill/>
+        </p:spPr>
+        <p:txBody>
+          <a:bodyPr wrap="square" lIns="0" rIns="0" tIns="0" bIns="0">
+            <a:spAutoFit/>
+          </a:bodyPr>
+          <a:lstStyle/>
+          <a:p>
+            <a:pPr algn="l">
+              <a:spcAft>
+                <a:spcPts val="300"/>
+              </a:spcAft>
+            </a:pPr>
+            <a:r>
+              <a:rPr sz="1100" b="1" i="0">
+                <a:solidFill>
+                  <a:srgbClr val="AE9141"/>
+                </a:solidFill>
+                <a:latin typeface="Georgia"/>
+              </a:rPr>
+              <a:t>THEIR SETUP</a:t>
+            </a:r>
+          </a:p>
+          <a:p>
+            <a:pPr algn="l">
+              <a:spcAft>
+                <a:spcPts val="500"/>
+              </a:spcAft>
+            </a:pPr>
+            <a:r>
+              <a:rPr sz="1150" b="0" i="0">
+                <a:solidFill>
+                  <a:srgbClr val="0C2340"/>
+                </a:solidFill>
+                <a:latin typeface="Georgia"/>
+              </a:rPr>
+              <a:t>Method paper: mixed-precision PTQ — important weights stored in 16-bit, the rest in 2–3 bits.</a:t>
+            </a:r>
+          </a:p>
+          <a:p>
+            <a:pPr algn="l">
+              <a:spcAft>
+                <a:spcPts val="500"/>
+              </a:spcAft>
+            </a:pPr>
+            <a:r>
+              <a:rPr sz="1150" b="1" i="0">
+                <a:solidFill>
+                  <a:srgbClr val="0C2340"/>
+                </a:solidFill>
+                <a:latin typeface="Georgia"/>
+              </a:rPr>
+              <a:t>Models: </a:t>
+            </a:r>
+            <a:r>
+              <a:rPr sz="1150" b="0" i="0">
+                <a:solidFill>
+                  <a:srgbClr val="0C2340"/>
+                </a:solidFill>
+                <a:latin typeface="Georgia"/>
+              </a:rPr>
+              <a:t>Llama-3-8B-Instruct (main — the OLDER generation; in our census it is mid-tier, NOT the collapsing 3.1), Qwen2.5-7B, scaling on Qwen2.5-32B.</a:t>
+            </a:r>
+          </a:p>
+          <a:p>
+            <a:pPr algn="l">
+              <a:spcAft>
+                <a:spcPts val="500"/>
+              </a:spcAft>
+            </a:pPr>
+            <a:r>
+              <a:rPr sz="1150" b="1" i="0">
+                <a:solidFill>
+                  <a:srgbClr val="0C2340"/>
+                </a:solidFill>
+                <a:latin typeface="Georgia"/>
+              </a:rPr>
+              <a:t>Bits: </a:t>
+            </a:r>
+            <a:r>
+              <a:rPr sz="1150" b="0" i="0">
+                <a:solidFill>
+                  <a:srgbClr val="0C2340"/>
+                </a:solidFill>
+                <a:latin typeface="Georgia"/>
+              </a:rPr>
+              <a:t>2-bit and 3-bit (3.1-bit average).</a:t>
+            </a:r>
+          </a:p>
+          <a:p>
+            <a:pPr algn="l">
+              <a:spcAft>
+                <a:spcPts val="500"/>
+              </a:spcAft>
+            </a:pPr>
+            <a:r>
+              <a:rPr sz="1150" b="1" i="0">
+                <a:solidFill>
+                  <a:srgbClr val="0C2340"/>
+                </a:solidFill>
+                <a:latin typeface="Georgia"/>
+              </a:rPr>
+              <a:t>Benchmarks: </a:t>
+            </a:r>
+            <a:r>
+              <a:rPr sz="1150" b="0" i="0">
+                <a:solidFill>
+                  <a:srgbClr val="0C2340"/>
+                </a:solidFill>
+                <a:latin typeface="Georgia"/>
+              </a:rPr>
+              <a:t>MMLU, GSM8K, Spider (SQL). No instruction-following, no multi-turn.</a:t>
+            </a:r>
+          </a:p>
+          <a:p>
+            <a:pPr algn="l"/>
+            <a:r>
+              <a:rPr sz="1150" b="1" i="0">
+                <a:solidFill>
+                  <a:srgbClr val="0C2340"/>
+                </a:solidFill>
+                <a:latin typeface="Georgia"/>
+              </a:rPr>
+              <a:t>Headline: </a:t>
+            </a:r>
+            <a:r>
+              <a:rPr sz="1150" b="0" i="0">
+                <a:solidFill>
+                  <a:srgbClr val="0C2340"/>
+                </a:solidFill>
+                <a:latin typeface="Georgia"/>
+              </a:rPr>
+              <a:t>2-bit beats the best baseline (SliM-LLM) by +14 to +22; 3-bit retains 91–96% of original accuracy.</a:t>
+            </a:r>
+          </a:p>
+        </p:txBody>
+      </p:sp>
+      <p:sp>
+        <p:nvSpPr>
+          <p:cNvPr id="7" name="TextBox 6"/>
+          <p:cNvSpPr txBox="1"/>
+          <p:nvPr/>
+        </p:nvSpPr>
+        <p:spPr>
+          <a:xfrm>
+            <a:off x="4846320" y="1371600"/>
+            <a:ext cx="3931920" cy="3383280"/>
+          </a:xfrm>
+          <a:prstGeom prst="rect">
+            <a:avLst/>
+          </a:prstGeom>
+          <a:noFill/>
+        </p:spPr>
+        <p:txBody>
+          <a:bodyPr wrap="square" lIns="0" rIns="0" tIns="0" bIns="0">
+            <a:spAutoFit/>
+          </a:bodyPr>
+          <a:lstStyle/>
+          <a:p>
+            <a:pPr algn="l">
+              <a:spcAft>
+                <a:spcPts val="300"/>
+              </a:spcAft>
+            </a:pPr>
+            <a:r>
+              <a:rPr sz="1100" b="1" i="0">
+                <a:solidFill>
+                  <a:srgbClr val="AE9141"/>
+                </a:solidFill>
+                <a:latin typeface="Georgia"/>
+              </a:rPr>
+              <a:t>RELATION TO US</a:t>
+            </a:r>
+          </a:p>
+          <a:p>
+            <a:pPr algn="l">
+              <a:spcAft>
+                <a:spcPts val="500"/>
+              </a:spcAft>
+            </a:pPr>
+            <a:r>
+              <a:rPr sz="1150" b="1" i="0">
+                <a:solidFill>
+                  <a:srgbClr val="0C2340"/>
+                </a:solidFill>
+                <a:latin typeface="Georgia"/>
+              </a:rPr>
+              <a:t>We take: </a:t>
+            </a:r>
+            <a:r>
+              <a:rPr sz="1150" b="0" i="0">
+                <a:solidFill>
+                  <a:srgbClr val="0C2340"/>
+                </a:solidFill>
+                <a:latin typeface="Georgia"/>
+              </a:rPr>
+              <a:t>their importance score, fully credited, as our instrument.</a:t>
+            </a:r>
+          </a:p>
+          <a:p>
+            <a:pPr algn="l">
+              <a:spcAft>
+                <a:spcPts val="500"/>
+              </a:spcAft>
+            </a:pPr>
+            <a:r>
+              <a:rPr sz="1150" b="1" i="0">
+                <a:solidFill>
+                  <a:srgbClr val="0C2340"/>
+                </a:solidFill>
+                <a:latin typeface="Georgia"/>
+              </a:rPr>
+              <a:t>We add what they lack: </a:t>
+            </a:r>
+            <a:r>
+              <a:rPr sz="1150" b="0" i="0">
+                <a:solidFill>
+                  <a:srgbClr val="0C2340"/>
+                </a:solidFill>
+                <a:latin typeface="Georgia"/>
+              </a:rPr>
+              <a:t>any “when it fails” case (their evals contain no null result), any mechanism experiment, and even the basic random-protection control at matched budget — absent from their paper.</a:t>
+            </a:r>
+          </a:p>
+          <a:p>
+            <a:pPr algn="l">
+              <a:spcAft>
+                <a:spcPts val="500"/>
+              </a:spcAft>
+            </a:pPr>
+            <a:r>
+              <a:rPr sz="1150" b="1" i="0">
+                <a:solidFill>
+                  <a:srgbClr val="0C2340"/>
+                </a:solidFill>
+                <a:latin typeface="Georgia"/>
+              </a:rPr>
+              <a:t>Open item: </a:t>
+            </a:r>
+            <a:r>
+              <a:rPr sz="1150" b="0" i="0">
+                <a:solidFill>
+                  <a:srgbClr val="0C2340"/>
+                </a:solidFill>
+                <a:latin typeface="Georgia"/>
+              </a:rPr>
+              <a:t>their 2-bit succeeds (mixed-precision storage), our 2-bit is terminal at matched budget — protocol reconciliation before submission.</a:t>
+            </a:r>
+          </a:p>
+          <a:p>
+            <a:pPr algn="l"/>
+            <a:r>
+              <a:rPr sz="1150" b="0" i="1">
+                <a:solidFill>
+                  <a:srgbClr val="AE9141"/>
+                </a:solidFill>
+                <a:latin typeface="Georgia"/>
+              </a:rPr>
+              <a:t>One line: they built the tool; we mapped when and why it works.</a:t>
+            </a:r>
+          </a:p>
+        </p:txBody>
+      </p:sp>
+    </p:spTree>
+  </p:cSld>
+  <p:clrMapOvr>
+    <a:masterClrMapping/>
+  </p:clrMapOvr>
+</p:sld>
+</file>
+
+<file path=ppt/slides/slide31.xml><?xml version="1.0" encoding="utf-8"?>
+<p:sld xmlns:a="http://schemas.openxmlformats.org/drawingml/2006/main" xmlns:p="http://schemas.openxmlformats.org/presentationml/2006/main" xmlns:r="http://schemas.openxmlformats.org/officeDocument/2006/relationships">
+  <p:cSld>
+    <p:spTree>
+      <p:nvGrpSpPr>
+        <p:cNvPr id="1" name=""/>
+        <p:cNvGrpSpPr/>
+        <p:nvPr/>
+      </p:nvGrpSpPr>
+      <p:grpSpPr/>
+      <p:sp>
+        <p:nvSpPr>
+          <p:cNvPr id="4" name="Title 3"/>
+          <p:cNvSpPr>
+            <a:spLocks noGrp="1"/>
+          </p:cNvSpPr>
+          <p:nvPr>
+            <p:ph type="title"/>
+          </p:nvPr>
+        </p:nvSpPr>
+        <p:spPr>
+          <a:xfrm>
+            <a:off x="411480" y="658368"/>
+            <a:ext cx="8321040" cy="658368"/>
+          </a:xfrm>
+        </p:spPr>
+        <p:txBody>
+          <a:bodyPr wrap="square"/>
+          <a:lstStyle/>
+          <a:p>
+            <a:pPr algn="l"/>
+            <a:r>
+              <a:rPr sz="2600" b="1">
+                <a:solidFill>
+                  <a:srgbClr val="0C2340"/>
+                </a:solidFill>
+                <a:latin typeface="Georgia"/>
+              </a:rPr>
+              <a:t>Super Weights (Mengxia Yu, ND + Apple, 2024)</a:t>
+            </a:r>
+          </a:p>
+        </p:txBody>
+      </p:sp>
+      <p:sp>
+        <p:nvSpPr>
+          <p:cNvPr id="5" name="Subtitle 4"/>
+          <p:cNvSpPr>
+            <a:spLocks noGrp="1"/>
+          </p:cNvSpPr>
+          <p:nvPr>
+            <p:ph type="subTitle" idx="3"/>
+          </p:nvPr>
+        </p:nvSpPr>
+        <p:spPr/>
+        <p:txBody>
+          <a:bodyPr/>
+          <a:lstStyle/>
+          <a:p>
+            <a:r>
+              <a:rPr sz="1100" b="1">
+                <a:solidFill>
+                  <a:srgbClr val="FFFFFF"/>
+                </a:solidFill>
+                <a:latin typeface="Georgia"/>
+              </a:rPr>
+              <a:t>BACKUP - SUPER WEIGHTS IN DETAIL</a:t>
+            </a:r>
+          </a:p>
+        </p:txBody>
+      </p:sp>
+      <p:sp>
+        <p:nvSpPr>
+          <p:cNvPr id="6" name="TextBox 5"/>
+          <p:cNvSpPr txBox="1"/>
+          <p:nvPr/>
+        </p:nvSpPr>
+        <p:spPr>
+          <a:xfrm>
+            <a:off x="411480" y="1371600"/>
+            <a:ext cx="4206240" cy="3383280"/>
+          </a:xfrm>
+          <a:prstGeom prst="rect">
+            <a:avLst/>
+          </a:prstGeom>
+          <a:noFill/>
+        </p:spPr>
+        <p:txBody>
+          <a:bodyPr wrap="square" lIns="0" rIns="0" tIns="0" bIns="0">
+            <a:spAutoFit/>
+          </a:bodyPr>
+          <a:lstStyle/>
+          <a:p>
+            <a:pPr algn="l">
+              <a:spcAft>
+                <a:spcPts val="300"/>
+              </a:spcAft>
+            </a:pPr>
+            <a:r>
+              <a:rPr sz="1100" b="1" i="0">
+                <a:solidFill>
+                  <a:srgbClr val="AE9141"/>
+                </a:solidFill>
+                <a:latin typeface="Georgia"/>
+              </a:rPr>
+              <a:t>THEIR SETUP</a:t>
+            </a:r>
+          </a:p>
+          <a:p>
+            <a:pPr algn="l">
+              <a:spcAft>
+                <a:spcPts val="500"/>
+              </a:spcAft>
+            </a:pPr>
+            <a:r>
+              <a:rPr sz="1150" b="0" i="0">
+                <a:solidFill>
+                  <a:srgbClr val="0C2340"/>
+                </a:solidFill>
+                <a:latin typeface="Georgia"/>
+              </a:rPr>
+              <a:t>Analysis + simple method. Models: Llama-1 7/13/30B, Llama-2 7/13B, Mistral-7B-v0.1, OLMo 1B/7B, Phi-3-mini — mostly BASE models, with published coordinates (e.g. Llama-7B [3968, 7003]).</a:t>
+            </a:r>
+          </a:p>
+          <a:p>
+            <a:pPr algn="l">
+              <a:spcAft>
+                <a:spcPts val="500"/>
+              </a:spcAft>
+            </a:pPr>
+            <a:r>
+              <a:rPr sz="1150" b="1" i="0">
+                <a:solidFill>
+                  <a:srgbClr val="0C2340"/>
+                </a:solidFill>
+                <a:latin typeface="Georgia"/>
+              </a:rPr>
+              <a:t>Quantization world: </a:t>
+            </a:r>
+            <a:r>
+              <a:rPr sz="1150" b="0" i="0">
+                <a:solidFill>
+                  <a:srgbClr val="0C2340"/>
+                </a:solidFill>
+                <a:latin typeface="Georgia"/>
+              </a:rPr>
+              <a:t>round-to-nearest only (weights + activations, large blocks). GPTQ-style error correction appears nowhere.</a:t>
+            </a:r>
+          </a:p>
+          <a:p>
+            <a:pPr algn="l">
+              <a:spcAft>
+                <a:spcPts val="500"/>
+              </a:spcAft>
+            </a:pPr>
+            <a:r>
+              <a:rPr sz="1150" b="1" i="0">
+                <a:solidFill>
+                  <a:srgbClr val="0C2340"/>
+                </a:solidFill>
+                <a:latin typeface="Georgia"/>
+              </a:rPr>
+              <a:t>Evals: </a:t>
+            </a:r>
+            <a:r>
+              <a:rPr sz="1150" b="0" i="0">
+                <a:solidFill>
+                  <a:srgbClr val="0C2340"/>
+                </a:solidFill>
+                <a:latin typeface="Georgia"/>
+              </a:rPr>
+              <a:t>perplexity + zero-shot multiple choice. No generative tasks.</a:t>
+            </a:r>
+          </a:p>
+          <a:p>
+            <a:pPr algn="l"/>
+            <a:r>
+              <a:rPr sz="1150" b="1" i="0">
+                <a:solidFill>
+                  <a:srgbClr val="0C2340"/>
+                </a:solidFill>
+                <a:latin typeface="Georgia"/>
+              </a:rPr>
+              <a:t>Headline: </a:t>
+            </a:r>
+            <a:r>
+              <a:rPr sz="1150" b="0" i="0">
+                <a:solidFill>
+                  <a:srgbClr val="0C2340"/>
+                </a:solidFill>
+                <a:latin typeface="Georgia"/>
+              </a:rPr>
+              <a:t>1–6 single weights per model; pruning ONE raises perplexity 1000× — found data-free in one forward pass.</a:t>
+            </a:r>
+          </a:p>
+        </p:txBody>
+      </p:sp>
+      <p:sp>
+        <p:nvSpPr>
+          <p:cNvPr id="7" name="TextBox 6"/>
+          <p:cNvSpPr txBox="1"/>
+          <p:nvPr/>
+        </p:nvSpPr>
+        <p:spPr>
+          <a:xfrm>
+            <a:off x="4846320" y="1371600"/>
+            <a:ext cx="3931920" cy="3383280"/>
+          </a:xfrm>
+          <a:prstGeom prst="rect">
+            <a:avLst/>
+          </a:prstGeom>
+          <a:noFill/>
+        </p:spPr>
+        <p:txBody>
+          <a:bodyPr wrap="square" lIns="0" rIns="0" tIns="0" bIns="0">
+            <a:spAutoFit/>
+          </a:bodyPr>
+          <a:lstStyle/>
+          <a:p>
+            <a:pPr algn="l">
+              <a:spcAft>
+                <a:spcPts val="300"/>
+              </a:spcAft>
+            </a:pPr>
+            <a:r>
+              <a:rPr sz="1100" b="1" i="0">
+                <a:solidFill>
+                  <a:srgbClr val="AE9141"/>
+                </a:solidFill>
+                <a:latin typeface="Georgia"/>
+              </a:rPr>
+              <a:t>RELATION TO US</a:t>
+            </a:r>
+          </a:p>
+          <a:p>
+            <a:pPr algn="l">
+              <a:spcAft>
+                <a:spcPts val="500"/>
+              </a:spcAft>
+            </a:pPr>
+            <a:r>
+              <a:rPr sz="1150" b="1" i="0">
+                <a:solidFill>
+                  <a:srgbClr val="0C2340"/>
+                </a:solidFill>
+                <a:latin typeface="Georgia"/>
+              </a:rPr>
+              <a:t>Lineage: </a:t>
+            </a:r>
+            <a:r>
+              <a:rPr sz="1150" b="0" i="0">
+                <a:solidFill>
+                  <a:srgbClr val="0C2340"/>
+                </a:solidFill>
+                <a:latin typeface="Georgia"/>
+              </a:rPr>
+              <a:t>“tiny lethal sets exist” is their concept; our zeroing experiment is its 100,000-weight analogue.</a:t>
+            </a:r>
+          </a:p>
+          <a:p>
+            <a:pPr algn="l">
+              <a:spcAft>
+                <a:spcPts val="500"/>
+              </a:spcAft>
+            </a:pPr>
+            <a:r>
+              <a:rPr sz="1150" b="1" i="0">
+                <a:solidFill>
+                  <a:srgbClr val="0C2340"/>
+                </a:solidFill>
+                <a:latin typeface="Georgia"/>
+              </a:rPr>
+              <a:t>We add: </a:t>
+            </a:r>
+            <a:r>
+              <a:rPr sz="1150" b="0" i="0">
+                <a:solidFill>
+                  <a:srgbClr val="0C2340"/>
+                </a:solidFill>
+                <a:latin typeface="Georgia"/>
+              </a:rPr>
+              <a:t>the GPTQ world. In our data naive rounding NEVER collapses — so their fix suits their disease. The compensation collapse is a different disease: protecting only super weights fails (0.163), and their spike signal anti-predicts who collapses.</a:t>
+            </a:r>
+          </a:p>
+          <a:p>
+            <a:pPr algn="l"/>
+            <a:r>
+              <a:rPr sz="1150" b="0" i="1">
+                <a:solidFill>
+                  <a:srgbClr val="AE9141"/>
+                </a:solidFill>
+                <a:latin typeface="Georgia"/>
+              </a:rPr>
+              <a:t>One line: two diseases, two medicines — our paper is the prescription chart saying which to use when. Complementary, not competing.</a:t>
+            </a:r>
+          </a:p>
+        </p:txBody>
+      </p:sp>
+    </p:spTree>
+  </p:cSld>
+  <p:clrMapOvr>
+    <a:masterClrMapping/>
+  </p:clrMapOvr>
+</p:sld>
+</file>
+
+<file path=ppt/slides/slide32.xml><?xml version="1.0" encoding="utf-8"?>
 <p:sld xmlns:a="http://schemas.openxmlformats.org/drawingml/2006/main" xmlns:p="http://schemas.openxmlformats.org/presentationml/2006/main" xmlns:r="http://schemas.openxmlformats.org/officeDocument/2006/relationships">
   <p:cSld>
     <p:spTree>

</xml_diff>

<commit_message>
Deck: full paper titles + arXiv ids on TaCQ/SW backup slides
</commit_message>
<xml_diff>
--- a/paper/IFH_advisor_update_2026-09-03.pptx
+++ b/paper/IFH_advisor_update_2026-09-03.pptx
@@ -22751,8 +22751,8 @@
         </p:nvSpPr>
         <p:spPr>
           <a:xfrm>
-            <a:off x="411480" y="1371600"/>
-            <a:ext cx="4206240" cy="3383280"/>
+            <a:off x="411480" y="1298448"/>
+            <a:ext cx="8321040" cy="274320"/>
           </a:xfrm>
           <a:prstGeom prst="rect">
             <a:avLst/>
@@ -22765,131 +22765,15 @@
           </a:bodyPr>
           <a:lstStyle/>
           <a:p>
-            <a:pPr algn="l">
-              <a:spcAft>
-                <a:spcPts val="300"/>
-              </a:spcAft>
-            </a:pPr>
-            <a:r>
-              <a:rPr sz="1100" b="1" i="0">
-                <a:solidFill>
-                  <a:srgbClr val="AE9141"/>
+            <a:pPr algn="l"/>
+            <a:r>
+              <a:rPr sz="1100" b="0" i="1">
+                <a:solidFill>
+                  <a:srgbClr val="5A5A5A"/>
                 </a:solidFill>
                 <a:latin typeface="Georgia"/>
               </a:rPr>
-              <a:t>THEIR SETUP</a:t>
-            </a:r>
-          </a:p>
-          <a:p>
-            <a:pPr algn="l">
-              <a:spcAft>
-                <a:spcPts val="500"/>
-              </a:spcAft>
-            </a:pPr>
-            <a:r>
-              <a:rPr sz="1150" b="0" i="0">
-                <a:solidFill>
-                  <a:srgbClr val="0C2340"/>
-                </a:solidFill>
-                <a:latin typeface="Georgia"/>
-              </a:rPr>
-              <a:t>Method paper: mixed-precision PTQ — important weights stored in 16-bit, the rest in 2–3 bits.</a:t>
-            </a:r>
-          </a:p>
-          <a:p>
-            <a:pPr algn="l">
-              <a:spcAft>
-                <a:spcPts val="500"/>
-              </a:spcAft>
-            </a:pPr>
-            <a:r>
-              <a:rPr sz="1150" b="1" i="0">
-                <a:solidFill>
-                  <a:srgbClr val="0C2340"/>
-                </a:solidFill>
-                <a:latin typeface="Georgia"/>
-              </a:rPr>
-              <a:t>Models: </a:t>
-            </a:r>
-            <a:r>
-              <a:rPr sz="1150" b="0" i="0">
-                <a:solidFill>
-                  <a:srgbClr val="0C2340"/>
-                </a:solidFill>
-                <a:latin typeface="Georgia"/>
-              </a:rPr>
-              <a:t>Llama-3-8B-Instruct (main — the OLDER generation; in our census it is mid-tier, NOT the collapsing 3.1), Qwen2.5-7B, scaling on Qwen2.5-32B.</a:t>
-            </a:r>
-          </a:p>
-          <a:p>
-            <a:pPr algn="l">
-              <a:spcAft>
-                <a:spcPts val="500"/>
-              </a:spcAft>
-            </a:pPr>
-            <a:r>
-              <a:rPr sz="1150" b="1" i="0">
-                <a:solidFill>
-                  <a:srgbClr val="0C2340"/>
-                </a:solidFill>
-                <a:latin typeface="Georgia"/>
-              </a:rPr>
-              <a:t>Bits: </a:t>
-            </a:r>
-            <a:r>
-              <a:rPr sz="1150" b="0" i="0">
-                <a:solidFill>
-                  <a:srgbClr val="0C2340"/>
-                </a:solidFill>
-                <a:latin typeface="Georgia"/>
-              </a:rPr>
-              <a:t>2-bit and 3-bit (3.1-bit average).</a:t>
-            </a:r>
-          </a:p>
-          <a:p>
-            <a:pPr algn="l">
-              <a:spcAft>
-                <a:spcPts val="500"/>
-              </a:spcAft>
-            </a:pPr>
-            <a:r>
-              <a:rPr sz="1150" b="1" i="0">
-                <a:solidFill>
-                  <a:srgbClr val="0C2340"/>
-                </a:solidFill>
-                <a:latin typeface="Georgia"/>
-              </a:rPr>
-              <a:t>Benchmarks: </a:t>
-            </a:r>
-            <a:r>
-              <a:rPr sz="1150" b="0" i="0">
-                <a:solidFill>
-                  <a:srgbClr val="0C2340"/>
-                </a:solidFill>
-                <a:latin typeface="Georgia"/>
-              </a:rPr>
-              <a:t>MMLU, GSM8K, Spider (SQL). No instruction-following, no multi-turn.</a:t>
-            </a:r>
-          </a:p>
-          <a:p>
-            <a:pPr algn="l"/>
-            <a:r>
-              <a:rPr sz="1150" b="1" i="0">
-                <a:solidFill>
-                  <a:srgbClr val="0C2340"/>
-                </a:solidFill>
-                <a:latin typeface="Georgia"/>
-              </a:rPr>
-              <a:t>Headline: </a:t>
-            </a:r>
-            <a:r>
-              <a:rPr sz="1150" b="0" i="0">
-                <a:solidFill>
-                  <a:srgbClr val="0C2340"/>
-                </a:solidFill>
-                <a:latin typeface="Georgia"/>
-              </a:rPr>
-              <a:t>2-bit beats the best baseline (SliM-LLM) by +14 to +22; 3-bit retains 91–96% of original accuracy.</a:t>
+              <a:t>“Task-Circuit Quantization: Leveraging Knowledge Localization and Interpretability for Compression” — Xiao, Stengel-Eskin &amp; Bansal, arXiv:2504.07389</a:t>
             </a:r>
           </a:p>
         </p:txBody>
@@ -22902,8 +22786,159 @@
         </p:nvSpPr>
         <p:spPr>
           <a:xfrm>
-            <a:off x="4846320" y="1371600"/>
-            <a:ext cx="3931920" cy="3383280"/>
+            <a:off x="411480" y="1664208"/>
+            <a:ext cx="4206240" cy="3200400"/>
+          </a:xfrm>
+          <a:prstGeom prst="rect">
+            <a:avLst/>
+          </a:prstGeom>
+          <a:noFill/>
+        </p:spPr>
+        <p:txBody>
+          <a:bodyPr wrap="square" lIns="0" rIns="0" tIns="0" bIns="0">
+            <a:spAutoFit/>
+          </a:bodyPr>
+          <a:lstStyle/>
+          <a:p>
+            <a:pPr algn="l">
+              <a:spcAft>
+                <a:spcPts val="300"/>
+              </a:spcAft>
+            </a:pPr>
+            <a:r>
+              <a:rPr sz="1100" b="1" i="0">
+                <a:solidFill>
+                  <a:srgbClr val="AE9141"/>
+                </a:solidFill>
+                <a:latin typeface="Georgia"/>
+              </a:rPr>
+              <a:t>THEIR SETUP</a:t>
+            </a:r>
+          </a:p>
+          <a:p>
+            <a:pPr algn="l">
+              <a:spcAft>
+                <a:spcPts val="500"/>
+              </a:spcAft>
+            </a:pPr>
+            <a:r>
+              <a:rPr sz="1150" b="0" i="0">
+                <a:solidFill>
+                  <a:srgbClr val="0C2340"/>
+                </a:solidFill>
+                <a:latin typeface="Georgia"/>
+              </a:rPr>
+              <a:t>Method paper: mixed-precision PTQ — important weights stored in 16-bit, the rest in 2–3 bits.</a:t>
+            </a:r>
+          </a:p>
+          <a:p>
+            <a:pPr algn="l">
+              <a:spcAft>
+                <a:spcPts val="500"/>
+              </a:spcAft>
+            </a:pPr>
+            <a:r>
+              <a:rPr sz="1150" b="1" i="0">
+                <a:solidFill>
+                  <a:srgbClr val="0C2340"/>
+                </a:solidFill>
+                <a:latin typeface="Georgia"/>
+              </a:rPr>
+              <a:t>Models: </a:t>
+            </a:r>
+            <a:r>
+              <a:rPr sz="1150" b="0" i="0">
+                <a:solidFill>
+                  <a:srgbClr val="0C2340"/>
+                </a:solidFill>
+                <a:latin typeface="Georgia"/>
+              </a:rPr>
+              <a:t>Llama-3-8B-Instruct (main — the OLDER generation; in our census it is mid-tier, NOT the collapsing 3.1), Qwen2.5-7B, scaling on Qwen2.5-32B.</a:t>
+            </a:r>
+          </a:p>
+          <a:p>
+            <a:pPr algn="l">
+              <a:spcAft>
+                <a:spcPts val="500"/>
+              </a:spcAft>
+            </a:pPr>
+            <a:r>
+              <a:rPr sz="1150" b="1" i="0">
+                <a:solidFill>
+                  <a:srgbClr val="0C2340"/>
+                </a:solidFill>
+                <a:latin typeface="Georgia"/>
+              </a:rPr>
+              <a:t>Bits: </a:t>
+            </a:r>
+            <a:r>
+              <a:rPr sz="1150" b="0" i="0">
+                <a:solidFill>
+                  <a:srgbClr val="0C2340"/>
+                </a:solidFill>
+                <a:latin typeface="Georgia"/>
+              </a:rPr>
+              <a:t>2-bit and 3-bit (3.1-bit average).</a:t>
+            </a:r>
+          </a:p>
+          <a:p>
+            <a:pPr algn="l">
+              <a:spcAft>
+                <a:spcPts val="500"/>
+              </a:spcAft>
+            </a:pPr>
+            <a:r>
+              <a:rPr sz="1150" b="1" i="0">
+                <a:solidFill>
+                  <a:srgbClr val="0C2340"/>
+                </a:solidFill>
+                <a:latin typeface="Georgia"/>
+              </a:rPr>
+              <a:t>Benchmarks: </a:t>
+            </a:r>
+            <a:r>
+              <a:rPr sz="1150" b="0" i="0">
+                <a:solidFill>
+                  <a:srgbClr val="0C2340"/>
+                </a:solidFill>
+                <a:latin typeface="Georgia"/>
+              </a:rPr>
+              <a:t>MMLU, GSM8K, Spider (SQL). No instruction-following, no multi-turn.</a:t>
+            </a:r>
+          </a:p>
+          <a:p>
+            <a:pPr algn="l"/>
+            <a:r>
+              <a:rPr sz="1150" b="1" i="0">
+                <a:solidFill>
+                  <a:srgbClr val="0C2340"/>
+                </a:solidFill>
+                <a:latin typeface="Georgia"/>
+              </a:rPr>
+              <a:t>Headline: </a:t>
+            </a:r>
+            <a:r>
+              <a:rPr sz="1150" b="0" i="0">
+                <a:solidFill>
+                  <a:srgbClr val="0C2340"/>
+                </a:solidFill>
+                <a:latin typeface="Georgia"/>
+              </a:rPr>
+              <a:t>2-bit beats the best baseline (SliM-LLM) by +14 to +22; 3-bit retains 91–96% of original accuracy.</a:t>
+            </a:r>
+          </a:p>
+        </p:txBody>
+      </p:sp>
+      <p:sp>
+        <p:nvSpPr>
+          <p:cNvPr id="8" name="TextBox 7"/>
+          <p:cNvSpPr txBox="1"/>
+          <p:nvPr/>
+        </p:nvSpPr>
+        <p:spPr>
+          <a:xfrm>
+            <a:off x="4846320" y="1664208"/>
+            <a:ext cx="3931920" cy="3200400"/>
           </a:xfrm>
           <a:prstGeom prst="rect">
             <a:avLst/>
@@ -23106,8 +23141,8 @@
         </p:nvSpPr>
         <p:spPr>
           <a:xfrm>
-            <a:off x="411480" y="1371600"/>
-            <a:ext cx="4206240" cy="3383280"/>
+            <a:off x="411480" y="1298448"/>
+            <a:ext cx="8321040" cy="274320"/>
           </a:xfrm>
           <a:prstGeom prst="rect">
             <a:avLst/>
@@ -23120,106 +23155,15 @@
           </a:bodyPr>
           <a:lstStyle/>
           <a:p>
-            <a:pPr algn="l">
-              <a:spcAft>
-                <a:spcPts val="300"/>
-              </a:spcAft>
-            </a:pPr>
-            <a:r>
-              <a:rPr sz="1100" b="1" i="0">
-                <a:solidFill>
-                  <a:srgbClr val="AE9141"/>
+            <a:pPr algn="l"/>
+            <a:r>
+              <a:rPr sz="1100" b="0" i="1">
+                <a:solidFill>
+                  <a:srgbClr val="5A5A5A"/>
                 </a:solidFill>
                 <a:latin typeface="Georgia"/>
               </a:rPr>
-              <a:t>THEIR SETUP</a:t>
-            </a:r>
-          </a:p>
-          <a:p>
-            <a:pPr algn="l">
-              <a:spcAft>
-                <a:spcPts val="500"/>
-              </a:spcAft>
-            </a:pPr>
-            <a:r>
-              <a:rPr sz="1150" b="0" i="0">
-                <a:solidFill>
-                  <a:srgbClr val="0C2340"/>
-                </a:solidFill>
-                <a:latin typeface="Georgia"/>
-              </a:rPr>
-              <a:t>Analysis + simple method. Models: Llama-1 7/13/30B, Llama-2 7/13B, Mistral-7B-v0.1, OLMo 1B/7B, Phi-3-mini — mostly BASE models, with published coordinates (e.g. Llama-7B [3968, 7003]).</a:t>
-            </a:r>
-          </a:p>
-          <a:p>
-            <a:pPr algn="l">
-              <a:spcAft>
-                <a:spcPts val="500"/>
-              </a:spcAft>
-            </a:pPr>
-            <a:r>
-              <a:rPr sz="1150" b="1" i="0">
-                <a:solidFill>
-                  <a:srgbClr val="0C2340"/>
-                </a:solidFill>
-                <a:latin typeface="Georgia"/>
-              </a:rPr>
-              <a:t>Quantization world: </a:t>
-            </a:r>
-            <a:r>
-              <a:rPr sz="1150" b="0" i="0">
-                <a:solidFill>
-                  <a:srgbClr val="0C2340"/>
-                </a:solidFill>
-                <a:latin typeface="Georgia"/>
-              </a:rPr>
-              <a:t>round-to-nearest only (weights + activations, large blocks). GPTQ-style error correction appears nowhere.</a:t>
-            </a:r>
-          </a:p>
-          <a:p>
-            <a:pPr algn="l">
-              <a:spcAft>
-                <a:spcPts val="500"/>
-              </a:spcAft>
-            </a:pPr>
-            <a:r>
-              <a:rPr sz="1150" b="1" i="0">
-                <a:solidFill>
-                  <a:srgbClr val="0C2340"/>
-                </a:solidFill>
-                <a:latin typeface="Georgia"/>
-              </a:rPr>
-              <a:t>Evals: </a:t>
-            </a:r>
-            <a:r>
-              <a:rPr sz="1150" b="0" i="0">
-                <a:solidFill>
-                  <a:srgbClr val="0C2340"/>
-                </a:solidFill>
-                <a:latin typeface="Georgia"/>
-              </a:rPr>
-              <a:t>perplexity + zero-shot multiple choice. No generative tasks.</a:t>
-            </a:r>
-          </a:p>
-          <a:p>
-            <a:pPr algn="l"/>
-            <a:r>
-              <a:rPr sz="1150" b="1" i="0">
-                <a:solidFill>
-                  <a:srgbClr val="0C2340"/>
-                </a:solidFill>
-                <a:latin typeface="Georgia"/>
-              </a:rPr>
-              <a:t>Headline: </a:t>
-            </a:r>
-            <a:r>
-              <a:rPr sz="1150" b="0" i="0">
-                <a:solidFill>
-                  <a:srgbClr val="0C2340"/>
-                </a:solidFill>
-                <a:latin typeface="Georgia"/>
-              </a:rPr>
-              <a:t>1–6 single weights per model; pruning ONE raises perplexity 1000× — found data-free in one forward pass.</a:t>
+              <a:t>“The Super Weight in Large Language Models” — Yu, Wang, Shan, Reed &amp; Wan, arXiv:2411.07191</a:t>
             </a:r>
           </a:p>
         </p:txBody>
@@ -23232,8 +23176,134 @@
         </p:nvSpPr>
         <p:spPr>
           <a:xfrm>
-            <a:off x="4846320" y="1371600"/>
-            <a:ext cx="3931920" cy="3383280"/>
+            <a:off x="411480" y="1664208"/>
+            <a:ext cx="4206240" cy="3200400"/>
+          </a:xfrm>
+          <a:prstGeom prst="rect">
+            <a:avLst/>
+          </a:prstGeom>
+          <a:noFill/>
+        </p:spPr>
+        <p:txBody>
+          <a:bodyPr wrap="square" lIns="0" rIns="0" tIns="0" bIns="0">
+            <a:spAutoFit/>
+          </a:bodyPr>
+          <a:lstStyle/>
+          <a:p>
+            <a:pPr algn="l">
+              <a:spcAft>
+                <a:spcPts val="300"/>
+              </a:spcAft>
+            </a:pPr>
+            <a:r>
+              <a:rPr sz="1100" b="1" i="0">
+                <a:solidFill>
+                  <a:srgbClr val="AE9141"/>
+                </a:solidFill>
+                <a:latin typeface="Georgia"/>
+              </a:rPr>
+              <a:t>THEIR SETUP</a:t>
+            </a:r>
+          </a:p>
+          <a:p>
+            <a:pPr algn="l">
+              <a:spcAft>
+                <a:spcPts val="500"/>
+              </a:spcAft>
+            </a:pPr>
+            <a:r>
+              <a:rPr sz="1150" b="0" i="0">
+                <a:solidFill>
+                  <a:srgbClr val="0C2340"/>
+                </a:solidFill>
+                <a:latin typeface="Georgia"/>
+              </a:rPr>
+              <a:t>Analysis + simple method. Models: Llama-1 7/13/30B, Llama-2 7/13B, Mistral-7B-v0.1, OLMo 1B/7B, Phi-3-mini — mostly BASE models, with published coordinates (e.g. Llama-7B [3968, 7003]).</a:t>
+            </a:r>
+          </a:p>
+          <a:p>
+            <a:pPr algn="l">
+              <a:spcAft>
+                <a:spcPts val="500"/>
+              </a:spcAft>
+            </a:pPr>
+            <a:r>
+              <a:rPr sz="1150" b="1" i="0">
+                <a:solidFill>
+                  <a:srgbClr val="0C2340"/>
+                </a:solidFill>
+                <a:latin typeface="Georgia"/>
+              </a:rPr>
+              <a:t>Quantization world: </a:t>
+            </a:r>
+            <a:r>
+              <a:rPr sz="1150" b="0" i="0">
+                <a:solidFill>
+                  <a:srgbClr val="0C2340"/>
+                </a:solidFill>
+                <a:latin typeface="Georgia"/>
+              </a:rPr>
+              <a:t>round-to-nearest only (weights + activations, large blocks). GPTQ-style error correction appears nowhere.</a:t>
+            </a:r>
+          </a:p>
+          <a:p>
+            <a:pPr algn="l">
+              <a:spcAft>
+                <a:spcPts val="500"/>
+              </a:spcAft>
+            </a:pPr>
+            <a:r>
+              <a:rPr sz="1150" b="1" i="0">
+                <a:solidFill>
+                  <a:srgbClr val="0C2340"/>
+                </a:solidFill>
+                <a:latin typeface="Georgia"/>
+              </a:rPr>
+              <a:t>Evals: </a:t>
+            </a:r>
+            <a:r>
+              <a:rPr sz="1150" b="0" i="0">
+                <a:solidFill>
+                  <a:srgbClr val="0C2340"/>
+                </a:solidFill>
+                <a:latin typeface="Georgia"/>
+              </a:rPr>
+              <a:t>perplexity + zero-shot multiple choice. No generative tasks.</a:t>
+            </a:r>
+          </a:p>
+          <a:p>
+            <a:pPr algn="l"/>
+            <a:r>
+              <a:rPr sz="1150" b="1" i="0">
+                <a:solidFill>
+                  <a:srgbClr val="0C2340"/>
+                </a:solidFill>
+                <a:latin typeface="Georgia"/>
+              </a:rPr>
+              <a:t>Headline: </a:t>
+            </a:r>
+            <a:r>
+              <a:rPr sz="1150" b="0" i="0">
+                <a:solidFill>
+                  <a:srgbClr val="0C2340"/>
+                </a:solidFill>
+                <a:latin typeface="Georgia"/>
+              </a:rPr>
+              <a:t>1–6 single weights per model; pruning ONE raises perplexity 1000× — found data-free in one forward pass.</a:t>
+            </a:r>
+          </a:p>
+        </p:txBody>
+      </p:sp>
+      <p:sp>
+        <p:nvSpPr>
+          <p:cNvPr id="8" name="TextBox 7"/>
+          <p:cNvSpPr txBox="1"/>
+          <p:nvPr/>
+        </p:nvSpPr>
+        <p:spPr>
+          <a:xfrm>
+            <a:off x="4846320" y="1664208"/>
+            <a:ext cx="3931920" cy="3200400"/>
           </a:xfrm>
           <a:prstGeom prst="rect">
             <a:avLst/>

</xml_diff>

<commit_message>
Deck: plain what-they-did summaries on TaCQ/SW backup slides
</commit_message>
<xml_diff>
--- a/paper/IFH_advisor_update_2026-09-03.pptx
+++ b/paper/IFH_advisor_update_2026-09-03.pptx
@@ -22812,13 +22812,13 @@
                 </a:solidFill>
                 <a:latin typeface="Georgia"/>
               </a:rPr>
-              <a:t>THEIR SETUP</a:t>
+              <a:t>WHAT THEY DID</a:t>
             </a:r>
           </a:p>
           <a:p>
             <a:pPr algn="l">
               <a:spcAft>
-                <a:spcPts val="500"/>
+                <a:spcPts val="600"/>
               </a:spcAft>
             </a:pPr>
             <a:r>
@@ -22828,7 +22828,7 @@
                 </a:solidFill>
                 <a:latin typeface="Georgia"/>
               </a:rPr>
-              <a:t>Method paper: mixed-precision PTQ — important weights stored in 16-bit, the rest in 2–3 bits.</a:t>
+              <a:t>Invented a score for every weight's importance (|weight| × |gradient| × |compression error|), kept the top-scoring ~0.5% in full 16-bit, and compressed the rest to 2–3 bits — beating all previous low-bit methods on accuracy.</a:t>
             </a:r>
           </a:p>
           <a:p>
@@ -23202,23 +23202,48 @@
                 </a:solidFill>
                 <a:latin typeface="Georgia"/>
               </a:rPr>
-              <a:t>THEIR SETUP</a:t>
+              <a:t>WHAT THEY DID</a:t>
             </a:r>
           </a:p>
           <a:p>
             <a:pPr algn="l">
               <a:spcAft>
+                <a:spcPts val="600"/>
+              </a:spcAft>
+            </a:pPr>
+            <a:r>
+              <a:rPr sz="1150" b="0" i="0">
+                <a:solidFill>
+                  <a:srgbClr val="0C2340"/>
+                </a:solidFill>
+                <a:latin typeface="Georgia"/>
+              </a:rPr>
+              <a:t>Discovered that every LLM contains a handful (1–6) of individual weights so critical that deleting a SINGLE one destroys the model; showed how to find them in one forward pass, and that keeping them (plus their activation spikes) precise makes even naive rounding competitive.</a:t>
+            </a:r>
+          </a:p>
+          <a:p>
+            <a:pPr algn="l">
+              <a:spcAft>
                 <a:spcPts val="500"/>
               </a:spcAft>
             </a:pPr>
             <a:r>
+              <a:rPr sz="1150" b="1" i="0">
+                <a:solidFill>
+                  <a:srgbClr val="0C2340"/>
+                </a:solidFill>
+                <a:latin typeface="Georgia"/>
+              </a:rPr>
+              <a:t>Models: </a:t>
+            </a:r>
+            <a:r>
               <a:rPr sz="1150" b="0" i="0">
                 <a:solidFill>
                   <a:srgbClr val="0C2340"/>
                 </a:solidFill>
                 <a:latin typeface="Georgia"/>
               </a:rPr>
-              <a:t>Analysis + simple method. Models: Llama-1 7/13/30B, Llama-2 7/13B, Mistral-7B-v0.1, OLMo 1B/7B, Phi-3-mini — mostly BASE models, with published coordinates (e.g. Llama-7B [3968, 7003]).</a:t>
+              <a:t>Llama-1 7/13/30B, Llama-2 7/13B, Mistral-7B-v0.1, OLMo 1B/7B, Phi-3-mini — mostly BASE models, with published coordinates (e.g. Llama-7B [3968, 7003]).</a:t>
             </a:r>
           </a:p>
           <a:p>
@@ -23247,11 +23272,7 @@
             </a:r>
           </a:p>
           <a:p>
-            <a:pPr algn="l">
-              <a:spcAft>
-                <a:spcPts val="500"/>
-              </a:spcAft>
-            </a:pPr>
+            <a:pPr algn="l"/>
             <a:r>
               <a:rPr sz="1150" b="1" i="0">
                 <a:solidFill>
@@ -23269,27 +23290,6 @@
                 <a:latin typeface="Georgia"/>
               </a:rPr>
               <a:t>perplexity + zero-shot multiple choice. No generative tasks.</a:t>
-            </a:r>
-          </a:p>
-          <a:p>
-            <a:pPr algn="l"/>
-            <a:r>
-              <a:rPr sz="1150" b="1" i="0">
-                <a:solidFill>
-                  <a:srgbClr val="0C2340"/>
-                </a:solidFill>
-                <a:latin typeface="Georgia"/>
-              </a:rPr>
-              <a:t>Headline: </a:t>
-            </a:r>
-            <a:r>
-              <a:rPr sz="1150" b="0" i="0">
-                <a:solidFill>
-                  <a:srgbClr val="0C2340"/>
-                </a:solidFill>
-                <a:latin typeface="Georgia"/>
-              </a:rPr>
-              <a:t>1–6 single weights per model; pruning ONE raises perplexity 1000× — found data-free in one forward pass.</a:t>
             </a:r>
           </a:p>
         </p:txBody>

</xml_diff>

<commit_message>
Deck+RESULTS: recover missing RTN+protection arm; culprit slide upgraded to full 2x2
</commit_message>
<xml_diff>
--- a/paper/IFH_advisor_update_2026-09-03.pptx
+++ b/paper/IFH_advisor_update_2026-09-03.pptx
@@ -2401,7 +2401,7 @@
           <a:lstStyle/>
           <a:p>
             <a:r>
-              <a:t>为什么崩：同一个Llama三种压法对比。笨办法RTN反而0.57（受伤但活着），聪明的GPTQ却0.15（崩了）——聪明反被聪明误。机制：GPTQ的纠错会把误差摊到其他权重上；模型里有约10万个超敏感权重（占0.001%，在原模型里把它们清零模型也会死），纠错一碰它们就把毒扩散到全网络。证据：事后把这10万个修回原值也救不活（0.16）——伤已经在网络其他地方了。所以保护必须在压缩过程中做，等于告诉纠错机制“这批别碰”。</a:t>
+              <a:t>为什么崩：同一个Llama的完整2×2对比（纠错开关×保护有无）。四格读法：笨办法0.57（无凶案）；笨办法+保护0.60（无凶案可拦，只有+0.036的小甜头，p=0.03压线）；GPTQ 0.15（纠错行凶）；GPTQ+保护0.64全场最高。最妙的一格是0.64&gt;0.60：临界集被屏蔽后，纠错从凶手变回帮手（净+0.04）——保护不是关掉纠错，是拆掉它唯一的作案工具。原三格版讲法：笨办法RTN反而0.57（受伤但活着），聪明的GPTQ却0.15（崩了）——聪明反被聪明误。机制：GPTQ的纠错会把误差摊到其他权重上；模型里有约10万个超敏感权重（占0.001%，在原模型里把它们清零模型也会死），纠错一碰它们就把毒扩散到全网络。证据：事后把这10万个修回原值也救不活（0.16）——伤已经在网络其他地方了。所以保护必须在压缩过程中做，等于告诉纠错机制“这批别碰”。</a:t>
             </a:r>
           </a:p>
         </p:txBody>
@@ -15264,7 +15264,7 @@
                 </a:solidFill>
                 <a:latin typeface="Georgia"/>
               </a:rPr>
-              <a:t>The Culprit: the Compressor's Own Error Correction</a:t>
+              <a:t>The Culprit: GPTQ's Own Error Correction</a:t>
             </a:r>
           </a:p>
         </p:txBody>
@@ -15320,13 +15320,13 @@
           <a:p>
             <a:pPr algn="l"/>
             <a:r>
-              <a:rPr sz="1350" b="0" i="0">
+              <a:rPr sz="1300" b="0" i="0">
                 <a:solidFill>
                   <a:srgbClr val="0C2340"/>
                 </a:solidFill>
                 <a:latin typeface="Georgia"/>
               </a:rPr>
-              <a:t>Same Llama-8B model, compressed to 3 bits in three different ways — IFEval scores (“protection” = the same top-0.5% weight set as in Finding 2):</a:t>
+              <a:t>Same Llama-8B model at 3 bits, all four combinations of {error correction on/off} × {protection on/off} — IFEval scores (protection = the same top-0.5% set as in Finding 2):</a:t>
             </a:r>
           </a:p>
         </p:txBody>
@@ -15339,8 +15339,8 @@
         </p:nvSpPr>
         <p:spPr>
           <a:xfrm>
-            <a:off x="640080" y="1920240"/>
-            <a:ext cx="2468880" cy="1371600"/>
+            <a:off x="640080" y="1828800"/>
+            <a:ext cx="3703320" cy="1005840"/>
           </a:xfrm>
           <a:prstGeom prst="rect">
             <a:avLst/>
@@ -15355,7 +15355,7 @@
           <a:p>
             <a:pPr algn="ctr"/>
             <a:r>
-              <a:rPr sz="4000" b="1" i="0">
+              <a:rPr sz="2600" b="1" i="0">
                 <a:solidFill>
                   <a:srgbClr val="0C2340"/>
                 </a:solidFill>
@@ -15365,11 +15365,7 @@
             </a:r>
           </a:p>
           <a:p>
-            <a:pPr algn="ctr">
-              <a:spcBef>
-                <a:spcPts val="300"/>
-              </a:spcBef>
-            </a:pPr>
+            <a:pPr algn="ctr"/>
             <a:r>
               <a:rPr sz="1200" b="1" i="0">
                 <a:solidFill>
@@ -15383,13 +15379,13 @@
           <a:p>
             <a:pPr algn="ctr"/>
             <a:r>
-              <a:rPr sz="1200" b="0" i="0">
-                <a:solidFill>
-                  <a:srgbClr val="0C2340"/>
+              <a:rPr sz="1050" b="0" i="0">
+                <a:solidFill>
+                  <a:srgbClr val="5A5A5A"/>
                 </a:solidFill>
                 <a:latin typeface="Georgia"/>
               </a:rPr>
-              <a:t>no error correction → damaged, not dead</a:t>
+              <a:t>no error correction — damaged, not dead</a:t>
             </a:r>
           </a:p>
         </p:txBody>
@@ -15402,8 +15398,8 @@
         </p:nvSpPr>
         <p:spPr>
           <a:xfrm>
-            <a:off x="3429000" y="1920240"/>
-            <a:ext cx="2468880" cy="1371600"/>
+            <a:off x="4800600" y="1828800"/>
+            <a:ext cx="3703320" cy="1005840"/>
           </a:xfrm>
           <a:prstGeom prst="rect">
             <a:avLst/>
@@ -15418,21 +15414,17 @@
           <a:p>
             <a:pPr algn="ctr"/>
             <a:r>
-              <a:rPr sz="4000" b="1" i="0">
-                <a:solidFill>
-                  <a:srgbClr val="9B1B1B"/>
+              <a:rPr sz="2600" b="1" i="0">
+                <a:solidFill>
+                  <a:srgbClr val="0C2340"/>
                 </a:solidFill>
                 <a:latin typeface="Georgia"/>
               </a:rPr>
-              <a:t>0.15</a:t>
-            </a:r>
-          </a:p>
-          <a:p>
-            <a:pPr algn="ctr">
-              <a:spcBef>
-                <a:spcPts val="300"/>
-              </a:spcBef>
-            </a:pPr>
+              <a:t>0.60</a:t>
+            </a:r>
+          </a:p>
+          <a:p>
+            <a:pPr algn="ctr"/>
             <a:r>
               <a:rPr sz="1200" b="1" i="0">
                 <a:solidFill>
@@ -15440,19 +15432,19 @@
                 </a:solidFill>
                 <a:latin typeface="Georgia"/>
               </a:rPr>
-              <a:t>smart GPTQ</a:t>
+              <a:t>naive rounding + protection</a:t>
             </a:r>
           </a:p>
           <a:p>
             <a:pPr algn="ctr"/>
             <a:r>
-              <a:rPr sz="1200" b="0" i="0">
-                <a:solidFill>
-                  <a:srgbClr val="0C2340"/>
+              <a:rPr sz="1050" b="0" i="0">
+                <a:solidFill>
+                  <a:srgbClr val="5A5A5A"/>
                 </a:solidFill>
                 <a:latin typeface="Georgia"/>
               </a:rPr>
-              <a:t>error correction on → COLLAPSE</a:t>
+              <a:t>little to fix here: +0.036 only</a:t>
             </a:r>
           </a:p>
         </p:txBody>
@@ -15465,8 +15457,8 @@
         </p:nvSpPr>
         <p:spPr>
           <a:xfrm>
-            <a:off x="6217920" y="1920240"/>
-            <a:ext cx="2468880" cy="1371600"/>
+            <a:off x="640080" y="2889504"/>
+            <a:ext cx="3703320" cy="1005840"/>
           </a:xfrm>
           <a:prstGeom prst="rect">
             <a:avLst/>
@@ -15481,21 +15473,17 @@
           <a:p>
             <a:pPr algn="ctr"/>
             <a:r>
-              <a:rPr sz="4000" b="1" i="0">
-                <a:solidFill>
-                  <a:srgbClr val="0A833C"/>
+              <a:rPr sz="2600" b="1" i="0">
+                <a:solidFill>
+                  <a:srgbClr val="9B1B1B"/>
                 </a:solidFill>
                 <a:latin typeface="Georgia"/>
               </a:rPr>
-              <a:t>0.64</a:t>
-            </a:r>
-          </a:p>
-          <a:p>
-            <a:pPr algn="ctr">
-              <a:spcBef>
-                <a:spcPts val="300"/>
-              </a:spcBef>
-            </a:pPr>
+              <a:t>0.15</a:t>
+            </a:r>
+          </a:p>
+          <a:p>
+            <a:pPr algn="ctr"/>
             <a:r>
               <a:rPr sz="1200" b="1" i="0">
                 <a:solidFill>
@@ -15503,19 +15491,19 @@
                 </a:solidFill>
                 <a:latin typeface="Georgia"/>
               </a:rPr>
-              <a:t>smart GPTQ + protection</a:t>
+              <a:t>smart GPTQ</a:t>
             </a:r>
           </a:p>
           <a:p>
             <a:pPr algn="ctr"/>
             <a:r>
-              <a:rPr sz="1200" b="0" i="0">
-                <a:solidFill>
-                  <a:srgbClr val="0C2340"/>
+              <a:rPr sz="1050" b="0" i="0">
+                <a:solidFill>
+                  <a:srgbClr val="5A5A5A"/>
                 </a:solidFill>
                 <a:latin typeface="Georgia"/>
               </a:rPr>
-              <a:t>correction told to skip those 0.5%</a:t>
+              <a:t>error correction on — COLLAPSE</a:t>
             </a:r>
           </a:p>
         </p:txBody>
@@ -15528,8 +15516,8 @@
         </p:nvSpPr>
         <p:spPr>
           <a:xfrm>
-            <a:off x="411480" y="3520440"/>
-            <a:ext cx="8321040" cy="1188720"/>
+            <a:off x="4800600" y="2889504"/>
+            <a:ext cx="3703320" cy="1005840"/>
           </a:xfrm>
           <a:prstGeom prst="rect">
             <a:avLst/>
@@ -15542,40 +15530,99 @@
           </a:bodyPr>
           <a:lstStyle/>
           <a:p>
+            <a:pPr algn="ctr"/>
+            <a:r>
+              <a:rPr sz="2600" b="1" i="0">
+                <a:solidFill>
+                  <a:srgbClr val="0A833C"/>
+                </a:solidFill>
+                <a:latin typeface="Georgia"/>
+              </a:rPr>
+              <a:t>0.64</a:t>
+            </a:r>
+          </a:p>
+          <a:p>
+            <a:pPr algn="ctr"/>
+            <a:r>
+              <a:rPr sz="1200" b="1" i="0">
+                <a:solidFill>
+                  <a:srgbClr val="0C2340"/>
+                </a:solidFill>
+                <a:latin typeface="Georgia"/>
+              </a:rPr>
+              <a:t>smart GPTQ + protection</a:t>
+            </a:r>
+          </a:p>
+          <a:p>
+            <a:pPr algn="ctr"/>
+            <a:r>
+              <a:rPr sz="1050" b="0" i="0">
+                <a:solidFill>
+                  <a:srgbClr val="5A5A5A"/>
+                </a:solidFill>
+                <a:latin typeface="Georgia"/>
+              </a:rPr>
+              <a:t>correction on, critical set shielded — BEST</a:t>
+            </a:r>
+          </a:p>
+        </p:txBody>
+      </p:sp>
+      <p:sp>
+        <p:nvSpPr>
+          <p:cNvPr id="11" name="TextBox 10"/>
+          <p:cNvSpPr txBox="1"/>
+          <p:nvPr/>
+        </p:nvSpPr>
+        <p:spPr>
+          <a:xfrm>
+            <a:off x="411480" y="4023360"/>
+            <a:ext cx="8321040" cy="914400"/>
+          </a:xfrm>
+          <a:prstGeom prst="rect">
+            <a:avLst/>
+          </a:prstGeom>
+          <a:noFill/>
+        </p:spPr>
+        <p:txBody>
+          <a:bodyPr wrap="square" lIns="0" rIns="0" tIns="0" bIns="0">
+            <a:spAutoFit/>
+          </a:bodyPr>
+          <a:lstStyle/>
+          <a:p>
             <a:pPr algn="l">
               <a:spcAft>
-                <a:spcPts val="700"/>
+                <a:spcPts val="500"/>
               </a:spcAft>
             </a:pPr>
             <a:r>
-              <a:rPr sz="1350" b="1" i="0">
+              <a:rPr sz="1250" b="1" i="0">
                 <a:solidFill>
                   <a:srgbClr val="0C2340"/>
                 </a:solidFill>
                 <a:latin typeface="Georgia"/>
               </a:rPr>
-              <a:t>The “smart” correction is the problem: </a:t>
-            </a:r>
-            <a:r>
-              <a:rPr sz="1350" b="0" i="0">
+              <a:t>The correction is the culprit: </a:t>
+            </a:r>
+            <a:r>
+              <a:rPr sz="1250" b="0" i="0">
                 <a:solidFill>
                   <a:srgbClr val="0C2340"/>
                 </a:solidFill>
                 <a:latin typeface="Georgia"/>
               </a:rPr>
-              <a:t>when it touches ~100,000 hyper-sensitive weights (0.001% of the model — zeroing them at full precision also destroys the model), it spreads their error everywhere.</a:t>
+              <a:t>it spreads error from ~100,000 hyper-sensitive weights (0.001%; zeroing them at full precision also kills the model) into the whole network; repairing them afterwards fails (0.16).</a:t>
             </a:r>
           </a:p>
           <a:p>
             <a:pPr algn="l"/>
             <a:r>
-              <a:rPr sz="1350" b="0" i="0">
-                <a:solidFill>
-                  <a:srgbClr val="0C2340"/>
+              <a:rPr sz="1250" b="1" i="0">
+                <a:solidFill>
+                  <a:srgbClr val="AE9141"/>
                 </a:solidFill>
                 <a:latin typeface="Georgia"/>
               </a:rPr>
-              <a:t>Proof: repairing those weights afterwards does NOT help (0.16) — the damage already lives in the rest of the network. Protection must happen during compression.</a:t>
+              <a:t>But also an asset: shielded, GPTQ beats even protected naive rounding (0.64 &gt; 0.60) — protection removes its weapon, not the correction.</a:t>
             </a:r>
           </a:p>
         </p:txBody>

</xml_diff>

<commit_message>
W18 verdicts: reverse dissociation confirmed (l32 158x PPL, mild generation); Yi MMLU = harness artifact; FINAL freeze
</commit_message>
<xml_diff>
--- a/paper/IFH_advisor_update_2026-09-03.pptx
+++ b/paper/IFH_advisor_update_2026-09-03.pptx
@@ -2681,7 +2681,7 @@
           <a:lstStyle/>
           <a:p>
             <a:r>
-              <a:t>更吓人的发现：这么严重的损坏，业界两个默认质检居然都看不出来。压缩后的14B有69%的回答变成复读机（画面上是真实输出），原版不到1%。但困惑度只涨35%（和无害情况一样）、MMLU选择题只掉6分（也和无害情况一样）。原因：这两个指标只测“逐词预测”，复读机只在模型连续自由生成时才发作。警示：压缩后必须用生成式任务测试。</a:t>
+              <a:t>底部新补一句（W18坐实的反向解离）：PPL不但会漏报——还会假报警：量化后的Llama-3.2-3B困惑度暴涨158倍（比真崩塌的8.2倍还大20倍），但生成能力只是中度受损、照常能用。所以PPL对崩塌检测既不充分也不必要，全谱13个模型点上PPL比值与生成损伤基本不相关。更吓人的发现：这么严重的损坏，业界两个默认质检居然都看不出来。压缩后的14B有69%的回答变成复读机（画面上是真实输出），原版不到1%。但困惑度只涨35%（和无害情况一样）、MMLU选择题只掉6分（也和无害情况一样）。原因：这两个指标只测“逐词预测”，复读机只在模型连续自由生成时才发作。警示：压缩后必须用生成式任务测试。</a:t>
             </a:r>
           </a:p>
         </p:txBody>
@@ -17778,6 +17778,41 @@
                 <a:latin typeface="Georgia"/>
               </a:rPr>
               <a:t>actual math score — the collapse both checks failed to notice</a:t>
+            </a:r>
+          </a:p>
+        </p:txBody>
+      </p:sp>
+      <p:sp>
+        <p:nvSpPr>
+          <p:cNvPr id="13" name="TextBox 12"/>
+          <p:cNvSpPr txBox="1"/>
+          <p:nvPr/>
+        </p:nvSpPr>
+        <p:spPr>
+          <a:xfrm>
+            <a:off x="411480" y="4315968"/>
+            <a:ext cx="8321040" cy="365760"/>
+          </a:xfrm>
+          <a:prstGeom prst="rect">
+            <a:avLst/>
+          </a:prstGeom>
+          <a:noFill/>
+        </p:spPr>
+        <p:txBody>
+          <a:bodyPr wrap="square" lIns="0" rIns="0" tIns="0" bIns="0">
+            <a:spAutoFit/>
+          </a:bodyPr>
+          <a:lstStyle/>
+          <a:p>
+            <a:pPr algn="l"/>
+            <a:r>
+              <a:rPr sz="1100" b="0" i="1">
+                <a:solidFill>
+                  <a:srgbClr val="5A5A5A"/>
+                </a:solidFill>
+                <a:latin typeface="Georgia"/>
+              </a:rPr>
+              <a:t>It cuts both ways: quantized Llama-3.2-3B shows a 158× perplexity explosion yet only mild generation damage — perplexity is neither necessary nor sufficient for detecting collapse.</a:t>
             </a:r>
           </a:p>
         </p:txBody>

</xml_diff>

<commit_message>
Remove Yi-1.5-9B from paper scope per author decision: census 2/11, RTN sign 5 points, all deck tables/notes updated; raw data remains archived in runs/
</commit_message>
<xml_diff>
--- a/paper/IFH_advisor_update_2026-09-03.pptx
+++ b/paper/IFH_advisor_update_2026-09-03.pptx
@@ -410,9 +410,9 @@
           </c:spPr>
           <c:cat>
             <c:strRef>
-              <c:f>Sheet1!$A$2:$A$13</c:f>
+              <c:f>Sheet1!$A$2:$A$12</c:f>
               <c:strCache>
-                <c:ptCount val="12"/>
+                <c:ptCount val="11"/>
                 <c:pt idx="0">
                   <c:v>Mist 24B</c:v>
                 </c:pt>
@@ -432,21 +432,18 @@
                   <c:v>Llama3 8B</c:v>
                 </c:pt>
                 <c:pt idx="6">
-                  <c:v>Yi 9B</c:v>
+                  <c:v>Llama 3B</c:v>
                 </c:pt>
                 <c:pt idx="7">
-                  <c:v>Llama 3B</c:v>
+                  <c:v>Nemo 12B</c:v>
                 </c:pt>
                 <c:pt idx="8">
-                  <c:v>Nemo 12B</c:v>
+                  <c:v>Qwen 3B</c:v>
                 </c:pt>
                 <c:pt idx="9">
-                  <c:v>Qwen 3B</c:v>
+                  <c:v>Qwen 14B</c:v>
                 </c:pt>
                 <c:pt idx="10">
-                  <c:v>Qwen 14B</c:v>
-                </c:pt>
-                <c:pt idx="11">
                   <c:v>Llama3.1 8B</c:v>
                 </c:pt>
               </c:strCache>
@@ -454,10 +451,10 @@
           </c:cat>
           <c:val>
             <c:numRef>
-              <c:f>Sheet1!$B$2:$B$13</c:f>
+              <c:f>Sheet1!$B$2:$B$12</c:f>
               <c:numCache>
                 <c:formatCode>General</c:formatCode>
-                <c:ptCount val="12"/>
+                <c:ptCount val="11"/>
                 <c:pt idx="0">
                   <c:v>0.06</c:v>
                 </c:pt>
@@ -498,9 +495,9 @@
           </c:spPr>
           <c:cat>
             <c:strRef>
-              <c:f>Sheet1!$A$2:$A$13</c:f>
+              <c:f>Sheet1!$A$2:$A$12</c:f>
               <c:strCache>
-                <c:ptCount val="12"/>
+                <c:ptCount val="11"/>
                 <c:pt idx="0">
                   <c:v>Mist 24B</c:v>
                 </c:pt>
@@ -520,21 +517,18 @@
                   <c:v>Llama3 8B</c:v>
                 </c:pt>
                 <c:pt idx="6">
-                  <c:v>Yi 9B</c:v>
+                  <c:v>Llama 3B</c:v>
                 </c:pt>
                 <c:pt idx="7">
-                  <c:v>Llama 3B</c:v>
+                  <c:v>Nemo 12B</c:v>
                 </c:pt>
                 <c:pt idx="8">
-                  <c:v>Nemo 12B</c:v>
+                  <c:v>Qwen 3B</c:v>
                 </c:pt>
                 <c:pt idx="9">
-                  <c:v>Qwen 3B</c:v>
+                  <c:v>Qwen 14B</c:v>
                 </c:pt>
                 <c:pt idx="10">
-                  <c:v>Qwen 14B</c:v>
-                </c:pt>
-                <c:pt idx="11">
                   <c:v>Llama3.1 8B</c:v>
                 </c:pt>
               </c:strCache>
@@ -542,23 +536,20 @@
           </c:cat>
           <c:val>
             <c:numRef>
-              <c:f>Sheet1!$C$2:$C$13</c:f>
+              <c:f>Sheet1!$C$2:$C$12</c:f>
               <c:numCache>
                 <c:formatCode>General</c:formatCode>
-                <c:ptCount val="12"/>
+                <c:ptCount val="11"/>
                 <c:pt idx="5">
                   <c:v>0.147</c:v>
                 </c:pt>
                 <c:pt idx="6">
-                  <c:v>0.151</c:v>
+                  <c:v>0.173</c:v>
                 </c:pt>
                 <c:pt idx="7">
-                  <c:v>0.173</c:v>
+                  <c:v>0.175</c:v>
                 </c:pt>
                 <c:pt idx="8">
-                  <c:v>0.175</c:v>
-                </c:pt>
-                <c:pt idx="9">
                   <c:v>0.247</c:v>
                 </c:pt>
               </c:numCache>
@@ -586,9 +577,9 @@
           </c:spPr>
           <c:cat>
             <c:strRef>
-              <c:f>Sheet1!$A$2:$A$13</c:f>
+              <c:f>Sheet1!$A$2:$A$12</c:f>
               <c:strCache>
-                <c:ptCount val="12"/>
+                <c:ptCount val="11"/>
                 <c:pt idx="0">
                   <c:v>Mist 24B</c:v>
                 </c:pt>
@@ -608,21 +599,18 @@
                   <c:v>Llama3 8B</c:v>
                 </c:pt>
                 <c:pt idx="6">
-                  <c:v>Yi 9B</c:v>
+                  <c:v>Llama 3B</c:v>
                 </c:pt>
                 <c:pt idx="7">
-                  <c:v>Llama 3B</c:v>
+                  <c:v>Nemo 12B</c:v>
                 </c:pt>
                 <c:pt idx="8">
-                  <c:v>Nemo 12B</c:v>
+                  <c:v>Qwen 3B</c:v>
                 </c:pt>
                 <c:pt idx="9">
-                  <c:v>Qwen 3B</c:v>
+                  <c:v>Qwen 14B</c:v>
                 </c:pt>
                 <c:pt idx="10">
-                  <c:v>Qwen 14B</c:v>
-                </c:pt>
-                <c:pt idx="11">
                   <c:v>Llama3.1 8B</c:v>
                 </c:pt>
               </c:strCache>
@@ -630,14 +618,14 @@
           </c:cat>
           <c:val>
             <c:numRef>
-              <c:f>Sheet1!$D$2:$D$13</c:f>
+              <c:f>Sheet1!$D$2:$D$12</c:f>
               <c:numCache>
                 <c:formatCode>General</c:formatCode>
-                <c:ptCount val="12"/>
-                <c:pt idx="10">
+                <c:ptCount val="11"/>
+                <c:pt idx="9">
                   <c:v>0.409</c:v>
                 </c:pt>
-                <c:pt idx="11">
+                <c:pt idx="10">
                   <c:v>0.619</c:v>
                 </c:pt>
               </c:numCache>
@@ -2681,7 +2669,7 @@
           <a:lstStyle/>
           <a:p>
             <a:r>
-              <a:t>底部新补一句（W18坐实的反向解离）：PPL不但会漏报——还会假报警：量化后的Llama-3.2-3B困惑度暴涨158倍（比真崩塌的8.2倍还大20倍），但生成能力只是中度受损、照常能用。所以PPL对崩塌检测既不充分也不必要，全谱13个模型点上PPL比值与生成损伤基本不相关。更吓人的发现：这么严重的损坏，业界两个默认质检居然都看不出来。压缩后的14B有69%的回答变成复读机（画面上是真实输出），原版不到1%。但困惑度只涨35%（和无害情况一样）、MMLU选择题只掉6分（也和无害情况一样）。原因：这两个指标只测“逐词预测”，复读机只在模型连续自由生成时才发作。警示：压缩后必须用生成式任务测试。</a:t>
+              <a:t>底部新补一句（W18坐实的反向解离）：PPL不但会漏报——还会假报警：量化后的Llama-3.2-3B困惑度暴涨158倍（比真崩塌的8.2倍还大20倍），但生成能力只是中度受损、照常能用。所以PPL对崩塌检测既不充分也不必要，全谱12个模型点上PPL比值与生成损伤基本不相关。更吓人的发现：这么严重的损坏，业界两个默认质检居然都看不出来。压缩后的14B有69%的回答变成复读机（画面上是真实输出），原版不到1%。但困惑度只涨35%（和无害情况一样）、MMLU选择题只掉6分（也和无害情况一样）。原因：这两个指标只测“逐词预测”，复读机只在模型连续自由生成时才发作。警示：压缩后必须用生成式任务测试。</a:t>
             </a:r>
           </a:p>
         </p:txBody>
@@ -2891,7 +2879,7 @@
           <a:lstStyle/>
           <a:p>
             <a:r>
-              <a:t>总表：12个模型、四种处理（原始/笨压缩RTN/聪明压缩GPTQ/GPTQ+保护）外加保护增益和层次归类，一页看全。读法：从右往左——tier列先看是哪一档；崩溃两行（红）里GPTQ远差于RTN（纠错行凶）、保护增益巨大；其余各行保护增益全是噪声级。空格“—”表示该臂没跑（跑了也不改变结论，普查臂只需fp16和GPTQ两步）。被问任何具体数字时翻回这页。</a:t>
+              <a:t>总表：11个模型、四种处理（原始/笨压缩RTN/聪明压缩GPTQ/GPTQ+保护）外加保护增益和层次归类，一页看全。读法：从右往左——tier列先看是哪一档；崩溃两行（红）里GPTQ远差于RTN（纠错行凶）、保护增益巨大；其余各行保护增益全是噪声级。空格“—”表示该臂没跑（跑了也不改变结论，普查臂只需fp16和GPTQ两步）。被问任何具体数字时翻回这页。</a:t>
             </a:r>
           </a:p>
         </p:txBody>
@@ -3381,7 +3369,7 @@
           <a:lstStyle/>
           <a:p>
             <a:r>
-              <a:t>六个主模型用完全相同的配方压到3位：四个只轻微掉分（掉0.06-0.09），两个崩溃——Llama-8B从0.77掉到0.15，Qwen-14B从0.82掉到0.41。关键是不可预测：同一家族的Qwen，7B没事、14B崩、32B又没事。每个崩溃都换随机种子重跑验证过，是稳定现象不是偶然。最新补充：又普查了6个模型（共12个）。新模型都落在中间档（掉0.15-0.25，多是3B小模型——小模型本来就压得更惨，这是已知规律），没有出现第三个崩溃。重点：两个崩溃严重偏离“越小越惨”的趋势线（Llama-3.2-3B才掉0.17，更大的Llama-3.1-8B却掉0.62），而且复读机率有断层（中间档最高22%，崩溃是55-92%）——所以崩溃是一种性质不同的故障，不是普通退化的加重版。如果被问“上一代Llama-3-8B呢”：它只掉0.15——同尺寸同家族，隔一代就翻转。（下一页就是12模型的完整数据图。）最新补测（W16）把分型钉死了：对中间档两个代表做RTN对照，GPTQ的纠错在它们身上是帮忙的（Qwen-3B：RTN只有0.13、GPTQ有0.41，帮了28分；Yi-9B帮了12分），方向和两个崩溃完全相反（崩溃处纠错是害41.5/28.6分）。所以判定崩溃的本质标准是“纠错在帮忙还是在行凶”，掉分大小只是表象。同时保护在中间档只有+7.4（Qwen-3B）和+2.0（Yi-9B，不显著）——远小于崩溃处的+37/+49：保护的价值≈它拦下的纠错之害。</a:t>
+              <a:t>六个主模型用完全相同的配方压到3位：四个只轻微掉分（掉0.06-0.09），两个崩溃——Llama-8B从0.77掉到0.15，Qwen-14B从0.82掉到0.41。关键是不可预测：同一家族的Qwen，7B没事、14B崩、32B又没事。每个崩溃都换随机种子重跑验证过，是稳定现象不是偶然。最新补充：又普查了6个模型（共12个）。新模型都落在中间档（掉0.15-0.25，多是3B小模型——小模型本来就压得更惨，这是已知规律），没有出现第三个崩溃。重点：两个崩溃严重偏离“越小越惨”的趋势线（Llama-3.2-3B才掉0.17，更大的Llama-3.1-8B却掉0.62），而且复读机率有断层（中间档最高22%，崩溃是55-92%）——所以崩溃是一种性质不同的故障，不是普通退化的加重版。如果被问“上一代Llama-3-8B呢”：它只掉0.15——同尺寸同家族，隔一代就翻转。（下一页就是11模型的完整数据图。注：Yi-1.5-9B已按决定从论文口径整体移除——其评测协议兼容性存疑，数据仅存档不入文。）最新补测（W16）把分型钉死了：对中间档两个代表做RTN对照，GPTQ的纠错在它们身上是帮忙的（Qwen-3B：RTN只有0.13、GPTQ有0.41，帮了28分；方向和两个崩溃完全相反（崩溃处纠错是害41.5/28.6分）。所以判定崩溃的本质标准是“纠错在帮忙还是在行凶”，掉分大小只是表象。同时保护在中间档代表Qwen-3B上只有+7.4——远小于崩溃处的+37/+49：保护的价值≈它拦下的纠错之害。</a:t>
             </a:r>
           </a:p>
         </p:txBody>
@@ -3451,7 +3439,7 @@
           <a:lstStyle/>
           <a:p>
             <a:r>
-              <a:t>12模型全景：柱子是压缩后损失的分数，越高越糟。三个层次一目了然：轻微档（掉0.06-0.09）、中间档（掉0.15-0.25，多为小模型——小模型冗余少，普通退化更大）、两个崩溃（掉0.41和0.62）。关键论据：崩溃不在“越小越惨”的趋势线上——最小的3B们才掉0.17-0.25，反而是8B和14B崩掉。判定中间档和崩溃是两种病的证据在后面（纠错方向相反+复读机率断层）。</a:t>
+              <a:t>11模型全景：柱子是压缩后损失的分数，越高越糟。三个层次一目了然：轻微档（掉0.06-0.09）、中间档（掉0.15-0.25，多为小模型——小模型冗余少，普通退化更大）、两个崩溃（掉0.41和0.62）。关键论据：崩溃不在“越小越惨”的趋势线上——最小的3B们才掉0.17-0.25，反而是8B和14B崩掉。判定中间档和崩溃是两种病的证据在后面（纠错方向相反+复读机率断层）。</a:t>
             </a:r>
           </a:p>
         </p:txBody>
@@ -3801,7 +3789,7 @@
           <a:lstStyle/>
           <a:p>
             <a:r>
-              <a:t>这页直接回答“WHEN是什么意思”：同一个模型内部沿bit阶梯看。Llama-8B：4位时轻伤（保护+0.008，无用），3位时崩溃（保护+0.49，救命）。Qwen-7B：8位无损、4位近无损、3位轻伤（保护+0.03，无用）、2位彻底毁灭（0.12，保护无用——加到10倍预算2%也只有0.13，救不活）。所以“何时”的答案是一个窗口：压得不够深没病可治；压进崩溃区保护决定生死；压到2位病入膏肓。加上第3页的跨模型轴（12模型只有2个崩）和发现4的算法轴（GPTQ崩、RTN不崩、旋转不崩），三个轴合起来的统一判据就是：保护只在“纠错在净行凶”的组合里有用。</a:t>
+              <a:t>这页直接回答“WHEN是什么意思”：同一个模型内部沿bit阶梯看。Llama-8B：4位时轻伤（保护+0.008，无用），3位时崩溃（保护+0.49，救命）。Qwen-7B：8位无损、4位近无损、3位轻伤（保护+0.03，无用）、2位彻底毁灭（0.12，保护无用——加到10倍预算2%也只有0.13，救不活）。所以“何时”的答案是一个窗口：压得不够深没病可治；压进崩溃区保护决定生死；压到2位病入膏肓。加上第3页的跨模型轴（11模型只有2个崩）和发现4的算法轴（GPTQ崩、RTN不崩、旋转不崩），三个轴合起来的统一判据就是：保护只在“纠错在净行凶”的组合里有用。</a:t>
             </a:r>
           </a:p>
         </p:txBody>
@@ -12088,7 +12076,7 @@
                 </a:solidFill>
                 <a:latin typeface="Georgia"/>
               </a:rPr>
-              <a:t>New 12-model census: </a:t>
+              <a:t>New 11-model census: </a:t>
             </a:r>
             <a:r>
               <a:rPr sz="1250" b="0" i="0">
@@ -12160,7 +12148,7 @@
                 </a:solidFill>
                 <a:latin typeface="Georgia"/>
               </a:rPr>
-              <a:t>How Common Is Collapse? 2 in 12 — and Not the Models You'd Guess</a:t>
+              <a:t>How Common Is Collapse? 2 in 11 — and Not the Models You'd Guess</a:t>
             </a:r>
           </a:p>
         </p:txBody>
@@ -12269,7 +12257,7 @@
                 </a:solidFill>
                 <a:latin typeface="Georgia"/>
               </a:rPr>
-              <a:t>Answer: 2 of 12 collapse. </a:t>
+              <a:t>Answer: 2 of 11 collapse. </a:t>
             </a:r>
             <a:r>
               <a:rPr sz="1200" b="0" i="0">
@@ -14130,7 +14118,7 @@
         </p:nvGraphicFramePr>
         <p:xfrm>
           <a:off x="822960" y="1965960"/>
-          <a:ext cx="7498080" cy="2798064"/>
+          <a:ext cx="7498080" cy="2523744"/>
         </p:xfrm>
         <a:graphic>
           <a:graphicData uri="http://schemas.openxmlformats.org/drawingml/2006/table">
@@ -14816,7 +14804,7 @@
                           </a:solidFill>
                           <a:latin typeface="Georgia"/>
                         </a:rPr>
-                        <a:t>Yi-9B @3-bit (middle tier)</a:t>
+                        <a:t>Llama-8B @4-bit (mild)</a:t>
                       </a:r>
                     </a:p>
                   </a:txBody>
@@ -14839,7 +14827,7 @@
                           </a:solidFill>
                           <a:latin typeface="Georgia"/>
                         </a:rPr>
-                        <a:t>+0.020</a:t>
+                        <a:t>+0.008</a:t>
                       </a:r>
                     </a:p>
                   </a:txBody>
@@ -14862,7 +14850,7 @@
                           </a:solidFill>
                           <a:latin typeface="Georgia"/>
                         </a:rPr>
-                        <a:t>[−0.013, +0.052]</a:t>
+                        <a:t>[−0.022, +0.038]</a:t>
                       </a:r>
                     </a:p>
                   </a:txBody>
@@ -14910,7 +14898,7 @@
                           </a:solidFill>
                           <a:latin typeface="Georgia"/>
                         </a:rPr>
-                        <a:t>Llama-8B @4-bit (mild)</a:t>
+                        <a:t>Qwen-7B: protect attention heads</a:t>
                       </a:r>
                     </a:p>
                   </a:txBody>
@@ -14933,7 +14921,7 @@
                           </a:solidFill>
                           <a:latin typeface="Georgia"/>
                         </a:rPr>
-                        <a:t>+0.008</a:t>
+                        <a:t>+0.003</a:t>
                       </a:r>
                     </a:p>
                   </a:txBody>
@@ -14956,7 +14944,7 @@
                           </a:solidFill>
                           <a:latin typeface="Georgia"/>
                         </a:rPr>
-                        <a:t>[−0.022, +0.038]</a:t>
+                        <a:t>[−0.027, +0.032]</a:t>
                       </a:r>
                     </a:p>
                   </a:txBody>
@@ -14986,100 +14974,6 @@
                   <a:tcPr anchor="ctr" marL="54864" marR="54864" marT="18288" marB="18288">
                     <a:solidFill>
                       <a:srgbClr val="EFE9D9"/>
-                    </a:solidFill>
-                  </a:tcPr>
-                </a:tc>
-              </a:tr>
-              <a:tr h="274320">
-                <a:tc>
-                  <a:txBody>
-                    <a:bodyPr wrap="square"/>
-                    <a:lstStyle/>
-                    <a:p>
-                      <a:pPr algn="l"/>
-                      <a:r>
-                        <a:rPr sz="1050" b="0">
-                          <a:solidFill>
-                            <a:srgbClr val="0C2340"/>
-                          </a:solidFill>
-                          <a:latin typeface="Georgia"/>
-                        </a:rPr>
-                        <a:t>Qwen-7B: protect attention heads</a:t>
-                      </a:r>
-                    </a:p>
-                  </a:txBody>
-                  <a:tcPr anchor="ctr" marL="54864" marR="54864" marT="18288" marB="18288">
-                    <a:solidFill>
-                      <a:srgbClr val="FFFFFF"/>
-                    </a:solidFill>
-                  </a:tcPr>
-                </a:tc>
-                <a:tc>
-                  <a:txBody>
-                    <a:bodyPr wrap="square"/>
-                    <a:lstStyle/>
-                    <a:p>
-                      <a:pPr algn="ctr"/>
-                      <a:r>
-                        <a:rPr sz="1050" b="0">
-                          <a:solidFill>
-                            <a:srgbClr val="0C2340"/>
-                          </a:solidFill>
-                          <a:latin typeface="Georgia"/>
-                        </a:rPr>
-                        <a:t>+0.003</a:t>
-                      </a:r>
-                    </a:p>
-                  </a:txBody>
-                  <a:tcPr anchor="ctr" marL="54864" marR="54864" marT="18288" marB="18288">
-                    <a:solidFill>
-                      <a:srgbClr val="FFFFFF"/>
-                    </a:solidFill>
-                  </a:tcPr>
-                </a:tc>
-                <a:tc>
-                  <a:txBody>
-                    <a:bodyPr wrap="square"/>
-                    <a:lstStyle/>
-                    <a:p>
-                      <a:pPr algn="ctr"/>
-                      <a:r>
-                        <a:rPr sz="1050" b="0">
-                          <a:solidFill>
-                            <a:srgbClr val="0C2340"/>
-                          </a:solidFill>
-                          <a:latin typeface="Georgia"/>
-                        </a:rPr>
-                        <a:t>[−0.027, +0.032]</a:t>
-                      </a:r>
-                    </a:p>
-                  </a:txBody>
-                  <a:tcPr anchor="ctr" marL="54864" marR="54864" marT="18288" marB="18288">
-                    <a:solidFill>
-                      <a:srgbClr val="FFFFFF"/>
-                    </a:solidFill>
-                  </a:tcPr>
-                </a:tc>
-                <a:tc>
-                  <a:txBody>
-                    <a:bodyPr wrap="square"/>
-                    <a:lstStyle/>
-                    <a:p>
-                      <a:pPr algn="ctr"/>
-                      <a:r>
-                        <a:rPr sz="1050" b="1">
-                          <a:solidFill>
-                            <a:srgbClr val="5A5A5A"/>
-                          </a:solidFill>
-                          <a:latin typeface="Georgia"/>
-                        </a:rPr>
-                        <a:t>noise</a:t>
-                      </a:r>
-                    </a:p>
-                  </a:txBody>
-                  <a:tcPr anchor="ctr" marL="54864" marR="54864" marT="18288" marB="18288">
-                    <a:solidFill>
-                      <a:srgbClr val="FFFFFF"/>
                     </a:solidFill>
                   </a:tcPr>
                 </a:tc>
@@ -15715,7 +15609,7 @@
         </p:nvGraphicFramePr>
         <p:xfrm>
           <a:off x="502920" y="1463040"/>
-          <a:ext cx="7863840" cy="2139696"/>
+          <a:ext cx="7863840" cy="1837944"/>
         </p:xfrm>
         <a:graphic>
           <a:graphicData uri="http://schemas.openxmlformats.org/drawingml/2006/table">
@@ -16095,7 +15989,7 @@
                           </a:solidFill>
                           <a:latin typeface="Georgia"/>
                         </a:rPr>
-                        <a:t>Yi-9B</a:t>
+                        <a:t>Mistral-7B</a:t>
                       </a:r>
                     </a:p>
                   </a:txBody>
@@ -16118,7 +16012,7 @@
                           </a:solidFill>
                           <a:latin typeface="Georgia"/>
                         </a:rPr>
-                        <a:t>0.320</a:t>
+                        <a:t>0.420</a:t>
                       </a:r>
                     </a:p>
                   </a:txBody>
@@ -16141,7 +16035,7 @@
                           </a:solidFill>
                           <a:latin typeface="Georgia"/>
                         </a:rPr>
-                        <a:t>0.443</a:t>
+                        <a:t>0.468</a:t>
                       </a:r>
                     </a:p>
                   </a:txBody>
@@ -16164,7 +16058,7 @@
                           </a:solidFill>
                           <a:latin typeface="Georgia"/>
                         </a:rPr>
-                        <a:t>+0.122  helps</a:t>
+                        <a:t>+0.048  helps</a:t>
                       </a:r>
                     </a:p>
                   </a:txBody>
@@ -16187,7 +16081,7 @@
                           </a:solidFill>
                           <a:latin typeface="Georgia"/>
                         </a:rPr>
-                        <a:t>+0.020 (noise)</a:t>
+                        <a:t>+0.033 (noise)</a:t>
                       </a:r>
                     </a:p>
                   </a:txBody>
@@ -16212,7 +16106,7 @@
                           </a:solidFill>
                           <a:latin typeface="Georgia"/>
                         </a:rPr>
-                        <a:t>Mistral-7B</a:t>
+                        <a:t>Llama-8B</a:t>
                       </a:r>
                     </a:p>
                   </a:txBody>
@@ -16235,7 +16129,7 @@
                           </a:solidFill>
                           <a:latin typeface="Georgia"/>
                         </a:rPr>
-                        <a:t>0.420</a:t>
+                        <a:t>0.565</a:t>
                       </a:r>
                     </a:p>
                   </a:txBody>
@@ -16258,7 +16152,7 @@
                           </a:solidFill>
                           <a:latin typeface="Georgia"/>
                         </a:rPr>
-                        <a:t>0.468</a:t>
+                        <a:t>0.150</a:t>
                       </a:r>
                     </a:p>
                   </a:txBody>
@@ -16277,34 +16171,34 @@
                       <a:r>
                         <a:rPr sz="1050" b="1">
                           <a:solidFill>
+                            <a:srgbClr val="9B1B1B"/>
+                          </a:solidFill>
+                          <a:latin typeface="Georgia"/>
+                        </a:rPr>
+                        <a:t>−0.415  HURTS</a:t>
+                      </a:r>
+                    </a:p>
+                  </a:txBody>
+                  <a:tcPr anchor="ctr" marL="54864" marR="54864" marT="18288" marB="18288">
+                    <a:solidFill>
+                      <a:srgbClr val="EFE9D9"/>
+                    </a:solidFill>
+                  </a:tcPr>
+                </a:tc>
+                <a:tc>
+                  <a:txBody>
+                    <a:bodyPr wrap="square"/>
+                    <a:lstStyle/>
+                    <a:p>
+                      <a:pPr algn="ctr"/>
+                      <a:r>
+                        <a:rPr sz="1050" b="1">
+                          <a:solidFill>
                             <a:srgbClr val="0A833C"/>
                           </a:solidFill>
                           <a:latin typeface="Georgia"/>
                         </a:rPr>
-                        <a:t>+0.048  helps</a:t>
-                      </a:r>
-                    </a:p>
-                  </a:txBody>
-                  <a:tcPr anchor="ctr" marL="54864" marR="54864" marT="18288" marB="18288">
-                    <a:solidFill>
-                      <a:srgbClr val="EFE9D9"/>
-                    </a:solidFill>
-                  </a:tcPr>
-                </a:tc>
-                <a:tc>
-                  <a:txBody>
-                    <a:bodyPr wrap="square"/>
-                    <a:lstStyle/>
-                    <a:p>
-                      <a:pPr algn="ctr"/>
-                      <a:r>
-                        <a:rPr sz="1050" b="0">
-                          <a:solidFill>
-                            <a:srgbClr val="0C2340"/>
-                          </a:solidFill>
-                          <a:latin typeface="Georgia"/>
-                        </a:rPr>
-                        <a:t>+0.033 (noise)</a:t>
+                        <a:t>+0.493 (rescue)</a:t>
                       </a:r>
                     </a:p>
                   </a:txBody>
@@ -16329,7 +16223,7 @@
                           </a:solidFill>
                           <a:latin typeface="Georgia"/>
                         </a:rPr>
-                        <a:t>Llama-8B</a:t>
+                        <a:t>Qwen-14B</a:t>
                       </a:r>
                     </a:p>
                   </a:txBody>
@@ -16352,7 +16246,7 @@
                           </a:solidFill>
                           <a:latin typeface="Georgia"/>
                         </a:rPr>
-                        <a:t>0.565</a:t>
+                        <a:t>0.697</a:t>
                       </a:r>
                     </a:p>
                   </a:txBody>
@@ -16375,7 +16269,7 @@
                           </a:solidFill>
                           <a:latin typeface="Georgia"/>
                         </a:rPr>
-                        <a:t>0.150</a:t>
+                        <a:t>0.412</a:t>
                       </a:r>
                     </a:p>
                   </a:txBody>
@@ -16398,7 +16292,7 @@
                           </a:solidFill>
                           <a:latin typeface="Georgia"/>
                         </a:rPr>
-                        <a:t>−0.415  HURTS</a:t>
+                        <a:t>−0.286  HURTS</a:t>
                       </a:r>
                     </a:p>
                   </a:txBody>
@@ -16421,130 +16315,13 @@
                           </a:solidFill>
                           <a:latin typeface="Georgia"/>
                         </a:rPr>
-                        <a:t>+0.493 (rescue)</a:t>
+                        <a:t>+0.370 (rescue)</a:t>
                       </a:r>
                     </a:p>
                   </a:txBody>
                   <a:tcPr anchor="ctr" marL="54864" marR="54864" marT="18288" marB="18288">
                     <a:solidFill>
                       <a:srgbClr val="FFFFFF"/>
-                    </a:solidFill>
-                  </a:tcPr>
-                </a:tc>
-              </a:tr>
-              <a:tr h="301752">
-                <a:tc>
-                  <a:txBody>
-                    <a:bodyPr wrap="square"/>
-                    <a:lstStyle/>
-                    <a:p>
-                      <a:pPr algn="l"/>
-                      <a:r>
-                        <a:rPr sz="1050" b="0">
-                          <a:solidFill>
-                            <a:srgbClr val="0C2340"/>
-                          </a:solidFill>
-                          <a:latin typeface="Georgia"/>
-                        </a:rPr>
-                        <a:t>Qwen-14B</a:t>
-                      </a:r>
-                    </a:p>
-                  </a:txBody>
-                  <a:tcPr anchor="ctr" marL="54864" marR="54864" marT="18288" marB="18288">
-                    <a:solidFill>
-                      <a:srgbClr val="EFE9D9"/>
-                    </a:solidFill>
-                  </a:tcPr>
-                </a:tc>
-                <a:tc>
-                  <a:txBody>
-                    <a:bodyPr wrap="square"/>
-                    <a:lstStyle/>
-                    <a:p>
-                      <a:pPr algn="ctr"/>
-                      <a:r>
-                        <a:rPr sz="1050" b="0">
-                          <a:solidFill>
-                            <a:srgbClr val="0C2340"/>
-                          </a:solidFill>
-                          <a:latin typeface="Georgia"/>
-                        </a:rPr>
-                        <a:t>0.697</a:t>
-                      </a:r>
-                    </a:p>
-                  </a:txBody>
-                  <a:tcPr anchor="ctr" marL="54864" marR="54864" marT="18288" marB="18288">
-                    <a:solidFill>
-                      <a:srgbClr val="EFE9D9"/>
-                    </a:solidFill>
-                  </a:tcPr>
-                </a:tc>
-                <a:tc>
-                  <a:txBody>
-                    <a:bodyPr wrap="square"/>
-                    <a:lstStyle/>
-                    <a:p>
-                      <a:pPr algn="ctr"/>
-                      <a:r>
-                        <a:rPr sz="1050" b="0">
-                          <a:solidFill>
-                            <a:srgbClr val="0C2340"/>
-                          </a:solidFill>
-                          <a:latin typeface="Georgia"/>
-                        </a:rPr>
-                        <a:t>0.412</a:t>
-                      </a:r>
-                    </a:p>
-                  </a:txBody>
-                  <a:tcPr anchor="ctr" marL="54864" marR="54864" marT="18288" marB="18288">
-                    <a:solidFill>
-                      <a:srgbClr val="EFE9D9"/>
-                    </a:solidFill>
-                  </a:tcPr>
-                </a:tc>
-                <a:tc>
-                  <a:txBody>
-                    <a:bodyPr wrap="square"/>
-                    <a:lstStyle/>
-                    <a:p>
-                      <a:pPr algn="ctr"/>
-                      <a:r>
-                        <a:rPr sz="1050" b="1">
-                          <a:solidFill>
-                            <a:srgbClr val="9B1B1B"/>
-                          </a:solidFill>
-                          <a:latin typeface="Georgia"/>
-                        </a:rPr>
-                        <a:t>−0.286  HURTS</a:t>
-                      </a:r>
-                    </a:p>
-                  </a:txBody>
-                  <a:tcPr anchor="ctr" marL="54864" marR="54864" marT="18288" marB="18288">
-                    <a:solidFill>
-                      <a:srgbClr val="EFE9D9"/>
-                    </a:solidFill>
-                  </a:tcPr>
-                </a:tc>
-                <a:tc>
-                  <a:txBody>
-                    <a:bodyPr wrap="square"/>
-                    <a:lstStyle/>
-                    <a:p>
-                      <a:pPr algn="ctr"/>
-                      <a:r>
-                        <a:rPr sz="1050" b="1">
-                          <a:solidFill>
-                            <a:srgbClr val="0A833C"/>
-                          </a:solidFill>
-                          <a:latin typeface="Georgia"/>
-                        </a:rPr>
-                        <a:t>+0.370 (rescue)</a:t>
-                      </a:r>
-                    </a:p>
-                  </a:txBody>
-                  <a:tcPr anchor="ctr" marL="54864" marR="54864" marT="18288" marB="18288">
-                    <a:solidFill>
-                      <a:srgbClr val="EFE9D9"/>
                     </a:solidFill>
                   </a:tcPr>
                 </a:tc>
@@ -19927,7 +19704,7 @@
         </p:nvGraphicFramePr>
         <p:xfrm>
           <a:off x="411480" y="1371600"/>
-          <a:ext cx="8366760" cy="3200400"/>
+          <a:ext cx="8366760" cy="2958084"/>
         </p:xfrm>
         <a:graphic>
           <a:graphicData uri="http://schemas.openxmlformats.org/drawingml/2006/table">
@@ -21099,7 +20876,7 @@
                           </a:solidFill>
                           <a:latin typeface="Georgia"/>
                         </a:rPr>
-                        <a:t>Yi-1.5-9B</a:t>
+                        <a:t>Llama-3.2-3B</a:t>
                       </a:r>
                     </a:p>
                   </a:txBody>
@@ -21122,7 +20899,7 @@
                           </a:solidFill>
                           <a:latin typeface="Georgia"/>
                         </a:rPr>
-                        <a:t>0.594</a:t>
+                        <a:t>0.750</a:t>
                       </a:r>
                     </a:p>
                   </a:txBody>
@@ -21145,7 +20922,7 @@
                           </a:solidFill>
                           <a:latin typeface="Georgia"/>
                         </a:rPr>
-                        <a:t>0.320</a:t>
+                        <a:t>—</a:t>
                       </a:r>
                     </a:p>
                   </a:txBody>
@@ -21168,7 +20945,7 @@
                           </a:solidFill>
                           <a:latin typeface="Georgia"/>
                         </a:rPr>
-                        <a:t>0.443</a:t>
+                        <a:t>0.577</a:t>
                       </a:r>
                     </a:p>
                   </a:txBody>
@@ -21191,7 +20968,7 @@
                           </a:solidFill>
                           <a:latin typeface="Georgia"/>
                         </a:rPr>
-                        <a:t>0.462</a:t>
+                        <a:t>—</a:t>
                       </a:r>
                     </a:p>
                   </a:txBody>
@@ -21214,7 +20991,7 @@
                           </a:solidFill>
                           <a:latin typeface="Georgia"/>
                         </a:rPr>
-                        <a:t>+0.020 (noise)</a:t>
+                        <a:t>—</a:t>
                       </a:r>
                     </a:p>
                   </a:txBody>
@@ -21262,7 +21039,7 @@
                           </a:solidFill>
                           <a:latin typeface="Georgia"/>
                         </a:rPr>
-                        <a:t>Llama-3.2-3B</a:t>
+                        <a:t>Mistral-Nemo-12B</a:t>
                       </a:r>
                     </a:p>
                   </a:txBody>
@@ -21285,7 +21062,7 @@
                           </a:solidFill>
                           <a:latin typeface="Georgia"/>
                         </a:rPr>
-                        <a:t>0.750</a:t>
+                        <a:t>0.651</a:t>
                       </a:r>
                     </a:p>
                   </a:txBody>
@@ -21331,7 +21108,7 @@
                           </a:solidFill>
                           <a:latin typeface="Georgia"/>
                         </a:rPr>
-                        <a:t>0.577</a:t>
+                        <a:t>0.476</a:t>
                       </a:r>
                     </a:p>
                   </a:txBody>
@@ -21425,7 +21202,7 @@
                           </a:solidFill>
                           <a:latin typeface="Georgia"/>
                         </a:rPr>
-                        <a:t>Mistral-Nemo-12B</a:t>
+                        <a:t>Qwen2.5-3B</a:t>
                       </a:r>
                     </a:p>
                   </a:txBody>
@@ -21448,7 +21225,7 @@
                           </a:solidFill>
                           <a:latin typeface="Georgia"/>
                         </a:rPr>
-                        <a:t>0.651</a:t>
+                        <a:t>0.658</a:t>
                       </a:r>
                     </a:p>
                   </a:txBody>
@@ -21471,7 +21248,7 @@
                           </a:solidFill>
                           <a:latin typeface="Georgia"/>
                         </a:rPr>
-                        <a:t>—</a:t>
+                        <a:t>0.130</a:t>
                       </a:r>
                     </a:p>
                   </a:txBody>
@@ -21494,7 +21271,7 @@
                           </a:solidFill>
                           <a:latin typeface="Georgia"/>
                         </a:rPr>
-                        <a:t>0.476</a:t>
+                        <a:t>0.411</a:t>
                       </a:r>
                     </a:p>
                   </a:txBody>
@@ -21517,7 +21294,7 @@
                           </a:solidFill>
                           <a:latin typeface="Georgia"/>
                         </a:rPr>
-                        <a:t>—</a:t>
+                        <a:t>0.484</a:t>
                       </a:r>
                     </a:p>
                   </a:txBody>
@@ -21540,7 +21317,7 @@
                           </a:solidFill>
                           <a:latin typeface="Georgia"/>
                         </a:rPr>
-                        <a:t>—</a:t>
+                        <a:t>+0.074 (small)</a:t>
                       </a:r>
                     </a:p>
                   </a:txBody>
@@ -21588,7 +21365,7 @@
                           </a:solidFill>
                           <a:latin typeface="Georgia"/>
                         </a:rPr>
-                        <a:t>Qwen2.5-3B</a:t>
+                        <a:t>Qwen2.5-14B</a:t>
                       </a:r>
                     </a:p>
                   </a:txBody>
@@ -21611,7 +21388,7 @@
                           </a:solidFill>
                           <a:latin typeface="Georgia"/>
                         </a:rPr>
-                        <a:t>0.658</a:t>
+                        <a:t>0.820</a:t>
                       </a:r>
                     </a:p>
                   </a:txBody>
@@ -21634,7 +21411,7 @@
                           </a:solidFill>
                           <a:latin typeface="Georgia"/>
                         </a:rPr>
-                        <a:t>0.130</a:t>
+                        <a:t>0.697</a:t>
                       </a:r>
                     </a:p>
                   </a:txBody>
@@ -21651,13 +21428,13 @@
                     <a:p>
                       <a:pPr algn="ctr"/>
                       <a:r>
-                        <a:rPr sz="950" b="0">
-                          <a:solidFill>
-                            <a:srgbClr val="0C2340"/>
-                          </a:solidFill>
-                          <a:latin typeface="Georgia"/>
-                        </a:rPr>
-                        <a:t>0.411</a:t>
+                        <a:rPr sz="950" b="1">
+                          <a:solidFill>
+                            <a:srgbClr val="9B1B1B"/>
+                          </a:solidFill>
+                          <a:latin typeface="Georgia"/>
+                        </a:rPr>
+                        <a:t>0.412</a:t>
                       </a:r>
                     </a:p>
                   </a:txBody>
@@ -21674,13 +21451,13 @@
                     <a:p>
                       <a:pPr algn="ctr"/>
                       <a:r>
-                        <a:rPr sz="950" b="0">
-                          <a:solidFill>
-                            <a:srgbClr val="0C2340"/>
-                          </a:solidFill>
-                          <a:latin typeface="Georgia"/>
-                        </a:rPr>
-                        <a:t>0.484</a:t>
+                        <a:rPr sz="950" b="1">
+                          <a:solidFill>
+                            <a:srgbClr val="0A833C"/>
+                          </a:solidFill>
+                          <a:latin typeface="Georgia"/>
+                        </a:rPr>
+                        <a:t>0.782</a:t>
                       </a:r>
                     </a:p>
                   </a:txBody>
@@ -21697,13 +21474,13 @@
                     <a:p>
                       <a:pPr algn="ctr"/>
                       <a:r>
-                        <a:rPr sz="950" b="0">
-                          <a:solidFill>
-                            <a:srgbClr val="0C2340"/>
-                          </a:solidFill>
-                          <a:latin typeface="Georgia"/>
-                        </a:rPr>
-                        <a:t>+0.074 (small)</a:t>
+                        <a:rPr sz="950" b="1">
+                          <a:solidFill>
+                            <a:srgbClr val="0A833C"/>
+                          </a:solidFill>
+                          <a:latin typeface="Georgia"/>
+                        </a:rPr>
+                        <a:t>+0.370 (rescue)</a:t>
                       </a:r>
                     </a:p>
                   </a:txBody>
@@ -21720,13 +21497,13 @@
                     <a:p>
                       <a:pPr algn="ctr"/>
                       <a:r>
-                        <a:rPr sz="950" b="0">
-                          <a:solidFill>
-                            <a:srgbClr val="0C2340"/>
-                          </a:solidFill>
-                          <a:latin typeface="Georgia"/>
-                        </a:rPr>
-                        <a:t>middle</a:t>
+                        <a:rPr sz="950" b="1">
+                          <a:solidFill>
+                            <a:srgbClr val="9B1B1B"/>
+                          </a:solidFill>
+                          <a:latin typeface="Georgia"/>
+                        </a:rPr>
+                        <a:t>COLLAPSE</a:t>
                       </a:r>
                     </a:p>
                   </a:txBody>
@@ -21751,7 +21528,7 @@
                           </a:solidFill>
                           <a:latin typeface="Georgia"/>
                         </a:rPr>
-                        <a:t>Qwen2.5-14B</a:t>
+                        <a:t>Llama-3.1-8B</a:t>
                       </a:r>
                     </a:p>
                   </a:txBody>
@@ -21774,7 +21551,7 @@
                           </a:solidFill>
                           <a:latin typeface="Georgia"/>
                         </a:rPr>
-                        <a:t>0.820</a:t>
+                        <a:t>0.768</a:t>
                       </a:r>
                     </a:p>
                   </a:txBody>
@@ -21797,7 +21574,7 @@
                           </a:solidFill>
                           <a:latin typeface="Georgia"/>
                         </a:rPr>
-                        <a:t>0.697</a:t>
+                        <a:t>0.565</a:t>
                       </a:r>
                     </a:p>
                   </a:txBody>
@@ -21820,7 +21597,7 @@
                           </a:solidFill>
                           <a:latin typeface="Georgia"/>
                         </a:rPr>
-                        <a:t>0.412</a:t>
+                        <a:t>0.150</a:t>
                       </a:r>
                     </a:p>
                   </a:txBody>
@@ -21843,7 +21620,7 @@
                           </a:solidFill>
                           <a:latin typeface="Georgia"/>
                         </a:rPr>
-                        <a:t>0.782</a:t>
+                        <a:t>0.643</a:t>
                       </a:r>
                     </a:p>
                   </a:txBody>
@@ -21866,7 +21643,7 @@
                           </a:solidFill>
                           <a:latin typeface="Georgia"/>
                         </a:rPr>
-                        <a:t>+0.370 (rescue)</a:t>
+                        <a:t>+0.493 (rescue)</a:t>
                       </a:r>
                     </a:p>
                   </a:txBody>
@@ -21896,169 +21673,6 @@
                   <a:tcPr anchor="ctr" marL="54864" marR="54864" marT="18288" marB="18288">
                     <a:solidFill>
                       <a:srgbClr val="FFFFFF"/>
-                    </a:solidFill>
-                  </a:tcPr>
-                </a:tc>
-              </a:tr>
-              <a:tr h="242316">
-                <a:tc>
-                  <a:txBody>
-                    <a:bodyPr wrap="square"/>
-                    <a:lstStyle/>
-                    <a:p>
-                      <a:pPr algn="l"/>
-                      <a:r>
-                        <a:rPr sz="950" b="0">
-                          <a:solidFill>
-                            <a:srgbClr val="0C2340"/>
-                          </a:solidFill>
-                          <a:latin typeface="Georgia"/>
-                        </a:rPr>
-                        <a:t>Llama-3.1-8B</a:t>
-                      </a:r>
-                    </a:p>
-                  </a:txBody>
-                  <a:tcPr anchor="ctr" marL="54864" marR="54864" marT="18288" marB="18288">
-                    <a:solidFill>
-                      <a:srgbClr val="EFE9D9"/>
-                    </a:solidFill>
-                  </a:tcPr>
-                </a:tc>
-                <a:tc>
-                  <a:txBody>
-                    <a:bodyPr wrap="square"/>
-                    <a:lstStyle/>
-                    <a:p>
-                      <a:pPr algn="ctr"/>
-                      <a:r>
-                        <a:rPr sz="950" b="0">
-                          <a:solidFill>
-                            <a:srgbClr val="0C2340"/>
-                          </a:solidFill>
-                          <a:latin typeface="Georgia"/>
-                        </a:rPr>
-                        <a:t>0.768</a:t>
-                      </a:r>
-                    </a:p>
-                  </a:txBody>
-                  <a:tcPr anchor="ctr" marL="54864" marR="54864" marT="18288" marB="18288">
-                    <a:solidFill>
-                      <a:srgbClr val="EFE9D9"/>
-                    </a:solidFill>
-                  </a:tcPr>
-                </a:tc>
-                <a:tc>
-                  <a:txBody>
-                    <a:bodyPr wrap="square"/>
-                    <a:lstStyle/>
-                    <a:p>
-                      <a:pPr algn="ctr"/>
-                      <a:r>
-                        <a:rPr sz="950" b="0">
-                          <a:solidFill>
-                            <a:srgbClr val="0C2340"/>
-                          </a:solidFill>
-                          <a:latin typeface="Georgia"/>
-                        </a:rPr>
-                        <a:t>0.565</a:t>
-                      </a:r>
-                    </a:p>
-                  </a:txBody>
-                  <a:tcPr anchor="ctr" marL="54864" marR="54864" marT="18288" marB="18288">
-                    <a:solidFill>
-                      <a:srgbClr val="EFE9D9"/>
-                    </a:solidFill>
-                  </a:tcPr>
-                </a:tc>
-                <a:tc>
-                  <a:txBody>
-                    <a:bodyPr wrap="square"/>
-                    <a:lstStyle/>
-                    <a:p>
-                      <a:pPr algn="ctr"/>
-                      <a:r>
-                        <a:rPr sz="950" b="1">
-                          <a:solidFill>
-                            <a:srgbClr val="9B1B1B"/>
-                          </a:solidFill>
-                          <a:latin typeface="Georgia"/>
-                        </a:rPr>
-                        <a:t>0.150</a:t>
-                      </a:r>
-                    </a:p>
-                  </a:txBody>
-                  <a:tcPr anchor="ctr" marL="54864" marR="54864" marT="18288" marB="18288">
-                    <a:solidFill>
-                      <a:srgbClr val="EFE9D9"/>
-                    </a:solidFill>
-                  </a:tcPr>
-                </a:tc>
-                <a:tc>
-                  <a:txBody>
-                    <a:bodyPr wrap="square"/>
-                    <a:lstStyle/>
-                    <a:p>
-                      <a:pPr algn="ctr"/>
-                      <a:r>
-                        <a:rPr sz="950" b="1">
-                          <a:solidFill>
-                            <a:srgbClr val="0A833C"/>
-                          </a:solidFill>
-                          <a:latin typeface="Georgia"/>
-                        </a:rPr>
-                        <a:t>0.643</a:t>
-                      </a:r>
-                    </a:p>
-                  </a:txBody>
-                  <a:tcPr anchor="ctr" marL="54864" marR="54864" marT="18288" marB="18288">
-                    <a:solidFill>
-                      <a:srgbClr val="EFE9D9"/>
-                    </a:solidFill>
-                  </a:tcPr>
-                </a:tc>
-                <a:tc>
-                  <a:txBody>
-                    <a:bodyPr wrap="square"/>
-                    <a:lstStyle/>
-                    <a:p>
-                      <a:pPr algn="ctr"/>
-                      <a:r>
-                        <a:rPr sz="950" b="1">
-                          <a:solidFill>
-                            <a:srgbClr val="0A833C"/>
-                          </a:solidFill>
-                          <a:latin typeface="Georgia"/>
-                        </a:rPr>
-                        <a:t>+0.493 (rescue)</a:t>
-                      </a:r>
-                    </a:p>
-                  </a:txBody>
-                  <a:tcPr anchor="ctr" marL="54864" marR="54864" marT="18288" marB="18288">
-                    <a:solidFill>
-                      <a:srgbClr val="EFE9D9"/>
-                    </a:solidFill>
-                  </a:tcPr>
-                </a:tc>
-                <a:tc>
-                  <a:txBody>
-                    <a:bodyPr wrap="square"/>
-                    <a:lstStyle/>
-                    <a:p>
-                      <a:pPr algn="ctr"/>
-                      <a:r>
-                        <a:rPr sz="950" b="1">
-                          <a:solidFill>
-                            <a:srgbClr val="9B1B1B"/>
-                          </a:solidFill>
-                          <a:latin typeface="Georgia"/>
-                        </a:rPr>
-                        <a:t>COLLAPSE</a:t>
-                      </a:r>
-                    </a:p>
-                  </a:txBody>
-                  <a:tcPr anchor="ctr" marL="54864" marR="54864" marT="18288" marB="18288">
-                    <a:solidFill>
-                      <a:srgbClr val="EFE9D9"/>
                     </a:solidFill>
                   </a:tcPr>
                 </a:tc>

</xml_diff>